<commit_message>
Slide 2: show Korea-China complementarity as a two-way exchange
Co-Authored-By: Claude Opus 5.5 <noreply@anthropic.com>
Claude-Session: https://claude.ai/code/session_01EAqNWxuCBt8vBHk7fm7zMv
</commit_message>
<xml_diff>
--- a/korea-china-trade.pptx
+++ b/korea-china-trade.pptx
@@ -27850,7 +27850,7 @@
       </p:sp>
       <p:sp>
         <p:nvSpPr>
-          <p:cNvPr id="2017" name="From box"/>
+          <p:cNvPr id="2018" name="From box"/>
           <p:cNvSpPr/>
           <p:nvPr/>
         </p:nvSpPr>
@@ -27903,7 +27903,7 @@
       </p:sp>
       <p:sp>
         <p:nvSpPr>
-          <p:cNvPr id="2018" name="To box"/>
+          <p:cNvPr id="2019" name="To box"/>
           <p:cNvSpPr/>
           <p:nvPr/>
         </p:nvSpPr>
@@ -27956,7 +27956,7 @@
       </p:sp>
       <p:cxnSp>
         <p:nvCxnSpPr>
-          <p:cNvPr id="2019" name="Shift arrow"/>
+          <p:cNvPr id="2020" name="Shift arrow"/>
           <p:cNvCxnSpPr/>
           <p:nvPr/>
         </p:nvCxnSpPr>
@@ -27978,7 +27978,7 @@
       </p:cxnSp>
       <p:sp>
         <p:nvSpPr>
-          <p:cNvPr id="2020" name="Shift driver"/>
+          <p:cNvPr id="2021" name="Shift driver"/>
           <p:cNvSpPr txBox="1"/>
           <p:nvPr/>
         </p:nvSpPr>
@@ -28029,7 +28029,7 @@
       </p:sp>
       <p:sp>
         <p:nvSpPr>
-          <p:cNvPr id="2021" name="Shift driver detail"/>
+          <p:cNvPr id="2022" name="Shift driver detail"/>
           <p:cNvSpPr txBox="1"/>
           <p:nvPr/>
         </p:nvSpPr>
@@ -28080,7 +28080,7 @@
       </p:sp>
       <p:sp>
         <p:nvSpPr>
-          <p:cNvPr id="2022" name="From caption"/>
+          <p:cNvPr id="2023" name="From caption"/>
           <p:cNvSpPr txBox="1"/>
           <p:nvPr/>
         </p:nvSpPr>
@@ -28131,7 +28131,7 @@
       </p:sp>
       <p:sp>
         <p:nvSpPr>
-          <p:cNvPr id="2023" name="To caption"/>
+          <p:cNvPr id="2024" name="To caption"/>
           <p:cNvSpPr txBox="1"/>
           <p:nvPr/>
         </p:nvSpPr>
@@ -28182,7 +28182,7 @@
       </p:sp>
       <p:cxnSp>
         <p:nvCxnSpPr>
-          <p:cNvPr id="2024" name="Timeline axis"/>
+          <p:cNvPr id="2025" name="Timeline axis"/>
           <p:cNvCxnSpPr/>
           <p:nvPr/>
         </p:nvCxnSpPr>
@@ -28203,7 +28203,7 @@
       </p:cxnSp>
       <p:sp>
         <p:nvSpPr>
-          <p:cNvPr id="2025" name="Timeline marker 1"/>
+          <p:cNvPr id="2026" name="Timeline marker 1"/>
           <p:cNvSpPr/>
           <p:nvPr/>
         </p:nvSpPr>
@@ -28234,7 +28234,7 @@
       </p:sp>
       <p:sp>
         <p:nvSpPr>
-          <p:cNvPr id="2026" name="Timeline year 1"/>
+          <p:cNvPr id="2027" name="Timeline year 1"/>
           <p:cNvSpPr txBox="1"/>
           <p:nvPr/>
         </p:nvSpPr>
@@ -28285,7 +28285,7 @@
       </p:sp>
       <p:sp>
         <p:nvSpPr>
-          <p:cNvPr id="2027" name="Timeline text 1"/>
+          <p:cNvPr id="2028" name="Timeline text 1"/>
           <p:cNvSpPr txBox="1"/>
           <p:nvPr/>
         </p:nvSpPr>
@@ -28336,7 +28336,7 @@
       </p:sp>
       <p:sp>
         <p:nvSpPr>
-          <p:cNvPr id="2028" name="Timeline marker 2"/>
+          <p:cNvPr id="2029" name="Timeline marker 2"/>
           <p:cNvSpPr/>
           <p:nvPr/>
         </p:nvSpPr>
@@ -28367,7 +28367,7 @@
       </p:sp>
       <p:sp>
         <p:nvSpPr>
-          <p:cNvPr id="2029" name="Timeline year 2"/>
+          <p:cNvPr id="2030" name="Timeline year 2"/>
           <p:cNvSpPr txBox="1"/>
           <p:nvPr/>
         </p:nvSpPr>
@@ -28418,7 +28418,7 @@
       </p:sp>
       <p:sp>
         <p:nvSpPr>
-          <p:cNvPr id="2030" name="Timeline text 2"/>
+          <p:cNvPr id="2031" name="Timeline text 2"/>
           <p:cNvSpPr txBox="1"/>
           <p:nvPr/>
         </p:nvSpPr>
@@ -28469,7 +28469,7 @@
       </p:sp>
       <p:sp>
         <p:nvSpPr>
-          <p:cNvPr id="2031" name="Timeline marker 3"/>
+          <p:cNvPr id="2032" name="Timeline marker 3"/>
           <p:cNvSpPr/>
           <p:nvPr/>
         </p:nvSpPr>
@@ -28500,7 +28500,7 @@
       </p:sp>
       <p:sp>
         <p:nvSpPr>
-          <p:cNvPr id="2032" name="Timeline year 3"/>
+          <p:cNvPr id="2033" name="Timeline year 3"/>
           <p:cNvSpPr txBox="1"/>
           <p:nvPr/>
         </p:nvSpPr>
@@ -28551,7 +28551,7 @@
       </p:sp>
       <p:sp>
         <p:nvSpPr>
-          <p:cNvPr id="2033" name="Timeline text 3"/>
+          <p:cNvPr id="2034" name="Timeline text 3"/>
           <p:cNvSpPr txBox="1"/>
           <p:nvPr/>
         </p:nvSpPr>
@@ -28602,7 +28602,7 @@
       </p:sp>
       <p:sp>
         <p:nvSpPr>
-          <p:cNvPr id="2034" name="Timeline marker 4"/>
+          <p:cNvPr id="2035" name="Timeline marker 4"/>
           <p:cNvSpPr/>
           <p:nvPr/>
         </p:nvSpPr>
@@ -28633,7 +28633,7 @@
       </p:sp>
       <p:sp>
         <p:nvSpPr>
-          <p:cNvPr id="2035" name="Timeline year 4"/>
+          <p:cNvPr id="2036" name="Timeline year 4"/>
           <p:cNvSpPr txBox="1"/>
           <p:nvPr/>
         </p:nvSpPr>
@@ -28684,7 +28684,7 @@
       </p:sp>
       <p:sp>
         <p:nvSpPr>
-          <p:cNvPr id="2036" name="Timeline text 4"/>
+          <p:cNvPr id="2037" name="Timeline text 4"/>
           <p:cNvSpPr txBox="1"/>
           <p:nvPr/>
         </p:nvSpPr>
@@ -28735,7 +28735,7 @@
       </p:sp>
       <p:sp>
         <p:nvSpPr>
-          <p:cNvPr id="2037" name="Takeaway banner"/>
+          <p:cNvPr id="2038" name="Takeaway banner"/>
           <p:cNvSpPr/>
           <p:nvPr/>
         </p:nvSpPr>
@@ -28799,7 +28799,7 @@
       </p:sp>
       <p:sp>
         <p:nvSpPr>
-          <p:cNvPr id="2038" name="Next topic"/>
+          <p:cNvPr id="2039" name="Next topic"/>
           <p:cNvSpPr txBox="1"/>
           <p:nvPr/>
         </p:nvSpPr>
@@ -29392,7 +29392,7 @@
         <p:spPr>
           <a:xfrm>
             <a:off x="950976" y="3767328"/>
-            <a:ext cx="8229600" cy="384048"/>
+            <a:ext cx="10058400" cy="384048"/>
           </a:xfrm>
           <a:prstGeom prst="rect">
             <a:avLst/>
@@ -29429,21 +29429,21 @@
                 <a:ea typeface="+mn-lt"/>
                 <a:cs typeface="+mn-lt"/>
               </a:rPr>
-              <a:t>A complementary production relationship</a:t>
+              <a:t>A complementary production relationship: both sides benefited</a:t>
             </a:r>
           </a:p>
         </p:txBody>
       </p:sp>
       <p:sp>
         <p:nvSpPr>
-          <p:cNvPr id="2011" name="Flow step 1"/>
+          <p:cNvPr id="2011" name="Economy 1"/>
           <p:cNvSpPr/>
           <p:nvPr/>
         </p:nvSpPr>
         <p:spPr>
           <a:xfrm>
-            <a:off x="950976" y="4206240"/>
-            <a:ext cx="3246120" cy="1783080"/>
+            <a:off x="950976" y="4224528"/>
+            <a:ext cx="3429000" cy="1810512"/>
           </a:xfrm>
           <a:prstGeom prst="rect">
             <a:avLst/>
@@ -29456,7 +29456,7 @@
           </a:ln>
         </p:spPr>
         <p:txBody>
-          <a:bodyPr wrap="square" lIns="137160" tIns="137160" rIns="137160" bIns="137160" anchor="ctr" rtlCol="0">
+          <a:bodyPr wrap="square" lIns="146304" tIns="146304" rIns="146304" bIns="146304" anchor="ctr" rtlCol="0">
             <a:noAutofit/>
           </a:bodyPr>
           <a:lstStyle/>
@@ -29507,43 +29507,21 @@
                 <a:ea typeface="+mn-lt"/>
                 <a:cs typeface="+mn-lt"/>
               </a:rPr>
-              <a:t>Intermediate goods: semiconductors, components, petrochemicals</a:t>
+              <a:t>Higher-value intermediate goods: semiconductors, electronic components, petrochemicals</a:t>
             </a:r>
           </a:p>
         </p:txBody>
       </p:sp>
-      <p:cxnSp>
-        <p:nvCxnSpPr>
-          <p:cNvPr id="2012" name="Flow arrow 1"/>
-          <p:cNvCxnSpPr/>
-          <p:nvPr/>
-        </p:nvCxnSpPr>
-        <p:spPr>
-          <a:xfrm>
-            <a:off x="4270248" y="5097780"/>
-            <a:ext cx="132588" cy="0"/>
-          </a:xfrm>
-          <a:prstGeom prst="straightConnector1">
-            <a:avLst/>
-          </a:prstGeom>
-          <a:ln w="22225">
-            <a:solidFill>
-              <a:schemeClr val="dk1"/>
-            </a:solidFill>
-            <a:tailEnd type="triangle" w="med" len="med"/>
-          </a:ln>
-        </p:spPr>
-      </p:cxnSp>
       <p:sp>
         <p:nvSpPr>
-          <p:cNvPr id="2013" name="Flow step 2"/>
+          <p:cNvPr id="2012" name="Economy 2"/>
           <p:cNvSpPr/>
           <p:nvPr/>
         </p:nvSpPr>
         <p:spPr>
           <a:xfrm>
-            <a:off x="4475988" y="4206240"/>
-            <a:ext cx="3246120" cy="1783080"/>
+            <a:off x="7818120" y="4224528"/>
+            <a:ext cx="3429000" cy="1810512"/>
           </a:xfrm>
           <a:prstGeom prst="rect">
             <a:avLst/>
@@ -29556,7 +29534,7 @@
           </a:ln>
         </p:spPr>
         <p:txBody>
-          <a:bodyPr wrap="square" lIns="137160" tIns="137160" rIns="137160" bIns="137160" anchor="ctr" rtlCol="0">
+          <a:bodyPr wrap="square" lIns="146304" tIns="146304" rIns="146304" bIns="146304" anchor="ctr" rtlCol="0">
             <a:noAutofit/>
           </a:bodyPr>
           <a:lstStyle/>
@@ -29607,28 +29585,28 @@
                 <a:ea typeface="+mn-lt"/>
                 <a:cs typeface="+mn-lt"/>
               </a:rPr>
-              <a:t>Assembly into finished goods, incl. in Korean-built factories</a:t>
+              <a:t>Imported them to make finished products: smartphones, computers, consumer electronics</a:t>
             </a:r>
           </a:p>
         </p:txBody>
       </p:sp>
       <p:cxnSp>
         <p:nvCxnSpPr>
-          <p:cNvPr id="2014" name="Flow arrow 2"/>
+          <p:cNvPr id="2013" name="Arrow: components to China"/>
           <p:cNvCxnSpPr/>
           <p:nvPr/>
         </p:nvCxnSpPr>
         <p:spPr>
           <a:xfrm>
-            <a:off x="7795260" y="5097780"/>
-            <a:ext cx="132588" cy="0"/>
+            <a:off x="4489704" y="4818888"/>
+            <a:ext cx="3218688" cy="0"/>
           </a:xfrm>
           <a:prstGeom prst="straightConnector1">
             <a:avLst/>
           </a:prstGeom>
-          <a:ln w="22225">
+          <a:ln w="28575">
             <a:solidFill>
-              <a:schemeClr val="dk1"/>
+              <a:schemeClr val="accent2"/>
             </a:solidFill>
             <a:tailEnd type="triangle" w="med" len="med"/>
           </a:ln>
@@ -29636,57 +29614,103 @@
       </p:cxnSp>
       <p:sp>
         <p:nvSpPr>
-          <p:cNvPr id="2015" name="Flow step 3"/>
-          <p:cNvSpPr/>
+          <p:cNvPr id="2014" name="Label: components"/>
+          <p:cNvSpPr txBox="1"/>
           <p:nvPr/>
         </p:nvSpPr>
         <p:spPr>
           <a:xfrm>
-            <a:off x="8001000" y="4206240"/>
-            <a:ext cx="3246120" cy="1783080"/>
+            <a:off x="4379976" y="4361688"/>
+            <a:ext cx="3438144" cy="384048"/>
           </a:xfrm>
           <a:prstGeom prst="rect">
             <a:avLst/>
           </a:prstGeom>
-          <a:solidFill>
-            <a:schemeClr val="accent5"/>
-          </a:solidFill>
+          <a:noFill/>
           <a:ln>
             <a:noFill/>
           </a:ln>
         </p:spPr>
         <p:txBody>
-          <a:bodyPr wrap="square" lIns="137160" tIns="137160" rIns="137160" bIns="137160" anchor="ctr" rtlCol="0">
+          <a:bodyPr wrap="square" lIns="0" tIns="0" rIns="0" bIns="0" anchor="b" rtlCol="0">
             <a:noAutofit/>
           </a:bodyPr>
           <a:lstStyle/>
           <a:p>
-            <a:pPr marL="0" indent="0" algn="l">
-              <a:lnSpc>
-                <a:spcPct val="100000"/>
-              </a:lnSpc>
-              <a:spcBef>
-                <a:spcPts val="0"/>
-              </a:spcBef>
-              <a:spcAft>
-                <a:spcPts val="200"/>
+            <a:pPr marL="0" indent="0" algn="ctr">
+              <a:lnSpc>
+                <a:spcPct val="100000"/>
+              </a:lnSpc>
+              <a:spcBef>
+                <a:spcPts val="0"/>
+              </a:spcBef>
+              <a:spcAft>
+                <a:spcPts val="0"/>
               </a:spcAft>
               <a:buNone/>
             </a:pPr>
             <a:r>
-              <a:rPr lang="en-US" sz="2000" b="1" dirty="0">
+              <a:rPr lang="en-US" sz="1800" b="1" dirty="0">
                 <a:solidFill>
-                  <a:schemeClr val="lt1"/>
+                  <a:schemeClr val="accent2"/>
                 </a:solidFill>
                 <a:latin typeface="+mn-lt"/>
                 <a:ea typeface="+mn-lt"/>
                 <a:cs typeface="+mn-lt"/>
               </a:rPr>
-              <a:t>Domestic &amp; global markets</a:t>
+              <a:t>Components &amp; technology</a:t>
             </a:r>
           </a:p>
+        </p:txBody>
+      </p:sp>
+      <p:cxnSp>
+        <p:nvCxnSpPr>
+          <p:cNvPr id="2015" name="Arrow: market access to Korea"/>
+          <p:cNvCxnSpPr/>
+          <p:nvPr/>
+        </p:nvCxnSpPr>
+        <p:spPr>
+          <a:xfrm flipH="1">
+            <a:off x="4489704" y="5440680"/>
+            <a:ext cx="3218688" cy="0"/>
+          </a:xfrm>
+          <a:prstGeom prst="straightConnector1">
+            <a:avLst/>
+          </a:prstGeom>
+          <a:ln w="28575">
+            <a:solidFill>
+              <a:schemeClr val="dk2"/>
+            </a:solidFill>
+            <a:tailEnd type="triangle" w="med" len="med"/>
+          </a:ln>
+        </p:spPr>
+      </p:cxnSp>
+      <p:sp>
+        <p:nvSpPr>
+          <p:cNvPr id="2016" name="Label: market access"/>
+          <p:cNvSpPr txBox="1"/>
+          <p:nvPr/>
+        </p:nvSpPr>
+        <p:spPr>
+          <a:xfrm>
+            <a:off x="4379976" y="5513832"/>
+            <a:ext cx="3438144" cy="384048"/>
+          </a:xfrm>
+          <a:prstGeom prst="rect">
+            <a:avLst/>
+          </a:prstGeom>
+          <a:noFill/>
+          <a:ln>
+            <a:noFill/>
+          </a:ln>
+        </p:spPr>
+        <p:txBody>
+          <a:bodyPr wrap="square" lIns="0" tIns="0" rIns="0" bIns="0" anchor="t" rtlCol="0">
+            <a:noAutofit/>
+          </a:bodyPr>
+          <a:lstStyle/>
           <a:p>
-            <a:pPr marL="0" indent="0" algn="l">
+            <a:pPr marL="0" indent="0" algn="ctr">
               <a:lnSpc>
                 <a:spcPct val="100000"/>
               </a:lnSpc>
@@ -29699,22 +29723,22 @@
               <a:buNone/>
             </a:pPr>
             <a:r>
-              <a:rPr lang="en-US" sz="1800" b="0" dirty="0">
+              <a:rPr lang="en-US" sz="1800" b="1" dirty="0">
                 <a:solidFill>
-                  <a:schemeClr val="lt1"/>
+                  <a:schemeClr val="dk2"/>
                 </a:solidFill>
                 <a:latin typeface="+mn-lt"/>
                 <a:ea typeface="+mn-lt"/>
                 <a:cs typeface="+mn-lt"/>
               </a:rPr>
-              <a:t>Finished products sold in China and worldwide</a:t>
+              <a:t>Access to a vast market</a:t>
             </a:r>
           </a:p>
         </p:txBody>
       </p:sp>
       <p:sp>
         <p:nvSpPr>
-          <p:cNvPr id="2016" name="Transition line"/>
+          <p:cNvPr id="2017" name="Transition line"/>
           <p:cNvSpPr txBox="1"/>
           <p:nvPr/>
         </p:nvSpPr>

</xml_diff>

<commit_message>
Slide 2: add navy title band
Co-Authored-By: Claude Opus 5.5 <noreply@anthropic.com>
Claude-Session: https://claude.ai/code/session_01EAqNWxuCBt8vBHk7fm7zMv
</commit_message>
<xml_diff>
--- a/korea-china-trade.pptx
+++ b/korea-china-trade.pptx
@@ -27850,7 +27850,7 @@
       </p:sp>
       <p:sp>
         <p:nvSpPr>
-          <p:cNvPr id="2018" name="From box"/>
+          <p:cNvPr id="2019" name="From box"/>
           <p:cNvSpPr/>
           <p:nvPr/>
         </p:nvSpPr>
@@ -27903,7 +27903,7 @@
       </p:sp>
       <p:sp>
         <p:nvSpPr>
-          <p:cNvPr id="2019" name="To box"/>
+          <p:cNvPr id="2020" name="To box"/>
           <p:cNvSpPr/>
           <p:nvPr/>
         </p:nvSpPr>
@@ -27956,7 +27956,7 @@
       </p:sp>
       <p:cxnSp>
         <p:nvCxnSpPr>
-          <p:cNvPr id="2020" name="Shift arrow"/>
+          <p:cNvPr id="2021" name="Shift arrow"/>
           <p:cNvCxnSpPr/>
           <p:nvPr/>
         </p:nvCxnSpPr>
@@ -27978,7 +27978,7 @@
       </p:cxnSp>
       <p:sp>
         <p:nvSpPr>
-          <p:cNvPr id="2021" name="Shift driver"/>
+          <p:cNvPr id="2022" name="Shift driver"/>
           <p:cNvSpPr txBox="1"/>
           <p:nvPr/>
         </p:nvSpPr>
@@ -28029,7 +28029,7 @@
       </p:sp>
       <p:sp>
         <p:nvSpPr>
-          <p:cNvPr id="2022" name="Shift driver detail"/>
+          <p:cNvPr id="2023" name="Shift driver detail"/>
           <p:cNvSpPr txBox="1"/>
           <p:nvPr/>
         </p:nvSpPr>
@@ -28080,7 +28080,7 @@
       </p:sp>
       <p:sp>
         <p:nvSpPr>
-          <p:cNvPr id="2023" name="From caption"/>
+          <p:cNvPr id="2024" name="From caption"/>
           <p:cNvSpPr txBox="1"/>
           <p:nvPr/>
         </p:nvSpPr>
@@ -28131,7 +28131,7 @@
       </p:sp>
       <p:sp>
         <p:nvSpPr>
-          <p:cNvPr id="2024" name="To caption"/>
+          <p:cNvPr id="2025" name="To caption"/>
           <p:cNvSpPr txBox="1"/>
           <p:nvPr/>
         </p:nvSpPr>
@@ -28182,7 +28182,7 @@
       </p:sp>
       <p:cxnSp>
         <p:nvCxnSpPr>
-          <p:cNvPr id="2025" name="Timeline axis"/>
+          <p:cNvPr id="2026" name="Timeline axis"/>
           <p:cNvCxnSpPr/>
           <p:nvPr/>
         </p:nvCxnSpPr>
@@ -28203,7 +28203,7 @@
       </p:cxnSp>
       <p:sp>
         <p:nvSpPr>
-          <p:cNvPr id="2026" name="Timeline marker 1"/>
+          <p:cNvPr id="2027" name="Timeline marker 1"/>
           <p:cNvSpPr/>
           <p:nvPr/>
         </p:nvSpPr>
@@ -28234,7 +28234,7 @@
       </p:sp>
       <p:sp>
         <p:nvSpPr>
-          <p:cNvPr id="2027" name="Timeline year 1"/>
+          <p:cNvPr id="2028" name="Timeline year 1"/>
           <p:cNvSpPr txBox="1"/>
           <p:nvPr/>
         </p:nvSpPr>
@@ -28285,7 +28285,7 @@
       </p:sp>
       <p:sp>
         <p:nvSpPr>
-          <p:cNvPr id="2028" name="Timeline text 1"/>
+          <p:cNvPr id="2029" name="Timeline text 1"/>
           <p:cNvSpPr txBox="1"/>
           <p:nvPr/>
         </p:nvSpPr>
@@ -28336,7 +28336,7 @@
       </p:sp>
       <p:sp>
         <p:nvSpPr>
-          <p:cNvPr id="2029" name="Timeline marker 2"/>
+          <p:cNvPr id="2030" name="Timeline marker 2"/>
           <p:cNvSpPr/>
           <p:nvPr/>
         </p:nvSpPr>
@@ -28367,7 +28367,7 @@
       </p:sp>
       <p:sp>
         <p:nvSpPr>
-          <p:cNvPr id="2030" name="Timeline year 2"/>
+          <p:cNvPr id="2031" name="Timeline year 2"/>
           <p:cNvSpPr txBox="1"/>
           <p:nvPr/>
         </p:nvSpPr>
@@ -28418,7 +28418,7 @@
       </p:sp>
       <p:sp>
         <p:nvSpPr>
-          <p:cNvPr id="2031" name="Timeline text 2"/>
+          <p:cNvPr id="2032" name="Timeline text 2"/>
           <p:cNvSpPr txBox="1"/>
           <p:nvPr/>
         </p:nvSpPr>
@@ -28469,7 +28469,7 @@
       </p:sp>
       <p:sp>
         <p:nvSpPr>
-          <p:cNvPr id="2032" name="Timeline marker 3"/>
+          <p:cNvPr id="2033" name="Timeline marker 3"/>
           <p:cNvSpPr/>
           <p:nvPr/>
         </p:nvSpPr>
@@ -28500,7 +28500,7 @@
       </p:sp>
       <p:sp>
         <p:nvSpPr>
-          <p:cNvPr id="2033" name="Timeline year 3"/>
+          <p:cNvPr id="2034" name="Timeline year 3"/>
           <p:cNvSpPr txBox="1"/>
           <p:nvPr/>
         </p:nvSpPr>
@@ -28551,7 +28551,7 @@
       </p:sp>
       <p:sp>
         <p:nvSpPr>
-          <p:cNvPr id="2034" name="Timeline text 3"/>
+          <p:cNvPr id="2035" name="Timeline text 3"/>
           <p:cNvSpPr txBox="1"/>
           <p:nvPr/>
         </p:nvSpPr>
@@ -28602,7 +28602,7 @@
       </p:sp>
       <p:sp>
         <p:nvSpPr>
-          <p:cNvPr id="2035" name="Timeline marker 4"/>
+          <p:cNvPr id="2036" name="Timeline marker 4"/>
           <p:cNvSpPr/>
           <p:nvPr/>
         </p:nvSpPr>
@@ -28633,7 +28633,7 @@
       </p:sp>
       <p:sp>
         <p:nvSpPr>
-          <p:cNvPr id="2036" name="Timeline year 4"/>
+          <p:cNvPr id="2037" name="Timeline year 4"/>
           <p:cNvSpPr txBox="1"/>
           <p:nvPr/>
         </p:nvSpPr>
@@ -28684,7 +28684,7 @@
       </p:sp>
       <p:sp>
         <p:nvSpPr>
-          <p:cNvPr id="2037" name="Timeline text 4"/>
+          <p:cNvPr id="2038" name="Timeline text 4"/>
           <p:cNvSpPr txBox="1"/>
           <p:nvPr/>
         </p:nvSpPr>
@@ -28735,7 +28735,7 @@
       </p:sp>
       <p:sp>
         <p:nvSpPr>
-          <p:cNvPr id="2038" name="Takeaway banner"/>
+          <p:cNvPr id="2039" name="Takeaway banner"/>
           <p:cNvSpPr/>
           <p:nvPr/>
         </p:nvSpPr>
@@ -28799,7 +28799,7 @@
       </p:sp>
       <p:sp>
         <p:nvSpPr>
-          <p:cNvPr id="2039" name="Next topic"/>
+          <p:cNvPr id="2040" name="Next topic"/>
           <p:cNvSpPr txBox="1"/>
           <p:nvPr/>
         </p:nvSpPr>
@@ -28875,6 +28875,37 @@
       </p:grpSpPr>
       <p:sp>
         <p:nvSpPr>
+          <p:cNvPr id="2000" name="Title band"/>
+          <p:cNvSpPr/>
+          <p:nvPr/>
+        </p:nvSpPr>
+        <p:spPr>
+          <a:xfrm>
+            <a:off x="0" y="274320"/>
+            <a:ext cx="11338560" cy="960120"/>
+          </a:xfrm>
+          <a:prstGeom prst="rect">
+            <a:avLst/>
+          </a:prstGeom>
+          <a:solidFill>
+            <a:schemeClr val="accent2"/>
+          </a:solidFill>
+          <a:ln>
+            <a:noFill/>
+          </a:ln>
+        </p:spPr>
+        <p:txBody>
+          <a:bodyPr wrap="square" lIns="0" tIns="0" rIns="0" bIns="0" anchor="t" rtlCol="0">
+            <a:noAutofit/>
+          </a:bodyPr>
+          <a:lstStyle/>
+          <a:p>
+            <a:endParaRPr lang="en-US"/>
+          </a:p>
+        </p:txBody>
+      </p:sp>
+      <p:sp>
+        <p:nvSpPr>
           <p:cNvPr id="395" name="Google Shape;395;p46"/>
           <p:cNvSpPr txBox="1"/>
           <p:nvPr>
@@ -28883,21 +28914,22 @@
         </p:nvSpPr>
         <p:spPr>
           <a:xfrm>
-            <a:off x="950967" y="593367"/>
-            <a:ext cx="10290000" cy="763600"/>
+            <a:off x="950976" y="274320"/>
+            <a:ext cx="10149840" cy="960120"/>
           </a:xfrm>
-          <a:prstGeom prst="rect">
-            <a:avLst/>
-          </a:prstGeom>
         </p:spPr>
         <p:txBody>
-          <a:bodyPr anchorCtr="0" anchor="t" bIns="121900" lIns="121900" spcFirstLastPara="1" rIns="121900" wrap="square" tIns="121900">
+          <a:bodyPr anchorCtr="0" bIns="121900" lIns="121900" spcFirstLastPara="1" rIns="121900" wrap="square" tIns="121900" anchor="ctr">
             <a:noAutofit/>
           </a:bodyPr>
           <a:lstStyle/>
           <a:p>
             <a:r>
-              <a:rPr lang="en-US" sz="3600" dirty="0"/>
+              <a:rPr lang="en-US" sz="3600" dirty="0">
+                <a:solidFill>
+                  <a:schemeClr val="lt1"/>
+                </a:solidFill>
+              </a:rPr>
               <a:t>Background: How the Relationship Developed</a:t>
             </a:r>
           </a:p>
@@ -28905,7 +28937,7 @@
       </p:sp>
       <p:sp>
         <p:nvSpPr>
-          <p:cNvPr id="2000" name="Stat 1 label"/>
+          <p:cNvPr id="2001" name="Stat 1 label"/>
           <p:cNvSpPr txBox="1"/>
           <p:nvPr/>
         </p:nvSpPr>
@@ -28956,7 +28988,7 @@
       </p:sp>
       <p:sp>
         <p:nvSpPr>
-          <p:cNvPr id="2001" name="Stat 1 value"/>
+          <p:cNvPr id="2002" name="Stat 1 value"/>
           <p:cNvSpPr txBox="1"/>
           <p:nvPr/>
         </p:nvSpPr>
@@ -29007,7 +29039,7 @@
       </p:sp>
       <p:sp>
         <p:nvSpPr>
-          <p:cNvPr id="2002" name="Stat 1 caption"/>
+          <p:cNvPr id="2003" name="Stat 1 caption"/>
           <p:cNvSpPr txBox="1"/>
           <p:nvPr/>
         </p:nvSpPr>
@@ -29058,7 +29090,7 @@
       </p:sp>
       <p:sp>
         <p:nvSpPr>
-          <p:cNvPr id="2003" name="Stat 2 label"/>
+          <p:cNvPr id="2004" name="Stat 2 label"/>
           <p:cNvSpPr txBox="1"/>
           <p:nvPr/>
         </p:nvSpPr>
@@ -29109,7 +29141,7 @@
       </p:sp>
       <p:sp>
         <p:nvSpPr>
-          <p:cNvPr id="2004" name="Stat 2 value"/>
+          <p:cNvPr id="2005" name="Stat 2 value"/>
           <p:cNvSpPr txBox="1"/>
           <p:nvPr/>
         </p:nvSpPr>
@@ -29160,7 +29192,7 @@
       </p:sp>
       <p:sp>
         <p:nvSpPr>
-          <p:cNvPr id="2005" name="Stat 2 caption"/>
+          <p:cNvPr id="2006" name="Stat 2 caption"/>
           <p:cNvSpPr txBox="1"/>
           <p:nvPr/>
         </p:nvSpPr>
@@ -29211,7 +29243,7 @@
       </p:sp>
       <p:sp>
         <p:nvSpPr>
-          <p:cNvPr id="2006" name="Stat 3 label"/>
+          <p:cNvPr id="2007" name="Stat 3 label"/>
           <p:cNvSpPr txBox="1"/>
           <p:nvPr/>
         </p:nvSpPr>
@@ -29262,7 +29294,7 @@
       </p:sp>
       <p:sp>
         <p:nvSpPr>
-          <p:cNvPr id="2007" name="Stat 3 value"/>
+          <p:cNvPr id="2008" name="Stat 3 value"/>
           <p:cNvSpPr txBox="1"/>
           <p:nvPr/>
         </p:nvSpPr>
@@ -29313,7 +29345,7 @@
       </p:sp>
       <p:sp>
         <p:nvSpPr>
-          <p:cNvPr id="2008" name="Stat 3 caption"/>
+          <p:cNvPr id="2009" name="Stat 3 caption"/>
           <p:cNvSpPr txBox="1"/>
           <p:nvPr/>
         </p:nvSpPr>
@@ -29364,7 +29396,7 @@
       </p:sp>
       <p:cxnSp>
         <p:nvCxnSpPr>
-          <p:cNvPr id="2009" name="Divider"/>
+          <p:cNvPr id="2010" name="Divider"/>
           <p:cNvCxnSpPr/>
           <p:nvPr/>
         </p:nvCxnSpPr>
@@ -29385,7 +29417,7 @@
       </p:cxnSp>
       <p:sp>
         <p:nvSpPr>
-          <p:cNvPr id="2010" name="Flow heading"/>
+          <p:cNvPr id="2011" name="Flow heading"/>
           <p:cNvSpPr txBox="1"/>
           <p:nvPr/>
         </p:nvSpPr>
@@ -29436,7 +29468,7 @@
       </p:sp>
       <p:sp>
         <p:nvSpPr>
-          <p:cNvPr id="2011" name="Economy 1"/>
+          <p:cNvPr id="2012" name="Economy 1"/>
           <p:cNvSpPr/>
           <p:nvPr/>
         </p:nvSpPr>
@@ -29514,7 +29546,7 @@
       </p:sp>
       <p:sp>
         <p:nvSpPr>
-          <p:cNvPr id="2012" name="Economy 2"/>
+          <p:cNvPr id="2013" name="Economy 2"/>
           <p:cNvSpPr/>
           <p:nvPr/>
         </p:nvSpPr>
@@ -29592,7 +29624,7 @@
       </p:sp>
       <p:cxnSp>
         <p:nvCxnSpPr>
-          <p:cNvPr id="2013" name="Arrow: components to China"/>
+          <p:cNvPr id="2014" name="Arrow: components to China"/>
           <p:cNvCxnSpPr/>
           <p:nvPr/>
         </p:nvCxnSpPr>
@@ -29614,7 +29646,7 @@
       </p:cxnSp>
       <p:sp>
         <p:nvSpPr>
-          <p:cNvPr id="2014" name="Label: components"/>
+          <p:cNvPr id="2015" name="Label: components"/>
           <p:cNvSpPr txBox="1"/>
           <p:nvPr/>
         </p:nvSpPr>
@@ -29665,7 +29697,7 @@
       </p:sp>
       <p:cxnSp>
         <p:nvCxnSpPr>
-          <p:cNvPr id="2015" name="Arrow: market access to Korea"/>
+          <p:cNvPr id="2016" name="Arrow: market access to Korea"/>
           <p:cNvCxnSpPr/>
           <p:nvPr/>
         </p:nvCxnSpPr>
@@ -29687,7 +29719,7 @@
       </p:cxnSp>
       <p:sp>
         <p:nvSpPr>
-          <p:cNvPr id="2016" name="Label: market access"/>
+          <p:cNvPr id="2017" name="Label: market access"/>
           <p:cNvSpPr txBox="1"/>
           <p:nvPr/>
         </p:nvSpPr>
@@ -29738,7 +29770,7 @@
       </p:sp>
       <p:sp>
         <p:nvSpPr>
-          <p:cNvPr id="2017" name="Transition line"/>
+          <p:cNvPr id="2018" name="Transition line"/>
           <p:cNvSpPr txBox="1"/>
           <p:nvPr/>
         </p:nvSpPr>

</xml_diff>

<commit_message>
Add slides 4-5: Korea's memory chip lead and China's rise
Co-Authored-By: Claude Opus 5.5 <noreply@anthropic.com>
Claude-Session: https://claude.ai/code/session_01EAqNWxuCBt8vBHk7fm7zMv
</commit_message>
<xml_diff>
--- a/korea-china-trade.pptx
+++ b/korea-china-trade.pptx
@@ -12,6 +12,8 @@
     <p:sldId id="256" r:id="rId7"/>
     <p:sldId id="263" r:id="rId14"/>
     <p:sldId id="266" r:id="rId17"/>
+    <p:sldId id="264" r:id="rId15"/>
+    <p:sldId id="286" r:id="rId37"/>
   </p:sldIdLst>
   <p:sldSz cx="12192000" cy="6858000"/>
   <p:notesSz cx="6858000" cy="9144000"/>
@@ -317,6 +319,164 @@
     </a:lvl9pPr>
   </p:defaultTextStyle>
 </p:presentation>
+</file>
+
+<file path=ppt/charts/chart_techgap.xml><?xml version="1.0" encoding="utf-8"?>
+<c:chartSpace xmlns:c="http://schemas.openxmlformats.org/drawingml/2006/chart" xmlns:a="http://schemas.openxmlformats.org/drawingml/2006/main" xmlns:r="http://schemas.openxmlformats.org/officeDocument/2006/relationships">
+  <c:date1904 val="0"/>
+  <c:chart>
+    <c:autoTitleDeleted val="1"/>
+    <c:plotArea>
+      <c:barChart>
+        <c:barDir val="bar"/>
+        <c:grouping val="clustered"/>
+        <c:varyColors val="0"/>
+        <c:ser>
+          <c:idx val="0"/>
+          <c:order val="0"/>
+          <c:tx>
+            <c:strRef>
+              <c:f>Sheet1!$B$1</c:f>
+              <c:strCache>
+                <c:ptCount val="1"/>
+                <c:pt idx="0">
+                  <c:v>Years China trails South Korea</c:v>
+                </c:pt>
+              </c:strCache>
+            </c:strRef>
+          </c:tx>
+          <c:spPr>
+            <a:solidFill>
+              <a:schemeClr val="accent2"/>
+            </a:solidFill>
+          </c:spPr>
+          <c:cat>
+            <c:strRef>
+              <c:f>Sheet1!$A$2:$A$4</c:f>
+              <c:strCache>
+                <c:ptCount val="3"/>
+                <c:pt idx="0">
+                  <c:v>DRAM</c:v>
+                </c:pt>
+                <c:pt idx="1">
+                  <c:v>HBM</c:v>
+                </c:pt>
+                <c:pt idx="2">
+                  <c:v>NAND flash</c:v>
+                </c:pt>
+              </c:strCache>
+            </c:strRef>
+          </c:cat>
+          <c:val>
+            <c:numRef>
+              <c:f>Sheet1!$B$2:$B$4</c:f>
+              <c:numCache>
+                <c:formatCode>[=1]0" year";0" years"</c:formatCode>
+                <c:ptCount val="3"/>
+                <c:pt idx="0">
+                  <c:v>2</c:v>
+                </c:pt>
+                <c:pt idx="1">
+                  <c:v>3</c:v>
+                </c:pt>
+                <c:pt idx="2">
+                  <c:v>1</c:v>
+                </c:pt>
+              </c:numCache>
+            </c:numRef>
+          </c:val>
+        </c:ser>
+        <c:dLbls>
+          <c:numFmt formatCode="[=1]0&quot; year&quot;;0&quot; years&quot;" sourceLinked="0"/>
+          <c:txPr>
+            <a:bodyPr wrap="none"/>
+            <a:lstStyle/>
+            <a:p>
+              <a:pPr>
+                <a:defRPr sz="2000" b="1"/>
+              </a:pPr>
+            </a:p>
+          </c:txPr>
+          <c:dLblPos val="outEnd"/>
+          <c:showLegendKey val="0"/>
+          <c:showVal val="1"/>
+          <c:showCatName val="0"/>
+          <c:showSerName val="0"/>
+          <c:showPercent val="0"/>
+          <c:showBubbleSize val="0"/>
+          <c:showLeaderLines val="1"/>
+        </c:dLbls>
+        <c:gapWidth val="55"/>
+        <c:axId val="-2068027336"/>
+        <c:axId val="-2113994440"/>
+      </c:barChart>
+      <c:catAx>
+        <c:axId val="-2068027336"/>
+        <c:scaling>
+          <c:orientation val="maxMin"/>
+        </c:scaling>
+        <c:delete val="0"/>
+        <c:axPos val="l"/>
+        <c:majorTickMark val="out"/>
+        <c:minorTickMark val="none"/>
+        <c:tickLblPos val="nextTo"/>
+        <c:spPr>
+          <a:ln>
+            <a:noFill/>
+          </a:ln>
+        </c:spPr>
+        <c:txPr>
+          <a:bodyPr/>
+          <a:lstStyle/>
+          <a:p>
+            <a:pPr>
+              <a:defRPr sz="2000"/>
+            </a:pPr>
+          </a:p>
+        </c:txPr>
+        <c:crossAx val="-2113994440"/>
+        <c:crosses val="autoZero"/>
+        <c:auto val="1"/>
+        <c:lblAlgn val="ctr"/>
+        <c:lblOffset val="100"/>
+        <c:noMultiLvlLbl val="0"/>
+      </c:catAx>
+      <c:valAx>
+        <c:axId val="-2113994440"/>
+        <c:scaling>
+          <c:max val="4.4"/>
+          <c:min val="0.0"/>
+        </c:scaling>
+        <c:delete/>
+        <c:axPos val="b"/>
+        <c:majorTickMark val="out"/>
+        <c:minorTickMark val="none"/>
+        <c:tickLblPos val="nextTo"/>
+        <c:crossAx val="-2068027336"/>
+        <c:crosses val="autoZero"/>
+      </c:valAx>
+    </c:plotArea>
+    <c:dispBlanksAs val="gap"/>
+  </c:chart>
+  <c:txPr>
+    <a:bodyPr/>
+    <a:lstStyle/>
+    <a:p>
+      <a:pPr>
+        <a:defRPr sz="1800">
+          <a:solidFill>
+            <a:schemeClr val="tx1"/>
+          </a:solidFill>
+          <a:latin typeface="+mn-lt"/>
+        </a:defRPr>
+      </a:pPr>
+      <a:endParaRPr lang="en-US"/>
+    </a:p>
+  </c:txPr>
+  <c:externalData r:id="rId1">
+    <c:autoUpdate val="0"/>
+  </c:externalData>
+</c:chartSpace>
 </file>
 
 <file path=ppt/notesMasters/notesMaster1.xml><?xml version="1.0" encoding="utf-8"?>
@@ -943,6 +1103,105 @@
 </p:notes>
 </file>
 
+<file path=ppt/notesSlides/notesSlide31.xml><?xml version="1.0" encoding="utf-8"?>
+<p:notes xmlns:a="http://schemas.openxmlformats.org/drawingml/2006/main" xmlns:r="http://schemas.openxmlformats.org/officeDocument/2006/relationships" xmlns:mc="http://schemas.openxmlformats.org/markup-compatibility/2006" xmlns:mv="urn:schemas-microsoft-com:mac:vml" xmlns:p="http://schemas.openxmlformats.org/presentationml/2006/main" xmlns:c="http://schemas.openxmlformats.org/drawingml/2006/chart" xmlns:dgm="http://schemas.openxmlformats.org/drawingml/2006/diagram" xmlns:o="urn:schemas-microsoft-com:office:office" xmlns:v="urn:schemas-microsoft-com:vml" xmlns:pvml="urn:schemas-microsoft-com:office:powerpoint" xmlns:com="http://schemas.openxmlformats.org/drawingml/2006/compatibility" xmlns:p14="http://schemas.microsoft.com/office/powerpoint/2010/main" xmlns:p15="http://schemas.microsoft.com/office/powerpoint/2012/main" xmlns:ahyp="http://schemas.microsoft.com/office/drawing/2018/hyperlinkcolor" showMasterPhAnim="0" showMasterSp="0">
+  <p:cSld>
+    <p:spTree>
+      <p:nvGrpSpPr>
+        <p:cNvPr id="714" name="Shape 714"/>
+        <p:cNvGrpSpPr/>
+        <p:nvPr/>
+      </p:nvGrpSpPr>
+      <p:grpSpPr>
+        <a:xfrm>
+          <a:off x="0" y="0"/>
+          <a:ext cx="0" cy="0"/>
+          <a:chOff x="0" y="0"/>
+          <a:chExt cx="0" cy="0"/>
+        </a:xfrm>
+      </p:grpSpPr>
+      <p:sp>
+        <p:nvSpPr>
+          <p:cNvPr id="715" name="Google Shape;715;g29a3c2a2d37_0_18089:notes"/>
+          <p:cNvSpPr/>
+          <p:nvPr>
+            <p:ph idx="2" type="sldImg"/>
+          </p:nvPr>
+        </p:nvSpPr>
+        <p:spPr>
+          <a:xfrm>
+            <a:off x="381300" y="685800"/>
+            <a:ext cx="6096000" cy="3429000"/>
+          </a:xfrm>
+          <a:custGeom>
+            <a:rect b="b" l="l" r="r" t="t"/>
+            <a:pathLst>
+              <a:path extrusionOk="0" h="120000" w="120000">
+                <a:moveTo>
+                  <a:pt x="0" y="0"/>
+                </a:moveTo>
+                <a:lnTo>
+                  <a:pt x="120000" y="0"/>
+                </a:lnTo>
+                <a:lnTo>
+                  <a:pt x="120000" y="120000"/>
+                </a:lnTo>
+                <a:lnTo>
+                  <a:pt x="0" y="120000"/>
+                </a:lnTo>
+                <a:close/>
+              </a:path>
+            </a:pathLst>
+          </a:custGeom>
+        </p:spPr>
+      </p:sp>
+      <p:sp>
+        <p:nvSpPr>
+          <p:cNvPr id="716" name="Google Shape;716;g29a3c2a2d37_0_18089:notes"/>
+          <p:cNvSpPr txBox="1"/>
+          <p:nvPr>
+            <p:ph idx="1" type="body"/>
+          </p:nvPr>
+        </p:nvSpPr>
+        <p:spPr>
+          <a:xfrm>
+            <a:off x="685800" y="4343400"/>
+            <a:ext cx="5486400" cy="4114800"/>
+          </a:xfrm>
+          <a:prstGeom prst="rect">
+            <a:avLst/>
+          </a:prstGeom>
+        </p:spPr>
+        <p:txBody>
+          <a:bodyPr anchorCtr="0" anchor="t" bIns="91425" lIns="91425" spcFirstLastPara="1" rIns="91425" wrap="square" tIns="91425">
+            <a:noAutofit/>
+          </a:bodyPr>
+          <a:lstStyle/>
+          <a:p>
+            <a:pPr indent="0" lvl="0" marL="0" rtl="0" algn="l">
+              <a:spcBef>
+                <a:spcPts val="0"/>
+              </a:spcBef>
+              <a:spcAft>
+                <a:spcPts val="0"/>
+              </a:spcAft>
+              <a:buNone/>
+            </a:pPr>
+            <a:r>
+              <a:t/>
+            </a:r>
+            <a:endParaRPr/>
+          </a:p>
+        </p:txBody>
+      </p:sp>
+    </p:spTree>
+  </p:cSld>
+  <p:clrMapOvr>
+    <a:masterClrMapping/>
+  </p:clrMapOvr>
+</p:notes>
+</file>
+
 <file path=ppt/notesSlides/notesSlide8.xml><?xml version="1.0" encoding="utf-8"?>
 <p:notes xmlns:a="http://schemas.openxmlformats.org/drawingml/2006/main" xmlns:r="http://schemas.openxmlformats.org/officeDocument/2006/relationships" xmlns:mc="http://schemas.openxmlformats.org/markup-compatibility/2006" xmlns:mv="urn:schemas-microsoft-com:mac:vml" xmlns:p="http://schemas.openxmlformats.org/presentationml/2006/main" xmlns:c="http://schemas.openxmlformats.org/drawingml/2006/chart" xmlns:dgm="http://schemas.openxmlformats.org/drawingml/2006/diagram" xmlns:o="urn:schemas-microsoft-com:office:office" xmlns:v="urn:schemas-microsoft-com:vml" xmlns:pvml="urn:schemas-microsoft-com:office:powerpoint" xmlns:com="http://schemas.openxmlformats.org/drawingml/2006/compatibility" xmlns:p14="http://schemas.microsoft.com/office/powerpoint/2010/main" xmlns:p15="http://schemas.microsoft.com/office/powerpoint/2012/main" xmlns:ahyp="http://schemas.microsoft.com/office/drawing/2018/hyperlinkcolor" showMasterPhAnim="0" showMasterSp="0">
   <p:cSld>
@@ -998,6 +1257,105 @@
       <p:sp>
         <p:nvSpPr>
           <p:cNvPr id="392" name="Google Shape;392;g29a3c2a2d37_0_55:notes"/>
+          <p:cNvSpPr txBox="1"/>
+          <p:nvPr>
+            <p:ph idx="1" type="body"/>
+          </p:nvPr>
+        </p:nvSpPr>
+        <p:spPr>
+          <a:xfrm>
+            <a:off x="685800" y="4343400"/>
+            <a:ext cx="5486400" cy="4114800"/>
+          </a:xfrm>
+          <a:prstGeom prst="rect">
+            <a:avLst/>
+          </a:prstGeom>
+        </p:spPr>
+        <p:txBody>
+          <a:bodyPr anchorCtr="0" anchor="t" bIns="91425" lIns="91425" spcFirstLastPara="1" rIns="91425" wrap="square" tIns="91425">
+            <a:noAutofit/>
+          </a:bodyPr>
+          <a:lstStyle/>
+          <a:p>
+            <a:pPr indent="0" lvl="0" marL="0" rtl="0" algn="l">
+              <a:spcBef>
+                <a:spcPts val="0"/>
+              </a:spcBef>
+              <a:spcAft>
+                <a:spcPts val="0"/>
+              </a:spcAft>
+              <a:buNone/>
+            </a:pPr>
+            <a:r>
+              <a:t/>
+            </a:r>
+            <a:endParaRPr/>
+          </a:p>
+        </p:txBody>
+      </p:sp>
+    </p:spTree>
+  </p:cSld>
+  <p:clrMapOvr>
+    <a:masterClrMapping/>
+  </p:clrMapOvr>
+</p:notes>
+</file>
+
+<file path=ppt/notesSlides/notesSlide9.xml><?xml version="1.0" encoding="utf-8"?>
+<p:notes xmlns:a="http://schemas.openxmlformats.org/drawingml/2006/main" xmlns:r="http://schemas.openxmlformats.org/officeDocument/2006/relationships" xmlns:mc="http://schemas.openxmlformats.org/markup-compatibility/2006" xmlns:mv="urn:schemas-microsoft-com:mac:vml" xmlns:p="http://schemas.openxmlformats.org/presentationml/2006/main" xmlns:c="http://schemas.openxmlformats.org/drawingml/2006/chart" xmlns:dgm="http://schemas.openxmlformats.org/drawingml/2006/diagram" xmlns:o="urn:schemas-microsoft-com:office:office" xmlns:v="urn:schemas-microsoft-com:vml" xmlns:pvml="urn:schemas-microsoft-com:office:powerpoint" xmlns:com="http://schemas.openxmlformats.org/drawingml/2006/compatibility" xmlns:p14="http://schemas.microsoft.com/office/powerpoint/2010/main" xmlns:p15="http://schemas.microsoft.com/office/powerpoint/2012/main" xmlns:ahyp="http://schemas.microsoft.com/office/drawing/2018/hyperlinkcolor" showMasterPhAnim="0" showMasterSp="0">
+  <p:cSld>
+    <p:spTree>
+      <p:nvGrpSpPr>
+        <p:cNvPr id="399" name="Shape 399"/>
+        <p:cNvGrpSpPr/>
+        <p:nvPr/>
+      </p:nvGrpSpPr>
+      <p:grpSpPr>
+        <a:xfrm>
+          <a:off x="0" y="0"/>
+          <a:ext cx="0" cy="0"/>
+          <a:chOff x="0" y="0"/>
+          <a:chExt cx="0" cy="0"/>
+        </a:xfrm>
+      </p:grpSpPr>
+      <p:sp>
+        <p:nvSpPr>
+          <p:cNvPr id="400" name="Google Shape;400;g29a3c2a2d37_0_88:notes"/>
+          <p:cNvSpPr/>
+          <p:nvPr>
+            <p:ph idx="2" type="sldImg"/>
+          </p:nvPr>
+        </p:nvSpPr>
+        <p:spPr>
+          <a:xfrm>
+            <a:off x="381300" y="685800"/>
+            <a:ext cx="6096000" cy="3429000"/>
+          </a:xfrm>
+          <a:custGeom>
+            <a:rect b="b" l="l" r="r" t="t"/>
+            <a:pathLst>
+              <a:path extrusionOk="0" h="120000" w="120000">
+                <a:moveTo>
+                  <a:pt x="0" y="0"/>
+                </a:moveTo>
+                <a:lnTo>
+                  <a:pt x="120000" y="0"/>
+                </a:lnTo>
+                <a:lnTo>
+                  <a:pt x="120000" y="120000"/>
+                </a:lnTo>
+                <a:lnTo>
+                  <a:pt x="0" y="120000"/>
+                </a:lnTo>
+                <a:close/>
+              </a:path>
+            </a:pathLst>
+          </a:custGeom>
+        </p:spPr>
+      </p:sp>
+      <p:sp>
+        <p:nvSpPr>
+          <p:cNvPr id="401" name="Google Shape;401;g29a3c2a2d37_0_88:notes"/>
           <p:cNvSpPr txBox="1"/>
           <p:nvPr>
             <p:ph idx="1" type="body"/>
@@ -28856,6 +29214,728 @@
 </p:sld>
 </file>
 
+<file path=ppt/slides/slide31.xml><?xml version="1.0" encoding="utf-8"?>
+<p:sld xmlns:a="http://schemas.openxmlformats.org/drawingml/2006/main" xmlns:r="http://schemas.openxmlformats.org/officeDocument/2006/relationships" xmlns:mc="http://schemas.openxmlformats.org/markup-compatibility/2006" xmlns:mv="urn:schemas-microsoft-com:mac:vml" xmlns:p="http://schemas.openxmlformats.org/presentationml/2006/main" xmlns:c="http://schemas.openxmlformats.org/drawingml/2006/chart" xmlns:dgm="http://schemas.openxmlformats.org/drawingml/2006/diagram" xmlns:o="urn:schemas-microsoft-com:office:office" xmlns:v="urn:schemas-microsoft-com:vml" xmlns:pvml="urn:schemas-microsoft-com:office:powerpoint" xmlns:com="http://schemas.openxmlformats.org/drawingml/2006/compatibility" xmlns:p14="http://schemas.microsoft.com/office/powerpoint/2010/main" xmlns:p15="http://schemas.microsoft.com/office/powerpoint/2012/main" xmlns:ahyp="http://schemas.microsoft.com/office/drawing/2018/hyperlinkcolor">
+  <p:cSld>
+    <p:spTree>
+      <p:nvGrpSpPr>
+        <p:cNvPr id="717" name="Shape 717"/>
+        <p:cNvGrpSpPr/>
+        <p:nvPr/>
+      </p:nvGrpSpPr>
+      <p:grpSpPr>
+        <a:xfrm>
+          <a:off x="0" y="0"/>
+          <a:ext cx="0" cy="0"/>
+          <a:chOff x="0" y="0"/>
+          <a:chExt cx="0" cy="0"/>
+        </a:xfrm>
+      </p:grpSpPr>
+      <p:sp>
+        <p:nvSpPr>
+          <p:cNvPr id="2061" name="Title band"/>
+          <p:cNvSpPr/>
+          <p:nvPr/>
+        </p:nvSpPr>
+        <p:spPr>
+          <a:xfrm>
+            <a:off x="0" y="274320"/>
+            <a:ext cx="11338560" cy="960120"/>
+          </a:xfrm>
+          <a:prstGeom prst="rect">
+            <a:avLst/>
+          </a:prstGeom>
+          <a:solidFill>
+            <a:schemeClr val="accent2"/>
+          </a:solidFill>
+          <a:ln>
+            <a:noFill/>
+          </a:ln>
+        </p:spPr>
+        <p:txBody>
+          <a:bodyPr wrap="square" lIns="0" tIns="0" rIns="0" bIns="0" anchor="t" rtlCol="0">
+            <a:noAutofit/>
+          </a:bodyPr>
+          <a:lstStyle/>
+          <a:p>
+            <a:endParaRPr lang="en-US"/>
+          </a:p>
+        </p:txBody>
+      </p:sp>
+      <p:sp>
+        <p:nvSpPr>
+          <p:cNvPr id="718" name="Google Shape;718;p69"/>
+          <p:cNvSpPr txBox="1"/>
+          <p:nvPr>
+            <p:ph type="title"/>
+          </p:nvPr>
+        </p:nvSpPr>
+        <p:spPr>
+          <a:xfrm>
+            <a:off x="950976" y="274320"/>
+            <a:ext cx="10149840" cy="960120"/>
+          </a:xfrm>
+        </p:spPr>
+        <p:txBody>
+          <a:bodyPr anchorCtr="0" bIns="121900" lIns="121900" spcFirstLastPara="1" rIns="121900" wrap="square" tIns="121900" anchor="ctr">
+            <a:noAutofit/>
+          </a:bodyPr>
+          <a:lstStyle/>
+          <a:p>
+            <a:r>
+              <a:rPr lang="en-US" sz="3600" dirty="0">
+                <a:solidFill>
+                  <a:schemeClr val="lt1"/>
+                </a:solidFill>
+              </a:rPr>
+              <a:t>China's Rise in Memory Chips</a:t>
+            </a:r>
+          </a:p>
+        </p:txBody>
+      </p:sp>
+      <p:sp>
+        <p:nvSpPr>
+          <p:cNvPr id="2062" name="CXMT heading"/>
+          <p:cNvSpPr txBox="1"/>
+          <p:nvPr/>
+        </p:nvSpPr>
+        <p:spPr>
+          <a:xfrm>
+            <a:off x="950976" y="1572768"/>
+            <a:ext cx="4434840" cy="384048"/>
+          </a:xfrm>
+          <a:prstGeom prst="rect">
+            <a:avLst/>
+          </a:prstGeom>
+          <a:noFill/>
+          <a:ln>
+            <a:noFill/>
+          </a:ln>
+        </p:spPr>
+        <p:txBody>
+          <a:bodyPr wrap="square" lIns="0" tIns="0" rIns="0" bIns="0" anchor="t" rtlCol="0">
+            <a:noAutofit/>
+          </a:bodyPr>
+          <a:lstStyle/>
+          <a:p>
+            <a:pPr marL="0" indent="0" algn="l">
+              <a:lnSpc>
+                <a:spcPct val="100000"/>
+              </a:lnSpc>
+              <a:spcBef>
+                <a:spcPts val="0"/>
+              </a:spcBef>
+              <a:spcAft>
+                <a:spcPts val="0"/>
+              </a:spcAft>
+              <a:buNone/>
+            </a:pPr>
+            <a:r>
+              <a:rPr lang="en-US" sz="2000" b="1" dirty="0">
+                <a:solidFill>
+                  <a:schemeClr val="dk2"/>
+                </a:solidFill>
+                <a:latin typeface="+mn-lt"/>
+                <a:ea typeface="+mn-lt"/>
+                <a:cs typeface="+mn-lt"/>
+              </a:rPr>
+              <a:t>CXMT</a:t>
+            </a:r>
+          </a:p>
+        </p:txBody>
+      </p:sp>
+      <p:sp>
+        <p:nvSpPr>
+          <p:cNvPr id="2063" name="CXMT intro"/>
+          <p:cNvSpPr txBox="1"/>
+          <p:nvPr/>
+        </p:nvSpPr>
+        <p:spPr>
+          <a:xfrm>
+            <a:off x="950976" y="1938528"/>
+            <a:ext cx="4434840" cy="685800"/>
+          </a:xfrm>
+          <a:prstGeom prst="rect">
+            <a:avLst/>
+          </a:prstGeom>
+          <a:noFill/>
+          <a:ln>
+            <a:noFill/>
+          </a:ln>
+        </p:spPr>
+        <p:txBody>
+          <a:bodyPr wrap="square" lIns="0" tIns="0" rIns="0" bIns="0" anchor="t" rtlCol="0">
+            <a:noAutofit/>
+          </a:bodyPr>
+          <a:lstStyle/>
+          <a:p>
+            <a:pPr marL="0" indent="0" algn="l">
+              <a:lnSpc>
+                <a:spcPct val="100000"/>
+              </a:lnSpc>
+              <a:spcBef>
+                <a:spcPts val="0"/>
+              </a:spcBef>
+              <a:spcAft>
+                <a:spcPts val="0"/>
+              </a:spcAft>
+              <a:buNone/>
+            </a:pPr>
+            <a:r>
+              <a:rPr lang="en-US" sz="1800" b="0" dirty="0">
+                <a:solidFill>
+                  <a:schemeClr val="dk1"/>
+                </a:solidFill>
+                <a:latin typeface="+mn-lt"/>
+                <a:ea typeface="+mn-lt"/>
+                <a:cs typeface="+mn-lt"/>
+              </a:rPr>
+              <a:t>ChangXin Memory Technologies: Chinese memory maker, founded 2016</a:t>
+            </a:r>
+          </a:p>
+        </p:txBody>
+      </p:sp>
+      <p:sp>
+        <p:nvSpPr>
+          <p:cNvPr id="2064" name="Share before"/>
+          <p:cNvSpPr txBox="1"/>
+          <p:nvPr/>
+        </p:nvSpPr>
+        <p:spPr>
+          <a:xfrm>
+            <a:off x="950976" y="2697480"/>
+            <a:ext cx="1463040" cy="868680"/>
+          </a:xfrm>
+          <a:prstGeom prst="rect">
+            <a:avLst/>
+          </a:prstGeom>
+          <a:noFill/>
+          <a:ln>
+            <a:noFill/>
+          </a:ln>
+        </p:spPr>
+        <p:txBody>
+          <a:bodyPr wrap="square" lIns="0" tIns="0" rIns="0" bIns="0" anchor="ctr" rtlCol="0">
+            <a:noAutofit/>
+          </a:bodyPr>
+          <a:lstStyle/>
+          <a:p>
+            <a:pPr marL="0" indent="0" algn="l">
+              <a:lnSpc>
+                <a:spcPct val="100000"/>
+              </a:lnSpc>
+              <a:spcBef>
+                <a:spcPts val="0"/>
+              </a:spcBef>
+              <a:spcAft>
+                <a:spcPts val="0"/>
+              </a:spcAft>
+              <a:buNone/>
+            </a:pPr>
+            <a:r>
+              <a:rPr lang="en-US" sz="5400" b="0" dirty="0">
+                <a:solidFill>
+                  <a:schemeClr val="accent4"/>
+                </a:solidFill>
+                <a:latin typeface="+mj-lt"/>
+                <a:ea typeface="+mj-lt"/>
+                <a:cs typeface="+mj-lt"/>
+              </a:rPr>
+              <a:t>4%</a:t>
+            </a:r>
+          </a:p>
+        </p:txBody>
+      </p:sp>
+      <p:cxnSp>
+        <p:nvCxnSpPr>
+          <p:cNvPr id="2065" name="Share arrow"/>
+          <p:cNvCxnSpPr/>
+          <p:nvPr/>
+        </p:nvCxnSpPr>
+        <p:spPr>
+          <a:xfrm>
+            <a:off x="2368296" y="3131820"/>
+            <a:ext cx="822960" cy="0"/>
+          </a:xfrm>
+          <a:prstGeom prst="straightConnector1">
+            <a:avLst/>
+          </a:prstGeom>
+          <a:ln w="22225">
+            <a:solidFill>
+              <a:schemeClr val="dk1"/>
+            </a:solidFill>
+            <a:tailEnd type="triangle" w="med" len="med"/>
+          </a:ln>
+        </p:spPr>
+      </p:cxnSp>
+      <p:sp>
+        <p:nvSpPr>
+          <p:cNvPr id="2066" name="Share after"/>
+          <p:cNvSpPr txBox="1"/>
+          <p:nvPr/>
+        </p:nvSpPr>
+        <p:spPr>
+          <a:xfrm>
+            <a:off x="3328416" y="2697480"/>
+            <a:ext cx="2011680" cy="868680"/>
+          </a:xfrm>
+          <a:prstGeom prst="rect">
+            <a:avLst/>
+          </a:prstGeom>
+          <a:noFill/>
+          <a:ln>
+            <a:noFill/>
+          </a:ln>
+        </p:spPr>
+        <p:txBody>
+          <a:bodyPr wrap="square" lIns="0" tIns="0" rIns="0" bIns="0" anchor="ctr" rtlCol="0">
+            <a:noAutofit/>
+          </a:bodyPr>
+          <a:lstStyle/>
+          <a:p>
+            <a:pPr marL="0" indent="0" algn="l">
+              <a:lnSpc>
+                <a:spcPct val="100000"/>
+              </a:lnSpc>
+              <a:spcBef>
+                <a:spcPts val="0"/>
+              </a:spcBef>
+              <a:spcAft>
+                <a:spcPts val="0"/>
+              </a:spcAft>
+              <a:buNone/>
+            </a:pPr>
+            <a:r>
+              <a:rPr lang="en-US" sz="5400" b="0" dirty="0">
+                <a:solidFill>
+                  <a:schemeClr val="accent2"/>
+                </a:solidFill>
+                <a:latin typeface="+mj-lt"/>
+                <a:ea typeface="+mj-lt"/>
+                <a:cs typeface="+mj-lt"/>
+              </a:rPr>
+              <a:t>10%</a:t>
+            </a:r>
+          </a:p>
+        </p:txBody>
+      </p:sp>
+      <p:sp>
+        <p:nvSpPr>
+          <p:cNvPr id="2067" name="Share label"/>
+          <p:cNvSpPr txBox="1"/>
+          <p:nvPr/>
+        </p:nvSpPr>
+        <p:spPr>
+          <a:xfrm>
+            <a:off x="950976" y="3584448"/>
+            <a:ext cx="4434840" cy="384048"/>
+          </a:xfrm>
+          <a:prstGeom prst="rect">
+            <a:avLst/>
+          </a:prstGeom>
+          <a:noFill/>
+          <a:ln>
+            <a:noFill/>
+          </a:ln>
+        </p:spPr>
+        <p:txBody>
+          <a:bodyPr wrap="square" lIns="0" tIns="0" rIns="0" bIns="0" anchor="t" rtlCol="0">
+            <a:noAutofit/>
+          </a:bodyPr>
+          <a:lstStyle/>
+          <a:p>
+            <a:pPr marL="0" indent="0" algn="l">
+              <a:lnSpc>
+                <a:spcPct val="100000"/>
+              </a:lnSpc>
+              <a:spcBef>
+                <a:spcPts val="0"/>
+              </a:spcBef>
+              <a:spcAft>
+                <a:spcPts val="0"/>
+              </a:spcAft>
+              <a:buNone/>
+            </a:pPr>
+            <a:r>
+              <a:rPr lang="en-US" sz="1800" b="1" dirty="0">
+                <a:solidFill>
+                  <a:schemeClr val="dk1"/>
+                </a:solidFill>
+                <a:latin typeface="+mn-lt"/>
+                <a:ea typeface="+mn-lt"/>
+                <a:cs typeface="+mn-lt"/>
+              </a:rPr>
+              <a:t>Global DRAM share, over the past year</a:t>
+            </a:r>
+          </a:p>
+        </p:txBody>
+      </p:sp>
+      <p:sp>
+        <p:nvSpPr>
+          <p:cNvPr id="2068" name="Rank value"/>
+          <p:cNvSpPr txBox="1"/>
+          <p:nvPr/>
+        </p:nvSpPr>
+        <p:spPr>
+          <a:xfrm>
+            <a:off x="950976" y="4160520"/>
+            <a:ext cx="1143000" cy="777240"/>
+          </a:xfrm>
+          <a:prstGeom prst="rect">
+            <a:avLst/>
+          </a:prstGeom>
+          <a:noFill/>
+          <a:ln>
+            <a:noFill/>
+          </a:ln>
+        </p:spPr>
+        <p:txBody>
+          <a:bodyPr wrap="square" lIns="0" tIns="0" rIns="0" bIns="0" anchor="ctr" rtlCol="0">
+            <a:noAutofit/>
+          </a:bodyPr>
+          <a:lstStyle/>
+          <a:p>
+            <a:pPr marL="0" indent="0" algn="l">
+              <a:lnSpc>
+                <a:spcPct val="100000"/>
+              </a:lnSpc>
+              <a:spcBef>
+                <a:spcPts val="0"/>
+              </a:spcBef>
+              <a:spcAft>
+                <a:spcPts val="0"/>
+              </a:spcAft>
+              <a:buNone/>
+            </a:pPr>
+            <a:r>
+              <a:rPr lang="en-US" sz="4400" b="0" dirty="0">
+                <a:solidFill>
+                  <a:schemeClr val="dk2"/>
+                </a:solidFill>
+                <a:latin typeface="+mj-lt"/>
+                <a:ea typeface="+mj-lt"/>
+                <a:cs typeface="+mj-lt"/>
+              </a:rPr>
+              <a:t>#4</a:t>
+            </a:r>
+          </a:p>
+        </p:txBody>
+      </p:sp>
+      <p:sp>
+        <p:nvSpPr>
+          <p:cNvPr id="2069" name="Rank text"/>
+          <p:cNvSpPr txBox="1"/>
+          <p:nvPr/>
+        </p:nvSpPr>
+        <p:spPr>
+          <a:xfrm>
+            <a:off x="2139696" y="4114800"/>
+            <a:ext cx="3246120" cy="868680"/>
+          </a:xfrm>
+          <a:prstGeom prst="rect">
+            <a:avLst/>
+          </a:prstGeom>
+          <a:noFill/>
+          <a:ln>
+            <a:noFill/>
+          </a:ln>
+        </p:spPr>
+        <p:txBody>
+          <a:bodyPr wrap="square" lIns="0" tIns="0" rIns="0" bIns="0" anchor="ctr" rtlCol="0">
+            <a:noAutofit/>
+          </a:bodyPr>
+          <a:lstStyle/>
+          <a:p>
+            <a:pPr marL="0" indent="0" algn="l">
+              <a:lnSpc>
+                <a:spcPct val="100000"/>
+              </a:lnSpc>
+              <a:spcBef>
+                <a:spcPts val="0"/>
+              </a:spcBef>
+              <a:spcAft>
+                <a:spcPts val="0"/>
+              </a:spcAft>
+              <a:buNone/>
+            </a:pPr>
+            <a:r>
+              <a:rPr lang="en-US" sz="1800" b="0" dirty="0">
+                <a:solidFill>
+                  <a:schemeClr val="dk1"/>
+                </a:solidFill>
+                <a:latin typeface="+mn-lt"/>
+                <a:ea typeface="+mn-lt"/>
+                <a:cs typeface="+mn-lt"/>
+              </a:rPr>
+              <a:t>in DRAM worldwide, behind Samsung, SK Hynix and Micron (US)</a:t>
+            </a:r>
+          </a:p>
+        </p:txBody>
+      </p:sp>
+      <p:cxnSp>
+        <p:nvCxnSpPr>
+          <p:cNvPr id="2071" name="Column divider"/>
+          <p:cNvCxnSpPr/>
+          <p:nvPr/>
+        </p:nvCxnSpPr>
+        <p:spPr>
+          <a:xfrm>
+            <a:off x="5669280" y="1645920"/>
+            <a:ext cx="0" cy="3429000"/>
+          </a:xfrm>
+          <a:prstGeom prst="line">
+            <a:avLst/>
+          </a:prstGeom>
+          <a:ln w="9525">
+            <a:solidFill>
+              <a:schemeClr val="accent4"/>
+            </a:solidFill>
+          </a:ln>
+        </p:spPr>
+      </p:cxnSp>
+      <p:sp>
+        <p:nvSpPr>
+          <p:cNvPr id="2072" name="Gap heading"/>
+          <p:cNvSpPr txBox="1"/>
+          <p:nvPr/>
+        </p:nvSpPr>
+        <p:spPr>
+          <a:xfrm>
+            <a:off x="5989320" y="1572768"/>
+            <a:ext cx="5257800" cy="384048"/>
+          </a:xfrm>
+          <a:prstGeom prst="rect">
+            <a:avLst/>
+          </a:prstGeom>
+          <a:noFill/>
+          <a:ln>
+            <a:noFill/>
+          </a:ln>
+        </p:spPr>
+        <p:txBody>
+          <a:bodyPr wrap="square" lIns="0" tIns="0" rIns="0" bIns="0" anchor="t" rtlCol="0">
+            <a:noAutofit/>
+          </a:bodyPr>
+          <a:lstStyle/>
+          <a:p>
+            <a:pPr marL="0" indent="0" algn="l">
+              <a:lnSpc>
+                <a:spcPct val="100000"/>
+              </a:lnSpc>
+              <a:spcBef>
+                <a:spcPts val="0"/>
+              </a:spcBef>
+              <a:spcAft>
+                <a:spcPts val="0"/>
+              </a:spcAft>
+              <a:buNone/>
+            </a:pPr>
+            <a:r>
+              <a:rPr lang="en-US" sz="2000" b="1" dirty="0">
+                <a:solidFill>
+                  <a:schemeClr val="dk2"/>
+                </a:solidFill>
+                <a:latin typeface="+mn-lt"/>
+                <a:ea typeface="+mn-lt"/>
+                <a:cs typeface="+mn-lt"/>
+              </a:rPr>
+              <a:t>Korea still leads: years China trails</a:t>
+            </a:r>
+          </a:p>
+        </p:txBody>
+      </p:sp>
+      <p:graphicFrame>
+        <p:nvGraphicFramePr>
+          <p:cNvPr id="2076" name="Technology gap chart"/>
+          <p:cNvGraphicFramePr>
+            <a:graphicFrameLocks noGrp="1"/>
+          </p:cNvGraphicFramePr>
+          <p:nvPr/>
+        </p:nvGraphicFramePr>
+        <p:xfrm>
+          <a:off x="5897880" y="2011680"/>
+          <a:ext cx="5440680" cy="2514600"/>
+        </p:xfrm>
+        <a:graphic>
+          <a:graphicData uri="http://schemas.openxmlformats.org/drawingml/2006/chart">
+            <c:chart xmlns:c="http://schemas.openxmlformats.org/drawingml/2006/chart" r:id="rIdTechGap"/>
+          </a:graphicData>
+        </a:graphic>
+      </p:graphicFrame>
+      <p:sp>
+        <p:nvSpPr>
+          <p:cNvPr id="2073" name="Gap source"/>
+          <p:cNvSpPr txBox="1"/>
+          <p:nvPr/>
+        </p:nvSpPr>
+        <p:spPr>
+          <a:xfrm>
+            <a:off x="5989320" y="4526280"/>
+            <a:ext cx="5257800" cy="566928"/>
+          </a:xfrm>
+          <a:prstGeom prst="rect">
+            <a:avLst/>
+          </a:prstGeom>
+          <a:noFill/>
+          <a:ln>
+            <a:noFill/>
+          </a:ln>
+        </p:spPr>
+        <p:txBody>
+          <a:bodyPr wrap="square" lIns="0" tIns="0" rIns="0" bIns="0" anchor="t" rtlCol="0">
+            <a:noAutofit/>
+          </a:bodyPr>
+          <a:lstStyle/>
+          <a:p>
+            <a:pPr marL="0" indent="0" algn="l">
+              <a:lnSpc>
+                <a:spcPct val="100000"/>
+              </a:lnSpc>
+              <a:spcBef>
+                <a:spcPts val="0"/>
+              </a:spcBef>
+              <a:spcAft>
+                <a:spcPts val="0"/>
+              </a:spcAft>
+              <a:buNone/>
+            </a:pPr>
+            <a:r>
+              <a:rPr lang="en-US" sz="1400" b="0" dirty="0">
+                <a:solidFill>
+                  <a:schemeClr val="accent3"/>
+                </a:solidFill>
+                <a:latin typeface="+mn-lt"/>
+                <a:ea typeface="+mn-lt"/>
+                <a:cs typeface="+mn-lt"/>
+              </a:rPr>
+              <a:t>Source: Korea Semiconductor Industry Association, Sept 2026. NAND flash = long-term data storage</a:t>
+            </a:r>
+          </a:p>
+        </p:txBody>
+      </p:sp>
+      <p:sp>
+        <p:nvSpPr>
+          <p:cNvPr id="2074" name="Takeaway banner"/>
+          <p:cNvSpPr/>
+          <p:nvPr/>
+        </p:nvSpPr>
+        <p:spPr>
+          <a:xfrm>
+            <a:off x="950976" y="5349240"/>
+            <a:ext cx="10296144" cy="685800"/>
+          </a:xfrm>
+          <a:prstGeom prst="rect">
+            <a:avLst/>
+          </a:prstGeom>
+          <a:solidFill>
+            <a:schemeClr val="accent2"/>
+          </a:solidFill>
+          <a:ln>
+            <a:noFill/>
+          </a:ln>
+        </p:spPr>
+        <p:txBody>
+          <a:bodyPr wrap="square" lIns="91440" tIns="91440" rIns="91440" bIns="91440" anchor="ctr" rtlCol="0">
+            <a:noAutofit/>
+          </a:bodyPr>
+          <a:lstStyle/>
+          <a:p>
+            <a:pPr marL="0" indent="0" algn="ctr">
+              <a:lnSpc>
+                <a:spcPct val="100000"/>
+              </a:lnSpc>
+              <a:spcBef>
+                <a:spcPts val="0"/>
+              </a:spcBef>
+              <a:spcAft>
+                <a:spcPts val="0"/>
+              </a:spcAft>
+              <a:buNone/>
+            </a:pPr>
+            <a:r>
+              <a:rPr lang="en-US" sz="2000" b="1" dirty="0">
+                <a:solidFill>
+                  <a:schemeClr val="lt1"/>
+                </a:solidFill>
+                <a:latin typeface="+mn-lt"/>
+                <a:ea typeface="+mn-lt"/>
+                <a:cs typeface="+mn-lt"/>
+              </a:rPr>
+              <a:t>From customer to competitor, </a:t>
+            </a:r>
+            <a:r>
+              <a:rPr lang="en-US" sz="2000" b="0" dirty="0">
+                <a:solidFill>
+                  <a:schemeClr val="lt1"/>
+                </a:solidFill>
+                <a:latin typeface="+mn-lt"/>
+                <a:ea typeface="+mn-lt"/>
+                <a:cs typeface="+mn-lt"/>
+              </a:rPr>
+              <a:t>yet still deeply interconnected</a:t>
+            </a:r>
+          </a:p>
+        </p:txBody>
+      </p:sp>
+      <p:sp>
+        <p:nvSpPr>
+          <p:cNvPr id="2075" name="Next topic"/>
+          <p:cNvSpPr txBox="1"/>
+          <p:nvPr/>
+        </p:nvSpPr>
+        <p:spPr>
+          <a:xfrm>
+            <a:off x="3931920" y="6172200"/>
+            <a:ext cx="7315200" cy="320040"/>
+          </a:xfrm>
+          <a:prstGeom prst="rect">
+            <a:avLst/>
+          </a:prstGeom>
+          <a:noFill/>
+          <a:ln>
+            <a:noFill/>
+          </a:ln>
+        </p:spPr>
+        <p:txBody>
+          <a:bodyPr wrap="square" lIns="0" tIns="0" rIns="0" bIns="0" anchor="t" rtlCol="0">
+            <a:noAutofit/>
+          </a:bodyPr>
+          <a:lstStyle/>
+          <a:p>
+            <a:pPr marL="0" indent="0" algn="r">
+              <a:lnSpc>
+                <a:spcPct val="100000"/>
+              </a:lnSpc>
+              <a:spcBef>
+                <a:spcPts val="0"/>
+              </a:spcBef>
+              <a:spcAft>
+                <a:spcPts val="0"/>
+              </a:spcAft>
+              <a:buNone/>
+            </a:pPr>
+            <a:r>
+              <a:rPr lang="en-US" sz="1400" b="0" i="1" dirty="0">
+                <a:solidFill>
+                  <a:schemeClr val="accent3"/>
+                </a:solidFill>
+                <a:latin typeface="+mn-lt"/>
+                <a:ea typeface="+mn-lt"/>
+                <a:cs typeface="+mn-lt"/>
+              </a:rPr>
+              <a:t>Next: the impact on South Korea's semiconductor industry and economy</a:t>
+            </a:r>
+          </a:p>
+        </p:txBody>
+      </p:sp>
+    </p:spTree>
+  </p:cSld>
+  <p:clrMapOvr>
+    <a:masterClrMapping/>
+  </p:clrMapOvr>
+</p:sld>
+</file>
+
 <file path=ppt/slides/slide8.xml><?xml version="1.0" encoding="utf-8"?>
 <p:sld xmlns:a="http://schemas.openxmlformats.org/drawingml/2006/main" xmlns:r="http://schemas.openxmlformats.org/officeDocument/2006/relationships" xmlns:mc="http://schemas.openxmlformats.org/markup-compatibility/2006" xmlns:mv="urn:schemas-microsoft-com:mac:vml" xmlns:p="http://schemas.openxmlformats.org/presentationml/2006/main" xmlns:c="http://schemas.openxmlformats.org/drawingml/2006/chart" xmlns:dgm="http://schemas.openxmlformats.org/drawingml/2006/diagram" xmlns:o="urn:schemas-microsoft-com:office:office" xmlns:v="urn:schemas-microsoft-com:vml" xmlns:pvml="urn:schemas-microsoft-com:office:powerpoint" xmlns:com="http://schemas.openxmlformats.org/drawingml/2006/compatibility" xmlns:p14="http://schemas.microsoft.com/office/powerpoint/2010/main" xmlns:p15="http://schemas.microsoft.com/office/powerpoint/2012/main" xmlns:ahyp="http://schemas.microsoft.com/office/drawing/2018/hyperlinkcolor">
   <p:cSld>
@@ -29815,6 +30895,963 @@
                 <a:cs typeface="+mn-lt"/>
               </a:rPr>
               <a:t>China's own industrial capabilities have expanded, and the relationship is evolving</a:t>
+            </a:r>
+          </a:p>
+        </p:txBody>
+      </p:sp>
+    </p:spTree>
+  </p:cSld>
+  <p:clrMapOvr>
+    <a:masterClrMapping/>
+  </p:clrMapOvr>
+</p:sld>
+</file>
+
+<file path=ppt/slides/slide9.xml><?xml version="1.0" encoding="utf-8"?>
+<p:sld xmlns:a="http://schemas.openxmlformats.org/drawingml/2006/main" xmlns:r="http://schemas.openxmlformats.org/officeDocument/2006/relationships" xmlns:mc="http://schemas.openxmlformats.org/markup-compatibility/2006" xmlns:mv="urn:schemas-microsoft-com:mac:vml" xmlns:p="http://schemas.openxmlformats.org/presentationml/2006/main" xmlns:c="http://schemas.openxmlformats.org/drawingml/2006/chart" xmlns:dgm="http://schemas.openxmlformats.org/drawingml/2006/diagram" xmlns:o="urn:schemas-microsoft-com:office:office" xmlns:v="urn:schemas-microsoft-com:vml" xmlns:pvml="urn:schemas-microsoft-com:office:powerpoint" xmlns:com="http://schemas.openxmlformats.org/drawingml/2006/compatibility" xmlns:p14="http://schemas.microsoft.com/office/powerpoint/2010/main" xmlns:p15="http://schemas.microsoft.com/office/powerpoint/2012/main" xmlns:ahyp="http://schemas.microsoft.com/office/drawing/2018/hyperlinkcolor">
+  <p:cSld>
+    <p:spTree>
+      <p:nvGrpSpPr>
+        <p:cNvPr id="402" name="Shape 402"/>
+        <p:cNvGrpSpPr/>
+        <p:nvPr/>
+      </p:nvGrpSpPr>
+      <p:grpSpPr>
+        <a:xfrm>
+          <a:off x="0" y="0"/>
+          <a:ext cx="0" cy="0"/>
+          <a:chOff x="0" y="0"/>
+          <a:chExt cx="0" cy="0"/>
+        </a:xfrm>
+      </p:grpSpPr>
+      <p:sp>
+        <p:nvSpPr>
+          <p:cNvPr id="2041" name="Title band"/>
+          <p:cNvSpPr/>
+          <p:nvPr/>
+        </p:nvSpPr>
+        <p:spPr>
+          <a:xfrm>
+            <a:off x="0" y="274320"/>
+            <a:ext cx="12191695" cy="960120"/>
+          </a:xfrm>
+          <a:prstGeom prst="rect">
+            <a:avLst/>
+          </a:prstGeom>
+          <a:solidFill>
+            <a:schemeClr val="accent2"/>
+          </a:solidFill>
+          <a:ln>
+            <a:noFill/>
+          </a:ln>
+        </p:spPr>
+        <p:txBody>
+          <a:bodyPr wrap="square" lIns="0" tIns="0" rIns="0" bIns="0" anchor="t" rtlCol="0">
+            <a:noAutofit/>
+          </a:bodyPr>
+          <a:lstStyle/>
+          <a:p>
+            <a:endParaRPr lang="en-US"/>
+          </a:p>
+        </p:txBody>
+      </p:sp>
+      <p:sp>
+        <p:nvSpPr>
+          <p:cNvPr id="404" name="Google Shape;404;p47"/>
+          <p:cNvSpPr txBox="1"/>
+          <p:nvPr>
+            <p:ph type="title"/>
+          </p:nvPr>
+        </p:nvSpPr>
+        <p:spPr>
+          <a:xfrm>
+            <a:off x="950976" y="274320"/>
+            <a:ext cx="10149840" cy="960120"/>
+          </a:xfrm>
+        </p:spPr>
+        <p:txBody>
+          <a:bodyPr anchorCtr="0" bIns="121900" lIns="121900" spcFirstLastPara="1" rIns="121900" wrap="square" tIns="121900" anchor="ctr">
+            <a:noAutofit/>
+          </a:bodyPr>
+          <a:lstStyle/>
+          <a:p>
+            <a:r>
+              <a:rPr lang="en-US" sz="3600" dirty="0">
+                <a:solidFill>
+                  <a:schemeClr val="lt1"/>
+                </a:solidFill>
+              </a:rPr>
+              <a:t>South Korea: A Global Memory Chip Leader</a:t>
+            </a:r>
+          </a:p>
+        </p:txBody>
+      </p:sp>
+      <p:sp>
+        <p:nvSpPr>
+          <p:cNvPr id="2042" name="Group 1 label"/>
+          <p:cNvSpPr txBox="1"/>
+          <p:nvPr/>
+        </p:nvSpPr>
+        <p:spPr>
+          <a:xfrm>
+            <a:off x="950976" y="1572768"/>
+            <a:ext cx="4965192" cy="384048"/>
+          </a:xfrm>
+          <a:prstGeom prst="rect">
+            <a:avLst/>
+          </a:prstGeom>
+          <a:noFill/>
+          <a:ln>
+            <a:noFill/>
+          </a:ln>
+        </p:spPr>
+        <p:txBody>
+          <a:bodyPr wrap="square" lIns="0" tIns="0" rIns="0" bIns="0" anchor="t" rtlCol="0">
+            <a:noAutofit/>
+          </a:bodyPr>
+          <a:lstStyle/>
+          <a:p>
+            <a:pPr marL="0" indent="0" algn="l">
+              <a:lnSpc>
+                <a:spcPct val="100000"/>
+              </a:lnSpc>
+              <a:spcBef>
+                <a:spcPts val="0"/>
+              </a:spcBef>
+              <a:spcAft>
+                <a:spcPts val="0"/>
+              </a:spcAft>
+              <a:buNone/>
+            </a:pPr>
+            <a:r>
+              <a:rPr lang="en-US" sz="2000" b="1" dirty="0">
+                <a:solidFill>
+                  <a:schemeClr val="dk2"/>
+                </a:solidFill>
+                <a:latin typeface="+mn-lt"/>
+                <a:ea typeface="+mn-lt"/>
+                <a:cs typeface="+mn-lt"/>
+              </a:rPr>
+              <a:t>Samsung + SK Hynix: global share</a:t>
+            </a:r>
+          </a:p>
+        </p:txBody>
+      </p:sp>
+      <p:cxnSp>
+        <p:nvCxnSpPr>
+          <p:cNvPr id="2043" name="Group 1 rule"/>
+          <p:cNvCxnSpPr/>
+          <p:nvPr/>
+        </p:nvCxnSpPr>
+        <p:spPr>
+          <a:xfrm>
+            <a:off x="950976" y="2011680"/>
+            <a:ext cx="4965192" cy="0"/>
+          </a:xfrm>
+          <a:prstGeom prst="straightConnector1">
+            <a:avLst/>
+          </a:prstGeom>
+          <a:ln w="9525">
+            <a:solidFill>
+              <a:schemeClr val="accent4"/>
+            </a:solidFill>
+          </a:ln>
+        </p:spPr>
+      </p:cxnSp>
+      <p:sp>
+        <p:nvSpPr>
+          <p:cNvPr id="2044" name="Group 2 label"/>
+          <p:cNvSpPr txBox="1"/>
+          <p:nvPr/>
+        </p:nvSpPr>
+        <p:spPr>
+          <a:xfrm>
+            <a:off x="6281928" y="1572768"/>
+            <a:ext cx="4965192" cy="384048"/>
+          </a:xfrm>
+          <a:prstGeom prst="rect">
+            <a:avLst/>
+          </a:prstGeom>
+          <a:noFill/>
+          <a:ln>
+            <a:noFill/>
+          </a:ln>
+        </p:spPr>
+        <p:txBody>
+          <a:bodyPr wrap="square" lIns="0" tIns="0" rIns="0" bIns="0" anchor="t" rtlCol="0">
+            <a:noAutofit/>
+          </a:bodyPr>
+          <a:lstStyle/>
+          <a:p>
+            <a:pPr marL="0" indent="0" algn="l">
+              <a:lnSpc>
+                <a:spcPct val="100000"/>
+              </a:lnSpc>
+              <a:spcBef>
+                <a:spcPts val="0"/>
+              </a:spcBef>
+              <a:spcAft>
+                <a:spcPts val="0"/>
+              </a:spcAft>
+              <a:buNone/>
+            </a:pPr>
+            <a:r>
+              <a:rPr lang="en-US" sz="2000" b="1" dirty="0">
+                <a:solidFill>
+                  <a:schemeClr val="dk2"/>
+                </a:solidFill>
+                <a:latin typeface="+mn-lt"/>
+                <a:ea typeface="+mn-lt"/>
+                <a:cs typeface="+mn-lt"/>
+              </a:rPr>
+              <a:t>Weight in Korea's economy</a:t>
+            </a:r>
+          </a:p>
+        </p:txBody>
+      </p:sp>
+      <p:cxnSp>
+        <p:nvCxnSpPr>
+          <p:cNvPr id="2045" name="Group 2 rule"/>
+          <p:cNvCxnSpPr/>
+          <p:nvPr/>
+        </p:nvCxnSpPr>
+        <p:spPr>
+          <a:xfrm>
+            <a:off x="6281928" y="2011680"/>
+            <a:ext cx="4965192" cy="0"/>
+          </a:xfrm>
+          <a:prstGeom prst="straightConnector1">
+            <a:avLst/>
+          </a:prstGeom>
+          <a:ln w="9525">
+            <a:solidFill>
+              <a:schemeClr val="accent4"/>
+            </a:solidFill>
+          </a:ln>
+        </p:spPr>
+      </p:cxnSp>
+      <p:sp>
+        <p:nvSpPr>
+          <p:cNvPr id="2046" name="Stat 1 value"/>
+          <p:cNvSpPr txBox="1"/>
+          <p:nvPr/>
+        </p:nvSpPr>
+        <p:spPr>
+          <a:xfrm>
+            <a:off x="950976" y="2103120"/>
+            <a:ext cx="2299716" cy="914400"/>
+          </a:xfrm>
+          <a:prstGeom prst="rect">
+            <a:avLst/>
+          </a:prstGeom>
+          <a:noFill/>
+          <a:ln>
+            <a:noFill/>
+          </a:ln>
+        </p:spPr>
+        <p:txBody>
+          <a:bodyPr wrap="square" lIns="0" tIns="0" rIns="0" bIns="0" anchor="ctr" rtlCol="0">
+            <a:noAutofit/>
+          </a:bodyPr>
+          <a:lstStyle/>
+          <a:p>
+            <a:pPr marL="0" indent="0" algn="l">
+              <a:lnSpc>
+                <a:spcPct val="100000"/>
+              </a:lnSpc>
+              <a:spcBef>
+                <a:spcPts val="0"/>
+              </a:spcBef>
+              <a:spcAft>
+                <a:spcPts val="0"/>
+              </a:spcAft>
+              <a:buNone/>
+            </a:pPr>
+            <a:r>
+              <a:rPr lang="en-US" sz="6000" b="0" dirty="0">
+                <a:solidFill>
+                  <a:schemeClr val="accent2"/>
+                </a:solidFill>
+                <a:latin typeface="+mj-lt"/>
+                <a:ea typeface="+mj-lt"/>
+                <a:cs typeface="+mj-lt"/>
+              </a:rPr>
+              <a:t>~80%</a:t>
+            </a:r>
+          </a:p>
+        </p:txBody>
+      </p:sp>
+      <p:sp>
+        <p:nvSpPr>
+          <p:cNvPr id="2047" name="Stat 1 label"/>
+          <p:cNvSpPr txBox="1"/>
+          <p:nvPr/>
+        </p:nvSpPr>
+        <p:spPr>
+          <a:xfrm>
+            <a:off x="950976" y="3063240"/>
+            <a:ext cx="2299716" cy="685800"/>
+          </a:xfrm>
+          <a:prstGeom prst="rect">
+            <a:avLst/>
+          </a:prstGeom>
+          <a:noFill/>
+          <a:ln>
+            <a:noFill/>
+          </a:ln>
+        </p:spPr>
+        <p:txBody>
+          <a:bodyPr wrap="square" lIns="0" tIns="0" rIns="0" bIns="0" anchor="t" rtlCol="0">
+            <a:noAutofit/>
+          </a:bodyPr>
+          <a:lstStyle/>
+          <a:p>
+            <a:pPr marL="0" indent="0" algn="l">
+              <a:lnSpc>
+                <a:spcPct val="100000"/>
+              </a:lnSpc>
+              <a:spcBef>
+                <a:spcPts val="0"/>
+              </a:spcBef>
+              <a:spcAft>
+                <a:spcPts val="0"/>
+              </a:spcAft>
+              <a:buNone/>
+            </a:pPr>
+            <a:r>
+              <a:rPr lang="en-US" sz="2000" b="1" dirty="0">
+                <a:solidFill>
+                  <a:schemeClr val="dk1"/>
+                </a:solidFill>
+                <a:latin typeface="+mn-lt"/>
+                <a:ea typeface="+mn-lt"/>
+                <a:cs typeface="+mn-lt"/>
+              </a:rPr>
+              <a:t>of global HBM</a:t>
+            </a:r>
+          </a:p>
+        </p:txBody>
+      </p:sp>
+      <p:sp>
+        <p:nvSpPr>
+          <p:cNvPr id="2048" name="Stat 1 caption"/>
+          <p:cNvSpPr txBox="1"/>
+          <p:nvPr/>
+        </p:nvSpPr>
+        <p:spPr>
+          <a:xfrm>
+            <a:off x="950976" y="3749040"/>
+            <a:ext cx="2299716" cy="777240"/>
+          </a:xfrm>
+          <a:prstGeom prst="rect">
+            <a:avLst/>
+          </a:prstGeom>
+          <a:noFill/>
+          <a:ln>
+            <a:noFill/>
+          </a:ln>
+        </p:spPr>
+        <p:txBody>
+          <a:bodyPr wrap="square" lIns="0" tIns="0" rIns="0" bIns="0" anchor="t" rtlCol="0">
+            <a:noAutofit/>
+          </a:bodyPr>
+          <a:lstStyle/>
+          <a:p>
+            <a:pPr marL="0" indent="0" algn="l">
+              <a:lnSpc>
+                <a:spcPct val="100000"/>
+              </a:lnSpc>
+              <a:spcBef>
+                <a:spcPts val="0"/>
+              </a:spcBef>
+              <a:spcAft>
+                <a:spcPts val="0"/>
+              </a:spcAft>
+              <a:buNone/>
+            </a:pPr>
+            <a:r>
+              <a:rPr lang="en-US" sz="1600" b="0" dirty="0">
+                <a:solidFill>
+                  <a:schemeClr val="accent3"/>
+                </a:solidFill>
+                <a:latin typeface="+mn-lt"/>
+                <a:ea typeface="+mn-lt"/>
+                <a:cs typeface="+mn-lt"/>
+              </a:rPr>
+              <a:t>HBM: high-speed data processing, especially for AI</a:t>
+            </a:r>
+          </a:p>
+        </p:txBody>
+      </p:sp>
+      <p:sp>
+        <p:nvSpPr>
+          <p:cNvPr id="2049" name="Stat 2 value"/>
+          <p:cNvSpPr txBox="1"/>
+          <p:nvPr/>
+        </p:nvSpPr>
+        <p:spPr>
+          <a:xfrm>
+            <a:off x="3616452" y="2103120"/>
+            <a:ext cx="2299716" cy="914400"/>
+          </a:xfrm>
+          <a:prstGeom prst="rect">
+            <a:avLst/>
+          </a:prstGeom>
+          <a:noFill/>
+          <a:ln>
+            <a:noFill/>
+          </a:ln>
+        </p:spPr>
+        <p:txBody>
+          <a:bodyPr wrap="square" lIns="0" tIns="0" rIns="0" bIns="0" anchor="ctr" rtlCol="0">
+            <a:noAutofit/>
+          </a:bodyPr>
+          <a:lstStyle/>
+          <a:p>
+            <a:pPr marL="0" indent="0" algn="l">
+              <a:lnSpc>
+                <a:spcPct val="100000"/>
+              </a:lnSpc>
+              <a:spcBef>
+                <a:spcPts val="0"/>
+              </a:spcBef>
+              <a:spcAft>
+                <a:spcPts val="0"/>
+              </a:spcAft>
+              <a:buNone/>
+            </a:pPr>
+            <a:r>
+              <a:rPr lang="en-US" sz="6000" b="0" dirty="0">
+                <a:solidFill>
+                  <a:schemeClr val="accent2"/>
+                </a:solidFill>
+                <a:latin typeface="+mj-lt"/>
+                <a:ea typeface="+mj-lt"/>
+                <a:cs typeface="+mj-lt"/>
+              </a:rPr>
+              <a:t>60%+</a:t>
+            </a:r>
+          </a:p>
+        </p:txBody>
+      </p:sp>
+      <p:sp>
+        <p:nvSpPr>
+          <p:cNvPr id="2050" name="Stat 2 label"/>
+          <p:cNvSpPr txBox="1"/>
+          <p:nvPr/>
+        </p:nvSpPr>
+        <p:spPr>
+          <a:xfrm>
+            <a:off x="3616452" y="3063240"/>
+            <a:ext cx="2299716" cy="685800"/>
+          </a:xfrm>
+          <a:prstGeom prst="rect">
+            <a:avLst/>
+          </a:prstGeom>
+          <a:noFill/>
+          <a:ln>
+            <a:noFill/>
+          </a:ln>
+        </p:spPr>
+        <p:txBody>
+          <a:bodyPr wrap="square" lIns="0" tIns="0" rIns="0" bIns="0" anchor="t" rtlCol="0">
+            <a:noAutofit/>
+          </a:bodyPr>
+          <a:lstStyle/>
+          <a:p>
+            <a:pPr marL="0" indent="0" algn="l">
+              <a:lnSpc>
+                <a:spcPct val="100000"/>
+              </a:lnSpc>
+              <a:spcBef>
+                <a:spcPts val="0"/>
+              </a:spcBef>
+              <a:spcAft>
+                <a:spcPts val="0"/>
+              </a:spcAft>
+              <a:buNone/>
+            </a:pPr>
+            <a:r>
+              <a:rPr lang="en-US" sz="2000" b="1" dirty="0">
+                <a:solidFill>
+                  <a:schemeClr val="dk1"/>
+                </a:solidFill>
+                <a:latin typeface="+mn-lt"/>
+                <a:ea typeface="+mn-lt"/>
+                <a:cs typeface="+mn-lt"/>
+              </a:rPr>
+              <a:t>of global DRAM</a:t>
+            </a:r>
+          </a:p>
+        </p:txBody>
+      </p:sp>
+      <p:sp>
+        <p:nvSpPr>
+          <p:cNvPr id="2051" name="Stat 2 caption"/>
+          <p:cNvSpPr txBox="1"/>
+          <p:nvPr/>
+        </p:nvSpPr>
+        <p:spPr>
+          <a:xfrm>
+            <a:off x="3616452" y="3749040"/>
+            <a:ext cx="2299716" cy="777240"/>
+          </a:xfrm>
+          <a:prstGeom prst="rect">
+            <a:avLst/>
+          </a:prstGeom>
+          <a:noFill/>
+          <a:ln>
+            <a:noFill/>
+          </a:ln>
+        </p:spPr>
+        <p:txBody>
+          <a:bodyPr wrap="square" lIns="0" tIns="0" rIns="0" bIns="0" anchor="t" rtlCol="0">
+            <a:noAutofit/>
+          </a:bodyPr>
+          <a:lstStyle/>
+          <a:p>
+            <a:pPr marL="0" indent="0" algn="l">
+              <a:lnSpc>
+                <a:spcPct val="100000"/>
+              </a:lnSpc>
+              <a:spcBef>
+                <a:spcPts val="0"/>
+              </a:spcBef>
+              <a:spcAft>
+                <a:spcPts val="0"/>
+              </a:spcAft>
+              <a:buNone/>
+            </a:pPr>
+            <a:r>
+              <a:rPr lang="en-US" sz="1600" b="0" dirty="0">
+                <a:solidFill>
+                  <a:schemeClr val="accent3"/>
+                </a:solidFill>
+                <a:latin typeface="+mn-lt"/>
+                <a:ea typeface="+mn-lt"/>
+                <a:cs typeface="+mn-lt"/>
+              </a:rPr>
+              <a:t>DRAM: temporary data storage</a:t>
+            </a:r>
+          </a:p>
+        </p:txBody>
+      </p:sp>
+      <p:sp>
+        <p:nvSpPr>
+          <p:cNvPr id="2052" name="Stat 3 value"/>
+          <p:cNvSpPr txBox="1"/>
+          <p:nvPr/>
+        </p:nvSpPr>
+        <p:spPr>
+          <a:xfrm>
+            <a:off x="6281928" y="2103120"/>
+            <a:ext cx="2299716" cy="914400"/>
+          </a:xfrm>
+          <a:prstGeom prst="rect">
+            <a:avLst/>
+          </a:prstGeom>
+          <a:noFill/>
+          <a:ln>
+            <a:noFill/>
+          </a:ln>
+        </p:spPr>
+        <p:txBody>
+          <a:bodyPr wrap="square" lIns="0" tIns="0" rIns="0" bIns="0" anchor="ctr" rtlCol="0">
+            <a:noAutofit/>
+          </a:bodyPr>
+          <a:lstStyle/>
+          <a:p>
+            <a:pPr marL="0" indent="0" algn="l">
+              <a:lnSpc>
+                <a:spcPct val="100000"/>
+              </a:lnSpc>
+              <a:spcBef>
+                <a:spcPts val="0"/>
+              </a:spcBef>
+              <a:spcAft>
+                <a:spcPts val="0"/>
+              </a:spcAft>
+              <a:buNone/>
+            </a:pPr>
+            <a:r>
+              <a:rPr lang="en-US" sz="6000" b="0" dirty="0">
+                <a:solidFill>
+                  <a:schemeClr val="accent2"/>
+                </a:solidFill>
+                <a:latin typeface="+mj-lt"/>
+                <a:ea typeface="+mj-lt"/>
+                <a:cs typeface="+mj-lt"/>
+              </a:rPr>
+              <a:t>~48%</a:t>
+            </a:r>
+          </a:p>
+        </p:txBody>
+      </p:sp>
+      <p:sp>
+        <p:nvSpPr>
+          <p:cNvPr id="2053" name="Stat 3 label"/>
+          <p:cNvSpPr txBox="1"/>
+          <p:nvPr/>
+        </p:nvSpPr>
+        <p:spPr>
+          <a:xfrm>
+            <a:off x="6281928" y="3063240"/>
+            <a:ext cx="2299716" cy="685800"/>
+          </a:xfrm>
+          <a:prstGeom prst="rect">
+            <a:avLst/>
+          </a:prstGeom>
+          <a:noFill/>
+          <a:ln>
+            <a:noFill/>
+          </a:ln>
+        </p:spPr>
+        <p:txBody>
+          <a:bodyPr wrap="square" lIns="0" tIns="0" rIns="0" bIns="0" anchor="t" rtlCol="0">
+            <a:noAutofit/>
+          </a:bodyPr>
+          <a:lstStyle/>
+          <a:p>
+            <a:pPr marL="0" indent="0" algn="l">
+              <a:lnSpc>
+                <a:spcPct val="100000"/>
+              </a:lnSpc>
+              <a:spcBef>
+                <a:spcPts val="0"/>
+              </a:spcBef>
+              <a:spcAft>
+                <a:spcPts val="0"/>
+              </a:spcAft>
+              <a:buNone/>
+            </a:pPr>
+            <a:r>
+              <a:rPr lang="en-US" sz="2000" b="1" dirty="0">
+                <a:solidFill>
+                  <a:schemeClr val="dk1"/>
+                </a:solidFill>
+                <a:latin typeface="+mn-lt"/>
+                <a:ea typeface="+mn-lt"/>
+                <a:cs typeface="+mn-lt"/>
+              </a:rPr>
+              <a:t>of Korea's total exports</a:t>
+            </a:r>
+          </a:p>
+        </p:txBody>
+      </p:sp>
+      <p:sp>
+        <p:nvSpPr>
+          <p:cNvPr id="2054" name="Stat 3 caption"/>
+          <p:cNvSpPr txBox="1"/>
+          <p:nvPr/>
+        </p:nvSpPr>
+        <p:spPr>
+          <a:xfrm>
+            <a:off x="6281928" y="3749040"/>
+            <a:ext cx="2299716" cy="777240"/>
+          </a:xfrm>
+          <a:prstGeom prst="rect">
+            <a:avLst/>
+          </a:prstGeom>
+          <a:noFill/>
+          <a:ln>
+            <a:noFill/>
+          </a:ln>
+        </p:spPr>
+        <p:txBody>
+          <a:bodyPr wrap="square" lIns="0" tIns="0" rIns="0" bIns="0" anchor="t" rtlCol="0">
+            <a:noAutofit/>
+          </a:bodyPr>
+          <a:lstStyle/>
+          <a:p>
+            <a:pPr marL="0" indent="0" algn="l">
+              <a:lnSpc>
+                <a:spcPct val="100000"/>
+              </a:lnSpc>
+              <a:spcBef>
+                <a:spcPts val="0"/>
+              </a:spcBef>
+              <a:spcAft>
+                <a:spcPts val="0"/>
+              </a:spcAft>
+              <a:buNone/>
+            </a:pPr>
+            <a:r>
+              <a:rPr lang="en-US" sz="1600" b="0" dirty="0">
+                <a:solidFill>
+                  <a:schemeClr val="accent3"/>
+                </a:solidFill>
+                <a:latin typeface="+mn-lt"/>
+                <a:ea typeface="+mn-lt"/>
+                <a:cs typeface="+mn-lt"/>
+              </a:rPr>
+              <a:t>Semiconductors, first 20 days of September 2026</a:t>
+            </a:r>
+          </a:p>
+        </p:txBody>
+      </p:sp>
+      <p:sp>
+        <p:nvSpPr>
+          <p:cNvPr id="2055" name="Stat 4 value"/>
+          <p:cNvSpPr txBox="1"/>
+          <p:nvPr/>
+        </p:nvSpPr>
+        <p:spPr>
+          <a:xfrm>
+            <a:off x="8947404" y="2103120"/>
+            <a:ext cx="2299716" cy="914400"/>
+          </a:xfrm>
+          <a:prstGeom prst="rect">
+            <a:avLst/>
+          </a:prstGeom>
+          <a:noFill/>
+          <a:ln>
+            <a:noFill/>
+          </a:ln>
+        </p:spPr>
+        <p:txBody>
+          <a:bodyPr wrap="square" lIns="0" tIns="0" rIns="0" bIns="0" anchor="ctr" rtlCol="0">
+            <a:noAutofit/>
+          </a:bodyPr>
+          <a:lstStyle/>
+          <a:p>
+            <a:pPr marL="0" indent="0" algn="l">
+              <a:lnSpc>
+                <a:spcPct val="100000"/>
+              </a:lnSpc>
+              <a:spcBef>
+                <a:spcPts val="0"/>
+              </a:spcBef>
+              <a:spcAft>
+                <a:spcPts val="0"/>
+              </a:spcAft>
+              <a:buNone/>
+            </a:pPr>
+            <a:r>
+              <a:rPr lang="en-US" sz="6000" b="0" dirty="0">
+                <a:solidFill>
+                  <a:schemeClr val="accent2"/>
+                </a:solidFill>
+                <a:latin typeface="+mj-lt"/>
+                <a:ea typeface="+mj-lt"/>
+                <a:cs typeface="+mj-lt"/>
+              </a:rPr>
+              <a:t>~½</a:t>
+            </a:r>
+          </a:p>
+        </p:txBody>
+      </p:sp>
+      <p:sp>
+        <p:nvSpPr>
+          <p:cNvPr id="2056" name="Stat 4 label"/>
+          <p:cNvSpPr txBox="1"/>
+          <p:nvPr/>
+        </p:nvSpPr>
+        <p:spPr>
+          <a:xfrm>
+            <a:off x="8947404" y="3063240"/>
+            <a:ext cx="2299716" cy="685800"/>
+          </a:xfrm>
+          <a:prstGeom prst="rect">
+            <a:avLst/>
+          </a:prstGeom>
+          <a:noFill/>
+          <a:ln>
+            <a:noFill/>
+          </a:ln>
+        </p:spPr>
+        <p:txBody>
+          <a:bodyPr wrap="square" lIns="0" tIns="0" rIns="0" bIns="0" anchor="t" rtlCol="0">
+            <a:noAutofit/>
+          </a:bodyPr>
+          <a:lstStyle/>
+          <a:p>
+            <a:pPr marL="0" indent="0" algn="l">
+              <a:lnSpc>
+                <a:spcPct val="100000"/>
+              </a:lnSpc>
+              <a:spcBef>
+                <a:spcPts val="0"/>
+              </a:spcBef>
+              <a:spcAft>
+                <a:spcPts val="0"/>
+              </a:spcAft>
+              <a:buNone/>
+            </a:pPr>
+            <a:r>
+              <a:rPr lang="en-US" sz="2000" b="1" dirty="0">
+                <a:solidFill>
+                  <a:schemeClr val="dk1"/>
+                </a:solidFill>
+                <a:latin typeface="+mn-lt"/>
+                <a:ea typeface="+mn-lt"/>
+                <a:cs typeface="+mn-lt"/>
+              </a:rPr>
+              <a:t>of KOSPI market cap</a:t>
+            </a:r>
+          </a:p>
+        </p:txBody>
+      </p:sp>
+      <p:sp>
+        <p:nvSpPr>
+          <p:cNvPr id="2057" name="Stat 4 caption"/>
+          <p:cNvSpPr txBox="1"/>
+          <p:nvPr/>
+        </p:nvSpPr>
+        <p:spPr>
+          <a:xfrm>
+            <a:off x="8947404" y="3749040"/>
+            <a:ext cx="2299716" cy="777240"/>
+          </a:xfrm>
+          <a:prstGeom prst="rect">
+            <a:avLst/>
+          </a:prstGeom>
+          <a:noFill/>
+          <a:ln>
+            <a:noFill/>
+          </a:ln>
+        </p:spPr>
+        <p:txBody>
+          <a:bodyPr wrap="square" lIns="0" tIns="0" rIns="0" bIns="0" anchor="t" rtlCol="0">
+            <a:noAutofit/>
+          </a:bodyPr>
+          <a:lstStyle/>
+          <a:p>
+            <a:pPr marL="0" indent="0" algn="l">
+              <a:lnSpc>
+                <a:spcPct val="100000"/>
+              </a:lnSpc>
+              <a:spcBef>
+                <a:spcPts val="0"/>
+              </a:spcBef>
+              <a:spcAft>
+                <a:spcPts val="0"/>
+              </a:spcAft>
+              <a:buNone/>
+            </a:pPr>
+            <a:r>
+              <a:rPr lang="en-US" sz="1600" b="0" dirty="0">
+                <a:solidFill>
+                  <a:schemeClr val="accent3"/>
+                </a:solidFill>
+                <a:latin typeface="+mn-lt"/>
+                <a:ea typeface="+mn-lt"/>
+                <a:cs typeface="+mn-lt"/>
+              </a:rPr>
+              <a:t>Samsung + SK Hynix combined</a:t>
+            </a:r>
+          </a:p>
+        </p:txBody>
+      </p:sp>
+      <p:cxnSp>
+        <p:nvCxnSpPr>
+          <p:cNvPr id="2058" name="Divider"/>
+          <p:cNvCxnSpPr/>
+          <p:nvPr/>
+        </p:nvCxnSpPr>
+        <p:spPr>
+          <a:xfrm>
+            <a:off x="950976" y="4754880"/>
+            <a:ext cx="10296144" cy="0"/>
+          </a:xfrm>
+          <a:prstGeom prst="straightConnector1">
+            <a:avLst/>
+          </a:prstGeom>
+          <a:ln w="9525">
+            <a:solidFill>
+              <a:schemeClr val="accent4"/>
+            </a:solidFill>
+          </a:ln>
+        </p:spPr>
+      </p:cxnSp>
+      <p:sp>
+        <p:nvSpPr>
+          <p:cNvPr id="2059" name="China note marker"/>
+          <p:cNvSpPr/>
+          <p:nvPr/>
+        </p:nvSpPr>
+        <p:spPr>
+          <a:xfrm>
+            <a:off x="950976" y="5056632"/>
+            <a:ext cx="219456" cy="219456"/>
+          </a:xfrm>
+          <a:prstGeom prst="rect">
+            <a:avLst/>
+          </a:prstGeom>
+          <a:solidFill>
+            <a:schemeClr val="dk2"/>
+          </a:solidFill>
+          <a:ln>
+            <a:noFill/>
+          </a:ln>
+        </p:spPr>
+        <p:txBody>
+          <a:bodyPr wrap="square" lIns="0" tIns="0" rIns="0" bIns="0" anchor="t" rtlCol="0">
+            <a:noAutofit/>
+          </a:bodyPr>
+          <a:lstStyle/>
+          <a:p>
+            <a:endParaRPr lang="en-US"/>
+          </a:p>
+        </p:txBody>
+      </p:sp>
+      <p:sp>
+        <p:nvSpPr>
+          <p:cNvPr id="2060" name="China note"/>
+          <p:cNvSpPr txBox="1"/>
+          <p:nvPr/>
+        </p:nvSpPr>
+        <p:spPr>
+          <a:xfrm>
+            <a:off x="1362456" y="4937760"/>
+            <a:ext cx="9884664" cy="914400"/>
+          </a:xfrm>
+          <a:prstGeom prst="rect">
+            <a:avLst/>
+          </a:prstGeom>
+          <a:noFill/>
+          <a:ln>
+            <a:noFill/>
+          </a:ln>
+        </p:spPr>
+        <p:txBody>
+          <a:bodyPr wrap="square" lIns="0" tIns="0" rIns="0" bIns="0" anchor="t" rtlCol="0">
+            <a:noAutofit/>
+          </a:bodyPr>
+          <a:lstStyle/>
+          <a:p>
+            <a:pPr marL="0" indent="0" algn="l">
+              <a:lnSpc>
+                <a:spcPct val="100000"/>
+              </a:lnSpc>
+              <a:spcBef>
+                <a:spcPts val="0"/>
+              </a:spcBef>
+              <a:spcAft>
+                <a:spcPts val="0"/>
+              </a:spcAft>
+              <a:buNone/>
+            </a:pPr>
+            <a:r>
+              <a:rPr lang="en-US" sz="2000" b="1" dirty="0">
+                <a:solidFill>
+                  <a:schemeClr val="accent2"/>
+                </a:solidFill>
+                <a:latin typeface="+mn-lt"/>
+                <a:ea typeface="+mn-lt"/>
+                <a:cs typeface="+mn-lt"/>
+              </a:rPr>
+              <a:t>China remains a major buyer of Korean chips, </a:t>
+            </a:r>
+            <a:r>
+              <a:rPr lang="en-US" sz="2000" b="0" dirty="0">
+                <a:solidFill>
+                  <a:schemeClr val="dk1"/>
+                </a:solidFill>
+                <a:latin typeface="+mn-lt"/>
+                <a:ea typeface="+mn-lt"/>
+                <a:cs typeface="+mn-lt"/>
+              </a:rPr>
+              <a:t>driven by its vast electronics manufacturing and fast-growing AI ecosystem</a:t>
             </a:r>
           </a:p>
         </p:txBody>

</xml_diff>

<commit_message>
Slides 4-5: remove on-slide term definitions
Co-Authored-By: Claude Opus 5.5 <noreply@anthropic.com>
Claude-Session: https://claude.ai/code/session_01EAqNWxuCBt8vBHk7fm7zMv
</commit_message>
<xml_diff>
--- a/korea-china-trade.pptx
+++ b/korea-china-trade.pptx
@@ -29233,7 +29233,7 @@
       </p:grpSpPr>
       <p:sp>
         <p:nvSpPr>
-          <p:cNvPr id="2061" name="Title band"/>
+          <p:cNvPr id="2059" name="Title band"/>
           <p:cNvSpPr/>
           <p:nvPr/>
         </p:nvSpPr>
@@ -29295,7 +29295,7 @@
       </p:sp>
       <p:sp>
         <p:nvSpPr>
-          <p:cNvPr id="2062" name="CXMT heading"/>
+          <p:cNvPr id="2060" name="CXMT heading"/>
           <p:cNvSpPr txBox="1"/>
           <p:nvPr/>
         </p:nvSpPr>
@@ -29346,7 +29346,7 @@
       </p:sp>
       <p:sp>
         <p:nvSpPr>
-          <p:cNvPr id="2063" name="CXMT intro"/>
+          <p:cNvPr id="2061" name="CXMT intro"/>
           <p:cNvSpPr txBox="1"/>
           <p:nvPr/>
         </p:nvSpPr>
@@ -29397,7 +29397,7 @@
       </p:sp>
       <p:sp>
         <p:nvSpPr>
-          <p:cNvPr id="2064" name="Share before"/>
+          <p:cNvPr id="2062" name="Share before"/>
           <p:cNvSpPr txBox="1"/>
           <p:nvPr/>
         </p:nvSpPr>
@@ -29448,7 +29448,7 @@
       </p:sp>
       <p:cxnSp>
         <p:nvCxnSpPr>
-          <p:cNvPr id="2065" name="Share arrow"/>
+          <p:cNvPr id="2063" name="Share arrow"/>
           <p:cNvCxnSpPr/>
           <p:nvPr/>
         </p:nvCxnSpPr>
@@ -29470,7 +29470,7 @@
       </p:cxnSp>
       <p:sp>
         <p:nvSpPr>
-          <p:cNvPr id="2066" name="Share after"/>
+          <p:cNvPr id="2064" name="Share after"/>
           <p:cNvSpPr txBox="1"/>
           <p:nvPr/>
         </p:nvSpPr>
@@ -29521,7 +29521,7 @@
       </p:sp>
       <p:sp>
         <p:nvSpPr>
-          <p:cNvPr id="2067" name="Share label"/>
+          <p:cNvPr id="2065" name="Share label"/>
           <p:cNvSpPr txBox="1"/>
           <p:nvPr/>
         </p:nvSpPr>
@@ -29572,7 +29572,7 @@
       </p:sp>
       <p:sp>
         <p:nvSpPr>
-          <p:cNvPr id="2068" name="Rank value"/>
+          <p:cNvPr id="2066" name="Rank value"/>
           <p:cNvSpPr txBox="1"/>
           <p:nvPr/>
         </p:nvSpPr>
@@ -29623,7 +29623,7 @@
       </p:sp>
       <p:sp>
         <p:nvSpPr>
-          <p:cNvPr id="2069" name="Rank text"/>
+          <p:cNvPr id="2067" name="Rank text"/>
           <p:cNvSpPr txBox="1"/>
           <p:nvPr/>
         </p:nvSpPr>
@@ -29674,7 +29674,7 @@
       </p:sp>
       <p:cxnSp>
         <p:nvCxnSpPr>
-          <p:cNvPr id="2071" name="Column divider"/>
+          <p:cNvPr id="2069" name="Column divider"/>
           <p:cNvCxnSpPr/>
           <p:nvPr/>
         </p:nvCxnSpPr>
@@ -29695,7 +29695,7 @@
       </p:cxnSp>
       <p:sp>
         <p:nvSpPr>
-          <p:cNvPr id="2072" name="Gap heading"/>
+          <p:cNvPr id="2070" name="Gap heading"/>
           <p:cNvSpPr txBox="1"/>
           <p:nvPr/>
         </p:nvSpPr>
@@ -29746,7 +29746,7 @@
       </p:sp>
       <p:graphicFrame>
         <p:nvGraphicFramePr>
-          <p:cNvPr id="2076" name="Technology gap chart"/>
+          <p:cNvPr id="2074" name="Technology gap chart"/>
           <p:cNvGraphicFramePr>
             <a:graphicFrameLocks noGrp="1"/>
           </p:cNvGraphicFramePr>
@@ -29764,7 +29764,7 @@
       </p:graphicFrame>
       <p:sp>
         <p:nvSpPr>
-          <p:cNvPr id="2073" name="Gap source"/>
+          <p:cNvPr id="2071" name="Gap source"/>
           <p:cNvSpPr txBox="1"/>
           <p:nvPr/>
         </p:nvSpPr>
@@ -29808,14 +29808,14 @@
                 <a:ea typeface="+mn-lt"/>
                 <a:cs typeface="+mn-lt"/>
               </a:rPr>
-              <a:t>Source: Korea Semiconductor Industry Association, Sept 2026. NAND flash = long-term data storage</a:t>
+              <a:t>Source: Korea Semiconductor Industry Association, September 2026</a:t>
             </a:r>
           </a:p>
         </p:txBody>
       </p:sp>
       <p:sp>
         <p:nvSpPr>
-          <p:cNvPr id="2074" name="Takeaway banner"/>
+          <p:cNvPr id="2072" name="Takeaway banner"/>
           <p:cNvSpPr/>
           <p:nvPr/>
         </p:nvSpPr>
@@ -29879,7 +29879,7 @@
       </p:sp>
       <p:sp>
         <p:nvSpPr>
-          <p:cNvPr id="2075" name="Next topic"/>
+          <p:cNvPr id="2073" name="Next topic"/>
           <p:cNvSpPr txBox="1"/>
           <p:nvPr/>
         </p:nvSpPr>
@@ -31234,58 +31234,7 @@
       </p:sp>
       <p:sp>
         <p:nvSpPr>
-          <p:cNvPr id="2048" name="Stat 1 caption"/>
-          <p:cNvSpPr txBox="1"/>
-          <p:nvPr/>
-        </p:nvSpPr>
-        <p:spPr>
-          <a:xfrm>
-            <a:off x="950976" y="3749040"/>
-            <a:ext cx="2299716" cy="777240"/>
-          </a:xfrm>
-          <a:prstGeom prst="rect">
-            <a:avLst/>
-          </a:prstGeom>
-          <a:noFill/>
-          <a:ln>
-            <a:noFill/>
-          </a:ln>
-        </p:spPr>
-        <p:txBody>
-          <a:bodyPr wrap="square" lIns="0" tIns="0" rIns="0" bIns="0" anchor="t" rtlCol="0">
-            <a:noAutofit/>
-          </a:bodyPr>
-          <a:lstStyle/>
-          <a:p>
-            <a:pPr marL="0" indent="0" algn="l">
-              <a:lnSpc>
-                <a:spcPct val="100000"/>
-              </a:lnSpc>
-              <a:spcBef>
-                <a:spcPts val="0"/>
-              </a:spcBef>
-              <a:spcAft>
-                <a:spcPts val="0"/>
-              </a:spcAft>
-              <a:buNone/>
-            </a:pPr>
-            <a:r>
-              <a:rPr lang="en-US" sz="1600" b="0" dirty="0">
-                <a:solidFill>
-                  <a:schemeClr val="accent3"/>
-                </a:solidFill>
-                <a:latin typeface="+mn-lt"/>
-                <a:ea typeface="+mn-lt"/>
-                <a:cs typeface="+mn-lt"/>
-              </a:rPr>
-              <a:t>HBM: high-speed data processing, especially for AI</a:t>
-            </a:r>
-          </a:p>
-        </p:txBody>
-      </p:sp>
-      <p:sp>
-        <p:nvSpPr>
-          <p:cNvPr id="2049" name="Stat 2 value"/>
+          <p:cNvPr id="2048" name="Stat 2 value"/>
           <p:cNvSpPr txBox="1"/>
           <p:nvPr/>
         </p:nvSpPr>
@@ -31336,7 +31285,7 @@
       </p:sp>
       <p:sp>
         <p:nvSpPr>
-          <p:cNvPr id="2050" name="Stat 2 label"/>
+          <p:cNvPr id="2049" name="Stat 2 label"/>
           <p:cNvSpPr txBox="1"/>
           <p:nvPr/>
         </p:nvSpPr>
@@ -31387,58 +31336,7 @@
       </p:sp>
       <p:sp>
         <p:nvSpPr>
-          <p:cNvPr id="2051" name="Stat 2 caption"/>
-          <p:cNvSpPr txBox="1"/>
-          <p:nvPr/>
-        </p:nvSpPr>
-        <p:spPr>
-          <a:xfrm>
-            <a:off x="3616452" y="3749040"/>
-            <a:ext cx="2299716" cy="777240"/>
-          </a:xfrm>
-          <a:prstGeom prst="rect">
-            <a:avLst/>
-          </a:prstGeom>
-          <a:noFill/>
-          <a:ln>
-            <a:noFill/>
-          </a:ln>
-        </p:spPr>
-        <p:txBody>
-          <a:bodyPr wrap="square" lIns="0" tIns="0" rIns="0" bIns="0" anchor="t" rtlCol="0">
-            <a:noAutofit/>
-          </a:bodyPr>
-          <a:lstStyle/>
-          <a:p>
-            <a:pPr marL="0" indent="0" algn="l">
-              <a:lnSpc>
-                <a:spcPct val="100000"/>
-              </a:lnSpc>
-              <a:spcBef>
-                <a:spcPts val="0"/>
-              </a:spcBef>
-              <a:spcAft>
-                <a:spcPts val="0"/>
-              </a:spcAft>
-              <a:buNone/>
-            </a:pPr>
-            <a:r>
-              <a:rPr lang="en-US" sz="1600" b="0" dirty="0">
-                <a:solidFill>
-                  <a:schemeClr val="accent3"/>
-                </a:solidFill>
-                <a:latin typeface="+mn-lt"/>
-                <a:ea typeface="+mn-lt"/>
-                <a:cs typeface="+mn-lt"/>
-              </a:rPr>
-              <a:t>DRAM: temporary data storage</a:t>
-            </a:r>
-          </a:p>
-        </p:txBody>
-      </p:sp>
-      <p:sp>
-        <p:nvSpPr>
-          <p:cNvPr id="2052" name="Stat 3 value"/>
+          <p:cNvPr id="2050" name="Stat 3 value"/>
           <p:cNvSpPr txBox="1"/>
           <p:nvPr/>
         </p:nvSpPr>
@@ -31489,7 +31387,7 @@
       </p:sp>
       <p:sp>
         <p:nvSpPr>
-          <p:cNvPr id="2053" name="Stat 3 label"/>
+          <p:cNvPr id="2051" name="Stat 3 label"/>
           <p:cNvSpPr txBox="1"/>
           <p:nvPr/>
         </p:nvSpPr>
@@ -31540,7 +31438,7 @@
       </p:sp>
       <p:sp>
         <p:nvSpPr>
-          <p:cNvPr id="2054" name="Stat 3 caption"/>
+          <p:cNvPr id="2052" name="Stat 3 caption"/>
           <p:cNvSpPr txBox="1"/>
           <p:nvPr/>
         </p:nvSpPr>
@@ -31591,7 +31489,7 @@
       </p:sp>
       <p:sp>
         <p:nvSpPr>
-          <p:cNvPr id="2055" name="Stat 4 value"/>
+          <p:cNvPr id="2053" name="Stat 4 value"/>
           <p:cNvSpPr txBox="1"/>
           <p:nvPr/>
         </p:nvSpPr>
@@ -31642,7 +31540,7 @@
       </p:sp>
       <p:sp>
         <p:nvSpPr>
-          <p:cNvPr id="2056" name="Stat 4 label"/>
+          <p:cNvPr id="2054" name="Stat 4 label"/>
           <p:cNvSpPr txBox="1"/>
           <p:nvPr/>
         </p:nvSpPr>
@@ -31693,7 +31591,7 @@
       </p:sp>
       <p:sp>
         <p:nvSpPr>
-          <p:cNvPr id="2057" name="Stat 4 caption"/>
+          <p:cNvPr id="2055" name="Stat 4 caption"/>
           <p:cNvSpPr txBox="1"/>
           <p:nvPr/>
         </p:nvSpPr>
@@ -31744,7 +31642,7 @@
       </p:sp>
       <p:cxnSp>
         <p:nvCxnSpPr>
-          <p:cNvPr id="2058" name="Divider"/>
+          <p:cNvPr id="2056" name="Divider"/>
           <p:cNvCxnSpPr/>
           <p:nvPr/>
         </p:nvCxnSpPr>
@@ -31765,7 +31663,7 @@
       </p:cxnSp>
       <p:sp>
         <p:nvSpPr>
-          <p:cNvPr id="2059" name="China note marker"/>
+          <p:cNvPr id="2057" name="China note marker"/>
           <p:cNvSpPr/>
           <p:nvPr/>
         </p:nvSpPr>
@@ -31796,7 +31694,7 @@
       </p:sp>
       <p:sp>
         <p:nvSpPr>
-          <p:cNvPr id="2060" name="China note"/>
+          <p:cNvPr id="2058" name="China note"/>
           <p:cNvSpPr txBox="1"/>
           <p:nvPr/>
         </p:nvSpPr>

</xml_diff>

<commit_message>
Slide 5: replace tech-gap bar chart with stat callouts
Co-Authored-By: Claude Opus 5.5 <noreply@anthropic.com>
Claude-Session: https://claude.ai/code/session_01EAqNWxuCBt8vBHk7fm7zMv
</commit_message>
<xml_diff>
--- a/korea-china-trade.pptx
+++ b/korea-china-trade.pptx
@@ -319,164 +319,6 @@
     </a:lvl9pPr>
   </p:defaultTextStyle>
 </p:presentation>
-</file>
-
-<file path=ppt/charts/chart_techgap.xml><?xml version="1.0" encoding="utf-8"?>
-<c:chartSpace xmlns:c="http://schemas.openxmlformats.org/drawingml/2006/chart" xmlns:a="http://schemas.openxmlformats.org/drawingml/2006/main" xmlns:r="http://schemas.openxmlformats.org/officeDocument/2006/relationships">
-  <c:date1904 val="0"/>
-  <c:chart>
-    <c:autoTitleDeleted val="1"/>
-    <c:plotArea>
-      <c:barChart>
-        <c:barDir val="bar"/>
-        <c:grouping val="clustered"/>
-        <c:varyColors val="0"/>
-        <c:ser>
-          <c:idx val="0"/>
-          <c:order val="0"/>
-          <c:tx>
-            <c:strRef>
-              <c:f>Sheet1!$B$1</c:f>
-              <c:strCache>
-                <c:ptCount val="1"/>
-                <c:pt idx="0">
-                  <c:v>Years China trails South Korea</c:v>
-                </c:pt>
-              </c:strCache>
-            </c:strRef>
-          </c:tx>
-          <c:spPr>
-            <a:solidFill>
-              <a:schemeClr val="accent2"/>
-            </a:solidFill>
-          </c:spPr>
-          <c:cat>
-            <c:strRef>
-              <c:f>Sheet1!$A$2:$A$4</c:f>
-              <c:strCache>
-                <c:ptCount val="3"/>
-                <c:pt idx="0">
-                  <c:v>DRAM</c:v>
-                </c:pt>
-                <c:pt idx="1">
-                  <c:v>HBM</c:v>
-                </c:pt>
-                <c:pt idx="2">
-                  <c:v>NAND flash</c:v>
-                </c:pt>
-              </c:strCache>
-            </c:strRef>
-          </c:cat>
-          <c:val>
-            <c:numRef>
-              <c:f>Sheet1!$B$2:$B$4</c:f>
-              <c:numCache>
-                <c:formatCode>[=1]0" year";0" years"</c:formatCode>
-                <c:ptCount val="3"/>
-                <c:pt idx="0">
-                  <c:v>2</c:v>
-                </c:pt>
-                <c:pt idx="1">
-                  <c:v>3</c:v>
-                </c:pt>
-                <c:pt idx="2">
-                  <c:v>1</c:v>
-                </c:pt>
-              </c:numCache>
-            </c:numRef>
-          </c:val>
-        </c:ser>
-        <c:dLbls>
-          <c:numFmt formatCode="[=1]0&quot; year&quot;;0&quot; years&quot;" sourceLinked="0"/>
-          <c:txPr>
-            <a:bodyPr wrap="none"/>
-            <a:lstStyle/>
-            <a:p>
-              <a:pPr>
-                <a:defRPr sz="2000" b="1"/>
-              </a:pPr>
-            </a:p>
-          </c:txPr>
-          <c:dLblPos val="outEnd"/>
-          <c:showLegendKey val="0"/>
-          <c:showVal val="1"/>
-          <c:showCatName val="0"/>
-          <c:showSerName val="0"/>
-          <c:showPercent val="0"/>
-          <c:showBubbleSize val="0"/>
-          <c:showLeaderLines val="1"/>
-        </c:dLbls>
-        <c:gapWidth val="55"/>
-        <c:axId val="-2068027336"/>
-        <c:axId val="-2113994440"/>
-      </c:barChart>
-      <c:catAx>
-        <c:axId val="-2068027336"/>
-        <c:scaling>
-          <c:orientation val="maxMin"/>
-        </c:scaling>
-        <c:delete val="0"/>
-        <c:axPos val="l"/>
-        <c:majorTickMark val="out"/>
-        <c:minorTickMark val="none"/>
-        <c:tickLblPos val="nextTo"/>
-        <c:spPr>
-          <a:ln>
-            <a:noFill/>
-          </a:ln>
-        </c:spPr>
-        <c:txPr>
-          <a:bodyPr/>
-          <a:lstStyle/>
-          <a:p>
-            <a:pPr>
-              <a:defRPr sz="2000"/>
-            </a:pPr>
-          </a:p>
-        </c:txPr>
-        <c:crossAx val="-2113994440"/>
-        <c:crosses val="autoZero"/>
-        <c:auto val="1"/>
-        <c:lblAlgn val="ctr"/>
-        <c:lblOffset val="100"/>
-        <c:noMultiLvlLbl val="0"/>
-      </c:catAx>
-      <c:valAx>
-        <c:axId val="-2113994440"/>
-        <c:scaling>
-          <c:max val="4.4"/>
-          <c:min val="0.0"/>
-        </c:scaling>
-        <c:delete/>
-        <c:axPos val="b"/>
-        <c:majorTickMark val="out"/>
-        <c:minorTickMark val="none"/>
-        <c:tickLblPos val="nextTo"/>
-        <c:crossAx val="-2068027336"/>
-        <c:crosses val="autoZero"/>
-      </c:valAx>
-    </c:plotArea>
-    <c:dispBlanksAs val="gap"/>
-  </c:chart>
-  <c:txPr>
-    <a:bodyPr/>
-    <a:lstStyle/>
-    <a:p>
-      <a:pPr>
-        <a:defRPr sz="1800">
-          <a:solidFill>
-            <a:schemeClr val="tx1"/>
-          </a:solidFill>
-          <a:latin typeface="+mn-lt"/>
-        </a:defRPr>
-      </a:pPr>
-      <a:endParaRPr lang="en-US"/>
-    </a:p>
-  </c:txPr>
-  <c:externalData r:id="rId1">
-    <c:autoUpdate val="0"/>
-  </c:externalData>
-</c:chartSpace>
 </file>
 
 <file path=ppt/notesMasters/notesMaster1.xml><?xml version="1.0" encoding="utf-8"?>
@@ -29744,27 +29586,357 @@
           </a:p>
         </p:txBody>
       </p:sp>
-      <p:graphicFrame>
-        <p:nvGraphicFramePr>
-          <p:cNvPr id="2074" name="Technology gap chart"/>
-          <p:cNvGraphicFramePr>
-            <a:graphicFrameLocks noGrp="1"/>
-          </p:cNvGraphicFramePr>
-          <p:nvPr/>
-        </p:nvGraphicFramePr>
-        <p:xfrm>
-          <a:off x="5897880" y="2011680"/>
-          <a:ext cx="5440680" cy="2514600"/>
-        </p:xfrm>
-        <a:graphic>
-          <a:graphicData uri="http://schemas.openxmlformats.org/drawingml/2006/chart">
-            <c:chart xmlns:c="http://schemas.openxmlformats.org/drawingml/2006/chart" r:id="rIdTechGap"/>
-          </a:graphicData>
-        </a:graphic>
-      </p:graphicFrame>
       <p:sp>
         <p:nvSpPr>
-          <p:cNvPr id="2071" name="Gap source"/>
+          <p:cNvPr id="2071" name="Gap 1 value"/>
+          <p:cNvSpPr txBox="1"/>
+          <p:nvPr/>
+        </p:nvSpPr>
+        <p:spPr>
+          <a:xfrm>
+            <a:off x="5989320" y="2103120"/>
+            <a:ext cx="2103120" cy="685800"/>
+          </a:xfrm>
+          <a:prstGeom prst="rect">
+            <a:avLst/>
+          </a:prstGeom>
+          <a:noFill/>
+          <a:ln>
+            <a:noFill/>
+          </a:ln>
+        </p:spPr>
+        <p:txBody>
+          <a:bodyPr wrap="square" lIns="0" tIns="0" rIns="0" bIns="0" anchor="ctr" rtlCol="0">
+            <a:noAutofit/>
+          </a:bodyPr>
+          <a:lstStyle/>
+          <a:p>
+            <a:pPr marL="0" indent="0" algn="l">
+              <a:lnSpc>
+                <a:spcPct val="100000"/>
+              </a:lnSpc>
+              <a:spcBef>
+                <a:spcPts val="0"/>
+              </a:spcBef>
+              <a:spcAft>
+                <a:spcPts val="0"/>
+              </a:spcAft>
+              <a:buNone/>
+            </a:pPr>
+            <a:r>
+              <a:rPr lang="en-US" sz="4000" b="0" dirty="0">
+                <a:solidFill>
+                  <a:schemeClr val="accent2"/>
+                </a:solidFill>
+                <a:latin typeface="+mj-lt"/>
+                <a:ea typeface="+mj-lt"/>
+                <a:cs typeface="+mj-lt"/>
+              </a:rPr>
+              <a:t>2 years</a:t>
+            </a:r>
+          </a:p>
+        </p:txBody>
+      </p:sp>
+      <p:sp>
+        <p:nvSpPr>
+          <p:cNvPr id="2072" name="Gap 1 label"/>
+          <p:cNvSpPr txBox="1"/>
+          <p:nvPr/>
+        </p:nvSpPr>
+        <p:spPr>
+          <a:xfrm>
+            <a:off x="8229600" y="2103120"/>
+            <a:ext cx="3017520" cy="685800"/>
+          </a:xfrm>
+          <a:prstGeom prst="rect">
+            <a:avLst/>
+          </a:prstGeom>
+          <a:noFill/>
+          <a:ln>
+            <a:noFill/>
+          </a:ln>
+        </p:spPr>
+        <p:txBody>
+          <a:bodyPr wrap="square" lIns="0" tIns="0" rIns="0" bIns="0" anchor="ctr" rtlCol="0">
+            <a:noAutofit/>
+          </a:bodyPr>
+          <a:lstStyle/>
+          <a:p>
+            <a:pPr marL="0" indent="0" algn="l">
+              <a:lnSpc>
+                <a:spcPct val="100000"/>
+              </a:lnSpc>
+              <a:spcBef>
+                <a:spcPts val="0"/>
+              </a:spcBef>
+              <a:spcAft>
+                <a:spcPts val="0"/>
+              </a:spcAft>
+              <a:buNone/>
+            </a:pPr>
+            <a:r>
+              <a:rPr lang="en-US" sz="2000" b="0" dirty="0">
+                <a:solidFill>
+                  <a:schemeClr val="dk1"/>
+                </a:solidFill>
+                <a:latin typeface="+mn-lt"/>
+                <a:ea typeface="+mn-lt"/>
+                <a:cs typeface="+mn-lt"/>
+              </a:rPr>
+              <a:t>behind in DRAM</a:t>
+            </a:r>
+          </a:p>
+        </p:txBody>
+      </p:sp>
+      <p:cxnSp>
+        <p:nvCxnSpPr>
+          <p:cNvPr id="2073" name="Gap rule 1"/>
+          <p:cNvCxnSpPr/>
+          <p:nvPr/>
+        </p:nvCxnSpPr>
+        <p:spPr>
+          <a:xfrm>
+            <a:off x="5989320" y="2834640"/>
+            <a:ext cx="5257800" cy="0"/>
+          </a:xfrm>
+          <a:prstGeom prst="straightConnector1">
+            <a:avLst/>
+          </a:prstGeom>
+          <a:ln w="9525">
+            <a:solidFill>
+              <a:schemeClr val="accent4"/>
+            </a:solidFill>
+          </a:ln>
+        </p:spPr>
+      </p:cxnSp>
+      <p:sp>
+        <p:nvSpPr>
+          <p:cNvPr id="2074" name="Gap 2 value"/>
+          <p:cNvSpPr txBox="1"/>
+          <p:nvPr/>
+        </p:nvSpPr>
+        <p:spPr>
+          <a:xfrm>
+            <a:off x="5989320" y="2880360"/>
+            <a:ext cx="2103120" cy="685800"/>
+          </a:xfrm>
+          <a:prstGeom prst="rect">
+            <a:avLst/>
+          </a:prstGeom>
+          <a:noFill/>
+          <a:ln>
+            <a:noFill/>
+          </a:ln>
+        </p:spPr>
+        <p:txBody>
+          <a:bodyPr wrap="square" lIns="0" tIns="0" rIns="0" bIns="0" anchor="ctr" rtlCol="0">
+            <a:noAutofit/>
+          </a:bodyPr>
+          <a:lstStyle/>
+          <a:p>
+            <a:pPr marL="0" indent="0" algn="l">
+              <a:lnSpc>
+                <a:spcPct val="100000"/>
+              </a:lnSpc>
+              <a:spcBef>
+                <a:spcPts val="0"/>
+              </a:spcBef>
+              <a:spcAft>
+                <a:spcPts val="0"/>
+              </a:spcAft>
+              <a:buNone/>
+            </a:pPr>
+            <a:r>
+              <a:rPr lang="en-US" sz="4000" b="0" dirty="0">
+                <a:solidFill>
+                  <a:schemeClr val="accent2"/>
+                </a:solidFill>
+                <a:latin typeface="+mj-lt"/>
+                <a:ea typeface="+mj-lt"/>
+                <a:cs typeface="+mj-lt"/>
+              </a:rPr>
+              <a:t>3 years</a:t>
+            </a:r>
+          </a:p>
+        </p:txBody>
+      </p:sp>
+      <p:sp>
+        <p:nvSpPr>
+          <p:cNvPr id="2075" name="Gap 2 label"/>
+          <p:cNvSpPr txBox="1"/>
+          <p:nvPr/>
+        </p:nvSpPr>
+        <p:spPr>
+          <a:xfrm>
+            <a:off x="8229600" y="2880360"/>
+            <a:ext cx="3017520" cy="685800"/>
+          </a:xfrm>
+          <a:prstGeom prst="rect">
+            <a:avLst/>
+          </a:prstGeom>
+          <a:noFill/>
+          <a:ln>
+            <a:noFill/>
+          </a:ln>
+        </p:spPr>
+        <p:txBody>
+          <a:bodyPr wrap="square" lIns="0" tIns="0" rIns="0" bIns="0" anchor="ctr" rtlCol="0">
+            <a:noAutofit/>
+          </a:bodyPr>
+          <a:lstStyle/>
+          <a:p>
+            <a:pPr marL="0" indent="0" algn="l">
+              <a:lnSpc>
+                <a:spcPct val="100000"/>
+              </a:lnSpc>
+              <a:spcBef>
+                <a:spcPts val="0"/>
+              </a:spcBef>
+              <a:spcAft>
+                <a:spcPts val="0"/>
+              </a:spcAft>
+              <a:buNone/>
+            </a:pPr>
+            <a:r>
+              <a:rPr lang="en-US" sz="2000" b="0" dirty="0">
+                <a:solidFill>
+                  <a:schemeClr val="dk1"/>
+                </a:solidFill>
+                <a:latin typeface="+mn-lt"/>
+                <a:ea typeface="+mn-lt"/>
+                <a:cs typeface="+mn-lt"/>
+              </a:rPr>
+              <a:t>behind in HBM</a:t>
+            </a:r>
+          </a:p>
+        </p:txBody>
+      </p:sp>
+      <p:cxnSp>
+        <p:nvCxnSpPr>
+          <p:cNvPr id="2076" name="Gap rule 2"/>
+          <p:cNvCxnSpPr/>
+          <p:nvPr/>
+        </p:nvCxnSpPr>
+        <p:spPr>
+          <a:xfrm>
+            <a:off x="5989320" y="3611880"/>
+            <a:ext cx="5257800" cy="0"/>
+          </a:xfrm>
+          <a:prstGeom prst="straightConnector1">
+            <a:avLst/>
+          </a:prstGeom>
+          <a:ln w="9525">
+            <a:solidFill>
+              <a:schemeClr val="accent4"/>
+            </a:solidFill>
+          </a:ln>
+        </p:spPr>
+      </p:cxnSp>
+      <p:sp>
+        <p:nvSpPr>
+          <p:cNvPr id="2077" name="Gap 3 value"/>
+          <p:cNvSpPr txBox="1"/>
+          <p:nvPr/>
+        </p:nvSpPr>
+        <p:spPr>
+          <a:xfrm>
+            <a:off x="5989320" y="3657600"/>
+            <a:ext cx="2103120" cy="685800"/>
+          </a:xfrm>
+          <a:prstGeom prst="rect">
+            <a:avLst/>
+          </a:prstGeom>
+          <a:noFill/>
+          <a:ln>
+            <a:noFill/>
+          </a:ln>
+        </p:spPr>
+        <p:txBody>
+          <a:bodyPr wrap="square" lIns="0" tIns="0" rIns="0" bIns="0" anchor="ctr" rtlCol="0">
+            <a:noAutofit/>
+          </a:bodyPr>
+          <a:lstStyle/>
+          <a:p>
+            <a:pPr marL="0" indent="0" algn="l">
+              <a:lnSpc>
+                <a:spcPct val="100000"/>
+              </a:lnSpc>
+              <a:spcBef>
+                <a:spcPts val="0"/>
+              </a:spcBef>
+              <a:spcAft>
+                <a:spcPts val="0"/>
+              </a:spcAft>
+              <a:buNone/>
+            </a:pPr>
+            <a:r>
+              <a:rPr lang="en-US" sz="4000" b="0" dirty="0">
+                <a:solidFill>
+                  <a:schemeClr val="dk2"/>
+                </a:solidFill>
+                <a:latin typeface="+mj-lt"/>
+                <a:ea typeface="+mj-lt"/>
+                <a:cs typeface="+mj-lt"/>
+              </a:rPr>
+              <a:t>1 year</a:t>
+            </a:r>
+          </a:p>
+        </p:txBody>
+      </p:sp>
+      <p:sp>
+        <p:nvSpPr>
+          <p:cNvPr id="2078" name="Gap 3 label"/>
+          <p:cNvSpPr txBox="1"/>
+          <p:nvPr/>
+        </p:nvSpPr>
+        <p:spPr>
+          <a:xfrm>
+            <a:off x="8229600" y="3657600"/>
+            <a:ext cx="3017520" cy="685800"/>
+          </a:xfrm>
+          <a:prstGeom prst="rect">
+            <a:avLst/>
+          </a:prstGeom>
+          <a:noFill/>
+          <a:ln>
+            <a:noFill/>
+          </a:ln>
+        </p:spPr>
+        <p:txBody>
+          <a:bodyPr wrap="square" lIns="0" tIns="0" rIns="0" bIns="0" anchor="ctr" rtlCol="0">
+            <a:noAutofit/>
+          </a:bodyPr>
+          <a:lstStyle/>
+          <a:p>
+            <a:pPr marL="0" indent="0" algn="l">
+              <a:lnSpc>
+                <a:spcPct val="100000"/>
+              </a:lnSpc>
+              <a:spcBef>
+                <a:spcPts val="0"/>
+              </a:spcBef>
+              <a:spcAft>
+                <a:spcPts val="0"/>
+              </a:spcAft>
+              <a:buNone/>
+            </a:pPr>
+            <a:r>
+              <a:rPr lang="en-US" sz="2000" b="0" dirty="0">
+                <a:solidFill>
+                  <a:schemeClr val="dk1"/>
+                </a:solidFill>
+                <a:latin typeface="+mn-lt"/>
+                <a:ea typeface="+mn-lt"/>
+                <a:cs typeface="+mn-lt"/>
+              </a:rPr>
+              <a:t>behind in NAND flash</a:t>
+            </a:r>
+          </a:p>
+        </p:txBody>
+      </p:sp>
+      <p:sp>
+        <p:nvSpPr>
+          <p:cNvPr id="2079" name="Gap source"/>
           <p:cNvSpPr txBox="1"/>
           <p:nvPr/>
         </p:nvSpPr>
@@ -29815,7 +29987,7 @@
       </p:sp>
       <p:sp>
         <p:nvSpPr>
-          <p:cNvPr id="2072" name="Takeaway banner"/>
+          <p:cNvPr id="2080" name="Takeaway banner"/>
           <p:cNvSpPr/>
           <p:nvPr/>
         </p:nvSpPr>
@@ -29879,7 +30051,7 @@
       </p:sp>
       <p:sp>
         <p:nvSpPr>
-          <p:cNvPr id="2073" name="Next topic"/>
+          <p:cNvPr id="2081" name="Next topic"/>
           <p:cNvSpPr txBox="1"/>
           <p:nvPr/>
         </p:nvSpPr>

</xml_diff>

<commit_message>
Slide 5: drop takeaway; spread gap callouts to fill right half
Co-Authored-By: Claude Opus 5.5 <noreply@anthropic.com>
Claude-Session: https://claude.ai/code/session_01EAqNWxuCBt8vBHk7fm7zMv
</commit_message>
<xml_diff>
--- a/korea-china-trade.pptx
+++ b/korea-china-trade.pptx
@@ -31666,7 +31666,7 @@
         <p:spPr>
           <a:xfrm>
             <a:off x="5989320" y="2103120"/>
-            <a:ext cx="2103120" cy="685800"/>
+            <a:ext cx="2514600" cy="960120"/>
           </a:xfrm>
           <a:prstGeom prst="rect">
             <a:avLst/>
@@ -31695,7 +31695,7 @@
               <a:buNone/>
             </a:pPr>
             <a:r>
-              <a:rPr lang="en-US" sz="4000" b="1" dirty="0">
+              <a:rPr lang="en-US" sz="5400" b="1" dirty="0">
                 <a:solidFill>
                   <a:schemeClr val="accent2"/>
                 </a:solidFill>
@@ -31722,8 +31722,8 @@
         </p:nvSpPr>
         <p:spPr>
           <a:xfrm>
-            <a:off x="8229600" y="2103120"/>
-            <a:ext cx="3017520" cy="685800"/>
+            <a:off x="8641080" y="2103120"/>
+            <a:ext cx="2606040" cy="960120"/>
           </a:xfrm>
           <a:prstGeom prst="rect">
             <a:avLst/>
@@ -31752,7 +31752,7 @@
               <a:buNone/>
             </a:pPr>
             <a:r>
-              <a:rPr lang="en-US" sz="2000" b="0" dirty="0">
+              <a:rPr lang="en-US" sz="2400" b="0" dirty="0">
                 <a:solidFill>
                   <a:schemeClr val="dk1"/>
                 </a:solidFill>
@@ -31779,7 +31779,7 @@
         </p:nvCxnSpPr>
         <p:spPr>
           <a:xfrm>
-            <a:off x="5989320" y="2834640"/>
+            <a:off x="5989320" y="3200400"/>
             <a:ext cx="5257800" cy="0"/>
           </a:xfrm>
           <a:prstGeom prst="straightConnector1">
@@ -31806,8 +31806,8 @@
         </p:nvSpPr>
         <p:spPr>
           <a:xfrm>
-            <a:off x="5989320" y="2880360"/>
-            <a:ext cx="2103120" cy="685800"/>
+            <a:off x="5989320" y="3364992"/>
+            <a:ext cx="2514600" cy="960120"/>
           </a:xfrm>
           <a:prstGeom prst="rect">
             <a:avLst/>
@@ -31836,7 +31836,7 @@
               <a:buNone/>
             </a:pPr>
             <a:r>
-              <a:rPr lang="en-US" sz="4000" b="1" dirty="0">
+              <a:rPr lang="en-US" sz="5400" b="1" dirty="0">
                 <a:solidFill>
                   <a:schemeClr val="accent2"/>
                 </a:solidFill>
@@ -31863,8 +31863,8 @@
         </p:nvSpPr>
         <p:spPr>
           <a:xfrm>
-            <a:off x="8229600" y="2880360"/>
-            <a:ext cx="3017520" cy="685800"/>
+            <a:off x="8641080" y="3364992"/>
+            <a:ext cx="2606040" cy="960120"/>
           </a:xfrm>
           <a:prstGeom prst="rect">
             <a:avLst/>
@@ -31893,7 +31893,7 @@
               <a:buNone/>
             </a:pPr>
             <a:r>
-              <a:rPr lang="en-US" sz="2000" b="0" dirty="0">
+              <a:rPr lang="en-US" sz="2400" b="0" dirty="0">
                 <a:solidFill>
                   <a:schemeClr val="dk1"/>
                 </a:solidFill>
@@ -31920,7 +31920,7 @@
         </p:nvCxnSpPr>
         <p:spPr>
           <a:xfrm>
-            <a:off x="5989320" y="3611880"/>
+            <a:off x="5989320" y="4462272"/>
             <a:ext cx="5257800" cy="0"/>
           </a:xfrm>
           <a:prstGeom prst="straightConnector1">
@@ -31947,8 +31947,8 @@
         </p:nvSpPr>
         <p:spPr>
           <a:xfrm>
-            <a:off x="5989320" y="3657600"/>
-            <a:ext cx="2103120" cy="685800"/>
+            <a:off x="5989320" y="4626864"/>
+            <a:ext cx="2514600" cy="960120"/>
           </a:xfrm>
           <a:prstGeom prst="rect">
             <a:avLst/>
@@ -31977,7 +31977,7 @@
               <a:buNone/>
             </a:pPr>
             <a:r>
-              <a:rPr lang="en-US" sz="4000" b="1" dirty="0">
+              <a:rPr lang="en-US" sz="5400" b="1" dirty="0">
                 <a:solidFill>
                   <a:schemeClr val="dk2"/>
                 </a:solidFill>
@@ -32004,8 +32004,8 @@
         </p:nvSpPr>
         <p:spPr>
           <a:xfrm>
-            <a:off x="8229600" y="3657600"/>
-            <a:ext cx="3017520" cy="685800"/>
+            <a:off x="8641080" y="4626864"/>
+            <a:ext cx="2606040" cy="960120"/>
           </a:xfrm>
           <a:prstGeom prst="rect">
             <a:avLst/>
@@ -32034,7 +32034,7 @@
               <a:buNone/>
             </a:pPr>
             <a:r>
-              <a:rPr lang="en-US" sz="2000" b="0" dirty="0">
+              <a:rPr lang="en-US" sz="2400" b="0" dirty="0">
                 <a:solidFill>
                   <a:schemeClr val="dk1"/>
                 </a:solidFill>
@@ -32047,123 +32047,9 @@
           </a:p>
         </p:txBody>
       </p:sp>
-      <p:cxnSp>
-        <p:nvCxnSpPr>
-          <p:cNvPr id="3001" name="Gap rule 3"/>
-          <p:cNvCxnSpPr/>
-          <p:nvPr/>
-        </p:nvCxnSpPr>
-        <p:spPr>
-          <a:xfrm>
-            <a:off x="5989320" y="4434840"/>
-            <a:ext cx="5257800" cy="0"/>
-          </a:xfrm>
-          <a:prstGeom prst="straightConnector1">
-            <a:avLst/>
-          </a:prstGeom>
-          <a:ln w="9525">
-            <a:solidFill>
-              <a:schemeClr val="accent4"/>
-            </a:solidFill>
-          </a:ln>
-        </p:spPr>
-      </p:cxnSp>
       <p:sp>
         <p:nvSpPr>
-          <p:cNvPr id="3002" name="Takeaway marker"/>
-          <p:cNvSpPr/>
-          <p:nvPr/>
-        </p:nvSpPr>
-        <p:spPr>
-          <a:xfrm>
-            <a:off x="5989320" y="4754880"/>
-            <a:ext cx="201168" cy="201168"/>
-          </a:xfrm>
-          <a:prstGeom prst="rect">
-            <a:avLst/>
-          </a:prstGeom>
-          <a:solidFill>
-            <a:schemeClr val="dk2"/>
-          </a:solidFill>
-          <a:ln>
-            <a:noFill/>
-          </a:ln>
-        </p:spPr>
-        <p:txBody>
-          <a:bodyPr wrap="square" lIns="0" tIns="0" rIns="0" bIns="0" rtlCol="0" anchor="t">
-            <a:noAutofit/>
-          </a:bodyPr>
-          <a:lstStyle/>
-          <a:p>
-            <a:endParaRPr lang="en-US"/>
-          </a:p>
-        </p:txBody>
-      </p:sp>
-      <p:sp>
-        <p:nvSpPr>
-          <p:cNvPr id="3003" name="Takeaway"/>
-          <p:cNvSpPr txBox="1"/>
-          <p:nvPr/>
-        </p:nvSpPr>
-        <p:spPr>
-          <a:xfrm>
-            <a:off x="6373368" y="4636008"/>
-            <a:ext cx="4873752" cy="1188720"/>
-          </a:xfrm>
-          <a:prstGeom prst="rect">
-            <a:avLst/>
-          </a:prstGeom>
-          <a:noFill/>
-          <a:ln>
-            <a:noFill/>
-          </a:ln>
-        </p:spPr>
-        <p:txBody>
-          <a:bodyPr wrap="square" lIns="0" tIns="0" rIns="0" bIns="0" rtlCol="0" anchor="t">
-            <a:noAutofit/>
-          </a:bodyPr>
-          <a:lstStyle/>
-          <a:p>
-            <a:pPr marL="0" indent="0" algn="l">
-              <a:lnSpc>
-                <a:spcPct val="100000"/>
-              </a:lnSpc>
-              <a:spcBef>
-                <a:spcPts val="0"/>
-              </a:spcBef>
-              <a:spcAft>
-                <a:spcPts val="0"/>
-              </a:spcAft>
-              <a:buNone/>
-            </a:pPr>
-            <a:r>
-              <a:rPr lang="en-US" sz="2000" b="1" dirty="0">
-                <a:solidFill>
-                  <a:schemeClr val="accent2"/>
-                </a:solidFill>
-                <a:latin typeface="Times New Roman" panose="02020603050405020304" pitchFamily="18" charset="0"/>
-                <a:ea typeface="+mn-lt"/>
-                <a:cs typeface="Times New Roman" panose="02020603050405020304" pitchFamily="18" charset="0"/>
-              </a:rPr>
-              <a:t>Korea still holds the tech edge, for now. </a:t>
-            </a:r>
-            <a:r>
-              <a:rPr lang="en-US" sz="2000" b="0" dirty="0">
-                <a:solidFill>
-                  <a:schemeClr val="dk1"/>
-                </a:solidFill>
-                <a:latin typeface="Times New Roman" panose="02020603050405020304" pitchFamily="18" charset="0"/>
-                <a:ea typeface="+mn-lt"/>
-                <a:cs typeface="Times New Roman" panose="02020603050405020304" pitchFamily="18" charset="0"/>
-              </a:rPr>
-              <a:t>China's demand for advanced Korean chips keeps both economies interconnected.</a:t>
-            </a:r>
-          </a:p>
-        </p:txBody>
-      </p:sp>
-      <p:sp>
-        <p:nvSpPr>
-          <p:cNvPr id="3004" name="Gap source"/>
+          <p:cNvPr id="3001" name="Gap source"/>
           <p:cNvSpPr txBox="1"/>
           <p:nvPr/>
         </p:nvSpPr>

</xml_diff>

<commit_message>
Add slides 6-7: the semiconductor paradox and South Korea's response
Co-Authored-By: Claude Opus 5.5 <noreply@anthropic.com>
Claude-Session: https://claude.ai/code/session_01EAqNWxuCBt8vBHk7fm7zMv
</commit_message>
<xml_diff>
--- a/korea-china-trade.pptx
+++ b/korea-china-trade.pptx
@@ -14,6 +14,8 @@
     <p:sldId id="266" r:id="rId5"/>
     <p:sldId id="264" r:id="rId6"/>
     <p:sldId id="286" r:id="rId7"/>
+    <p:sldId id="287" r:id="rId29"/>
+    <p:sldId id="288" r:id="rId30"/>
   </p:sldIdLst>
   <p:sldSz cx="12192000" cy="6858000"/>
   <p:notesSz cx="6858000" cy="9144000"/>
@@ -32106,6 +32108,2047 @@
 </p:sld>
 </file>
 
+<file path=ppt/slides/slide6.xml><?xml version="1.0" encoding="utf-8"?>
+<p:sld xmlns:a="http://schemas.openxmlformats.org/drawingml/2006/main" xmlns:r="http://schemas.openxmlformats.org/officeDocument/2006/relationships" xmlns:p="http://schemas.openxmlformats.org/presentationml/2006/main">
+  <p:cSld>
+    <p:spTree>
+      <p:nvGrpSpPr>
+        <p:cNvPr id="1" name=""/>
+        <p:cNvGrpSpPr/>
+        <p:nvPr/>
+      </p:nvGrpSpPr>
+      <p:grpSpPr>
+        <a:xfrm>
+          <a:off x="0" y="0"/>
+          <a:ext cx="0" cy="0"/>
+          <a:chOff x="0" y="0"/>
+          <a:chExt cx="0" cy="0"/>
+        </a:xfrm>
+      </p:grpSpPr>
+      <p:sp>
+        <p:nvSpPr>
+          <p:cNvPr id="3101" name="Title band"/>
+          <p:cNvSpPr/>
+          <p:nvPr/>
+        </p:nvSpPr>
+        <p:spPr>
+          <a:xfrm>
+            <a:off x="0" y="274320"/>
+            <a:ext cx="10515600" cy="960120"/>
+          </a:xfrm>
+          <a:prstGeom prst="rect">
+            <a:avLst/>
+          </a:prstGeom>
+          <a:solidFill>
+            <a:schemeClr val="accent2"/>
+          </a:solidFill>
+          <a:ln>
+            <a:noFill/>
+          </a:ln>
+        </p:spPr>
+        <p:txBody>
+          <a:bodyPr wrap="square" lIns="0" tIns="0" rIns="0" bIns="0" rtlCol="0" anchor="t">
+            <a:noAutofit/>
+          </a:bodyPr>
+          <a:lstStyle/>
+          <a:p>
+            <a:endParaRPr lang="en-US">
+              <a:latin typeface="Times New Roman" panose="02020603050405020304" pitchFamily="18" charset="0"/>
+              <a:cs typeface="Times New Roman" panose="02020603050405020304" pitchFamily="18" charset="0"/>
+            </a:endParaRPr>
+          </a:p>
+        </p:txBody>
+      </p:sp>
+      <p:sp>
+        <p:nvSpPr>
+          <p:cNvPr id="3102" name="Title"/>
+          <p:cNvSpPr txBox="1">
+            <a:spLocks noGrp="1"/>
+          </p:cNvSpPr>
+          <p:nvPr>
+            <p:ph type="title"/>
+          </p:nvPr>
+        </p:nvSpPr>
+        <p:spPr>
+          <a:xfrm>
+            <a:off x="950976" y="274320"/>
+            <a:ext cx="9473184" cy="960120"/>
+          </a:xfrm>
+        </p:spPr>
+        <p:txBody>
+          <a:bodyPr spcFirstLastPara="1" wrap="square" lIns="121900" tIns="121900" rIns="121900" bIns="121900" anchor="ctr" anchorCtr="0">
+            <a:noAutofit/>
+          </a:bodyPr>
+          <a:lstStyle/>
+          <a:p>
+            <a:pPr algn="l"/>
+            <a:r>
+              <a:rPr lang="en-US" sz="3600" b="1" dirty="0">
+                <a:solidFill>
+                  <a:schemeClr val="lt1"/>
+                </a:solidFill>
+                <a:latin typeface="Times New Roman" panose="02020603050405020304" pitchFamily="18" charset="0"/>
+                <a:cs typeface="Times New Roman" panose="02020603050405020304" pitchFamily="18" charset="0"/>
+              </a:rPr>
+              <a:t>The Paradox: Strong Demand, Growing Risk</a:t>
+            </a:r>
+          </a:p>
+        </p:txBody>
+      </p:sp>
+      <p:sp>
+        <p:nvSpPr>
+          <p:cNvPr id="3103" name="Left heading"/>
+          <p:cNvSpPr txBox="1"/>
+          <p:nvPr/>
+        </p:nvSpPr>
+        <p:spPr>
+          <a:xfrm>
+            <a:off x="950976" y="1572768"/>
+            <a:ext cx="4736592" cy="731520"/>
+          </a:xfrm>
+          <a:prstGeom prst="rect">
+            <a:avLst/>
+          </a:prstGeom>
+          <a:noFill/>
+          <a:ln>
+            <a:noFill/>
+          </a:ln>
+        </p:spPr>
+        <p:txBody>
+          <a:bodyPr wrap="square" lIns="0" tIns="0" rIns="0" bIns="0" rtlCol="0" anchor="t">
+            <a:noAutofit/>
+          </a:bodyPr>
+          <a:lstStyle/>
+          <a:p>
+            <a:pPr marL="0" indent="0" algn="l">
+              <a:lnSpc>
+                <a:spcPct val="100000"/>
+              </a:lnSpc>
+              <a:spcBef>
+                <a:spcPts val="0"/>
+              </a:spcBef>
+              <a:spcAft>
+                <a:spcPts val="0"/>
+              </a:spcAft>
+              <a:buNone/>
+            </a:pPr>
+            <a:r>
+              <a:rPr lang="en-US" sz="2000" b="1" dirty="0">
+                <a:solidFill>
+                  <a:schemeClr val="dk2"/>
+                </a:solidFill>
+                <a:latin typeface="Times New Roman" panose="02020603050405020304" pitchFamily="18" charset="0"/>
+                <a:cs typeface="Times New Roman" panose="02020603050405020304" pitchFamily="18" charset="0"/>
+              </a:rPr>
+              <a:t>Short-term strength</a:t>
+            </a:r>
+          </a:p>
+          <a:p>
+            <a:pPr marL="0" indent="0" algn="l">
+              <a:lnSpc>
+                <a:spcPct val="100000"/>
+              </a:lnSpc>
+              <a:spcBef>
+                <a:spcPts val="0"/>
+              </a:spcBef>
+              <a:spcAft>
+                <a:spcPts val="0"/>
+              </a:spcAft>
+              <a:buNone/>
+            </a:pPr>
+            <a:r>
+              <a:rPr lang="en-US" sz="2000" b="1" dirty="0">
+                <a:solidFill>
+                  <a:schemeClr val="accent2"/>
+                </a:solidFill>
+                <a:latin typeface="Times New Roman" panose="02020603050405020304" pitchFamily="18" charset="0"/>
+                <a:cs typeface="Times New Roman" panose="02020603050405020304" pitchFamily="18" charset="0"/>
+              </a:rPr>
+              <a:t>Chinese demand persists</a:t>
+            </a:r>
+          </a:p>
+        </p:txBody>
+      </p:sp>
+      <p:sp>
+        <p:nvSpPr>
+          <p:cNvPr id="3104" name="Right heading"/>
+          <p:cNvSpPr txBox="1"/>
+          <p:nvPr/>
+        </p:nvSpPr>
+        <p:spPr>
+          <a:xfrm>
+            <a:off x="6510528" y="1572768"/>
+            <a:ext cx="4736592" cy="731520"/>
+          </a:xfrm>
+          <a:prstGeom prst="rect">
+            <a:avLst/>
+          </a:prstGeom>
+          <a:noFill/>
+          <a:ln>
+            <a:noFill/>
+          </a:ln>
+        </p:spPr>
+        <p:txBody>
+          <a:bodyPr wrap="square" lIns="0" tIns="0" rIns="0" bIns="0" rtlCol="0" anchor="t">
+            <a:noAutofit/>
+          </a:bodyPr>
+          <a:lstStyle/>
+          <a:p>
+            <a:pPr marL="0" indent="0" algn="l">
+              <a:lnSpc>
+                <a:spcPct val="100000"/>
+              </a:lnSpc>
+              <a:spcBef>
+                <a:spcPts val="0"/>
+              </a:spcBef>
+              <a:spcAft>
+                <a:spcPts val="0"/>
+              </a:spcAft>
+              <a:buNone/>
+            </a:pPr>
+            <a:r>
+              <a:rPr lang="en-US" sz="2000" b="1" dirty="0">
+                <a:solidFill>
+                  <a:schemeClr val="dk2"/>
+                </a:solidFill>
+                <a:latin typeface="Times New Roman" panose="02020603050405020304" pitchFamily="18" charset="0"/>
+                <a:cs typeface="Times New Roman" panose="02020603050405020304" pitchFamily="18" charset="0"/>
+              </a:rPr>
+              <a:t>Long-term risk</a:t>
+            </a:r>
+          </a:p>
+          <a:p>
+            <a:pPr marL="0" indent="0" algn="l">
+              <a:lnSpc>
+                <a:spcPct val="100000"/>
+              </a:lnSpc>
+              <a:spcBef>
+                <a:spcPts val="0"/>
+              </a:spcBef>
+              <a:spcAft>
+                <a:spcPts val="0"/>
+              </a:spcAft>
+              <a:buNone/>
+            </a:pPr>
+            <a:r>
+              <a:rPr lang="en-US" sz="2000" b="1" dirty="0">
+                <a:solidFill>
+                  <a:schemeClr val="accent2"/>
+                </a:solidFill>
+                <a:latin typeface="Times New Roman" panose="02020603050405020304" pitchFamily="18" charset="0"/>
+                <a:cs typeface="Times New Roman" panose="02020603050405020304" pitchFamily="18" charset="0"/>
+              </a:rPr>
+              <a:t>Markets fear China's competitiveness</a:t>
+            </a:r>
+          </a:p>
+        </p:txBody>
+      </p:sp>
+      <p:cxnSp>
+        <p:nvCxnSpPr>
+          <p:cNvPr id="3105" name="Column divider"/>
+          <p:cNvCxnSpPr/>
+          <p:nvPr/>
+        </p:nvCxnSpPr>
+        <p:spPr>
+          <a:xfrm>
+            <a:off x="6099048" y="1645920"/>
+            <a:ext cx="0" cy="3520440"/>
+          </a:xfrm>
+          <a:prstGeom prst="straightConnector1">
+            <a:avLst/>
+          </a:prstGeom>
+          <a:ln w="9525">
+            <a:solidFill>
+              <a:schemeClr val="accent4"/>
+            </a:solidFill>
+          </a:ln>
+        </p:spPr>
+      </p:cxnSp>
+      <p:sp>
+        <p:nvSpPr>
+          <p:cNvPr id="3106" name="Share 2018"/>
+          <p:cNvSpPr txBox="1"/>
+          <p:nvPr/>
+        </p:nvSpPr>
+        <p:spPr>
+          <a:xfrm>
+            <a:off x="950976" y="2468880"/>
+            <a:ext cx="1828800" cy="777240"/>
+          </a:xfrm>
+          <a:prstGeom prst="rect">
+            <a:avLst/>
+          </a:prstGeom>
+          <a:noFill/>
+          <a:ln>
+            <a:noFill/>
+          </a:ln>
+        </p:spPr>
+        <p:txBody>
+          <a:bodyPr wrap="square" lIns="0" tIns="0" rIns="0" bIns="0" rtlCol="0" anchor="ctr">
+            <a:noAutofit/>
+          </a:bodyPr>
+          <a:lstStyle/>
+          <a:p>
+            <a:pPr marL="0" indent="0" algn="l">
+              <a:lnSpc>
+                <a:spcPct val="100000"/>
+              </a:lnSpc>
+              <a:spcBef>
+                <a:spcPts val="0"/>
+              </a:spcBef>
+              <a:spcAft>
+                <a:spcPts val="0"/>
+              </a:spcAft>
+              <a:buNone/>
+            </a:pPr>
+            <a:r>
+              <a:rPr lang="en-US" sz="4800" b="1" dirty="0">
+                <a:solidFill>
+                  <a:schemeClr val="accent4"/>
+                </a:solidFill>
+                <a:latin typeface="Times New Roman" panose="02020603050405020304" pitchFamily="18" charset="0"/>
+                <a:cs typeface="Times New Roman" panose="02020603050405020304" pitchFamily="18" charset="0"/>
+              </a:rPr>
+              <a:t>45.7%</a:t>
+            </a:r>
+          </a:p>
+        </p:txBody>
+      </p:sp>
+      <p:cxnSp>
+        <p:nvCxnSpPr>
+          <p:cNvPr id="3107" name="Share arrow"/>
+          <p:cNvCxnSpPr/>
+          <p:nvPr/>
+        </p:nvCxnSpPr>
+        <p:spPr>
+          <a:xfrm>
+            <a:off x="2825496" y="2857500"/>
+            <a:ext cx="731520" cy="0"/>
+          </a:xfrm>
+          <a:prstGeom prst="straightConnector1">
+            <a:avLst/>
+          </a:prstGeom>
+          <a:ln w="22225">
+            <a:solidFill>
+              <a:schemeClr val="dk1"/>
+            </a:solidFill>
+            <a:tailEnd type="triangle" w="med" len="med"/>
+          </a:ln>
+        </p:spPr>
+      </p:cxnSp>
+      <p:sp>
+        <p:nvSpPr>
+          <p:cNvPr id="3108" name="Share 2024"/>
+          <p:cNvSpPr txBox="1"/>
+          <p:nvPr/>
+        </p:nvSpPr>
+        <p:spPr>
+          <a:xfrm>
+            <a:off x="3694176" y="2468880"/>
+            <a:ext cx="1920240" cy="777240"/>
+          </a:xfrm>
+          <a:prstGeom prst="rect">
+            <a:avLst/>
+          </a:prstGeom>
+          <a:noFill/>
+          <a:ln>
+            <a:noFill/>
+          </a:ln>
+        </p:spPr>
+        <p:txBody>
+          <a:bodyPr wrap="square" lIns="0" tIns="0" rIns="0" bIns="0" rtlCol="0" anchor="ctr">
+            <a:noAutofit/>
+          </a:bodyPr>
+          <a:lstStyle/>
+          <a:p>
+            <a:pPr marL="0" indent="0" algn="l">
+              <a:lnSpc>
+                <a:spcPct val="100000"/>
+              </a:lnSpc>
+              <a:spcBef>
+                <a:spcPts val="0"/>
+              </a:spcBef>
+              <a:spcAft>
+                <a:spcPts val="0"/>
+              </a:spcAft>
+              <a:buNone/>
+            </a:pPr>
+            <a:r>
+              <a:rPr lang="en-US" sz="4800" b="1" dirty="0">
+                <a:solidFill>
+                  <a:schemeClr val="accent2"/>
+                </a:solidFill>
+                <a:latin typeface="Times New Roman" panose="02020603050405020304" pitchFamily="18" charset="0"/>
+                <a:cs typeface="Times New Roman" panose="02020603050405020304" pitchFamily="18" charset="0"/>
+              </a:rPr>
+              <a:t>31.7%</a:t>
+            </a:r>
+          </a:p>
+        </p:txBody>
+      </p:sp>
+      <p:sp>
+        <p:nvSpPr>
+          <p:cNvPr id="3109" name="Year 2018"/>
+          <p:cNvSpPr txBox="1"/>
+          <p:nvPr/>
+        </p:nvSpPr>
+        <p:spPr>
+          <a:xfrm>
+            <a:off x="950976" y="3246120"/>
+            <a:ext cx="1828800" cy="320040"/>
+          </a:xfrm>
+          <a:prstGeom prst="rect">
+            <a:avLst/>
+          </a:prstGeom>
+          <a:noFill/>
+          <a:ln>
+            <a:noFill/>
+          </a:ln>
+        </p:spPr>
+        <p:txBody>
+          <a:bodyPr wrap="square" lIns="0" tIns="0" rIns="0" bIns="0" rtlCol="0" anchor="t">
+            <a:noAutofit/>
+          </a:bodyPr>
+          <a:lstStyle/>
+          <a:p>
+            <a:pPr marL="0" indent="0" algn="l">
+              <a:lnSpc>
+                <a:spcPct val="100000"/>
+              </a:lnSpc>
+              <a:spcBef>
+                <a:spcPts val="0"/>
+              </a:spcBef>
+              <a:spcAft>
+                <a:spcPts val="0"/>
+              </a:spcAft>
+              <a:buNone/>
+            </a:pPr>
+            <a:r>
+              <a:rPr lang="en-US" sz="1800" b="0" dirty="0">
+                <a:solidFill>
+                  <a:schemeClr val="accent3"/>
+                </a:solidFill>
+                <a:latin typeface="Times New Roman" panose="02020603050405020304" pitchFamily="18" charset="0"/>
+                <a:cs typeface="Times New Roman" panose="02020603050405020304" pitchFamily="18" charset="0"/>
+              </a:rPr>
+              <a:t>2018</a:t>
+            </a:r>
+          </a:p>
+        </p:txBody>
+      </p:sp>
+      <p:sp>
+        <p:nvSpPr>
+          <p:cNvPr id="3110" name="Year 2024"/>
+          <p:cNvSpPr txBox="1"/>
+          <p:nvPr/>
+        </p:nvSpPr>
+        <p:spPr>
+          <a:xfrm>
+            <a:off x="3694176" y="3246120"/>
+            <a:ext cx="1920240" cy="320040"/>
+          </a:xfrm>
+          <a:prstGeom prst="rect">
+            <a:avLst/>
+          </a:prstGeom>
+          <a:noFill/>
+          <a:ln>
+            <a:noFill/>
+          </a:ln>
+        </p:spPr>
+        <p:txBody>
+          <a:bodyPr wrap="square" lIns="0" tIns="0" rIns="0" bIns="0" rtlCol="0" anchor="t">
+            <a:noAutofit/>
+          </a:bodyPr>
+          <a:lstStyle/>
+          <a:p>
+            <a:pPr marL="0" indent="0" algn="l">
+              <a:lnSpc>
+                <a:spcPct val="100000"/>
+              </a:lnSpc>
+              <a:spcBef>
+                <a:spcPts val="0"/>
+              </a:spcBef>
+              <a:spcAft>
+                <a:spcPts val="0"/>
+              </a:spcAft>
+              <a:buNone/>
+            </a:pPr>
+            <a:r>
+              <a:rPr lang="en-US" sz="1800" b="0" dirty="0">
+                <a:solidFill>
+                  <a:schemeClr val="accent3"/>
+                </a:solidFill>
+                <a:latin typeface="Times New Roman" panose="02020603050405020304" pitchFamily="18" charset="0"/>
+                <a:cs typeface="Times New Roman" panose="02020603050405020304" pitchFamily="18" charset="0"/>
+              </a:rPr>
+              <a:t>2024</a:t>
+            </a:r>
+          </a:p>
+        </p:txBody>
+      </p:sp>
+      <p:sp>
+        <p:nvSpPr>
+          <p:cNvPr id="3111" name="Share label"/>
+          <p:cNvSpPr txBox="1"/>
+          <p:nvPr/>
+        </p:nvSpPr>
+        <p:spPr>
+          <a:xfrm>
+            <a:off x="950976" y="3611880"/>
+            <a:ext cx="4736592" cy="685800"/>
+          </a:xfrm>
+          <a:prstGeom prst="rect">
+            <a:avLst/>
+          </a:prstGeom>
+          <a:noFill/>
+          <a:ln>
+            <a:noFill/>
+          </a:ln>
+        </p:spPr>
+        <p:txBody>
+          <a:bodyPr wrap="square" lIns="0" tIns="0" rIns="0" bIns="0" rtlCol="0" anchor="t">
+            <a:noAutofit/>
+          </a:bodyPr>
+          <a:lstStyle/>
+          <a:p>
+            <a:pPr marL="0" indent="0" algn="l">
+              <a:lnSpc>
+                <a:spcPct val="100000"/>
+              </a:lnSpc>
+              <a:spcBef>
+                <a:spcPts val="0"/>
+              </a:spcBef>
+              <a:spcAft>
+                <a:spcPts val="0"/>
+              </a:spcAft>
+              <a:buNone/>
+            </a:pPr>
+            <a:r>
+              <a:rPr lang="en-US" sz="2000" b="1" dirty="0">
+                <a:solidFill>
+                  <a:schemeClr val="dk1"/>
+                </a:solidFill>
+                <a:latin typeface="Times New Roman" panose="02020603050405020304" pitchFamily="18" charset="0"/>
+                <a:cs typeface="Times New Roman" panose="02020603050405020304" pitchFamily="18" charset="0"/>
+              </a:rPr>
+              <a:t>China's share of Korea's memory chip exports</a:t>
+            </a:r>
+          </a:p>
+        </p:txBody>
+      </p:sp>
+      <p:sp>
+        <p:nvSpPr>
+          <p:cNvPr id="3112" name="Share source"/>
+          <p:cNvSpPr txBox="1"/>
+          <p:nvPr/>
+        </p:nvSpPr>
+        <p:spPr>
+          <a:xfrm>
+            <a:off x="950976" y="4224528"/>
+            <a:ext cx="4736592" cy="320040"/>
+          </a:xfrm>
+          <a:prstGeom prst="rect">
+            <a:avLst/>
+          </a:prstGeom>
+          <a:noFill/>
+          <a:ln>
+            <a:noFill/>
+          </a:ln>
+        </p:spPr>
+        <p:txBody>
+          <a:bodyPr wrap="square" lIns="0" tIns="0" rIns="0" bIns="0" rtlCol="0" anchor="t">
+            <a:noAutofit/>
+          </a:bodyPr>
+          <a:lstStyle/>
+          <a:p>
+            <a:pPr marL="0" indent="0" algn="l">
+              <a:lnSpc>
+                <a:spcPct val="100000"/>
+              </a:lnSpc>
+              <a:spcBef>
+                <a:spcPts val="0"/>
+              </a:spcBef>
+              <a:spcAft>
+                <a:spcPts val="0"/>
+              </a:spcAft>
+              <a:buNone/>
+            </a:pPr>
+            <a:r>
+              <a:rPr lang="en-US" sz="1400" b="0" dirty="0">
+                <a:solidFill>
+                  <a:schemeClr val="accent3"/>
+                </a:solidFill>
+                <a:latin typeface="Times New Roman" panose="02020603050405020304" pitchFamily="18" charset="0"/>
+                <a:cs typeface="Times New Roman" panose="02020603050405020304" pitchFamily="18" charset="0"/>
+              </a:rPr>
+              <a:t>Source: Korea Institute for International Economic Policy (2025)</a:t>
+            </a:r>
+          </a:p>
+        </p:txBody>
+      </p:sp>
+      <p:sp>
+        <p:nvSpPr>
+          <p:cNvPr id="3113" name="Rebound marker"/>
+          <p:cNvSpPr/>
+          <p:nvPr/>
+        </p:nvSpPr>
+        <p:spPr>
+          <a:xfrm>
+            <a:off x="950976" y="4754880"/>
+            <a:ext cx="201168" cy="201168"/>
+          </a:xfrm>
+          <a:prstGeom prst="rect">
+            <a:avLst/>
+          </a:prstGeom>
+          <a:solidFill>
+            <a:schemeClr val="accent5"/>
+          </a:solidFill>
+          <a:ln>
+            <a:noFill/>
+          </a:ln>
+        </p:spPr>
+        <p:txBody>
+          <a:bodyPr wrap="square" lIns="0" tIns="0" rIns="0" bIns="0" rtlCol="0" anchor="t">
+            <a:noAutofit/>
+          </a:bodyPr>
+          <a:lstStyle/>
+          <a:p>
+            <a:endParaRPr lang="en-US"/>
+          </a:p>
+        </p:txBody>
+      </p:sp>
+      <p:sp>
+        <p:nvSpPr>
+          <p:cNvPr id="3114" name="Rebound"/>
+          <p:cNvSpPr txBox="1"/>
+          <p:nvPr/>
+        </p:nvSpPr>
+        <p:spPr>
+          <a:xfrm>
+            <a:off x="1316736" y="4645152"/>
+            <a:ext cx="4370832" cy="685800"/>
+          </a:xfrm>
+          <a:prstGeom prst="rect">
+            <a:avLst/>
+          </a:prstGeom>
+          <a:noFill/>
+          <a:ln>
+            <a:noFill/>
+          </a:ln>
+        </p:spPr>
+        <p:txBody>
+          <a:bodyPr wrap="square" lIns="0" tIns="0" rIns="0" bIns="0" rtlCol="0" anchor="t">
+            <a:noAutofit/>
+          </a:bodyPr>
+          <a:lstStyle/>
+          <a:p>
+            <a:pPr marL="0" indent="0" algn="l">
+              <a:lnSpc>
+                <a:spcPct val="100000"/>
+              </a:lnSpc>
+              <a:spcBef>
+                <a:spcPts val="0"/>
+              </a:spcBef>
+              <a:spcAft>
+                <a:spcPts val="0"/>
+              </a:spcAft>
+              <a:buNone/>
+            </a:pPr>
+            <a:r>
+              <a:rPr lang="en-US" sz="2000" b="1" dirty="0">
+                <a:solidFill>
+                  <a:schemeClr val="accent5"/>
+                </a:solidFill>
+                <a:latin typeface="Times New Roman" panose="02020603050405020304" pitchFamily="18" charset="0"/>
+                <a:cs typeface="Times New Roman" panose="02020603050405020304" pitchFamily="18" charset="0"/>
+              </a:rPr>
+              <a:t>2026: exports to China rebound strongly, </a:t>
+            </a:r>
+            <a:r>
+              <a:rPr lang="en-US" sz="2000" b="0" dirty="0">
+                <a:solidFill>
+                  <a:schemeClr val="dk1"/>
+                </a:solidFill>
+                <a:latin typeface="Times New Roman" panose="02020603050405020304" pitchFamily="18" charset="0"/>
+                <a:cs typeface="Times New Roman" panose="02020603050405020304" pitchFamily="18" charset="0"/>
+              </a:rPr>
+              <a:t>driven by AI chip demand</a:t>
+            </a:r>
+          </a:p>
+        </p:txBody>
+      </p:sp>
+      <p:sp>
+        <p:nvSpPr>
+          <p:cNvPr id="3115" name="Recent label"/>
+          <p:cNvSpPr txBox="1"/>
+          <p:nvPr/>
+        </p:nvSpPr>
+        <p:spPr>
+          <a:xfrm>
+            <a:off x="6510528" y="2468880"/>
+            <a:ext cx="4736592" cy="347472"/>
+          </a:xfrm>
+          <a:prstGeom prst="rect">
+            <a:avLst/>
+          </a:prstGeom>
+          <a:noFill/>
+          <a:ln>
+            <a:noFill/>
+          </a:ln>
+        </p:spPr>
+        <p:txBody>
+          <a:bodyPr wrap="square" lIns="0" tIns="0" rIns="0" bIns="0" rtlCol="0" anchor="t">
+            <a:noAutofit/>
+          </a:bodyPr>
+          <a:lstStyle/>
+          <a:p>
+            <a:pPr marL="0" indent="0" algn="l">
+              <a:lnSpc>
+                <a:spcPct val="100000"/>
+              </a:lnSpc>
+              <a:spcBef>
+                <a:spcPts val="0"/>
+              </a:spcBef>
+              <a:spcAft>
+                <a:spcPts val="0"/>
+              </a:spcAft>
+              <a:buNone/>
+            </a:pPr>
+            <a:r>
+              <a:rPr lang="en-US" sz="1800" b="1" dirty="0">
+                <a:solidFill>
+                  <a:schemeClr val="accent3"/>
+                </a:solidFill>
+                <a:latin typeface="Times New Roman" panose="02020603050405020304" pitchFamily="18" charset="0"/>
+                <a:cs typeface="Times New Roman" panose="02020603050405020304" pitchFamily="18" charset="0"/>
+              </a:rPr>
+              <a:t>Most recent selloff (approx.)</a:t>
+            </a:r>
+          </a:p>
+        </p:txBody>
+      </p:sp>
+      <p:sp>
+        <p:nvSpPr>
+          <p:cNvPr id="3116" name="Selloff 1 value"/>
+          <p:cNvSpPr txBox="1"/>
+          <p:nvPr/>
+        </p:nvSpPr>
+        <p:spPr>
+          <a:xfrm>
+            <a:off x="6510528" y="2788920"/>
+            <a:ext cx="1578864" cy="685800"/>
+          </a:xfrm>
+          <a:prstGeom prst="rect">
+            <a:avLst/>
+          </a:prstGeom>
+          <a:noFill/>
+          <a:ln>
+            <a:noFill/>
+          </a:ln>
+        </p:spPr>
+        <p:txBody>
+          <a:bodyPr wrap="square" lIns="0" tIns="0" rIns="0" bIns="0" rtlCol="0" anchor="ctr">
+            <a:noAutofit/>
+          </a:bodyPr>
+          <a:lstStyle/>
+          <a:p>
+            <a:pPr marL="0" indent="0" algn="l">
+              <a:lnSpc>
+                <a:spcPct val="100000"/>
+              </a:lnSpc>
+              <a:spcBef>
+                <a:spcPts val="0"/>
+              </a:spcBef>
+              <a:spcAft>
+                <a:spcPts val="0"/>
+              </a:spcAft>
+              <a:buNone/>
+            </a:pPr>
+            <a:r>
+              <a:rPr lang="en-US" sz="4000" b="1" dirty="0">
+                <a:solidFill>
+                  <a:schemeClr val="dk2"/>
+                </a:solidFill>
+                <a:latin typeface="Times New Roman" panose="02020603050405020304" pitchFamily="18" charset="0"/>
+                <a:cs typeface="Times New Roman" panose="02020603050405020304" pitchFamily="18" charset="0"/>
+              </a:rPr>
+              <a:t>−5.5%</a:t>
+            </a:r>
+          </a:p>
+        </p:txBody>
+      </p:sp>
+      <p:sp>
+        <p:nvSpPr>
+          <p:cNvPr id="3117" name="Selloff 1 name"/>
+          <p:cNvSpPr txBox="1"/>
+          <p:nvPr/>
+        </p:nvSpPr>
+        <p:spPr>
+          <a:xfrm>
+            <a:off x="6510528" y="3474720"/>
+            <a:ext cx="1578864" cy="365760"/>
+          </a:xfrm>
+          <a:prstGeom prst="rect">
+            <a:avLst/>
+          </a:prstGeom>
+          <a:noFill/>
+          <a:ln>
+            <a:noFill/>
+          </a:ln>
+        </p:spPr>
+        <p:txBody>
+          <a:bodyPr wrap="square" lIns="0" tIns="0" rIns="0" bIns="0" rtlCol="0" anchor="t">
+            <a:noAutofit/>
+          </a:bodyPr>
+          <a:lstStyle/>
+          <a:p>
+            <a:pPr marL="0" indent="0" algn="l">
+              <a:lnSpc>
+                <a:spcPct val="100000"/>
+              </a:lnSpc>
+              <a:spcBef>
+                <a:spcPts val="0"/>
+              </a:spcBef>
+              <a:spcAft>
+                <a:spcPts val="0"/>
+              </a:spcAft>
+              <a:buNone/>
+            </a:pPr>
+            <a:r>
+              <a:rPr lang="en-US" sz="2000" b="0" dirty="0">
+                <a:solidFill>
+                  <a:schemeClr val="dk1"/>
+                </a:solidFill>
+                <a:latin typeface="Times New Roman" panose="02020603050405020304" pitchFamily="18" charset="0"/>
+                <a:cs typeface="Times New Roman" panose="02020603050405020304" pitchFamily="18" charset="0"/>
+              </a:rPr>
+              <a:t>KOSPI</a:t>
+            </a:r>
+          </a:p>
+        </p:txBody>
+      </p:sp>
+      <p:sp>
+        <p:nvSpPr>
+          <p:cNvPr id="3118" name="Selloff 2 value"/>
+          <p:cNvSpPr txBox="1"/>
+          <p:nvPr/>
+        </p:nvSpPr>
+        <p:spPr>
+          <a:xfrm>
+            <a:off x="8089392" y="2788920"/>
+            <a:ext cx="1578864" cy="685800"/>
+          </a:xfrm>
+          <a:prstGeom prst="rect">
+            <a:avLst/>
+          </a:prstGeom>
+          <a:noFill/>
+          <a:ln>
+            <a:noFill/>
+          </a:ln>
+        </p:spPr>
+        <p:txBody>
+          <a:bodyPr wrap="square" lIns="0" tIns="0" rIns="0" bIns="0" rtlCol="0" anchor="ctr">
+            <a:noAutofit/>
+          </a:bodyPr>
+          <a:lstStyle/>
+          <a:p>
+            <a:pPr marL="0" indent="0" algn="l">
+              <a:lnSpc>
+                <a:spcPct val="100000"/>
+              </a:lnSpc>
+              <a:spcBef>
+                <a:spcPts val="0"/>
+              </a:spcBef>
+              <a:spcAft>
+                <a:spcPts val="0"/>
+              </a:spcAft>
+              <a:buNone/>
+            </a:pPr>
+            <a:r>
+              <a:rPr lang="en-US" sz="4000" b="1" dirty="0">
+                <a:solidFill>
+                  <a:schemeClr val="dk2"/>
+                </a:solidFill>
+                <a:latin typeface="Times New Roman" panose="02020603050405020304" pitchFamily="18" charset="0"/>
+                <a:cs typeface="Times New Roman" panose="02020603050405020304" pitchFamily="18" charset="0"/>
+              </a:rPr>
+              <a:t>−7%</a:t>
+            </a:r>
+          </a:p>
+        </p:txBody>
+      </p:sp>
+      <p:sp>
+        <p:nvSpPr>
+          <p:cNvPr id="3119" name="Selloff 2 name"/>
+          <p:cNvSpPr txBox="1"/>
+          <p:nvPr/>
+        </p:nvSpPr>
+        <p:spPr>
+          <a:xfrm>
+            <a:off x="8089392" y="3474720"/>
+            <a:ext cx="1578864" cy="365760"/>
+          </a:xfrm>
+          <a:prstGeom prst="rect">
+            <a:avLst/>
+          </a:prstGeom>
+          <a:noFill/>
+          <a:ln>
+            <a:noFill/>
+          </a:ln>
+        </p:spPr>
+        <p:txBody>
+          <a:bodyPr wrap="square" lIns="0" tIns="0" rIns="0" bIns="0" rtlCol="0" anchor="t">
+            <a:noAutofit/>
+          </a:bodyPr>
+          <a:lstStyle/>
+          <a:p>
+            <a:pPr marL="0" indent="0" algn="l">
+              <a:lnSpc>
+                <a:spcPct val="100000"/>
+              </a:lnSpc>
+              <a:spcBef>
+                <a:spcPts val="0"/>
+              </a:spcBef>
+              <a:spcAft>
+                <a:spcPts val="0"/>
+              </a:spcAft>
+              <a:buNone/>
+            </a:pPr>
+            <a:r>
+              <a:rPr lang="en-US" sz="2000" b="0" dirty="0">
+                <a:solidFill>
+                  <a:schemeClr val="dk1"/>
+                </a:solidFill>
+                <a:latin typeface="Times New Roman" panose="02020603050405020304" pitchFamily="18" charset="0"/>
+                <a:cs typeface="Times New Roman" panose="02020603050405020304" pitchFamily="18" charset="0"/>
+              </a:rPr>
+              <a:t>Samsung</a:t>
+            </a:r>
+          </a:p>
+        </p:txBody>
+      </p:sp>
+      <p:sp>
+        <p:nvSpPr>
+          <p:cNvPr id="3120" name="Selloff 3 value"/>
+          <p:cNvSpPr txBox="1"/>
+          <p:nvPr/>
+        </p:nvSpPr>
+        <p:spPr>
+          <a:xfrm>
+            <a:off x="9668256" y="2788920"/>
+            <a:ext cx="1578864" cy="685800"/>
+          </a:xfrm>
+          <a:prstGeom prst="rect">
+            <a:avLst/>
+          </a:prstGeom>
+          <a:noFill/>
+          <a:ln>
+            <a:noFill/>
+          </a:ln>
+        </p:spPr>
+        <p:txBody>
+          <a:bodyPr wrap="square" lIns="0" tIns="0" rIns="0" bIns="0" rtlCol="0" anchor="ctr">
+            <a:noAutofit/>
+          </a:bodyPr>
+          <a:lstStyle/>
+          <a:p>
+            <a:pPr marL="0" indent="0" algn="l">
+              <a:lnSpc>
+                <a:spcPct val="100000"/>
+              </a:lnSpc>
+              <a:spcBef>
+                <a:spcPts val="0"/>
+              </a:spcBef>
+              <a:spcAft>
+                <a:spcPts val="0"/>
+              </a:spcAft>
+              <a:buNone/>
+            </a:pPr>
+            <a:r>
+              <a:rPr lang="en-US" sz="4000" b="1" dirty="0">
+                <a:solidFill>
+                  <a:schemeClr val="dk2"/>
+                </a:solidFill>
+                <a:latin typeface="Times New Roman" panose="02020603050405020304" pitchFamily="18" charset="0"/>
+                <a:cs typeface="Times New Roman" panose="02020603050405020304" pitchFamily="18" charset="0"/>
+              </a:rPr>
+              <a:t>−10%</a:t>
+            </a:r>
+          </a:p>
+        </p:txBody>
+      </p:sp>
+      <p:sp>
+        <p:nvSpPr>
+          <p:cNvPr id="3121" name="Selloff 3 name"/>
+          <p:cNvSpPr txBox="1"/>
+          <p:nvPr/>
+        </p:nvSpPr>
+        <p:spPr>
+          <a:xfrm>
+            <a:off x="9668256" y="3474720"/>
+            <a:ext cx="1578864" cy="365760"/>
+          </a:xfrm>
+          <a:prstGeom prst="rect">
+            <a:avLst/>
+          </a:prstGeom>
+          <a:noFill/>
+          <a:ln>
+            <a:noFill/>
+          </a:ln>
+        </p:spPr>
+        <p:txBody>
+          <a:bodyPr wrap="square" lIns="0" tIns="0" rIns="0" bIns="0" rtlCol="0" anchor="t">
+            <a:noAutofit/>
+          </a:bodyPr>
+          <a:lstStyle/>
+          <a:p>
+            <a:pPr marL="0" indent="0" algn="l">
+              <a:lnSpc>
+                <a:spcPct val="100000"/>
+              </a:lnSpc>
+              <a:spcBef>
+                <a:spcPts val="0"/>
+              </a:spcBef>
+              <a:spcAft>
+                <a:spcPts val="0"/>
+              </a:spcAft>
+              <a:buNone/>
+            </a:pPr>
+            <a:r>
+              <a:rPr lang="en-US" sz="2000" b="0" dirty="0">
+                <a:solidFill>
+                  <a:schemeClr val="dk1"/>
+                </a:solidFill>
+                <a:latin typeface="Times New Roman" panose="02020603050405020304" pitchFamily="18" charset="0"/>
+                <a:cs typeface="Times New Roman" panose="02020603050405020304" pitchFamily="18" charset="0"/>
+              </a:rPr>
+              <a:t>SK Hynix</a:t>
+            </a:r>
+          </a:p>
+        </p:txBody>
+      </p:sp>
+      <p:cxnSp>
+        <p:nvCxnSpPr>
+          <p:cNvPr id="3122" name="Selloff rule"/>
+          <p:cNvCxnSpPr/>
+          <p:nvPr/>
+        </p:nvCxnSpPr>
+        <p:spPr>
+          <a:xfrm>
+            <a:off x="6510528" y="3959352"/>
+            <a:ext cx="4736592" cy="0"/>
+          </a:xfrm>
+          <a:prstGeom prst="straightConnector1">
+            <a:avLst/>
+          </a:prstGeom>
+          <a:ln w="9525">
+            <a:solidFill>
+              <a:schemeClr val="accent4"/>
+            </a:solidFill>
+          </a:ln>
+        </p:spPr>
+      </p:cxnSp>
+      <p:sp>
+        <p:nvSpPr>
+          <p:cNvPr id="3123" name="July selloff"/>
+          <p:cNvSpPr txBox="1"/>
+          <p:nvPr/>
+        </p:nvSpPr>
+        <p:spPr>
+          <a:xfrm>
+            <a:off x="6510528" y="4041648"/>
+            <a:ext cx="4736592" cy="384048"/>
+          </a:xfrm>
+          <a:prstGeom prst="rect">
+            <a:avLst/>
+          </a:prstGeom>
+          <a:noFill/>
+          <a:ln>
+            <a:noFill/>
+          </a:ln>
+        </p:spPr>
+        <p:txBody>
+          <a:bodyPr wrap="square" lIns="0" tIns="0" rIns="0" bIns="0" rtlCol="0" anchor="t">
+            <a:noAutofit/>
+          </a:bodyPr>
+          <a:lstStyle/>
+          <a:p>
+            <a:pPr marL="0" indent="0" algn="l">
+              <a:lnSpc>
+                <a:spcPct val="100000"/>
+              </a:lnSpc>
+              <a:spcBef>
+                <a:spcPts val="0"/>
+              </a:spcBef>
+              <a:spcAft>
+                <a:spcPts val="0"/>
+              </a:spcAft>
+              <a:buNone/>
+            </a:pPr>
+            <a:r>
+              <a:rPr lang="en-US" sz="2000" b="1" dirty="0">
+                <a:solidFill>
+                  <a:schemeClr val="dk1"/>
+                </a:solidFill>
+                <a:latin typeface="Times New Roman" panose="02020603050405020304" pitchFamily="18" charset="0"/>
+                <a:cs typeface="Times New Roman" panose="02020603050405020304" pitchFamily="18" charset="0"/>
+              </a:rPr>
+              <a:t>July selloff: </a:t>
+            </a:r>
+            <a:r>
+              <a:rPr lang="en-US" sz="2000" b="1" dirty="0">
+                <a:solidFill>
+                  <a:schemeClr val="dk2"/>
+                </a:solidFill>
+                <a:latin typeface="Times New Roman" panose="02020603050405020304" pitchFamily="18" charset="0"/>
+                <a:cs typeface="Times New Roman" panose="02020603050405020304" pitchFamily="18" charset="0"/>
+              </a:rPr>
+              <a:t>KOSPI fell nearly 11%</a:t>
+            </a:r>
+          </a:p>
+        </p:txBody>
+      </p:sp>
+      <p:sp>
+        <p:nvSpPr>
+          <p:cNvPr id="3124" name="Selloff note"/>
+          <p:cNvSpPr txBox="1"/>
+          <p:nvPr/>
+        </p:nvSpPr>
+        <p:spPr>
+          <a:xfrm>
+            <a:off x="6510528" y="4498848"/>
+            <a:ext cx="4736592" cy="777240"/>
+          </a:xfrm>
+          <a:prstGeom prst="rect">
+            <a:avLst/>
+          </a:prstGeom>
+          <a:noFill/>
+          <a:ln>
+            <a:noFill/>
+          </a:ln>
+        </p:spPr>
+        <p:txBody>
+          <a:bodyPr wrap="square" lIns="0" tIns="0" rIns="0" bIns="0" rtlCol="0" anchor="t">
+            <a:noAutofit/>
+          </a:bodyPr>
+          <a:lstStyle/>
+          <a:p>
+            <a:pPr marL="0" indent="0" algn="l">
+              <a:lnSpc>
+                <a:spcPct val="100000"/>
+              </a:lnSpc>
+              <a:spcBef>
+                <a:spcPts val="0"/>
+              </a:spcBef>
+              <a:spcAft>
+                <a:spcPts val="0"/>
+              </a:spcAft>
+              <a:buNone/>
+            </a:pPr>
+            <a:r>
+              <a:rPr lang="en-US" sz="1600" b="0" i="1" dirty="0">
+                <a:solidFill>
+                  <a:schemeClr val="accent3"/>
+                </a:solidFill>
+                <a:latin typeface="Times New Roman" panose="02020603050405020304" pitchFamily="18" charset="0"/>
+                <a:cs typeface="Times New Roman" panose="02020603050405020304" pitchFamily="18" charset="0"/>
+              </a:rPr>
+              <a:t>AI-investment worries played a part, but CXMT's progress raised fears that more chip supply will squeeze Korean prices and profits</a:t>
+            </a:r>
+          </a:p>
+        </p:txBody>
+      </p:sp>
+      <p:sp>
+        <p:nvSpPr>
+          <p:cNvPr id="3125" name="Takeaway banner"/>
+          <p:cNvSpPr/>
+          <p:nvPr/>
+        </p:nvSpPr>
+        <p:spPr>
+          <a:xfrm>
+            <a:off x="950976" y="5440680"/>
+            <a:ext cx="10296144" cy="868680"/>
+          </a:xfrm>
+          <a:prstGeom prst="rect">
+            <a:avLst/>
+          </a:prstGeom>
+          <a:solidFill>
+            <a:schemeClr val="tx1">
+              <a:lumMod val="50000"/>
+              <a:lumOff val="50000"/>
+            </a:schemeClr>
+          </a:solidFill>
+          <a:ln>
+            <a:noFill/>
+          </a:ln>
+        </p:spPr>
+        <p:txBody>
+          <a:bodyPr wrap="square" lIns="91440" tIns="91440" rIns="91440" bIns="91440" rtlCol="0" anchor="ctr">
+            <a:noAutofit/>
+          </a:bodyPr>
+          <a:lstStyle/>
+          <a:p>
+            <a:pPr marL="0" indent="0" algn="ctr">
+              <a:lnSpc>
+                <a:spcPct val="100000"/>
+              </a:lnSpc>
+              <a:spcBef>
+                <a:spcPts val="0"/>
+              </a:spcBef>
+              <a:spcAft>
+                <a:spcPts val="0"/>
+              </a:spcAft>
+              <a:buNone/>
+            </a:pPr>
+            <a:r>
+              <a:rPr lang="en-US" sz="1800" b="1" dirty="0">
+                <a:solidFill>
+                  <a:schemeClr val="bg1"/>
+                </a:solidFill>
+                <a:latin typeface="Times New Roman" panose="02020603050405020304" pitchFamily="18" charset="0"/>
+                <a:cs typeface="Times New Roman" panose="02020603050405020304" pitchFamily="18" charset="0"/>
+              </a:rPr>
+              <a:t>Chinese demand supports Korean exports today, but competition could extend into higher-value chips. </a:t>
+            </a:r>
+            <a:r>
+              <a:rPr lang="en-US" sz="1800" b="1" i="1" dirty="0">
+                <a:solidFill>
+                  <a:schemeClr val="bg1"/>
+                </a:solidFill>
+                <a:latin typeface="Times New Roman" panose="02020603050405020304" pitchFamily="18" charset="0"/>
+                <a:cs typeface="Times New Roman" panose="02020603050405020304" pitchFamily="18" charset="0"/>
+              </a:rPr>
+              <a:t>Can Korea sustain its export strength as China shifts from customer to competitor?</a:t>
+            </a:r>
+          </a:p>
+        </p:txBody>
+      </p:sp>
+    </p:spTree>
+  </p:cSld>
+  <p:clrMapOvr>
+    <a:masterClrMapping/>
+  </p:clrMapOvr>
+</p:sld>
+</file>
+
+<file path=ppt/slides/slide7.xml><?xml version="1.0" encoding="utf-8"?>
+<p:sld xmlns:a="http://schemas.openxmlformats.org/drawingml/2006/main" xmlns:r="http://schemas.openxmlformats.org/officeDocument/2006/relationships" xmlns:p="http://schemas.openxmlformats.org/presentationml/2006/main">
+  <p:cSld>
+    <p:spTree>
+      <p:nvGrpSpPr>
+        <p:cNvPr id="1" name=""/>
+        <p:cNvGrpSpPr/>
+        <p:nvPr/>
+      </p:nvGrpSpPr>
+      <p:grpSpPr>
+        <a:xfrm>
+          <a:off x="0" y="0"/>
+          <a:ext cx="0" cy="0"/>
+          <a:chOff x="0" y="0"/>
+          <a:chExt cx="0" cy="0"/>
+        </a:xfrm>
+      </p:grpSpPr>
+      <p:sp>
+        <p:nvSpPr>
+          <p:cNvPr id="3126" name="Title band"/>
+          <p:cNvSpPr/>
+          <p:nvPr/>
+        </p:nvSpPr>
+        <p:spPr>
+          <a:xfrm>
+            <a:off x="0" y="274320"/>
+            <a:ext cx="10881360" cy="960120"/>
+          </a:xfrm>
+          <a:prstGeom prst="rect">
+            <a:avLst/>
+          </a:prstGeom>
+          <a:solidFill>
+            <a:schemeClr val="accent2"/>
+          </a:solidFill>
+          <a:ln>
+            <a:noFill/>
+          </a:ln>
+        </p:spPr>
+        <p:txBody>
+          <a:bodyPr wrap="square" lIns="0" tIns="0" rIns="0" bIns="0" rtlCol="0" anchor="t">
+            <a:noAutofit/>
+          </a:bodyPr>
+          <a:lstStyle/>
+          <a:p>
+            <a:endParaRPr lang="en-US">
+              <a:latin typeface="Times New Roman" panose="02020603050405020304" pitchFamily="18" charset="0"/>
+              <a:cs typeface="Times New Roman" panose="02020603050405020304" pitchFamily="18" charset="0"/>
+            </a:endParaRPr>
+          </a:p>
+        </p:txBody>
+      </p:sp>
+      <p:sp>
+        <p:nvSpPr>
+          <p:cNvPr id="3127" name="Title"/>
+          <p:cNvSpPr txBox="1">
+            <a:spLocks noGrp="1"/>
+          </p:cNvSpPr>
+          <p:nvPr>
+            <p:ph type="title"/>
+          </p:nvPr>
+        </p:nvSpPr>
+        <p:spPr>
+          <a:xfrm>
+            <a:off x="950976" y="274320"/>
+            <a:ext cx="9838944" cy="960120"/>
+          </a:xfrm>
+        </p:spPr>
+        <p:txBody>
+          <a:bodyPr spcFirstLastPara="1" wrap="square" lIns="121900" tIns="121900" rIns="121900" bIns="121900" anchor="ctr" anchorCtr="0">
+            <a:noAutofit/>
+          </a:bodyPr>
+          <a:lstStyle/>
+          <a:p>
+            <a:pPr algn="l"/>
+            <a:r>
+              <a:rPr lang="en-US" sz="3600" b="1" dirty="0">
+                <a:solidFill>
+                  <a:schemeClr val="lt1"/>
+                </a:solidFill>
+                <a:latin typeface="Times New Roman" panose="02020603050405020304" pitchFamily="18" charset="0"/>
+                <a:cs typeface="Times New Roman" panose="02020603050405020304" pitchFamily="18" charset="0"/>
+              </a:rPr>
+              <a:t>South Korea's Response</a:t>
+            </a:r>
+          </a:p>
+        </p:txBody>
+      </p:sp>
+      <p:sp>
+        <p:nvSpPr>
+          <p:cNvPr id="3128" name="Column 1 header"/>
+          <p:cNvSpPr/>
+          <p:nvPr/>
+        </p:nvSpPr>
+        <p:spPr>
+          <a:xfrm>
+            <a:off x="950976" y="1572768"/>
+            <a:ext cx="4690872" cy="868680"/>
+          </a:xfrm>
+          <a:prstGeom prst="rect">
+            <a:avLst/>
+          </a:prstGeom>
+          <a:solidFill>
+            <a:schemeClr val="accent2"/>
+          </a:solidFill>
+          <a:ln>
+            <a:noFill/>
+          </a:ln>
+        </p:spPr>
+        <p:txBody>
+          <a:bodyPr wrap="square" lIns="164592" tIns="164592" rIns="164592" bIns="164592" rtlCol="0" anchor="ctr">
+            <a:noAutofit/>
+          </a:bodyPr>
+          <a:lstStyle/>
+          <a:p>
+            <a:pPr marL="0" indent="0" algn="l">
+              <a:lnSpc>
+                <a:spcPct val="100000"/>
+              </a:lnSpc>
+              <a:spcBef>
+                <a:spcPts val="0"/>
+              </a:spcBef>
+              <a:spcAft>
+                <a:spcPts val="0"/>
+              </a:spcAft>
+              <a:buNone/>
+            </a:pPr>
+            <a:r>
+              <a:rPr lang="en-US" sz="2000" b="1" dirty="0">
+                <a:solidFill>
+                  <a:schemeClr val="bg1"/>
+                </a:solidFill>
+                <a:latin typeface="Times New Roman" panose="02020603050405020304" pitchFamily="18" charset="0"/>
+                <a:cs typeface="Times New Roman" panose="02020603050405020304" pitchFamily="18" charset="0"/>
+              </a:rPr>
+              <a:t>Private sector</a:t>
+            </a:r>
+          </a:p>
+          <a:p>
+            <a:pPr marL="0" indent="0" algn="l">
+              <a:lnSpc>
+                <a:spcPct val="100000"/>
+              </a:lnSpc>
+              <a:spcBef>
+                <a:spcPts val="0"/>
+              </a:spcBef>
+              <a:spcAft>
+                <a:spcPts val="0"/>
+              </a:spcAft>
+              <a:buNone/>
+            </a:pPr>
+            <a:r>
+              <a:rPr lang="en-US" sz="2000" b="0" dirty="0">
+                <a:solidFill>
+                  <a:schemeClr val="bg1"/>
+                </a:solidFill>
+                <a:latin typeface="Times New Roman" panose="02020603050405020304" pitchFamily="18" charset="0"/>
+                <a:cs typeface="Times New Roman" panose="02020603050405020304" pitchFamily="18" charset="0"/>
+              </a:rPr>
+              <a:t>Samsung Electronics &amp; SK Hynix</a:t>
+            </a:r>
+          </a:p>
+        </p:txBody>
+      </p:sp>
+      <p:sp>
+        <p:nvSpPr>
+          <p:cNvPr id="3129" name="Column 1 marker 1"/>
+          <p:cNvSpPr/>
+          <p:nvPr/>
+        </p:nvSpPr>
+        <p:spPr>
+          <a:xfrm>
+            <a:off x="996696" y="2788920"/>
+            <a:ext cx="182880" cy="182880"/>
+          </a:xfrm>
+          <a:prstGeom prst="rect">
+            <a:avLst/>
+          </a:prstGeom>
+          <a:solidFill>
+            <a:schemeClr val="accent2"/>
+          </a:solidFill>
+          <a:ln>
+            <a:noFill/>
+          </a:ln>
+        </p:spPr>
+        <p:txBody>
+          <a:bodyPr wrap="square" lIns="0" tIns="0" rIns="0" bIns="0" rtlCol="0" anchor="t">
+            <a:noAutofit/>
+          </a:bodyPr>
+          <a:lstStyle/>
+          <a:p>
+            <a:endParaRPr lang="en-US"/>
+          </a:p>
+        </p:txBody>
+      </p:sp>
+      <p:sp>
+        <p:nvSpPr>
+          <p:cNvPr id="3130" name="Column 1 point 1"/>
+          <p:cNvSpPr txBox="1"/>
+          <p:nvPr/>
+        </p:nvSpPr>
+        <p:spPr>
+          <a:xfrm>
+            <a:off x="1362456" y="2697480"/>
+            <a:ext cx="4233672" cy="777240"/>
+          </a:xfrm>
+          <a:prstGeom prst="rect">
+            <a:avLst/>
+          </a:prstGeom>
+          <a:noFill/>
+          <a:ln>
+            <a:noFill/>
+          </a:ln>
+        </p:spPr>
+        <p:txBody>
+          <a:bodyPr wrap="square" lIns="0" tIns="0" rIns="0" bIns="0" rtlCol="0" anchor="t">
+            <a:noAutofit/>
+          </a:bodyPr>
+          <a:lstStyle/>
+          <a:p>
+            <a:pPr marL="0" indent="0" algn="l">
+              <a:lnSpc>
+                <a:spcPct val="100000"/>
+              </a:lnSpc>
+              <a:spcBef>
+                <a:spcPts val="0"/>
+              </a:spcBef>
+              <a:spcAft>
+                <a:spcPts val="0"/>
+              </a:spcAft>
+              <a:buNone/>
+            </a:pPr>
+            <a:r>
+              <a:rPr lang="en-US" sz="2000" b="0" dirty="0">
+                <a:solidFill>
+                  <a:schemeClr val="dk1"/>
+                </a:solidFill>
+                <a:latin typeface="Times New Roman" panose="02020603050405020304" pitchFamily="18" charset="0"/>
+                <a:cs typeface="Times New Roman" panose="02020603050405020304" pitchFamily="18" charset="0"/>
+              </a:rPr>
+              <a:t>Focus on advanced memory, especially HBM, </a:t>
+            </a:r>
+            <a:r>
+              <a:rPr lang="en-US" sz="2000" b="1" dirty="0">
+                <a:solidFill>
+                  <a:schemeClr val="accent2"/>
+                </a:solidFill>
+                <a:latin typeface="Times New Roman" panose="02020603050405020304" pitchFamily="18" charset="0"/>
+                <a:cs typeface="Times New Roman" panose="02020603050405020304" pitchFamily="18" charset="0"/>
+              </a:rPr>
+              <a:t>where Korea leads China</a:t>
+            </a:r>
+          </a:p>
+        </p:txBody>
+      </p:sp>
+      <p:sp>
+        <p:nvSpPr>
+          <p:cNvPr id="3131" name="Column 1 marker 2"/>
+          <p:cNvSpPr/>
+          <p:nvPr/>
+        </p:nvSpPr>
+        <p:spPr>
+          <a:xfrm>
+            <a:off x="996696" y="3703320"/>
+            <a:ext cx="182880" cy="182880"/>
+          </a:xfrm>
+          <a:prstGeom prst="rect">
+            <a:avLst/>
+          </a:prstGeom>
+          <a:solidFill>
+            <a:schemeClr val="accent2"/>
+          </a:solidFill>
+          <a:ln>
+            <a:noFill/>
+          </a:ln>
+        </p:spPr>
+        <p:txBody>
+          <a:bodyPr wrap="square" lIns="0" tIns="0" rIns="0" bIns="0" rtlCol="0" anchor="t">
+            <a:noAutofit/>
+          </a:bodyPr>
+          <a:lstStyle/>
+          <a:p>
+            <a:endParaRPr lang="en-US"/>
+          </a:p>
+        </p:txBody>
+      </p:sp>
+      <p:sp>
+        <p:nvSpPr>
+          <p:cNvPr id="3132" name="Column 1 point 2"/>
+          <p:cNvSpPr txBox="1"/>
+          <p:nvPr/>
+        </p:nvSpPr>
+        <p:spPr>
+          <a:xfrm>
+            <a:off x="1362456" y="3611880"/>
+            <a:ext cx="4233672" cy="777240"/>
+          </a:xfrm>
+          <a:prstGeom prst="rect">
+            <a:avLst/>
+          </a:prstGeom>
+          <a:noFill/>
+          <a:ln>
+            <a:noFill/>
+          </a:ln>
+        </p:spPr>
+        <p:txBody>
+          <a:bodyPr wrap="square" lIns="0" tIns="0" rIns="0" bIns="0" rtlCol="0" anchor="t">
+            <a:noAutofit/>
+          </a:bodyPr>
+          <a:lstStyle/>
+          <a:p>
+            <a:pPr marL="0" indent="0" algn="l">
+              <a:lnSpc>
+                <a:spcPct val="100000"/>
+              </a:lnSpc>
+              <a:spcBef>
+                <a:spcPts val="0"/>
+              </a:spcBef>
+              <a:spcAft>
+                <a:spcPts val="0"/>
+              </a:spcAft>
+              <a:buNone/>
+            </a:pPr>
+            <a:r>
+              <a:rPr lang="en-US" sz="2000" b="0" dirty="0">
+                <a:solidFill>
+                  <a:schemeClr val="dk1"/>
+                </a:solidFill>
+                <a:latin typeface="Times New Roman" panose="02020603050405020304" pitchFamily="18" charset="0"/>
+                <a:cs typeface="Times New Roman" panose="02020603050405020304" pitchFamily="18" charset="0"/>
+              </a:rPr>
+              <a:t>CXMT is developing HBM but still struggles to make it reliably at scale</a:t>
+            </a:r>
+          </a:p>
+        </p:txBody>
+      </p:sp>
+      <p:sp>
+        <p:nvSpPr>
+          <p:cNvPr id="3133" name="Column 1 marker 3"/>
+          <p:cNvSpPr/>
+          <p:nvPr/>
+        </p:nvSpPr>
+        <p:spPr>
+          <a:xfrm>
+            <a:off x="996696" y="4617720"/>
+            <a:ext cx="182880" cy="182880"/>
+          </a:xfrm>
+          <a:prstGeom prst="rect">
+            <a:avLst/>
+          </a:prstGeom>
+          <a:solidFill>
+            <a:schemeClr val="accent2"/>
+          </a:solidFill>
+          <a:ln>
+            <a:noFill/>
+          </a:ln>
+        </p:spPr>
+        <p:txBody>
+          <a:bodyPr wrap="square" lIns="0" tIns="0" rIns="0" bIns="0" rtlCol="0" anchor="t">
+            <a:noAutofit/>
+          </a:bodyPr>
+          <a:lstStyle/>
+          <a:p>
+            <a:endParaRPr lang="en-US"/>
+          </a:p>
+        </p:txBody>
+      </p:sp>
+      <p:sp>
+        <p:nvSpPr>
+          <p:cNvPr id="3134" name="Column 1 point 3"/>
+          <p:cNvSpPr txBox="1"/>
+          <p:nvPr/>
+        </p:nvSpPr>
+        <p:spPr>
+          <a:xfrm>
+            <a:off x="1362456" y="4526280"/>
+            <a:ext cx="4233672" cy="777240"/>
+          </a:xfrm>
+          <a:prstGeom prst="rect">
+            <a:avLst/>
+          </a:prstGeom>
+          <a:noFill/>
+          <a:ln>
+            <a:noFill/>
+          </a:ln>
+        </p:spPr>
+        <p:txBody>
+          <a:bodyPr wrap="square" lIns="0" tIns="0" rIns="0" bIns="0" rtlCol="0" anchor="t">
+            <a:noAutofit/>
+          </a:bodyPr>
+          <a:lstStyle/>
+          <a:p>
+            <a:pPr marL="0" indent="0" algn="l">
+              <a:lnSpc>
+                <a:spcPct val="100000"/>
+              </a:lnSpc>
+              <a:spcBef>
+                <a:spcPts val="0"/>
+              </a:spcBef>
+              <a:spcAft>
+                <a:spcPts val="0"/>
+              </a:spcAft>
+              <a:buNone/>
+            </a:pPr>
+            <a:r>
+              <a:rPr lang="en-US" sz="2000" b="1" dirty="0">
+                <a:solidFill>
+                  <a:schemeClr val="accent2"/>
+                </a:solidFill>
+                <a:latin typeface="Times New Roman" panose="02020603050405020304" pitchFamily="18" charset="0"/>
+                <a:cs typeface="Times New Roman" panose="02020603050405020304" pitchFamily="18" charset="0"/>
+              </a:rPr>
+              <a:t>Strategy: </a:t>
+            </a:r>
+            <a:r>
+              <a:rPr lang="en-US" sz="2000" b="0" dirty="0">
+                <a:solidFill>
+                  <a:schemeClr val="dk1"/>
+                </a:solidFill>
+                <a:latin typeface="Times New Roman" panose="02020603050405020304" pitchFamily="18" charset="0"/>
+                <a:cs typeface="Times New Roman" panose="02020603050405020304" pitchFamily="18" charset="0"/>
+              </a:rPr>
+              <a:t>higher-value chips as China gains in conventional DRAM</a:t>
+            </a:r>
+          </a:p>
+        </p:txBody>
+      </p:sp>
+      <p:sp>
+        <p:nvSpPr>
+          <p:cNvPr id="3135" name="Column 2 header"/>
+          <p:cNvSpPr/>
+          <p:nvPr/>
+        </p:nvSpPr>
+        <p:spPr>
+          <a:xfrm>
+            <a:off x="6007608" y="1572768"/>
+            <a:ext cx="4690872" cy="868680"/>
+          </a:xfrm>
+          <a:prstGeom prst="rect">
+            <a:avLst/>
+          </a:prstGeom>
+          <a:solidFill>
+            <a:schemeClr val="accent5"/>
+          </a:solidFill>
+          <a:ln>
+            <a:noFill/>
+          </a:ln>
+        </p:spPr>
+        <p:txBody>
+          <a:bodyPr wrap="square" lIns="164592" tIns="164592" rIns="164592" bIns="164592" rtlCol="0" anchor="ctr">
+            <a:noAutofit/>
+          </a:bodyPr>
+          <a:lstStyle/>
+          <a:p>
+            <a:pPr marL="0" indent="0" algn="l">
+              <a:lnSpc>
+                <a:spcPct val="100000"/>
+              </a:lnSpc>
+              <a:spcBef>
+                <a:spcPts val="0"/>
+              </a:spcBef>
+              <a:spcAft>
+                <a:spcPts val="0"/>
+              </a:spcAft>
+              <a:buNone/>
+            </a:pPr>
+            <a:r>
+              <a:rPr lang="en-US" sz="2000" b="1" dirty="0">
+                <a:solidFill>
+                  <a:schemeClr val="bg1"/>
+                </a:solidFill>
+                <a:latin typeface="Times New Roman" panose="02020603050405020304" pitchFamily="18" charset="0"/>
+                <a:cs typeface="Times New Roman" panose="02020603050405020304" pitchFamily="18" charset="0"/>
+              </a:rPr>
+              <a:t>Government</a:t>
+            </a:r>
+          </a:p>
+          <a:p>
+            <a:pPr marL="0" indent="0" algn="l">
+              <a:lnSpc>
+                <a:spcPct val="100000"/>
+              </a:lnSpc>
+              <a:spcBef>
+                <a:spcPts val="0"/>
+              </a:spcBef>
+              <a:spcAft>
+                <a:spcPts val="0"/>
+              </a:spcAft>
+              <a:buNone/>
+            </a:pPr>
+            <a:r>
+              <a:rPr lang="en-US" sz="2000" b="0" dirty="0">
+                <a:solidFill>
+                  <a:schemeClr val="bg1"/>
+                </a:solidFill>
+                <a:latin typeface="Times New Roman" panose="02020603050405020304" pitchFamily="18" charset="0"/>
+                <a:cs typeface="Times New Roman" panose="02020603050405020304" pitchFamily="18" charset="0"/>
+              </a:rPr>
+              <a:t>Semiconductor Special Act</a:t>
+            </a:r>
+          </a:p>
+        </p:txBody>
+      </p:sp>
+      <p:sp>
+        <p:nvSpPr>
+          <p:cNvPr id="3136" name="Column 2 marker 1"/>
+          <p:cNvSpPr/>
+          <p:nvPr/>
+        </p:nvSpPr>
+        <p:spPr>
+          <a:xfrm>
+            <a:off x="6053328" y="2788920"/>
+            <a:ext cx="182880" cy="182880"/>
+          </a:xfrm>
+          <a:prstGeom prst="rect">
+            <a:avLst/>
+          </a:prstGeom>
+          <a:solidFill>
+            <a:schemeClr val="accent5"/>
+          </a:solidFill>
+          <a:ln>
+            <a:noFill/>
+          </a:ln>
+        </p:spPr>
+        <p:txBody>
+          <a:bodyPr wrap="square" lIns="0" tIns="0" rIns="0" bIns="0" rtlCol="0" anchor="t">
+            <a:noAutofit/>
+          </a:bodyPr>
+          <a:lstStyle/>
+          <a:p>
+            <a:endParaRPr lang="en-US"/>
+          </a:p>
+        </p:txBody>
+      </p:sp>
+      <p:sp>
+        <p:nvSpPr>
+          <p:cNvPr id="3137" name="Column 2 point 1"/>
+          <p:cNvSpPr txBox="1"/>
+          <p:nvPr/>
+        </p:nvSpPr>
+        <p:spPr>
+          <a:xfrm>
+            <a:off x="6419088" y="2697480"/>
+            <a:ext cx="4233672" cy="777240"/>
+          </a:xfrm>
+          <a:prstGeom prst="rect">
+            <a:avLst/>
+          </a:prstGeom>
+          <a:noFill/>
+          <a:ln>
+            <a:noFill/>
+          </a:ln>
+        </p:spPr>
+        <p:txBody>
+          <a:bodyPr wrap="square" lIns="0" tIns="0" rIns="0" bIns="0" rtlCol="0" anchor="t">
+            <a:noAutofit/>
+          </a:bodyPr>
+          <a:lstStyle/>
+          <a:p>
+            <a:pPr marL="0" indent="0" algn="l">
+              <a:lnSpc>
+                <a:spcPct val="100000"/>
+              </a:lnSpc>
+              <a:spcBef>
+                <a:spcPts val="0"/>
+              </a:spcBef>
+              <a:spcAft>
+                <a:spcPts val="0"/>
+              </a:spcAft>
+              <a:buNone/>
+            </a:pPr>
+            <a:r>
+              <a:rPr lang="en-US" sz="2000" b="1" dirty="0">
+                <a:solidFill>
+                  <a:schemeClr val="accent2"/>
+                </a:solidFill>
+                <a:latin typeface="Times New Roman" panose="02020603050405020304" pitchFamily="18" charset="0"/>
+                <a:cs typeface="Times New Roman" panose="02020603050405020304" pitchFamily="18" charset="0"/>
+              </a:rPr>
+              <a:t>Took effect August 11, 2026</a:t>
+            </a:r>
+          </a:p>
+        </p:txBody>
+      </p:sp>
+      <p:sp>
+        <p:nvSpPr>
+          <p:cNvPr id="3138" name="Column 2 marker 2"/>
+          <p:cNvSpPr/>
+          <p:nvPr/>
+        </p:nvSpPr>
+        <p:spPr>
+          <a:xfrm>
+            <a:off x="6053328" y="3703320"/>
+            <a:ext cx="182880" cy="182880"/>
+          </a:xfrm>
+          <a:prstGeom prst="rect">
+            <a:avLst/>
+          </a:prstGeom>
+          <a:solidFill>
+            <a:schemeClr val="accent5"/>
+          </a:solidFill>
+          <a:ln>
+            <a:noFill/>
+          </a:ln>
+        </p:spPr>
+        <p:txBody>
+          <a:bodyPr wrap="square" lIns="0" tIns="0" rIns="0" bIns="0" rtlCol="0" anchor="t">
+            <a:noAutofit/>
+          </a:bodyPr>
+          <a:lstStyle/>
+          <a:p>
+            <a:endParaRPr lang="en-US"/>
+          </a:p>
+        </p:txBody>
+      </p:sp>
+      <p:sp>
+        <p:nvSpPr>
+          <p:cNvPr id="3139" name="Column 2 point 2"/>
+          <p:cNvSpPr txBox="1"/>
+          <p:nvPr/>
+        </p:nvSpPr>
+        <p:spPr>
+          <a:xfrm>
+            <a:off x="6419088" y="3611880"/>
+            <a:ext cx="4233672" cy="777240"/>
+          </a:xfrm>
+          <a:prstGeom prst="rect">
+            <a:avLst/>
+          </a:prstGeom>
+          <a:noFill/>
+          <a:ln>
+            <a:noFill/>
+          </a:ln>
+        </p:spPr>
+        <p:txBody>
+          <a:bodyPr wrap="square" lIns="0" tIns="0" rIns="0" bIns="0" rtlCol="0" anchor="t">
+            <a:noAutofit/>
+          </a:bodyPr>
+          <a:lstStyle/>
+          <a:p>
+            <a:pPr marL="0" indent="0" algn="l">
+              <a:lnSpc>
+                <a:spcPct val="100000"/>
+              </a:lnSpc>
+              <a:spcBef>
+                <a:spcPts val="0"/>
+              </a:spcBef>
+              <a:spcAft>
+                <a:spcPts val="0"/>
+              </a:spcAft>
+              <a:buNone/>
+            </a:pPr>
+            <a:r>
+              <a:rPr lang="en-US" sz="2000" b="0" dirty="0">
+                <a:solidFill>
+                  <a:schemeClr val="dk1"/>
+                </a:solidFill>
+                <a:latin typeface="Times New Roman" panose="02020603050405020304" pitchFamily="18" charset="0"/>
+                <a:cs typeface="Times New Roman" panose="02020603050405020304" pitchFamily="18" charset="0"/>
+              </a:rPr>
+              <a:t>Expands manufacturing infrastructure, chip clusters and R&amp;D support</a:t>
+            </a:r>
+          </a:p>
+        </p:txBody>
+      </p:sp>
+      <p:sp>
+        <p:nvSpPr>
+          <p:cNvPr id="3140" name="Column 2 marker 3"/>
+          <p:cNvSpPr/>
+          <p:nvPr/>
+        </p:nvSpPr>
+        <p:spPr>
+          <a:xfrm>
+            <a:off x="6053328" y="4617720"/>
+            <a:ext cx="182880" cy="182880"/>
+          </a:xfrm>
+          <a:prstGeom prst="rect">
+            <a:avLst/>
+          </a:prstGeom>
+          <a:solidFill>
+            <a:schemeClr val="accent5"/>
+          </a:solidFill>
+          <a:ln>
+            <a:noFill/>
+          </a:ln>
+        </p:spPr>
+        <p:txBody>
+          <a:bodyPr wrap="square" lIns="0" tIns="0" rIns="0" bIns="0" rtlCol="0" anchor="t">
+            <a:noAutofit/>
+          </a:bodyPr>
+          <a:lstStyle/>
+          <a:p>
+            <a:endParaRPr lang="en-US"/>
+          </a:p>
+        </p:txBody>
+      </p:sp>
+      <p:sp>
+        <p:nvSpPr>
+          <p:cNvPr id="3141" name="Column 2 point 3"/>
+          <p:cNvSpPr txBox="1"/>
+          <p:nvPr/>
+        </p:nvSpPr>
+        <p:spPr>
+          <a:xfrm>
+            <a:off x="6419088" y="4526280"/>
+            <a:ext cx="4233672" cy="777240"/>
+          </a:xfrm>
+          <a:prstGeom prst="rect">
+            <a:avLst/>
+          </a:prstGeom>
+          <a:noFill/>
+          <a:ln>
+            <a:noFill/>
+          </a:ln>
+        </p:spPr>
+        <p:txBody>
+          <a:bodyPr wrap="square" lIns="0" tIns="0" rIns="0" bIns="0" rtlCol="0" anchor="t">
+            <a:noAutofit/>
+          </a:bodyPr>
+          <a:lstStyle/>
+          <a:p>
+            <a:pPr marL="0" indent="0" algn="l">
+              <a:lnSpc>
+                <a:spcPct val="100000"/>
+              </a:lnSpc>
+              <a:spcBef>
+                <a:spcPts val="0"/>
+              </a:spcBef>
+              <a:spcAft>
+                <a:spcPts val="0"/>
+              </a:spcAft>
+              <a:buNone/>
+            </a:pPr>
+            <a:r>
+              <a:rPr lang="en-US" sz="2000" b="1" dirty="0">
+                <a:solidFill>
+                  <a:schemeClr val="accent2"/>
+                </a:solidFill>
+                <a:latin typeface="Times New Roman" panose="02020603050405020304" pitchFamily="18" charset="0"/>
+                <a:cs typeface="Times New Roman" panose="02020603050405020304" pitchFamily="18" charset="0"/>
+              </a:rPr>
+              <a:t>Goal: </a:t>
+            </a:r>
+            <a:r>
+              <a:rPr lang="en-US" sz="2000" b="0" dirty="0">
+                <a:solidFill>
+                  <a:schemeClr val="dk1"/>
+                </a:solidFill>
+                <a:latin typeface="Times New Roman" panose="02020603050405020304" pitchFamily="18" charset="0"/>
+                <a:cs typeface="Times New Roman" panose="02020603050405020304" pitchFamily="18" charset="0"/>
+              </a:rPr>
+              <a:t>stronger competitiveness amid rising competition, including China's</a:t>
+            </a:r>
+          </a:p>
+        </p:txBody>
+      </p:sp>
+      <p:sp>
+        <p:nvSpPr>
+          <p:cNvPr id="3142" name="Takeaway banner"/>
+          <p:cNvSpPr/>
+          <p:nvPr/>
+        </p:nvSpPr>
+        <p:spPr>
+          <a:xfrm>
+            <a:off x="950976" y="5440680"/>
+            <a:ext cx="9747504" cy="731520"/>
+          </a:xfrm>
+          <a:prstGeom prst="rect">
+            <a:avLst/>
+          </a:prstGeom>
+          <a:solidFill>
+            <a:schemeClr val="tx1">
+              <a:lumMod val="50000"/>
+              <a:lumOff val="50000"/>
+            </a:schemeClr>
+          </a:solidFill>
+          <a:ln>
+            <a:noFill/>
+          </a:ln>
+        </p:spPr>
+        <p:txBody>
+          <a:bodyPr wrap="square" lIns="91440" tIns="91440" rIns="91440" bIns="91440" rtlCol="0" anchor="ctr">
+            <a:noAutofit/>
+          </a:bodyPr>
+          <a:lstStyle/>
+          <a:p>
+            <a:pPr marL="0" indent="0" algn="ctr">
+              <a:lnSpc>
+                <a:spcPct val="100000"/>
+              </a:lnSpc>
+              <a:spcBef>
+                <a:spcPts val="0"/>
+              </a:spcBef>
+              <a:spcAft>
+                <a:spcPts val="0"/>
+              </a:spcAft>
+              <a:buNone/>
+            </a:pPr>
+            <a:r>
+              <a:rPr lang="en-US" sz="2000" b="1" dirty="0">
+                <a:solidFill>
+                  <a:schemeClr val="bg1"/>
+                </a:solidFill>
+                <a:latin typeface="Times New Roman" panose="02020603050405020304" pitchFamily="18" charset="0"/>
+                <a:cs typeface="Times New Roman" panose="02020603050405020304" pitchFamily="18" charset="0"/>
+              </a:rPr>
+              <a:t>Korea's strategy: move up to higher-value chips, backed by government support</a:t>
+            </a:r>
+          </a:p>
+        </p:txBody>
+      </p:sp>
+    </p:spTree>
+  </p:cSld>
+  <p:clrMapOvr>
+    <a:masterClrMapping/>
+  </p:clrMapOvr>
+</p:sld>
+</file>
+
 <file path=ppt/theme/theme1.xml><?xml version="1.0" encoding="utf-8"?>
 <a:theme xmlns:a="http://schemas.openxmlformats.org/drawingml/2006/main" name="The Four Asian Tigers: Singapore, Hong Kong, Taiwan and South Korea by Slidesgo">
   <a:themeElements>

</xml_diff>

<commit_message>
Split paradox slide into short-term and long-term slides with photo space
Co-Authored-By: Claude Opus 5.5 <noreply@anthropic.com>
Claude-Session: https://claude.ai/code/session_01EAqNWxuCBt8vBHk7fm7zMv
</commit_message>
<xml_diff>
--- a/korea-china-trade.pptx
+++ b/korea-china-trade.pptx
@@ -16,6 +16,7 @@
     <p:sldId id="286" r:id="rId7"/>
     <p:sldId id="287" r:id="rId29"/>
     <p:sldId id="288" r:id="rId30"/>
+    <p:sldId id="289" r:id="rId31"/>
   </p:sldIdLst>
   <p:sldSz cx="12192000" cy="6858000"/>
   <p:notesSz cx="6858000" cy="9144000"/>
@@ -32190,21 +32191,21 @@
                 <a:latin typeface="Times New Roman" panose="02020603050405020304" pitchFamily="18" charset="0"/>
                 <a:cs typeface="Times New Roman" panose="02020603050405020304" pitchFamily="18" charset="0"/>
               </a:rPr>
-              <a:t>The Paradox: Strong Demand, Growing Risk</a:t>
+              <a:t>Short-Term: Chinese Demand Persists</a:t>
             </a:r>
           </a:p>
         </p:txBody>
       </p:sp>
       <p:sp>
         <p:nvSpPr>
-          <p:cNvPr id="3103" name="Left heading"/>
+          <p:cNvPr id="3103" name="Share label"/>
           <p:cNvSpPr txBox="1"/>
           <p:nvPr/>
         </p:nvSpPr>
         <p:spPr>
           <a:xfrm>
-            <a:off x="950976" y="1572768"/>
-            <a:ext cx="4736592" cy="731520"/>
+            <a:off x="950976" y="1828800"/>
+            <a:ext cx="5120640" cy="411480"/>
           </a:xfrm>
           <a:prstGeom prst="rect">
             <a:avLst/>
@@ -32240,9 +32241,35 @@
                 <a:latin typeface="Times New Roman" panose="02020603050405020304" pitchFamily="18" charset="0"/>
                 <a:cs typeface="Times New Roman" panose="02020603050405020304" pitchFamily="18" charset="0"/>
               </a:rPr>
-              <a:t>Short-term strength</a:t>
+              <a:t>China's share of Korea's memory chip exports</a:t>
             </a:r>
           </a:p>
+        </p:txBody>
+      </p:sp>
+      <p:sp>
+        <p:nvSpPr>
+          <p:cNvPr id="3104" name="Share 2018"/>
+          <p:cNvSpPr txBox="1"/>
+          <p:nvPr/>
+        </p:nvSpPr>
+        <p:spPr>
+          <a:xfrm>
+            <a:off x="950976" y="2377440"/>
+            <a:ext cx="2194560" cy="960120"/>
+          </a:xfrm>
+          <a:prstGeom prst="rect">
+            <a:avLst/>
+          </a:prstGeom>
+          <a:noFill/>
+          <a:ln>
+            <a:noFill/>
+          </a:ln>
+        </p:spPr>
+        <p:txBody>
+          <a:bodyPr wrap="square" lIns="0" tIns="0" rIns="0" bIns="0" rtlCol="0" anchor="ctr">
+            <a:noAutofit/>
+          </a:bodyPr>
+          <a:lstStyle/>
           <a:p>
             <a:pPr marL="0" indent="0" algn="l">
               <a:lnSpc>
@@ -32257,28 +32284,100 @@
               <a:buNone/>
             </a:pPr>
             <a:r>
-              <a:rPr lang="en-US" sz="2000" b="1" dirty="0">
+              <a:rPr lang="en-US" sz="6000" b="1" dirty="0">
+                <a:solidFill>
+                  <a:schemeClr val="accent4"/>
+                </a:solidFill>
+                <a:latin typeface="Times New Roman" panose="02020603050405020304" pitchFamily="18" charset="0"/>
+                <a:cs typeface="Times New Roman" panose="02020603050405020304" pitchFamily="18" charset="0"/>
+              </a:rPr>
+              <a:t>45.7%</a:t>
+            </a:r>
+          </a:p>
+        </p:txBody>
+      </p:sp>
+      <p:cxnSp>
+        <p:nvCxnSpPr>
+          <p:cNvPr id="3105" name="Share arrow"/>
+          <p:cNvCxnSpPr/>
+          <p:nvPr/>
+        </p:nvCxnSpPr>
+        <p:spPr>
+          <a:xfrm>
+            <a:off x="3191256" y="2857500"/>
+            <a:ext cx="640080" cy="0"/>
+          </a:xfrm>
+          <a:prstGeom prst="straightConnector1">
+            <a:avLst/>
+          </a:prstGeom>
+          <a:ln w="22225">
+            <a:solidFill>
+              <a:schemeClr val="dk1"/>
+            </a:solidFill>
+            <a:tailEnd type="triangle" w="med" len="med"/>
+          </a:ln>
+        </p:spPr>
+      </p:cxnSp>
+      <p:sp>
+        <p:nvSpPr>
+          <p:cNvPr id="3106" name="Share 2024"/>
+          <p:cNvSpPr txBox="1"/>
+          <p:nvPr/>
+        </p:nvSpPr>
+        <p:spPr>
+          <a:xfrm>
+            <a:off x="3968496" y="2377440"/>
+            <a:ext cx="2194560" cy="960120"/>
+          </a:xfrm>
+          <a:prstGeom prst="rect">
+            <a:avLst/>
+          </a:prstGeom>
+          <a:noFill/>
+          <a:ln>
+            <a:noFill/>
+          </a:ln>
+        </p:spPr>
+        <p:txBody>
+          <a:bodyPr wrap="square" lIns="0" tIns="0" rIns="0" bIns="0" rtlCol="0" anchor="ctr">
+            <a:noAutofit/>
+          </a:bodyPr>
+          <a:lstStyle/>
+          <a:p>
+            <a:pPr marL="0" indent="0" algn="l">
+              <a:lnSpc>
+                <a:spcPct val="100000"/>
+              </a:lnSpc>
+              <a:spcBef>
+                <a:spcPts val="0"/>
+              </a:spcBef>
+              <a:spcAft>
+                <a:spcPts val="0"/>
+              </a:spcAft>
+              <a:buNone/>
+            </a:pPr>
+            <a:r>
+              <a:rPr lang="en-US" sz="6000" b="1" dirty="0">
                 <a:solidFill>
                   <a:schemeClr val="accent2"/>
                 </a:solidFill>
                 <a:latin typeface="Times New Roman" panose="02020603050405020304" pitchFamily="18" charset="0"/>
                 <a:cs typeface="Times New Roman" panose="02020603050405020304" pitchFamily="18" charset="0"/>
               </a:rPr>
-              <a:t>Chinese demand persists</a:t>
+              <a:t>31.7%</a:t>
             </a:r>
           </a:p>
         </p:txBody>
       </p:sp>
       <p:sp>
         <p:nvSpPr>
-          <p:cNvPr id="3104" name="Right heading"/>
+          <p:cNvPr id="3107" name="Year 2018"/>
           <p:cNvSpPr txBox="1"/>
           <p:nvPr/>
         </p:nvSpPr>
         <p:spPr>
           <a:xfrm>
-            <a:off x="6510528" y="1572768"/>
-            <a:ext cx="4736592" cy="731520"/>
+            <a:off x="950976" y="3337560"/>
+            <a:ext cx="2194560" cy="365760"/>
           </a:xfrm>
           <a:prstGeom prst="rect">
             <a:avLst/>
@@ -32307,195 +32406,28 @@
               <a:buNone/>
             </a:pPr>
             <a:r>
-              <a:rPr lang="en-US" sz="2000" b="1" dirty="0">
+              <a:rPr lang="en-US" sz="2000" b="0" dirty="0">
                 <a:solidFill>
-                  <a:schemeClr val="dk2"/>
+                  <a:schemeClr val="accent3"/>
                 </a:solidFill>
                 <a:latin typeface="Times New Roman" panose="02020603050405020304" pitchFamily="18" charset="0"/>
                 <a:cs typeface="Times New Roman" panose="02020603050405020304" pitchFamily="18" charset="0"/>
               </a:rPr>
-              <a:t>Long-term risk</a:t>
-            </a:r>
-          </a:p>
-          <a:p>
-            <a:pPr marL="0" indent="0" algn="l">
-              <a:lnSpc>
-                <a:spcPct val="100000"/>
-              </a:lnSpc>
-              <a:spcBef>
-                <a:spcPts val="0"/>
-              </a:spcBef>
-              <a:spcAft>
-                <a:spcPts val="0"/>
-              </a:spcAft>
-              <a:buNone/>
-            </a:pPr>
-            <a:r>
-              <a:rPr lang="en-US" sz="2000" b="1" dirty="0">
-                <a:solidFill>
-                  <a:schemeClr val="accent2"/>
-                </a:solidFill>
-                <a:latin typeface="Times New Roman" panose="02020603050405020304" pitchFamily="18" charset="0"/>
-                <a:cs typeface="Times New Roman" panose="02020603050405020304" pitchFamily="18" charset="0"/>
-              </a:rPr>
-              <a:t>Markets fear China's competitiveness</a:t>
-            </a:r>
-          </a:p>
-        </p:txBody>
-      </p:sp>
-      <p:cxnSp>
-        <p:nvCxnSpPr>
-          <p:cNvPr id="3105" name="Column divider"/>
-          <p:cNvCxnSpPr/>
-          <p:nvPr/>
-        </p:nvCxnSpPr>
-        <p:spPr>
-          <a:xfrm>
-            <a:off x="6099048" y="1645920"/>
-            <a:ext cx="0" cy="3520440"/>
-          </a:xfrm>
-          <a:prstGeom prst="straightConnector1">
-            <a:avLst/>
-          </a:prstGeom>
-          <a:ln w="9525">
-            <a:solidFill>
-              <a:schemeClr val="accent4"/>
-            </a:solidFill>
-          </a:ln>
-        </p:spPr>
-      </p:cxnSp>
-      <p:sp>
-        <p:nvSpPr>
-          <p:cNvPr id="3106" name="Share 2018"/>
-          <p:cNvSpPr txBox="1"/>
-          <p:nvPr/>
-        </p:nvSpPr>
-        <p:spPr>
-          <a:xfrm>
-            <a:off x="950976" y="2468880"/>
-            <a:ext cx="1828800" cy="777240"/>
-          </a:xfrm>
-          <a:prstGeom prst="rect">
-            <a:avLst/>
-          </a:prstGeom>
-          <a:noFill/>
-          <a:ln>
-            <a:noFill/>
-          </a:ln>
-        </p:spPr>
-        <p:txBody>
-          <a:bodyPr wrap="square" lIns="0" tIns="0" rIns="0" bIns="0" rtlCol="0" anchor="ctr">
-            <a:noAutofit/>
-          </a:bodyPr>
-          <a:lstStyle/>
-          <a:p>
-            <a:pPr marL="0" indent="0" algn="l">
-              <a:lnSpc>
-                <a:spcPct val="100000"/>
-              </a:lnSpc>
-              <a:spcBef>
-                <a:spcPts val="0"/>
-              </a:spcBef>
-              <a:spcAft>
-                <a:spcPts val="0"/>
-              </a:spcAft>
-              <a:buNone/>
-            </a:pPr>
-            <a:r>
-              <a:rPr lang="en-US" sz="4800" b="1" dirty="0">
-                <a:solidFill>
-                  <a:schemeClr val="accent4"/>
-                </a:solidFill>
-                <a:latin typeface="Times New Roman" panose="02020603050405020304" pitchFamily="18" charset="0"/>
-                <a:cs typeface="Times New Roman" panose="02020603050405020304" pitchFamily="18" charset="0"/>
-              </a:rPr>
-              <a:t>45.7%</a:t>
-            </a:r>
-          </a:p>
-        </p:txBody>
-      </p:sp>
-      <p:cxnSp>
-        <p:nvCxnSpPr>
-          <p:cNvPr id="3107" name="Share arrow"/>
-          <p:cNvCxnSpPr/>
-          <p:nvPr/>
-        </p:nvCxnSpPr>
-        <p:spPr>
-          <a:xfrm>
-            <a:off x="2825496" y="2857500"/>
-            <a:ext cx="731520" cy="0"/>
-          </a:xfrm>
-          <a:prstGeom prst="straightConnector1">
-            <a:avLst/>
-          </a:prstGeom>
-          <a:ln w="22225">
-            <a:solidFill>
-              <a:schemeClr val="dk1"/>
-            </a:solidFill>
-            <a:tailEnd type="triangle" w="med" len="med"/>
-          </a:ln>
-        </p:spPr>
-      </p:cxnSp>
-      <p:sp>
-        <p:nvSpPr>
-          <p:cNvPr id="3108" name="Share 2024"/>
-          <p:cNvSpPr txBox="1"/>
-          <p:nvPr/>
-        </p:nvSpPr>
-        <p:spPr>
-          <a:xfrm>
-            <a:off x="3694176" y="2468880"/>
-            <a:ext cx="1920240" cy="777240"/>
-          </a:xfrm>
-          <a:prstGeom prst="rect">
-            <a:avLst/>
-          </a:prstGeom>
-          <a:noFill/>
-          <a:ln>
-            <a:noFill/>
-          </a:ln>
-        </p:spPr>
-        <p:txBody>
-          <a:bodyPr wrap="square" lIns="0" tIns="0" rIns="0" bIns="0" rtlCol="0" anchor="ctr">
-            <a:noAutofit/>
-          </a:bodyPr>
-          <a:lstStyle/>
-          <a:p>
-            <a:pPr marL="0" indent="0" algn="l">
-              <a:lnSpc>
-                <a:spcPct val="100000"/>
-              </a:lnSpc>
-              <a:spcBef>
-                <a:spcPts val="0"/>
-              </a:spcBef>
-              <a:spcAft>
-                <a:spcPts val="0"/>
-              </a:spcAft>
-              <a:buNone/>
-            </a:pPr>
-            <a:r>
-              <a:rPr lang="en-US" sz="4800" b="1" dirty="0">
-                <a:solidFill>
-                  <a:schemeClr val="accent2"/>
-                </a:solidFill>
-                <a:latin typeface="Times New Roman" panose="02020603050405020304" pitchFamily="18" charset="0"/>
-                <a:cs typeface="Times New Roman" panose="02020603050405020304" pitchFamily="18" charset="0"/>
-              </a:rPr>
-              <a:t>31.7%</a:t>
+              <a:t>2018</a:t>
             </a:r>
           </a:p>
         </p:txBody>
       </p:sp>
       <p:sp>
         <p:nvSpPr>
-          <p:cNvPr id="3109" name="Year 2018"/>
+          <p:cNvPr id="3108" name="Year 2024"/>
           <p:cNvSpPr txBox="1"/>
           <p:nvPr/>
         </p:nvSpPr>
         <p:spPr>
           <a:xfrm>
-            <a:off x="950976" y="3246120"/>
-            <a:ext cx="1828800" cy="320040"/>
+            <a:off x="3968496" y="3337560"/>
+            <a:ext cx="2194560" cy="365760"/>
           </a:xfrm>
           <a:prstGeom prst="rect">
             <a:avLst/>
@@ -32524,57 +32456,7 @@
               <a:buNone/>
             </a:pPr>
             <a:r>
-              <a:rPr lang="en-US" sz="1800" b="0" dirty="0">
-                <a:solidFill>
-                  <a:schemeClr val="accent3"/>
-                </a:solidFill>
-                <a:latin typeface="Times New Roman" panose="02020603050405020304" pitchFamily="18" charset="0"/>
-                <a:cs typeface="Times New Roman" panose="02020603050405020304" pitchFamily="18" charset="0"/>
-              </a:rPr>
-              <a:t>2018</a:t>
-            </a:r>
-          </a:p>
-        </p:txBody>
-      </p:sp>
-      <p:sp>
-        <p:nvSpPr>
-          <p:cNvPr id="3110" name="Year 2024"/>
-          <p:cNvSpPr txBox="1"/>
-          <p:nvPr/>
-        </p:nvSpPr>
-        <p:spPr>
-          <a:xfrm>
-            <a:off x="3694176" y="3246120"/>
-            <a:ext cx="1920240" cy="320040"/>
-          </a:xfrm>
-          <a:prstGeom prst="rect">
-            <a:avLst/>
-          </a:prstGeom>
-          <a:noFill/>
-          <a:ln>
-            <a:noFill/>
-          </a:ln>
-        </p:spPr>
-        <p:txBody>
-          <a:bodyPr wrap="square" lIns="0" tIns="0" rIns="0" bIns="0" rtlCol="0" anchor="t">
-            <a:noAutofit/>
-          </a:bodyPr>
-          <a:lstStyle/>
-          <a:p>
-            <a:pPr marL="0" indent="0" algn="l">
-              <a:lnSpc>
-                <a:spcPct val="100000"/>
-              </a:lnSpc>
-              <a:spcBef>
-                <a:spcPts val="0"/>
-              </a:spcBef>
-              <a:spcAft>
-                <a:spcPts val="0"/>
-              </a:spcAft>
-              <a:buNone/>
-            </a:pPr>
-            <a:r>
-              <a:rPr lang="en-US" sz="1800" b="0" dirty="0">
+              <a:rPr lang="en-US" sz="2000" b="0" dirty="0">
                 <a:solidFill>
                   <a:schemeClr val="accent3"/>
                 </a:solidFill>
@@ -32586,116 +32468,37 @@
           </a:p>
         </p:txBody>
       </p:sp>
+      <p:cxnSp>
+        <p:nvCxnSpPr>
+          <p:cNvPr id="3109" name="Divider"/>
+          <p:cNvCxnSpPr/>
+          <p:nvPr/>
+        </p:nvCxnSpPr>
+        <p:spPr>
+          <a:xfrm>
+            <a:off x="950976" y="4160520"/>
+            <a:ext cx="5120640" cy="0"/>
+          </a:xfrm>
+          <a:prstGeom prst="straightConnector1">
+            <a:avLst/>
+          </a:prstGeom>
+          <a:ln w="9525">
+            <a:solidFill>
+              <a:schemeClr val="accent4"/>
+            </a:solidFill>
+          </a:ln>
+        </p:spPr>
+      </p:cxnSp>
       <p:sp>
         <p:nvSpPr>
-          <p:cNvPr id="3111" name="Share label"/>
-          <p:cNvSpPr txBox="1"/>
-          <p:nvPr/>
-        </p:nvSpPr>
-        <p:spPr>
-          <a:xfrm>
-            <a:off x="950976" y="3611880"/>
-            <a:ext cx="4736592" cy="685800"/>
-          </a:xfrm>
-          <a:prstGeom prst="rect">
-            <a:avLst/>
-          </a:prstGeom>
-          <a:noFill/>
-          <a:ln>
-            <a:noFill/>
-          </a:ln>
-        </p:spPr>
-        <p:txBody>
-          <a:bodyPr wrap="square" lIns="0" tIns="0" rIns="0" bIns="0" rtlCol="0" anchor="t">
-            <a:noAutofit/>
-          </a:bodyPr>
-          <a:lstStyle/>
-          <a:p>
-            <a:pPr marL="0" indent="0" algn="l">
-              <a:lnSpc>
-                <a:spcPct val="100000"/>
-              </a:lnSpc>
-              <a:spcBef>
-                <a:spcPts val="0"/>
-              </a:spcBef>
-              <a:spcAft>
-                <a:spcPts val="0"/>
-              </a:spcAft>
-              <a:buNone/>
-            </a:pPr>
-            <a:r>
-              <a:rPr lang="en-US" sz="2000" b="1" dirty="0">
-                <a:solidFill>
-                  <a:schemeClr val="dk1"/>
-                </a:solidFill>
-                <a:latin typeface="Times New Roman" panose="02020603050405020304" pitchFamily="18" charset="0"/>
-                <a:cs typeface="Times New Roman" panose="02020603050405020304" pitchFamily="18" charset="0"/>
-              </a:rPr>
-              <a:t>China's share of Korea's memory chip exports</a:t>
-            </a:r>
-          </a:p>
-        </p:txBody>
-      </p:sp>
-      <p:sp>
-        <p:nvSpPr>
-          <p:cNvPr id="3112" name="Share source"/>
-          <p:cNvSpPr txBox="1"/>
-          <p:nvPr/>
-        </p:nvSpPr>
-        <p:spPr>
-          <a:xfrm>
-            <a:off x="950976" y="4224528"/>
-            <a:ext cx="4736592" cy="320040"/>
-          </a:xfrm>
-          <a:prstGeom prst="rect">
-            <a:avLst/>
-          </a:prstGeom>
-          <a:noFill/>
-          <a:ln>
-            <a:noFill/>
-          </a:ln>
-        </p:spPr>
-        <p:txBody>
-          <a:bodyPr wrap="square" lIns="0" tIns="0" rIns="0" bIns="0" rtlCol="0" anchor="t">
-            <a:noAutofit/>
-          </a:bodyPr>
-          <a:lstStyle/>
-          <a:p>
-            <a:pPr marL="0" indent="0" algn="l">
-              <a:lnSpc>
-                <a:spcPct val="100000"/>
-              </a:lnSpc>
-              <a:spcBef>
-                <a:spcPts val="0"/>
-              </a:spcBef>
-              <a:spcAft>
-                <a:spcPts val="0"/>
-              </a:spcAft>
-              <a:buNone/>
-            </a:pPr>
-            <a:r>
-              <a:rPr lang="en-US" sz="1400" b="0" dirty="0">
-                <a:solidFill>
-                  <a:schemeClr val="accent3"/>
-                </a:solidFill>
-                <a:latin typeface="Times New Roman" panose="02020603050405020304" pitchFamily="18" charset="0"/>
-                <a:cs typeface="Times New Roman" panose="02020603050405020304" pitchFamily="18" charset="0"/>
-              </a:rPr>
-              <a:t>Source: Korea Institute for International Economic Policy (2025)</a:t>
-            </a:r>
-          </a:p>
-        </p:txBody>
-      </p:sp>
-      <p:sp>
-        <p:nvSpPr>
-          <p:cNvPr id="3113" name="Rebound marker"/>
+          <p:cNvPr id="3110" name="Rebound marker"/>
           <p:cNvSpPr/>
           <p:nvPr/>
         </p:nvSpPr>
         <p:spPr>
           <a:xfrm>
-            <a:off x="950976" y="4754880"/>
-            <a:ext cx="201168" cy="201168"/>
+            <a:off x="950976" y="4498848"/>
+            <a:ext cx="219456" cy="219456"/>
           </a:xfrm>
           <a:prstGeom prst="rect">
             <a:avLst/>
@@ -32719,14 +32522,14 @@
       </p:sp>
       <p:sp>
         <p:nvSpPr>
-          <p:cNvPr id="3114" name="Rebound"/>
+          <p:cNvPr id="3111" name="Rebound"/>
           <p:cNvSpPr txBox="1"/>
           <p:nvPr/>
         </p:nvSpPr>
         <p:spPr>
           <a:xfrm>
-            <a:off x="1316736" y="4645152"/>
-            <a:ext cx="4370832" cy="685800"/>
+            <a:off x="1362456" y="4370832"/>
+            <a:ext cx="4709160" cy="1097280"/>
           </a:xfrm>
           <a:prstGeom prst="rect">
             <a:avLst/>
@@ -32750,20 +32553,34 @@
                 <a:spcPts val="0"/>
               </a:spcBef>
               <a:spcAft>
-                <a:spcPts val="0"/>
+                <a:spcPts val="400"/>
               </a:spcAft>
               <a:buNone/>
             </a:pPr>
             <a:r>
-              <a:rPr lang="en-US" sz="2000" b="1" dirty="0">
+              <a:rPr lang="en-US" sz="2200" b="1" dirty="0">
                 <a:solidFill>
                   <a:schemeClr val="accent5"/>
                 </a:solidFill>
                 <a:latin typeface="Times New Roman" panose="02020603050405020304" pitchFamily="18" charset="0"/>
                 <a:cs typeface="Times New Roman" panose="02020603050405020304" pitchFamily="18" charset="0"/>
               </a:rPr>
-              <a:t>2026: exports to China rebound strongly, </a:t>
+              <a:t>2026: exports to China rebound strongly</a:t>
             </a:r>
+          </a:p>
+          <a:p>
+            <a:pPr marL="0" indent="0" algn="l">
+              <a:lnSpc>
+                <a:spcPct val="100000"/>
+              </a:lnSpc>
+              <a:spcBef>
+                <a:spcPts val="0"/>
+              </a:spcBef>
+              <a:spcAft>
+                <a:spcPts val="0"/>
+              </a:spcAft>
+              <a:buNone/>
+            </a:pPr>
             <a:r>
               <a:rPr lang="en-US" sz="2000" b="0" dirty="0">
                 <a:solidFill>
@@ -32773,552 +32590,6 @@
                 <a:cs typeface="Times New Roman" panose="02020603050405020304" pitchFamily="18" charset="0"/>
               </a:rPr>
               <a:t>driven by AI chip demand</a:t>
-            </a:r>
-          </a:p>
-        </p:txBody>
-      </p:sp>
-      <p:sp>
-        <p:nvSpPr>
-          <p:cNvPr id="3115" name="Recent label"/>
-          <p:cNvSpPr txBox="1"/>
-          <p:nvPr/>
-        </p:nvSpPr>
-        <p:spPr>
-          <a:xfrm>
-            <a:off x="6510528" y="2468880"/>
-            <a:ext cx="4736592" cy="347472"/>
-          </a:xfrm>
-          <a:prstGeom prst="rect">
-            <a:avLst/>
-          </a:prstGeom>
-          <a:noFill/>
-          <a:ln>
-            <a:noFill/>
-          </a:ln>
-        </p:spPr>
-        <p:txBody>
-          <a:bodyPr wrap="square" lIns="0" tIns="0" rIns="0" bIns="0" rtlCol="0" anchor="t">
-            <a:noAutofit/>
-          </a:bodyPr>
-          <a:lstStyle/>
-          <a:p>
-            <a:pPr marL="0" indent="0" algn="l">
-              <a:lnSpc>
-                <a:spcPct val="100000"/>
-              </a:lnSpc>
-              <a:spcBef>
-                <a:spcPts val="0"/>
-              </a:spcBef>
-              <a:spcAft>
-                <a:spcPts val="0"/>
-              </a:spcAft>
-              <a:buNone/>
-            </a:pPr>
-            <a:r>
-              <a:rPr lang="en-US" sz="1800" b="1" dirty="0">
-                <a:solidFill>
-                  <a:schemeClr val="accent3"/>
-                </a:solidFill>
-                <a:latin typeface="Times New Roman" panose="02020603050405020304" pitchFamily="18" charset="0"/>
-                <a:cs typeface="Times New Roman" panose="02020603050405020304" pitchFamily="18" charset="0"/>
-              </a:rPr>
-              <a:t>Most recent selloff (approx.)</a:t>
-            </a:r>
-          </a:p>
-        </p:txBody>
-      </p:sp>
-      <p:sp>
-        <p:nvSpPr>
-          <p:cNvPr id="3116" name="Selloff 1 value"/>
-          <p:cNvSpPr txBox="1"/>
-          <p:nvPr/>
-        </p:nvSpPr>
-        <p:spPr>
-          <a:xfrm>
-            <a:off x="6510528" y="2788920"/>
-            <a:ext cx="1578864" cy="685800"/>
-          </a:xfrm>
-          <a:prstGeom prst="rect">
-            <a:avLst/>
-          </a:prstGeom>
-          <a:noFill/>
-          <a:ln>
-            <a:noFill/>
-          </a:ln>
-        </p:spPr>
-        <p:txBody>
-          <a:bodyPr wrap="square" lIns="0" tIns="0" rIns="0" bIns="0" rtlCol="0" anchor="ctr">
-            <a:noAutofit/>
-          </a:bodyPr>
-          <a:lstStyle/>
-          <a:p>
-            <a:pPr marL="0" indent="0" algn="l">
-              <a:lnSpc>
-                <a:spcPct val="100000"/>
-              </a:lnSpc>
-              <a:spcBef>
-                <a:spcPts val="0"/>
-              </a:spcBef>
-              <a:spcAft>
-                <a:spcPts val="0"/>
-              </a:spcAft>
-              <a:buNone/>
-            </a:pPr>
-            <a:r>
-              <a:rPr lang="en-US" sz="4000" b="1" dirty="0">
-                <a:solidFill>
-                  <a:schemeClr val="dk2"/>
-                </a:solidFill>
-                <a:latin typeface="Times New Roman" panose="02020603050405020304" pitchFamily="18" charset="0"/>
-                <a:cs typeface="Times New Roman" panose="02020603050405020304" pitchFamily="18" charset="0"/>
-              </a:rPr>
-              <a:t>−5.5%</a:t>
-            </a:r>
-          </a:p>
-        </p:txBody>
-      </p:sp>
-      <p:sp>
-        <p:nvSpPr>
-          <p:cNvPr id="3117" name="Selloff 1 name"/>
-          <p:cNvSpPr txBox="1"/>
-          <p:nvPr/>
-        </p:nvSpPr>
-        <p:spPr>
-          <a:xfrm>
-            <a:off x="6510528" y="3474720"/>
-            <a:ext cx="1578864" cy="365760"/>
-          </a:xfrm>
-          <a:prstGeom prst="rect">
-            <a:avLst/>
-          </a:prstGeom>
-          <a:noFill/>
-          <a:ln>
-            <a:noFill/>
-          </a:ln>
-        </p:spPr>
-        <p:txBody>
-          <a:bodyPr wrap="square" lIns="0" tIns="0" rIns="0" bIns="0" rtlCol="0" anchor="t">
-            <a:noAutofit/>
-          </a:bodyPr>
-          <a:lstStyle/>
-          <a:p>
-            <a:pPr marL="0" indent="0" algn="l">
-              <a:lnSpc>
-                <a:spcPct val="100000"/>
-              </a:lnSpc>
-              <a:spcBef>
-                <a:spcPts val="0"/>
-              </a:spcBef>
-              <a:spcAft>
-                <a:spcPts val="0"/>
-              </a:spcAft>
-              <a:buNone/>
-            </a:pPr>
-            <a:r>
-              <a:rPr lang="en-US" sz="2000" b="0" dirty="0">
-                <a:solidFill>
-                  <a:schemeClr val="dk1"/>
-                </a:solidFill>
-                <a:latin typeface="Times New Roman" panose="02020603050405020304" pitchFamily="18" charset="0"/>
-                <a:cs typeface="Times New Roman" panose="02020603050405020304" pitchFamily="18" charset="0"/>
-              </a:rPr>
-              <a:t>KOSPI</a:t>
-            </a:r>
-          </a:p>
-        </p:txBody>
-      </p:sp>
-      <p:sp>
-        <p:nvSpPr>
-          <p:cNvPr id="3118" name="Selloff 2 value"/>
-          <p:cNvSpPr txBox="1"/>
-          <p:nvPr/>
-        </p:nvSpPr>
-        <p:spPr>
-          <a:xfrm>
-            <a:off x="8089392" y="2788920"/>
-            <a:ext cx="1578864" cy="685800"/>
-          </a:xfrm>
-          <a:prstGeom prst="rect">
-            <a:avLst/>
-          </a:prstGeom>
-          <a:noFill/>
-          <a:ln>
-            <a:noFill/>
-          </a:ln>
-        </p:spPr>
-        <p:txBody>
-          <a:bodyPr wrap="square" lIns="0" tIns="0" rIns="0" bIns="0" rtlCol="0" anchor="ctr">
-            <a:noAutofit/>
-          </a:bodyPr>
-          <a:lstStyle/>
-          <a:p>
-            <a:pPr marL="0" indent="0" algn="l">
-              <a:lnSpc>
-                <a:spcPct val="100000"/>
-              </a:lnSpc>
-              <a:spcBef>
-                <a:spcPts val="0"/>
-              </a:spcBef>
-              <a:spcAft>
-                <a:spcPts val="0"/>
-              </a:spcAft>
-              <a:buNone/>
-            </a:pPr>
-            <a:r>
-              <a:rPr lang="en-US" sz="4000" b="1" dirty="0">
-                <a:solidFill>
-                  <a:schemeClr val="dk2"/>
-                </a:solidFill>
-                <a:latin typeface="Times New Roman" panose="02020603050405020304" pitchFamily="18" charset="0"/>
-                <a:cs typeface="Times New Roman" panose="02020603050405020304" pitchFamily="18" charset="0"/>
-              </a:rPr>
-              <a:t>−7%</a:t>
-            </a:r>
-          </a:p>
-        </p:txBody>
-      </p:sp>
-      <p:sp>
-        <p:nvSpPr>
-          <p:cNvPr id="3119" name="Selloff 2 name"/>
-          <p:cNvSpPr txBox="1"/>
-          <p:nvPr/>
-        </p:nvSpPr>
-        <p:spPr>
-          <a:xfrm>
-            <a:off x="8089392" y="3474720"/>
-            <a:ext cx="1578864" cy="365760"/>
-          </a:xfrm>
-          <a:prstGeom prst="rect">
-            <a:avLst/>
-          </a:prstGeom>
-          <a:noFill/>
-          <a:ln>
-            <a:noFill/>
-          </a:ln>
-        </p:spPr>
-        <p:txBody>
-          <a:bodyPr wrap="square" lIns="0" tIns="0" rIns="0" bIns="0" rtlCol="0" anchor="t">
-            <a:noAutofit/>
-          </a:bodyPr>
-          <a:lstStyle/>
-          <a:p>
-            <a:pPr marL="0" indent="0" algn="l">
-              <a:lnSpc>
-                <a:spcPct val="100000"/>
-              </a:lnSpc>
-              <a:spcBef>
-                <a:spcPts val="0"/>
-              </a:spcBef>
-              <a:spcAft>
-                <a:spcPts val="0"/>
-              </a:spcAft>
-              <a:buNone/>
-            </a:pPr>
-            <a:r>
-              <a:rPr lang="en-US" sz="2000" b="0" dirty="0">
-                <a:solidFill>
-                  <a:schemeClr val="dk1"/>
-                </a:solidFill>
-                <a:latin typeface="Times New Roman" panose="02020603050405020304" pitchFamily="18" charset="0"/>
-                <a:cs typeface="Times New Roman" panose="02020603050405020304" pitchFamily="18" charset="0"/>
-              </a:rPr>
-              <a:t>Samsung</a:t>
-            </a:r>
-          </a:p>
-        </p:txBody>
-      </p:sp>
-      <p:sp>
-        <p:nvSpPr>
-          <p:cNvPr id="3120" name="Selloff 3 value"/>
-          <p:cNvSpPr txBox="1"/>
-          <p:nvPr/>
-        </p:nvSpPr>
-        <p:spPr>
-          <a:xfrm>
-            <a:off x="9668256" y="2788920"/>
-            <a:ext cx="1578864" cy="685800"/>
-          </a:xfrm>
-          <a:prstGeom prst="rect">
-            <a:avLst/>
-          </a:prstGeom>
-          <a:noFill/>
-          <a:ln>
-            <a:noFill/>
-          </a:ln>
-        </p:spPr>
-        <p:txBody>
-          <a:bodyPr wrap="square" lIns="0" tIns="0" rIns="0" bIns="0" rtlCol="0" anchor="ctr">
-            <a:noAutofit/>
-          </a:bodyPr>
-          <a:lstStyle/>
-          <a:p>
-            <a:pPr marL="0" indent="0" algn="l">
-              <a:lnSpc>
-                <a:spcPct val="100000"/>
-              </a:lnSpc>
-              <a:spcBef>
-                <a:spcPts val="0"/>
-              </a:spcBef>
-              <a:spcAft>
-                <a:spcPts val="0"/>
-              </a:spcAft>
-              <a:buNone/>
-            </a:pPr>
-            <a:r>
-              <a:rPr lang="en-US" sz="4000" b="1" dirty="0">
-                <a:solidFill>
-                  <a:schemeClr val="dk2"/>
-                </a:solidFill>
-                <a:latin typeface="Times New Roman" panose="02020603050405020304" pitchFamily="18" charset="0"/>
-                <a:cs typeface="Times New Roman" panose="02020603050405020304" pitchFamily="18" charset="0"/>
-              </a:rPr>
-              <a:t>−10%</a:t>
-            </a:r>
-          </a:p>
-        </p:txBody>
-      </p:sp>
-      <p:sp>
-        <p:nvSpPr>
-          <p:cNvPr id="3121" name="Selloff 3 name"/>
-          <p:cNvSpPr txBox="1"/>
-          <p:nvPr/>
-        </p:nvSpPr>
-        <p:spPr>
-          <a:xfrm>
-            <a:off x="9668256" y="3474720"/>
-            <a:ext cx="1578864" cy="365760"/>
-          </a:xfrm>
-          <a:prstGeom prst="rect">
-            <a:avLst/>
-          </a:prstGeom>
-          <a:noFill/>
-          <a:ln>
-            <a:noFill/>
-          </a:ln>
-        </p:spPr>
-        <p:txBody>
-          <a:bodyPr wrap="square" lIns="0" tIns="0" rIns="0" bIns="0" rtlCol="0" anchor="t">
-            <a:noAutofit/>
-          </a:bodyPr>
-          <a:lstStyle/>
-          <a:p>
-            <a:pPr marL="0" indent="0" algn="l">
-              <a:lnSpc>
-                <a:spcPct val="100000"/>
-              </a:lnSpc>
-              <a:spcBef>
-                <a:spcPts val="0"/>
-              </a:spcBef>
-              <a:spcAft>
-                <a:spcPts val="0"/>
-              </a:spcAft>
-              <a:buNone/>
-            </a:pPr>
-            <a:r>
-              <a:rPr lang="en-US" sz="2000" b="0" dirty="0">
-                <a:solidFill>
-                  <a:schemeClr val="dk1"/>
-                </a:solidFill>
-                <a:latin typeface="Times New Roman" panose="02020603050405020304" pitchFamily="18" charset="0"/>
-                <a:cs typeface="Times New Roman" panose="02020603050405020304" pitchFamily="18" charset="0"/>
-              </a:rPr>
-              <a:t>SK Hynix</a:t>
-            </a:r>
-          </a:p>
-        </p:txBody>
-      </p:sp>
-      <p:cxnSp>
-        <p:nvCxnSpPr>
-          <p:cNvPr id="3122" name="Selloff rule"/>
-          <p:cNvCxnSpPr/>
-          <p:nvPr/>
-        </p:nvCxnSpPr>
-        <p:spPr>
-          <a:xfrm>
-            <a:off x="6510528" y="3959352"/>
-            <a:ext cx="4736592" cy="0"/>
-          </a:xfrm>
-          <a:prstGeom prst="straightConnector1">
-            <a:avLst/>
-          </a:prstGeom>
-          <a:ln w="9525">
-            <a:solidFill>
-              <a:schemeClr val="accent4"/>
-            </a:solidFill>
-          </a:ln>
-        </p:spPr>
-      </p:cxnSp>
-      <p:sp>
-        <p:nvSpPr>
-          <p:cNvPr id="3123" name="July selloff"/>
-          <p:cNvSpPr txBox="1"/>
-          <p:nvPr/>
-        </p:nvSpPr>
-        <p:spPr>
-          <a:xfrm>
-            <a:off x="6510528" y="4041648"/>
-            <a:ext cx="4736592" cy="384048"/>
-          </a:xfrm>
-          <a:prstGeom prst="rect">
-            <a:avLst/>
-          </a:prstGeom>
-          <a:noFill/>
-          <a:ln>
-            <a:noFill/>
-          </a:ln>
-        </p:spPr>
-        <p:txBody>
-          <a:bodyPr wrap="square" lIns="0" tIns="0" rIns="0" bIns="0" rtlCol="0" anchor="t">
-            <a:noAutofit/>
-          </a:bodyPr>
-          <a:lstStyle/>
-          <a:p>
-            <a:pPr marL="0" indent="0" algn="l">
-              <a:lnSpc>
-                <a:spcPct val="100000"/>
-              </a:lnSpc>
-              <a:spcBef>
-                <a:spcPts val="0"/>
-              </a:spcBef>
-              <a:spcAft>
-                <a:spcPts val="0"/>
-              </a:spcAft>
-              <a:buNone/>
-            </a:pPr>
-            <a:r>
-              <a:rPr lang="en-US" sz="2000" b="1" dirty="0">
-                <a:solidFill>
-                  <a:schemeClr val="dk1"/>
-                </a:solidFill>
-                <a:latin typeface="Times New Roman" panose="02020603050405020304" pitchFamily="18" charset="0"/>
-                <a:cs typeface="Times New Roman" panose="02020603050405020304" pitchFamily="18" charset="0"/>
-              </a:rPr>
-              <a:t>July selloff: </a:t>
-            </a:r>
-            <a:r>
-              <a:rPr lang="en-US" sz="2000" b="1" dirty="0">
-                <a:solidFill>
-                  <a:schemeClr val="dk2"/>
-                </a:solidFill>
-                <a:latin typeface="Times New Roman" panose="02020603050405020304" pitchFamily="18" charset="0"/>
-                <a:cs typeface="Times New Roman" panose="02020603050405020304" pitchFamily="18" charset="0"/>
-              </a:rPr>
-              <a:t>KOSPI fell nearly 11%</a:t>
-            </a:r>
-          </a:p>
-        </p:txBody>
-      </p:sp>
-      <p:sp>
-        <p:nvSpPr>
-          <p:cNvPr id="3124" name="Selloff note"/>
-          <p:cNvSpPr txBox="1"/>
-          <p:nvPr/>
-        </p:nvSpPr>
-        <p:spPr>
-          <a:xfrm>
-            <a:off x="6510528" y="4498848"/>
-            <a:ext cx="4736592" cy="777240"/>
-          </a:xfrm>
-          <a:prstGeom prst="rect">
-            <a:avLst/>
-          </a:prstGeom>
-          <a:noFill/>
-          <a:ln>
-            <a:noFill/>
-          </a:ln>
-        </p:spPr>
-        <p:txBody>
-          <a:bodyPr wrap="square" lIns="0" tIns="0" rIns="0" bIns="0" rtlCol="0" anchor="t">
-            <a:noAutofit/>
-          </a:bodyPr>
-          <a:lstStyle/>
-          <a:p>
-            <a:pPr marL="0" indent="0" algn="l">
-              <a:lnSpc>
-                <a:spcPct val="100000"/>
-              </a:lnSpc>
-              <a:spcBef>
-                <a:spcPts val="0"/>
-              </a:spcBef>
-              <a:spcAft>
-                <a:spcPts val="0"/>
-              </a:spcAft>
-              <a:buNone/>
-            </a:pPr>
-            <a:r>
-              <a:rPr lang="en-US" sz="1600" b="0" i="1" dirty="0">
-                <a:solidFill>
-                  <a:schemeClr val="accent3"/>
-                </a:solidFill>
-                <a:latin typeface="Times New Roman" panose="02020603050405020304" pitchFamily="18" charset="0"/>
-                <a:cs typeface="Times New Roman" panose="02020603050405020304" pitchFamily="18" charset="0"/>
-              </a:rPr>
-              <a:t>AI-investment worries played a part, but CXMT's progress raised fears that more chip supply will squeeze Korean prices and profits</a:t>
-            </a:r>
-          </a:p>
-        </p:txBody>
-      </p:sp>
-      <p:sp>
-        <p:nvSpPr>
-          <p:cNvPr id="3125" name="Takeaway banner"/>
-          <p:cNvSpPr/>
-          <p:nvPr/>
-        </p:nvSpPr>
-        <p:spPr>
-          <a:xfrm>
-            <a:off x="950976" y="5440680"/>
-            <a:ext cx="10296144" cy="868680"/>
-          </a:xfrm>
-          <a:prstGeom prst="rect">
-            <a:avLst/>
-          </a:prstGeom>
-          <a:solidFill>
-            <a:schemeClr val="tx1">
-              <a:lumMod val="50000"/>
-              <a:lumOff val="50000"/>
-            </a:schemeClr>
-          </a:solidFill>
-          <a:ln>
-            <a:noFill/>
-          </a:ln>
-        </p:spPr>
-        <p:txBody>
-          <a:bodyPr wrap="square" lIns="91440" tIns="91440" rIns="91440" bIns="91440" rtlCol="0" anchor="ctr">
-            <a:noAutofit/>
-          </a:bodyPr>
-          <a:lstStyle/>
-          <a:p>
-            <a:pPr marL="0" indent="0" algn="ctr">
-              <a:lnSpc>
-                <a:spcPct val="100000"/>
-              </a:lnSpc>
-              <a:spcBef>
-                <a:spcPts val="0"/>
-              </a:spcBef>
-              <a:spcAft>
-                <a:spcPts val="0"/>
-              </a:spcAft>
-              <a:buNone/>
-            </a:pPr>
-            <a:r>
-              <a:rPr lang="en-US" sz="1800" b="1" dirty="0">
-                <a:solidFill>
-                  <a:schemeClr val="bg1"/>
-                </a:solidFill>
-                <a:latin typeface="Times New Roman" panose="02020603050405020304" pitchFamily="18" charset="0"/>
-                <a:cs typeface="Times New Roman" panose="02020603050405020304" pitchFamily="18" charset="0"/>
-              </a:rPr>
-              <a:t>Chinese demand supports Korean exports today, but competition could extend into higher-value chips. </a:t>
-            </a:r>
-            <a:r>
-              <a:rPr lang="en-US" sz="1800" b="1" i="1" dirty="0">
-                <a:solidFill>
-                  <a:schemeClr val="bg1"/>
-                </a:solidFill>
-                <a:latin typeface="Times New Roman" panose="02020603050405020304" pitchFamily="18" charset="0"/>
-                <a:cs typeface="Times New Roman" panose="02020603050405020304" pitchFamily="18" charset="0"/>
-              </a:rPr>
-              <a:t>Can Korea sustain its export strength as China shifts from customer to competitor?</a:t>
             </a:r>
           </a:p>
         </p:txBody>
@@ -33350,7 +32621,728 @@
       </p:grpSpPr>
       <p:sp>
         <p:nvSpPr>
-          <p:cNvPr id="3126" name="Title band"/>
+          <p:cNvPr id="3112" name="Title band"/>
+          <p:cNvSpPr/>
+          <p:nvPr/>
+        </p:nvSpPr>
+        <p:spPr>
+          <a:xfrm>
+            <a:off x="0" y="274320"/>
+            <a:ext cx="12191695" cy="960120"/>
+          </a:xfrm>
+          <a:prstGeom prst="rect">
+            <a:avLst/>
+          </a:prstGeom>
+          <a:solidFill>
+            <a:schemeClr val="accent2"/>
+          </a:solidFill>
+          <a:ln>
+            <a:noFill/>
+          </a:ln>
+        </p:spPr>
+        <p:txBody>
+          <a:bodyPr wrap="square" lIns="0" tIns="0" rIns="0" bIns="0" rtlCol="0" anchor="t">
+            <a:noAutofit/>
+          </a:bodyPr>
+          <a:lstStyle/>
+          <a:p>
+            <a:endParaRPr lang="en-US">
+              <a:latin typeface="Times New Roman" panose="02020603050405020304" pitchFamily="18" charset="0"/>
+              <a:cs typeface="Times New Roman" panose="02020603050405020304" pitchFamily="18" charset="0"/>
+            </a:endParaRPr>
+          </a:p>
+        </p:txBody>
+      </p:sp>
+      <p:sp>
+        <p:nvSpPr>
+          <p:cNvPr id="3113" name="Title"/>
+          <p:cNvSpPr txBox="1">
+            <a:spLocks noGrp="1"/>
+          </p:cNvSpPr>
+          <p:nvPr>
+            <p:ph type="title"/>
+          </p:nvPr>
+        </p:nvSpPr>
+        <p:spPr>
+          <a:xfrm>
+            <a:off x="950976" y="274320"/>
+            <a:ext cx="11149279" cy="960120"/>
+          </a:xfrm>
+        </p:spPr>
+        <p:txBody>
+          <a:bodyPr spcFirstLastPara="1" wrap="square" lIns="121900" tIns="121900" rIns="121900" bIns="121900" anchor="ctr" anchorCtr="0">
+            <a:noAutofit/>
+          </a:bodyPr>
+          <a:lstStyle/>
+          <a:p>
+            <a:pPr algn="l"/>
+            <a:r>
+              <a:rPr lang="en-US" sz="3600" b="1" dirty="0">
+                <a:solidFill>
+                  <a:schemeClr val="lt1"/>
+                </a:solidFill>
+                <a:latin typeface="Times New Roman" panose="02020603050405020304" pitchFamily="18" charset="0"/>
+                <a:cs typeface="Times New Roman" panose="02020603050405020304" pitchFamily="18" charset="0"/>
+              </a:rPr>
+              <a:t>Long-Term: Markets Fear China's Rise</a:t>
+            </a:r>
+          </a:p>
+        </p:txBody>
+      </p:sp>
+      <p:sp>
+        <p:nvSpPr>
+          <p:cNvPr id="3114" name="Most recent selloff (approx.) label"/>
+          <p:cNvSpPr txBox="1"/>
+          <p:nvPr/>
+        </p:nvSpPr>
+        <p:spPr>
+          <a:xfrm>
+            <a:off x="5943600" y="1600200"/>
+            <a:ext cx="5303520" cy="384048"/>
+          </a:xfrm>
+          <a:prstGeom prst="rect">
+            <a:avLst/>
+          </a:prstGeom>
+          <a:noFill/>
+          <a:ln>
+            <a:noFill/>
+          </a:ln>
+        </p:spPr>
+        <p:txBody>
+          <a:bodyPr wrap="square" lIns="0" tIns="0" rIns="0" bIns="0" rtlCol="0" anchor="t">
+            <a:noAutofit/>
+          </a:bodyPr>
+          <a:lstStyle/>
+          <a:p>
+            <a:pPr marL="0" indent="0" algn="l">
+              <a:lnSpc>
+                <a:spcPct val="100000"/>
+              </a:lnSpc>
+              <a:spcBef>
+                <a:spcPts val="0"/>
+              </a:spcBef>
+              <a:spcAft>
+                <a:spcPts val="0"/>
+              </a:spcAft>
+              <a:buNone/>
+            </a:pPr>
+            <a:r>
+              <a:rPr lang="en-US" sz="2000" b="1" dirty="0">
+                <a:solidFill>
+                  <a:schemeClr val="accent2"/>
+                </a:solidFill>
+                <a:latin typeface="Times New Roman" panose="02020603050405020304" pitchFamily="18" charset="0"/>
+                <a:cs typeface="Times New Roman" panose="02020603050405020304" pitchFamily="18" charset="0"/>
+              </a:rPr>
+              <a:t>Most recent selloff (approx.)</a:t>
+            </a:r>
+          </a:p>
+        </p:txBody>
+      </p:sp>
+      <p:sp>
+        <p:nvSpPr>
+          <p:cNvPr id="3115" name="Most recent selloff (approx.) 1 value"/>
+          <p:cNvSpPr txBox="1"/>
+          <p:nvPr/>
+        </p:nvSpPr>
+        <p:spPr>
+          <a:xfrm>
+            <a:off x="5943600" y="2011680"/>
+            <a:ext cx="1767840" cy="777240"/>
+          </a:xfrm>
+          <a:prstGeom prst="rect">
+            <a:avLst/>
+          </a:prstGeom>
+          <a:noFill/>
+          <a:ln>
+            <a:noFill/>
+          </a:ln>
+        </p:spPr>
+        <p:txBody>
+          <a:bodyPr wrap="square" lIns="0" tIns="0" rIns="0" bIns="0" rtlCol="0" anchor="ctr">
+            <a:noAutofit/>
+          </a:bodyPr>
+          <a:lstStyle/>
+          <a:p>
+            <a:pPr marL="0" indent="0" algn="l">
+              <a:lnSpc>
+                <a:spcPct val="100000"/>
+              </a:lnSpc>
+              <a:spcBef>
+                <a:spcPts val="0"/>
+              </a:spcBef>
+              <a:spcAft>
+                <a:spcPts val="0"/>
+              </a:spcAft>
+              <a:buNone/>
+            </a:pPr>
+            <a:r>
+              <a:rPr lang="en-US" sz="4400" b="1" dirty="0">
+                <a:solidFill>
+                  <a:schemeClr val="dk2"/>
+                </a:solidFill>
+                <a:latin typeface="Times New Roman" panose="02020603050405020304" pitchFamily="18" charset="0"/>
+                <a:cs typeface="Times New Roman" panose="02020603050405020304" pitchFamily="18" charset="0"/>
+              </a:rPr>
+              <a:t>−5.5%</a:t>
+            </a:r>
+          </a:p>
+        </p:txBody>
+      </p:sp>
+      <p:sp>
+        <p:nvSpPr>
+          <p:cNvPr id="3116" name="Most recent selloff (approx.) 1 name"/>
+          <p:cNvSpPr txBox="1"/>
+          <p:nvPr/>
+        </p:nvSpPr>
+        <p:spPr>
+          <a:xfrm>
+            <a:off x="5943600" y="2788920"/>
+            <a:ext cx="1767840" cy="365760"/>
+          </a:xfrm>
+          <a:prstGeom prst="rect">
+            <a:avLst/>
+          </a:prstGeom>
+          <a:noFill/>
+          <a:ln>
+            <a:noFill/>
+          </a:ln>
+        </p:spPr>
+        <p:txBody>
+          <a:bodyPr wrap="square" lIns="0" tIns="0" rIns="0" bIns="0" rtlCol="0" anchor="t">
+            <a:noAutofit/>
+          </a:bodyPr>
+          <a:lstStyle/>
+          <a:p>
+            <a:pPr marL="0" indent="0" algn="l">
+              <a:lnSpc>
+                <a:spcPct val="100000"/>
+              </a:lnSpc>
+              <a:spcBef>
+                <a:spcPts val="0"/>
+              </a:spcBef>
+              <a:spcAft>
+                <a:spcPts val="0"/>
+              </a:spcAft>
+              <a:buNone/>
+            </a:pPr>
+            <a:r>
+              <a:rPr lang="en-US" sz="2000" b="0" dirty="0">
+                <a:solidFill>
+                  <a:schemeClr val="dk1"/>
+                </a:solidFill>
+                <a:latin typeface="Times New Roman" panose="02020603050405020304" pitchFamily="18" charset="0"/>
+                <a:cs typeface="Times New Roman" panose="02020603050405020304" pitchFamily="18" charset="0"/>
+              </a:rPr>
+              <a:t>KOSPI</a:t>
+            </a:r>
+          </a:p>
+        </p:txBody>
+      </p:sp>
+      <p:sp>
+        <p:nvSpPr>
+          <p:cNvPr id="3117" name="Most recent selloff (approx.) 2 value"/>
+          <p:cNvSpPr txBox="1"/>
+          <p:nvPr/>
+        </p:nvSpPr>
+        <p:spPr>
+          <a:xfrm>
+            <a:off x="7711440" y="2011680"/>
+            <a:ext cx="1767840" cy="777240"/>
+          </a:xfrm>
+          <a:prstGeom prst="rect">
+            <a:avLst/>
+          </a:prstGeom>
+          <a:noFill/>
+          <a:ln>
+            <a:noFill/>
+          </a:ln>
+        </p:spPr>
+        <p:txBody>
+          <a:bodyPr wrap="square" lIns="0" tIns="0" rIns="0" bIns="0" rtlCol="0" anchor="ctr">
+            <a:noAutofit/>
+          </a:bodyPr>
+          <a:lstStyle/>
+          <a:p>
+            <a:pPr marL="0" indent="0" algn="l">
+              <a:lnSpc>
+                <a:spcPct val="100000"/>
+              </a:lnSpc>
+              <a:spcBef>
+                <a:spcPts val="0"/>
+              </a:spcBef>
+              <a:spcAft>
+                <a:spcPts val="0"/>
+              </a:spcAft>
+              <a:buNone/>
+            </a:pPr>
+            <a:r>
+              <a:rPr lang="en-US" sz="4400" b="1" dirty="0">
+                <a:solidFill>
+                  <a:schemeClr val="dk2"/>
+                </a:solidFill>
+                <a:latin typeface="Times New Roman" panose="02020603050405020304" pitchFamily="18" charset="0"/>
+                <a:cs typeface="Times New Roman" panose="02020603050405020304" pitchFamily="18" charset="0"/>
+              </a:rPr>
+              <a:t>−7%</a:t>
+            </a:r>
+          </a:p>
+        </p:txBody>
+      </p:sp>
+      <p:sp>
+        <p:nvSpPr>
+          <p:cNvPr id="3118" name="Most recent selloff (approx.) 2 name"/>
+          <p:cNvSpPr txBox="1"/>
+          <p:nvPr/>
+        </p:nvSpPr>
+        <p:spPr>
+          <a:xfrm>
+            <a:off x="7711440" y="2788920"/>
+            <a:ext cx="1767840" cy="365760"/>
+          </a:xfrm>
+          <a:prstGeom prst="rect">
+            <a:avLst/>
+          </a:prstGeom>
+          <a:noFill/>
+          <a:ln>
+            <a:noFill/>
+          </a:ln>
+        </p:spPr>
+        <p:txBody>
+          <a:bodyPr wrap="square" lIns="0" tIns="0" rIns="0" bIns="0" rtlCol="0" anchor="t">
+            <a:noAutofit/>
+          </a:bodyPr>
+          <a:lstStyle/>
+          <a:p>
+            <a:pPr marL="0" indent="0" algn="l">
+              <a:lnSpc>
+                <a:spcPct val="100000"/>
+              </a:lnSpc>
+              <a:spcBef>
+                <a:spcPts val="0"/>
+              </a:spcBef>
+              <a:spcAft>
+                <a:spcPts val="0"/>
+              </a:spcAft>
+              <a:buNone/>
+            </a:pPr>
+            <a:r>
+              <a:rPr lang="en-US" sz="2000" b="0" dirty="0">
+                <a:solidFill>
+                  <a:schemeClr val="dk1"/>
+                </a:solidFill>
+                <a:latin typeface="Times New Roman" panose="02020603050405020304" pitchFamily="18" charset="0"/>
+                <a:cs typeface="Times New Roman" panose="02020603050405020304" pitchFamily="18" charset="0"/>
+              </a:rPr>
+              <a:t>Samsung</a:t>
+            </a:r>
+          </a:p>
+        </p:txBody>
+      </p:sp>
+      <p:sp>
+        <p:nvSpPr>
+          <p:cNvPr id="3119" name="Most recent selloff (approx.) 3 value"/>
+          <p:cNvSpPr txBox="1"/>
+          <p:nvPr/>
+        </p:nvSpPr>
+        <p:spPr>
+          <a:xfrm>
+            <a:off x="9479280" y="2011680"/>
+            <a:ext cx="1767840" cy="777240"/>
+          </a:xfrm>
+          <a:prstGeom prst="rect">
+            <a:avLst/>
+          </a:prstGeom>
+          <a:noFill/>
+          <a:ln>
+            <a:noFill/>
+          </a:ln>
+        </p:spPr>
+        <p:txBody>
+          <a:bodyPr wrap="square" lIns="0" tIns="0" rIns="0" bIns="0" rtlCol="0" anchor="ctr">
+            <a:noAutofit/>
+          </a:bodyPr>
+          <a:lstStyle/>
+          <a:p>
+            <a:pPr marL="0" indent="0" algn="l">
+              <a:lnSpc>
+                <a:spcPct val="100000"/>
+              </a:lnSpc>
+              <a:spcBef>
+                <a:spcPts val="0"/>
+              </a:spcBef>
+              <a:spcAft>
+                <a:spcPts val="0"/>
+              </a:spcAft>
+              <a:buNone/>
+            </a:pPr>
+            <a:r>
+              <a:rPr lang="en-US" sz="4400" b="1" dirty="0">
+                <a:solidFill>
+                  <a:schemeClr val="dk2"/>
+                </a:solidFill>
+                <a:latin typeface="Times New Roman" panose="02020603050405020304" pitchFamily="18" charset="0"/>
+                <a:cs typeface="Times New Roman" panose="02020603050405020304" pitchFamily="18" charset="0"/>
+              </a:rPr>
+              <a:t>−10%</a:t>
+            </a:r>
+          </a:p>
+        </p:txBody>
+      </p:sp>
+      <p:sp>
+        <p:nvSpPr>
+          <p:cNvPr id="3120" name="Most recent selloff (approx.) 3 name"/>
+          <p:cNvSpPr txBox="1"/>
+          <p:nvPr/>
+        </p:nvSpPr>
+        <p:spPr>
+          <a:xfrm>
+            <a:off x="9479280" y="2788920"/>
+            <a:ext cx="1767840" cy="365760"/>
+          </a:xfrm>
+          <a:prstGeom prst="rect">
+            <a:avLst/>
+          </a:prstGeom>
+          <a:noFill/>
+          <a:ln>
+            <a:noFill/>
+          </a:ln>
+        </p:spPr>
+        <p:txBody>
+          <a:bodyPr wrap="square" lIns="0" tIns="0" rIns="0" bIns="0" rtlCol="0" anchor="t">
+            <a:noAutofit/>
+          </a:bodyPr>
+          <a:lstStyle/>
+          <a:p>
+            <a:pPr marL="0" indent="0" algn="l">
+              <a:lnSpc>
+                <a:spcPct val="100000"/>
+              </a:lnSpc>
+              <a:spcBef>
+                <a:spcPts val="0"/>
+              </a:spcBef>
+              <a:spcAft>
+                <a:spcPts val="0"/>
+              </a:spcAft>
+              <a:buNone/>
+            </a:pPr>
+            <a:r>
+              <a:rPr lang="en-US" sz="2000" b="0" dirty="0">
+                <a:solidFill>
+                  <a:schemeClr val="dk1"/>
+                </a:solidFill>
+                <a:latin typeface="Times New Roman" panose="02020603050405020304" pitchFamily="18" charset="0"/>
+                <a:cs typeface="Times New Roman" panose="02020603050405020304" pitchFamily="18" charset="0"/>
+              </a:rPr>
+              <a:t>SK Hynix</a:t>
+            </a:r>
+          </a:p>
+        </p:txBody>
+      </p:sp>
+      <p:cxnSp>
+        <p:nvCxnSpPr>
+          <p:cNvPr id="3121" name="Selloff rule"/>
+          <p:cNvCxnSpPr/>
+          <p:nvPr/>
+        </p:nvCxnSpPr>
+        <p:spPr>
+          <a:xfrm>
+            <a:off x="5943600" y="3310128"/>
+            <a:ext cx="5303520" cy="0"/>
+          </a:xfrm>
+          <a:prstGeom prst="straightConnector1">
+            <a:avLst/>
+          </a:prstGeom>
+          <a:ln w="9525">
+            <a:solidFill>
+              <a:schemeClr val="accent4"/>
+            </a:solidFill>
+          </a:ln>
+        </p:spPr>
+      </p:cxnSp>
+      <p:sp>
+        <p:nvSpPr>
+          <p:cNvPr id="3122" name="July selloff label"/>
+          <p:cNvSpPr txBox="1"/>
+          <p:nvPr/>
+        </p:nvSpPr>
+        <p:spPr>
+          <a:xfrm>
+            <a:off x="5943600" y="3429000"/>
+            <a:ext cx="5303520" cy="384048"/>
+          </a:xfrm>
+          <a:prstGeom prst="rect">
+            <a:avLst/>
+          </a:prstGeom>
+          <a:noFill/>
+          <a:ln>
+            <a:noFill/>
+          </a:ln>
+        </p:spPr>
+        <p:txBody>
+          <a:bodyPr wrap="square" lIns="0" tIns="0" rIns="0" bIns="0" rtlCol="0" anchor="t">
+            <a:noAutofit/>
+          </a:bodyPr>
+          <a:lstStyle/>
+          <a:p>
+            <a:pPr marL="0" indent="0" algn="l">
+              <a:lnSpc>
+                <a:spcPct val="100000"/>
+              </a:lnSpc>
+              <a:spcBef>
+                <a:spcPts val="0"/>
+              </a:spcBef>
+              <a:spcAft>
+                <a:spcPts val="0"/>
+              </a:spcAft>
+              <a:buNone/>
+            </a:pPr>
+            <a:r>
+              <a:rPr lang="en-US" sz="2000" b="1" dirty="0">
+                <a:solidFill>
+                  <a:schemeClr val="accent2"/>
+                </a:solidFill>
+                <a:latin typeface="Times New Roman" panose="02020603050405020304" pitchFamily="18" charset="0"/>
+                <a:cs typeface="Times New Roman" panose="02020603050405020304" pitchFamily="18" charset="0"/>
+              </a:rPr>
+              <a:t>July selloff</a:t>
+            </a:r>
+          </a:p>
+        </p:txBody>
+      </p:sp>
+      <p:sp>
+        <p:nvSpPr>
+          <p:cNvPr id="3123" name="July selloff 1 value"/>
+          <p:cNvSpPr txBox="1"/>
+          <p:nvPr/>
+        </p:nvSpPr>
+        <p:spPr>
+          <a:xfrm>
+            <a:off x="5943600" y="3840480"/>
+            <a:ext cx="1767840" cy="777240"/>
+          </a:xfrm>
+          <a:prstGeom prst="rect">
+            <a:avLst/>
+          </a:prstGeom>
+          <a:noFill/>
+          <a:ln>
+            <a:noFill/>
+          </a:ln>
+        </p:spPr>
+        <p:txBody>
+          <a:bodyPr wrap="square" lIns="0" tIns="0" rIns="0" bIns="0" rtlCol="0" anchor="ctr">
+            <a:noAutofit/>
+          </a:bodyPr>
+          <a:lstStyle/>
+          <a:p>
+            <a:pPr marL="0" indent="0" algn="l">
+              <a:lnSpc>
+                <a:spcPct val="100000"/>
+              </a:lnSpc>
+              <a:spcBef>
+                <a:spcPts val="0"/>
+              </a:spcBef>
+              <a:spcAft>
+                <a:spcPts val="0"/>
+              </a:spcAft>
+              <a:buNone/>
+            </a:pPr>
+            <a:r>
+              <a:rPr lang="en-US" sz="4400" b="1" dirty="0">
+                <a:solidFill>
+                  <a:schemeClr val="dk2"/>
+                </a:solidFill>
+                <a:latin typeface="Times New Roman" panose="02020603050405020304" pitchFamily="18" charset="0"/>
+                <a:cs typeface="Times New Roman" panose="02020603050405020304" pitchFamily="18" charset="0"/>
+              </a:rPr>
+              <a:t>−11%</a:t>
+            </a:r>
+          </a:p>
+        </p:txBody>
+      </p:sp>
+      <p:sp>
+        <p:nvSpPr>
+          <p:cNvPr id="3124" name="July selloff 1 name"/>
+          <p:cNvSpPr txBox="1"/>
+          <p:nvPr/>
+        </p:nvSpPr>
+        <p:spPr>
+          <a:xfrm>
+            <a:off x="5943600" y="4617720"/>
+            <a:ext cx="1767840" cy="365760"/>
+          </a:xfrm>
+          <a:prstGeom prst="rect">
+            <a:avLst/>
+          </a:prstGeom>
+          <a:noFill/>
+          <a:ln>
+            <a:noFill/>
+          </a:ln>
+        </p:spPr>
+        <p:txBody>
+          <a:bodyPr wrap="square" lIns="0" tIns="0" rIns="0" bIns="0" rtlCol="0" anchor="t">
+            <a:noAutofit/>
+          </a:bodyPr>
+          <a:lstStyle/>
+          <a:p>
+            <a:pPr marL="0" indent="0" algn="l">
+              <a:lnSpc>
+                <a:spcPct val="100000"/>
+              </a:lnSpc>
+              <a:spcBef>
+                <a:spcPts val="0"/>
+              </a:spcBef>
+              <a:spcAft>
+                <a:spcPts val="0"/>
+              </a:spcAft>
+              <a:buNone/>
+            </a:pPr>
+            <a:r>
+              <a:rPr lang="en-US" sz="2000" b="0" dirty="0">
+                <a:solidFill>
+                  <a:schemeClr val="dk1"/>
+                </a:solidFill>
+                <a:latin typeface="Times New Roman" panose="02020603050405020304" pitchFamily="18" charset="0"/>
+                <a:cs typeface="Times New Roman" panose="02020603050405020304" pitchFamily="18" charset="0"/>
+              </a:rPr>
+              <a:t>KOSPI (nearly)</a:t>
+            </a:r>
+          </a:p>
+        </p:txBody>
+      </p:sp>
+      <p:sp>
+        <p:nvSpPr>
+          <p:cNvPr id="3125" name="Selloff note"/>
+          <p:cNvSpPr txBox="1"/>
+          <p:nvPr/>
+        </p:nvSpPr>
+        <p:spPr>
+          <a:xfrm>
+            <a:off x="7802880" y="3931920"/>
+            <a:ext cx="3444240" cy="1097280"/>
+          </a:xfrm>
+          <a:prstGeom prst="rect">
+            <a:avLst/>
+          </a:prstGeom>
+          <a:noFill/>
+          <a:ln>
+            <a:noFill/>
+          </a:ln>
+        </p:spPr>
+        <p:txBody>
+          <a:bodyPr wrap="square" lIns="0" tIns="0" rIns="0" bIns="0" rtlCol="0" anchor="ctr">
+            <a:noAutofit/>
+          </a:bodyPr>
+          <a:lstStyle/>
+          <a:p>
+            <a:pPr marL="0" indent="0" algn="l">
+              <a:lnSpc>
+                <a:spcPct val="100000"/>
+              </a:lnSpc>
+              <a:spcBef>
+                <a:spcPts val="0"/>
+              </a:spcBef>
+              <a:spcAft>
+                <a:spcPts val="0"/>
+              </a:spcAft>
+              <a:buNone/>
+            </a:pPr>
+            <a:r>
+              <a:rPr lang="en-US" sz="1800" b="0" i="1" dirty="0">
+                <a:solidFill>
+                  <a:schemeClr val="accent3"/>
+                </a:solidFill>
+                <a:latin typeface="Times New Roman" panose="02020603050405020304" pitchFamily="18" charset="0"/>
+                <a:cs typeface="Times New Roman" panose="02020603050405020304" pitchFamily="18" charset="0"/>
+              </a:rPr>
+              <a:t>CXMT's progress fuels fears that more chip supply will squeeze Korean prices and profits</a:t>
+            </a:r>
+          </a:p>
+        </p:txBody>
+      </p:sp>
+      <p:sp>
+        <p:nvSpPr>
+          <p:cNvPr id="3126" name="Takeaway banner"/>
+          <p:cNvSpPr/>
+          <p:nvPr/>
+        </p:nvSpPr>
+        <p:spPr>
+          <a:xfrm>
+            <a:off x="950976" y="5486400"/>
+            <a:ext cx="9473184" cy="685800"/>
+          </a:xfrm>
+          <a:prstGeom prst="rect">
+            <a:avLst/>
+          </a:prstGeom>
+          <a:solidFill>
+            <a:schemeClr val="tx1">
+              <a:lumMod val="50000"/>
+              <a:lumOff val="50000"/>
+            </a:schemeClr>
+          </a:solidFill>
+          <a:ln>
+            <a:noFill/>
+          </a:ln>
+        </p:spPr>
+        <p:txBody>
+          <a:bodyPr wrap="square" lIns="91440" tIns="91440" rIns="91440" bIns="91440" rtlCol="0" anchor="ctr">
+            <a:noAutofit/>
+          </a:bodyPr>
+          <a:lstStyle/>
+          <a:p>
+            <a:pPr marL="0" indent="0" algn="ctr">
+              <a:lnSpc>
+                <a:spcPct val="100000"/>
+              </a:lnSpc>
+              <a:spcBef>
+                <a:spcPts val="0"/>
+              </a:spcBef>
+              <a:spcAft>
+                <a:spcPts val="0"/>
+              </a:spcAft>
+              <a:buNone/>
+            </a:pPr>
+            <a:r>
+              <a:rPr lang="en-US" sz="2000" b="1" i="1" dirty="0">
+                <a:solidFill>
+                  <a:schemeClr val="bg1"/>
+                </a:solidFill>
+                <a:latin typeface="Times New Roman" panose="02020603050405020304" pitchFamily="18" charset="0"/>
+                <a:cs typeface="Times New Roman" panose="02020603050405020304" pitchFamily="18" charset="0"/>
+              </a:rPr>
+              <a:t>Can Korea sustain its export strength as China shifts from customer to competitor?</a:t>
+            </a:r>
+          </a:p>
+        </p:txBody>
+      </p:sp>
+    </p:spTree>
+  </p:cSld>
+  <p:clrMapOvr>
+    <a:masterClrMapping/>
+  </p:clrMapOvr>
+</p:sld>
+</file>
+
+<file path=ppt/slides/slide8.xml><?xml version="1.0" encoding="utf-8"?>
+<p:sld xmlns:a="http://schemas.openxmlformats.org/drawingml/2006/main" xmlns:r="http://schemas.openxmlformats.org/officeDocument/2006/relationships" xmlns:p="http://schemas.openxmlformats.org/presentationml/2006/main">
+  <p:cSld>
+    <p:spTree>
+      <p:nvGrpSpPr>
+        <p:cNvPr id="1" name=""/>
+        <p:cNvGrpSpPr/>
+        <p:nvPr/>
+      </p:nvGrpSpPr>
+      <p:grpSpPr>
+        <a:xfrm>
+          <a:off x="0" y="0"/>
+          <a:ext cx="0" cy="0"/>
+          <a:chOff x="0" y="0"/>
+          <a:chExt cx="0" cy="0"/>
+        </a:xfrm>
+      </p:grpSpPr>
+      <p:sp>
+        <p:nvSpPr>
+          <p:cNvPr id="3127" name="Title band"/>
           <p:cNvSpPr/>
           <p:nvPr/>
         </p:nvSpPr>
@@ -33384,7 +33376,7 @@
       </p:sp>
       <p:sp>
         <p:nvSpPr>
-          <p:cNvPr id="3127" name="Title"/>
+          <p:cNvPr id="3128" name="Title"/>
           <p:cNvSpPr txBox="1">
             <a:spLocks noGrp="1"/>
           </p:cNvSpPr>
@@ -33420,7 +33412,7 @@
       </p:sp>
       <p:sp>
         <p:nvSpPr>
-          <p:cNvPr id="3128" name="Column 1 header"/>
+          <p:cNvPr id="3129" name="Column 1 header"/>
           <p:cNvSpPr/>
           <p:nvPr/>
         </p:nvSpPr>
@@ -33496,7 +33488,7 @@
       </p:sp>
       <p:sp>
         <p:nvSpPr>
-          <p:cNvPr id="3129" name="Column 1 marker 1"/>
+          <p:cNvPr id="3130" name="Column 1 marker 1"/>
           <p:cNvSpPr/>
           <p:nvPr/>
         </p:nvSpPr>
@@ -33527,7 +33519,7 @@
       </p:sp>
       <p:sp>
         <p:nvSpPr>
-          <p:cNvPr id="3130" name="Column 1 point 1"/>
+          <p:cNvPr id="3131" name="Column 1 point 1"/>
           <p:cNvSpPr txBox="1"/>
           <p:nvPr/>
         </p:nvSpPr>
@@ -33587,7 +33579,7 @@
       </p:sp>
       <p:sp>
         <p:nvSpPr>
-          <p:cNvPr id="3131" name="Column 1 marker 2"/>
+          <p:cNvPr id="3132" name="Column 1 marker 2"/>
           <p:cNvSpPr/>
           <p:nvPr/>
         </p:nvSpPr>
@@ -33618,7 +33610,7 @@
       </p:sp>
       <p:sp>
         <p:nvSpPr>
-          <p:cNvPr id="3132" name="Column 1 point 2"/>
+          <p:cNvPr id="3133" name="Column 1 point 2"/>
           <p:cNvSpPr txBox="1"/>
           <p:nvPr/>
         </p:nvSpPr>
@@ -33668,7 +33660,7 @@
       </p:sp>
       <p:sp>
         <p:nvSpPr>
-          <p:cNvPr id="3133" name="Column 1 marker 3"/>
+          <p:cNvPr id="3134" name="Column 1 marker 3"/>
           <p:cNvSpPr/>
           <p:nvPr/>
         </p:nvSpPr>
@@ -33699,7 +33691,7 @@
       </p:sp>
       <p:sp>
         <p:nvSpPr>
-          <p:cNvPr id="3134" name="Column 1 point 3"/>
+          <p:cNvPr id="3135" name="Column 1 point 3"/>
           <p:cNvSpPr txBox="1"/>
           <p:nvPr/>
         </p:nvSpPr>
@@ -33759,7 +33751,7 @@
       </p:sp>
       <p:sp>
         <p:nvSpPr>
-          <p:cNvPr id="3135" name="Column 2 header"/>
+          <p:cNvPr id="3136" name="Column 2 header"/>
           <p:cNvSpPr/>
           <p:nvPr/>
         </p:nvSpPr>
@@ -33835,7 +33827,7 @@
       </p:sp>
       <p:sp>
         <p:nvSpPr>
-          <p:cNvPr id="3136" name="Column 2 marker 1"/>
+          <p:cNvPr id="3137" name="Column 2 marker 1"/>
           <p:cNvSpPr/>
           <p:nvPr/>
         </p:nvSpPr>
@@ -33866,7 +33858,7 @@
       </p:sp>
       <p:sp>
         <p:nvSpPr>
-          <p:cNvPr id="3137" name="Column 2 point 1"/>
+          <p:cNvPr id="3138" name="Column 2 point 1"/>
           <p:cNvSpPr txBox="1"/>
           <p:nvPr/>
         </p:nvSpPr>
@@ -33916,7 +33908,7 @@
       </p:sp>
       <p:sp>
         <p:nvSpPr>
-          <p:cNvPr id="3138" name="Column 2 marker 2"/>
+          <p:cNvPr id="3139" name="Column 2 marker 2"/>
           <p:cNvSpPr/>
           <p:nvPr/>
         </p:nvSpPr>
@@ -33947,7 +33939,7 @@
       </p:sp>
       <p:sp>
         <p:nvSpPr>
-          <p:cNvPr id="3139" name="Column 2 point 2"/>
+          <p:cNvPr id="3140" name="Column 2 point 2"/>
           <p:cNvSpPr txBox="1"/>
           <p:nvPr/>
         </p:nvSpPr>
@@ -33997,7 +33989,7 @@
       </p:sp>
       <p:sp>
         <p:nvSpPr>
-          <p:cNvPr id="3140" name="Column 2 marker 3"/>
+          <p:cNvPr id="3141" name="Column 2 marker 3"/>
           <p:cNvSpPr/>
           <p:nvPr/>
         </p:nvSpPr>
@@ -34028,7 +34020,7 @@
       </p:sp>
       <p:sp>
         <p:nvSpPr>
-          <p:cNvPr id="3141" name="Column 2 point 3"/>
+          <p:cNvPr id="3142" name="Column 2 point 3"/>
           <p:cNvSpPr txBox="1"/>
           <p:nvPr/>
         </p:nvSpPr>
@@ -34088,7 +34080,7 @@
       </p:sp>
       <p:sp>
         <p:nvSpPr>
-          <p:cNvPr id="3142" name="Takeaway banner"/>
+          <p:cNvPr id="3143" name="Takeaway banner"/>
           <p:cNvSpPr/>
           <p:nvPr/>
         </p:nvSpPr>

</xml_diff>

<commit_message>
Restore single paradox slide; make 2026 rebound the headline, share decline as context
Co-Authored-By: Claude Opus 5.5 <noreply@anthropic.com>
Claude-Session: https://claude.ai/code/session_01EAqNWxuCBt8vBHk7fm7zMv
</commit_message>
<xml_diff>
--- a/korea-china-trade.pptx
+++ b/korea-china-trade.pptx
@@ -16,7 +16,6 @@
     <p:sldId id="286" r:id="rId7"/>
     <p:sldId id="287" r:id="rId29"/>
     <p:sldId id="288" r:id="rId30"/>
-    <p:sldId id="289" r:id="rId31"/>
   </p:sldIdLst>
   <p:sldSz cx="12192000" cy="6858000"/>
   <p:notesSz cx="6858000" cy="9144000"/>
@@ -32191,21 +32190,21 @@
                 <a:latin typeface="Times New Roman" panose="02020603050405020304" pitchFamily="18" charset="0"/>
                 <a:cs typeface="Times New Roman" panose="02020603050405020304" pitchFamily="18" charset="0"/>
               </a:rPr>
-              <a:t>Short-Term: Chinese Demand Persists</a:t>
+              <a:t>The Paradox: Strong Demand, Growing Risk</a:t>
             </a:r>
           </a:p>
         </p:txBody>
       </p:sp>
       <p:sp>
         <p:nvSpPr>
-          <p:cNvPr id="3103" name="Share label"/>
+          <p:cNvPr id="3103" name="Left heading"/>
           <p:cNvSpPr txBox="1"/>
           <p:nvPr/>
         </p:nvSpPr>
         <p:spPr>
           <a:xfrm>
-            <a:off x="950976" y="1828800"/>
-            <a:ext cx="5120640" cy="411480"/>
+            <a:off x="950976" y="1572768"/>
+            <a:ext cx="4736592" cy="731520"/>
           </a:xfrm>
           <a:prstGeom prst="rect">
             <a:avLst/>
@@ -32241,21 +32240,162 @@
                 <a:latin typeface="Times New Roman" panose="02020603050405020304" pitchFamily="18" charset="0"/>
                 <a:cs typeface="Times New Roman" panose="02020603050405020304" pitchFamily="18" charset="0"/>
               </a:rPr>
-              <a:t>China's share of Korea's memory chip exports</a:t>
+              <a:t>Short-term strength</a:t>
+            </a:r>
+          </a:p>
+          <a:p>
+            <a:pPr marL="0" indent="0" algn="l">
+              <a:lnSpc>
+                <a:spcPct val="100000"/>
+              </a:lnSpc>
+              <a:spcBef>
+                <a:spcPts val="0"/>
+              </a:spcBef>
+              <a:spcAft>
+                <a:spcPts val="0"/>
+              </a:spcAft>
+              <a:buNone/>
+            </a:pPr>
+            <a:r>
+              <a:rPr lang="en-US" sz="2000" b="1" dirty="0">
+                <a:solidFill>
+                  <a:schemeClr val="accent2"/>
+                </a:solidFill>
+                <a:latin typeface="Times New Roman" panose="02020603050405020304" pitchFamily="18" charset="0"/>
+                <a:cs typeface="Times New Roman" panose="02020603050405020304" pitchFamily="18" charset="0"/>
+              </a:rPr>
+              <a:t>Chinese demand persists</a:t>
             </a:r>
           </a:p>
         </p:txBody>
       </p:sp>
       <p:sp>
         <p:nvSpPr>
-          <p:cNvPr id="3104" name="Share 2018"/>
+          <p:cNvPr id="3104" name="Right heading"/>
           <p:cNvSpPr txBox="1"/>
           <p:nvPr/>
         </p:nvSpPr>
         <p:spPr>
           <a:xfrm>
-            <a:off x="950976" y="2377440"/>
-            <a:ext cx="2194560" cy="960120"/>
+            <a:off x="6510528" y="1572768"/>
+            <a:ext cx="4736592" cy="731520"/>
+          </a:xfrm>
+          <a:prstGeom prst="rect">
+            <a:avLst/>
+          </a:prstGeom>
+          <a:noFill/>
+          <a:ln>
+            <a:noFill/>
+          </a:ln>
+        </p:spPr>
+        <p:txBody>
+          <a:bodyPr wrap="square" lIns="0" tIns="0" rIns="0" bIns="0" rtlCol="0" anchor="t">
+            <a:noAutofit/>
+          </a:bodyPr>
+          <a:lstStyle/>
+          <a:p>
+            <a:pPr marL="0" indent="0" algn="l">
+              <a:lnSpc>
+                <a:spcPct val="100000"/>
+              </a:lnSpc>
+              <a:spcBef>
+                <a:spcPts val="0"/>
+              </a:spcBef>
+              <a:spcAft>
+                <a:spcPts val="0"/>
+              </a:spcAft>
+              <a:buNone/>
+            </a:pPr>
+            <a:r>
+              <a:rPr lang="en-US" sz="2000" b="1" dirty="0">
+                <a:solidFill>
+                  <a:schemeClr val="dk2"/>
+                </a:solidFill>
+                <a:latin typeface="Times New Roman" panose="02020603050405020304" pitchFamily="18" charset="0"/>
+                <a:cs typeface="Times New Roman" panose="02020603050405020304" pitchFamily="18" charset="0"/>
+              </a:rPr>
+              <a:t>Long-term risk</a:t>
+            </a:r>
+          </a:p>
+          <a:p>
+            <a:pPr marL="0" indent="0" algn="l">
+              <a:lnSpc>
+                <a:spcPct val="100000"/>
+              </a:lnSpc>
+              <a:spcBef>
+                <a:spcPts val="0"/>
+              </a:spcBef>
+              <a:spcAft>
+                <a:spcPts val="0"/>
+              </a:spcAft>
+              <a:buNone/>
+            </a:pPr>
+            <a:r>
+              <a:rPr lang="en-US" sz="2000" b="1" dirty="0">
+                <a:solidFill>
+                  <a:schemeClr val="accent2"/>
+                </a:solidFill>
+                <a:latin typeface="Times New Roman" panose="02020603050405020304" pitchFamily="18" charset="0"/>
+                <a:cs typeface="Times New Roman" panose="02020603050405020304" pitchFamily="18" charset="0"/>
+              </a:rPr>
+              <a:t>Markets fear China's competitiveness</a:t>
+            </a:r>
+          </a:p>
+        </p:txBody>
+      </p:sp>
+      <p:cxnSp>
+        <p:nvCxnSpPr>
+          <p:cNvPr id="3105" name="Column divider"/>
+          <p:cNvCxnSpPr/>
+          <p:nvPr/>
+        </p:nvCxnSpPr>
+        <p:spPr>
+          <a:xfrm>
+            <a:off x="6099048" y="1645920"/>
+            <a:ext cx="0" cy="3520440"/>
+          </a:xfrm>
+          <a:prstGeom prst="straightConnector1">
+            <a:avLst/>
+          </a:prstGeom>
+          <a:ln w="9525">
+            <a:solidFill>
+              <a:schemeClr val="accent4"/>
+            </a:solidFill>
+          </a:ln>
+        </p:spPr>
+      </p:cxnSp>
+      <p:sp>
+        <p:nvSpPr>
+          <p:cNvPr id="3106" name="Rebound arrow"/>
+          <p:cNvSpPr/>
+          <p:nvPr/>
+        </p:nvSpPr>
+        <p:spPr>
+          <a:xfrm>
+            <a:off x="950976" y="2542032"/>
+            <a:ext cx="868680" cy="1234440"/>
+          </a:xfrm>
+          <a:prstGeom prst="upArrow">
+            <a:avLst/>
+          </a:prstGeom>
+          <a:solidFill>
+            <a:schemeClr val="accent5"/>
+          </a:solidFill>
+          <a:ln>
+            <a:noFill/>
+          </a:ln>
+        </p:spPr>
+      </p:sp>
+      <p:sp>
+        <p:nvSpPr>
+          <p:cNvPr id="3107" name="Rebound headline"/>
+          <p:cNvSpPr txBox="1"/>
+          <p:nvPr/>
+        </p:nvSpPr>
+        <p:spPr>
+          <a:xfrm>
+            <a:off x="2048256" y="2450592"/>
+            <a:ext cx="3639312" cy="1051560"/>
           </a:xfrm>
           <a:prstGeom prst="rect">
             <a:avLst/>
@@ -32284,50 +32424,249 @@
               <a:buNone/>
             </a:pPr>
             <a:r>
-              <a:rPr lang="en-US" sz="6000" b="1" dirty="0">
+              <a:rPr lang="en-US" sz="3000" b="1" dirty="0">
                 <a:solidFill>
-                  <a:schemeClr val="accent4"/>
+                  <a:schemeClr val="accent5"/>
+                </a:solidFill>
+                <a:latin typeface="Times New Roman" panose="02020603050405020304" pitchFamily="18" charset="0"/>
+                <a:cs typeface="Times New Roman" panose="02020603050405020304" pitchFamily="18" charset="0"/>
+              </a:rPr>
+              <a:t>Exports to China rebound strongly</a:t>
+            </a:r>
+          </a:p>
+        </p:txBody>
+      </p:sp>
+      <p:sp>
+        <p:nvSpPr>
+          <p:cNvPr id="3108" name="Rebound driver"/>
+          <p:cNvSpPr txBox="1"/>
+          <p:nvPr/>
+        </p:nvSpPr>
+        <p:spPr>
+          <a:xfrm>
+            <a:off x="2048256" y="3520440"/>
+            <a:ext cx="3639312" cy="384048"/>
+          </a:xfrm>
+          <a:prstGeom prst="rect">
+            <a:avLst/>
+          </a:prstGeom>
+          <a:noFill/>
+          <a:ln>
+            <a:noFill/>
+          </a:ln>
+        </p:spPr>
+        <p:txBody>
+          <a:bodyPr wrap="square" lIns="0" tIns="0" rIns="0" bIns="0" rtlCol="0" anchor="t">
+            <a:noAutofit/>
+          </a:bodyPr>
+          <a:lstStyle/>
+          <a:p>
+            <a:pPr marL="0" indent="0" algn="l">
+              <a:lnSpc>
+                <a:spcPct val="100000"/>
+              </a:lnSpc>
+              <a:spcBef>
+                <a:spcPts val="0"/>
+              </a:spcBef>
+              <a:spcAft>
+                <a:spcPts val="0"/>
+              </a:spcAft>
+              <a:buNone/>
+            </a:pPr>
+            <a:r>
+              <a:rPr lang="en-US" sz="2000" b="0" dirty="0">
+                <a:solidFill>
+                  <a:schemeClr val="dk1"/>
+                </a:solidFill>
+                <a:latin typeface="Times New Roman" panose="02020603050405020304" pitchFamily="18" charset="0"/>
+                <a:cs typeface="Times New Roman" panose="02020603050405020304" pitchFamily="18" charset="0"/>
+              </a:rPr>
+              <a:t>in 2026, driven by AI chip demand</a:t>
+            </a:r>
+          </a:p>
+        </p:txBody>
+      </p:sp>
+      <p:cxnSp>
+        <p:nvCxnSpPr>
+          <p:cNvPr id="3109" name="Context rule"/>
+          <p:cNvCxnSpPr/>
+          <p:nvPr/>
+        </p:nvCxnSpPr>
+        <p:spPr>
+          <a:xfrm>
+            <a:off x="950976" y="4160520"/>
+            <a:ext cx="4736592" cy="0"/>
+          </a:xfrm>
+          <a:prstGeom prst="straightConnector1">
+            <a:avLst/>
+          </a:prstGeom>
+          <a:ln w="9525">
+            <a:solidFill>
+              <a:schemeClr val="accent4"/>
+            </a:solidFill>
+          </a:ln>
+        </p:spPr>
+      </p:cxnSp>
+      <p:sp>
+        <p:nvSpPr>
+          <p:cNvPr id="3110" name="Share context"/>
+          <p:cNvSpPr txBox="1"/>
+          <p:nvPr/>
+        </p:nvSpPr>
+        <p:spPr>
+          <a:xfrm>
+            <a:off x="950976" y="4279392"/>
+            <a:ext cx="4736592" cy="868680"/>
+          </a:xfrm>
+          <a:prstGeom prst="rect">
+            <a:avLst/>
+          </a:prstGeom>
+          <a:noFill/>
+          <a:ln>
+            <a:noFill/>
+          </a:ln>
+        </p:spPr>
+        <p:txBody>
+          <a:bodyPr wrap="square" lIns="0" tIns="0" rIns="0" bIns="0" rtlCol="0" anchor="t">
+            <a:noAutofit/>
+          </a:bodyPr>
+          <a:lstStyle/>
+          <a:p>
+            <a:pPr marL="0" indent="0" algn="l">
+              <a:lnSpc>
+                <a:spcPct val="100000"/>
+              </a:lnSpc>
+              <a:spcBef>
+                <a:spcPts val="0"/>
+              </a:spcBef>
+              <a:spcAft>
+                <a:spcPts val="0"/>
+              </a:spcAft>
+              <a:buNone/>
+            </a:pPr>
+            <a:r>
+              <a:rPr lang="en-US" sz="1800" b="1" dirty="0">
+                <a:solidFill>
+                  <a:schemeClr val="accent3"/>
+                </a:solidFill>
+                <a:latin typeface="Times New Roman" panose="02020603050405020304" pitchFamily="18" charset="0"/>
+                <a:cs typeface="Times New Roman" panose="02020603050405020304" pitchFamily="18" charset="0"/>
+              </a:rPr>
+              <a:t>Context: </a:t>
+            </a:r>
+            <a:r>
+              <a:rPr lang="en-US" sz="1800" b="0" dirty="0">
+                <a:solidFill>
+                  <a:schemeClr val="accent3"/>
+                </a:solidFill>
+                <a:latin typeface="Times New Roman" panose="02020603050405020304" pitchFamily="18" charset="0"/>
+                <a:cs typeface="Times New Roman" panose="02020603050405020304" pitchFamily="18" charset="0"/>
+              </a:rPr>
+              <a:t>China's share of Korea's memory chip exports fell from </a:t>
+            </a:r>
+            <a:r>
+              <a:rPr lang="en-US" sz="1800" b="1" dirty="0">
+                <a:solidFill>
+                  <a:schemeClr val="accent2"/>
                 </a:solidFill>
                 <a:latin typeface="Times New Roman" panose="02020603050405020304" pitchFamily="18" charset="0"/>
                 <a:cs typeface="Times New Roman" panose="02020603050405020304" pitchFamily="18" charset="0"/>
               </a:rPr>
               <a:t>45.7%</a:t>
             </a:r>
+            <a:r>
+              <a:rPr lang="en-US" sz="1800" b="0" dirty="0">
+                <a:solidFill>
+                  <a:schemeClr val="accent3"/>
+                </a:solidFill>
+                <a:latin typeface="Times New Roman" panose="02020603050405020304" pitchFamily="18" charset="0"/>
+                <a:cs typeface="Times New Roman" panose="02020603050405020304" pitchFamily="18" charset="0"/>
+              </a:rPr>
+              <a:t> (2018) to </a:t>
+            </a:r>
+            <a:r>
+              <a:rPr lang="en-US" sz="1800" b="1" dirty="0">
+                <a:solidFill>
+                  <a:schemeClr val="accent2"/>
+                </a:solidFill>
+                <a:latin typeface="Times New Roman" panose="02020603050405020304" pitchFamily="18" charset="0"/>
+                <a:cs typeface="Times New Roman" panose="02020603050405020304" pitchFamily="18" charset="0"/>
+              </a:rPr>
+              <a:t>31.7%</a:t>
+            </a:r>
+            <a:r>
+              <a:rPr lang="en-US" sz="1800" b="0" dirty="0">
+                <a:solidFill>
+                  <a:schemeClr val="accent3"/>
+                </a:solidFill>
+                <a:latin typeface="Times New Roman" panose="02020603050405020304" pitchFamily="18" charset="0"/>
+                <a:cs typeface="Times New Roman" panose="02020603050405020304" pitchFamily="18" charset="0"/>
+              </a:rPr>
+              <a:t> (2024)</a:t>
+            </a:r>
           </a:p>
         </p:txBody>
       </p:sp>
-      <p:cxnSp>
-        <p:nvCxnSpPr>
-          <p:cNvPr id="3105" name="Share arrow"/>
-          <p:cNvCxnSpPr/>
-          <p:nvPr/>
-        </p:nvCxnSpPr>
-        <p:spPr>
-          <a:xfrm>
-            <a:off x="3191256" y="2857500"/>
-            <a:ext cx="640080" cy="0"/>
-          </a:xfrm>
-          <a:prstGeom prst="straightConnector1">
-            <a:avLst/>
-          </a:prstGeom>
-          <a:ln w="22225">
-            <a:solidFill>
-              <a:schemeClr val="dk1"/>
-            </a:solidFill>
-            <a:tailEnd type="triangle" w="med" len="med"/>
-          </a:ln>
-        </p:spPr>
-      </p:cxnSp>
       <p:sp>
         <p:nvSpPr>
-          <p:cNvPr id="3106" name="Share 2024"/>
+          <p:cNvPr id="3111" name="Recent label"/>
           <p:cNvSpPr txBox="1"/>
           <p:nvPr/>
         </p:nvSpPr>
         <p:spPr>
           <a:xfrm>
-            <a:off x="3968496" y="2377440"/>
-            <a:ext cx="2194560" cy="960120"/>
+            <a:off x="6510528" y="2468880"/>
+            <a:ext cx="4736592" cy="347472"/>
+          </a:xfrm>
+          <a:prstGeom prst="rect">
+            <a:avLst/>
+          </a:prstGeom>
+          <a:noFill/>
+          <a:ln>
+            <a:noFill/>
+          </a:ln>
+        </p:spPr>
+        <p:txBody>
+          <a:bodyPr wrap="square" lIns="0" tIns="0" rIns="0" bIns="0" rtlCol="0" anchor="t">
+            <a:noAutofit/>
+          </a:bodyPr>
+          <a:lstStyle/>
+          <a:p>
+            <a:pPr marL="0" indent="0" algn="l">
+              <a:lnSpc>
+                <a:spcPct val="100000"/>
+              </a:lnSpc>
+              <a:spcBef>
+                <a:spcPts val="0"/>
+              </a:spcBef>
+              <a:spcAft>
+                <a:spcPts val="0"/>
+              </a:spcAft>
+              <a:buNone/>
+            </a:pPr>
+            <a:r>
+              <a:rPr lang="en-US" sz="1800" b="1" dirty="0">
+                <a:solidFill>
+                  <a:schemeClr val="accent3"/>
+                </a:solidFill>
+                <a:latin typeface="Times New Roman" panose="02020603050405020304" pitchFamily="18" charset="0"/>
+                <a:cs typeface="Times New Roman" panose="02020603050405020304" pitchFamily="18" charset="0"/>
+              </a:rPr>
+              <a:t>Most recent selloff (approx.)</a:t>
+            </a:r>
+          </a:p>
+        </p:txBody>
+      </p:sp>
+      <p:sp>
+        <p:nvSpPr>
+          <p:cNvPr id="3112" name="Selloff 1 value"/>
+          <p:cNvSpPr txBox="1"/>
+          <p:nvPr/>
+        </p:nvSpPr>
+        <p:spPr>
+          <a:xfrm>
+            <a:off x="6510528" y="2788920"/>
+            <a:ext cx="1578864" cy="685800"/>
           </a:xfrm>
           <a:prstGeom prst="rect">
             <a:avLst/>
@@ -32356,28 +32695,28 @@
               <a:buNone/>
             </a:pPr>
             <a:r>
-              <a:rPr lang="en-US" sz="6000" b="1" dirty="0">
+              <a:rPr lang="en-US" sz="4000" b="1" dirty="0">
                 <a:solidFill>
-                  <a:schemeClr val="accent2"/>
+                  <a:schemeClr val="dk2"/>
                 </a:solidFill>
                 <a:latin typeface="Times New Roman" panose="02020603050405020304" pitchFamily="18" charset="0"/>
                 <a:cs typeface="Times New Roman" panose="02020603050405020304" pitchFamily="18" charset="0"/>
               </a:rPr>
-              <a:t>31.7%</a:t>
+              <a:t>−5.5%</a:t>
             </a:r>
           </a:p>
         </p:txBody>
       </p:sp>
       <p:sp>
         <p:nvSpPr>
-          <p:cNvPr id="3107" name="Year 2018"/>
+          <p:cNvPr id="3113" name="Selloff 1 name"/>
           <p:cNvSpPr txBox="1"/>
           <p:nvPr/>
         </p:nvSpPr>
         <p:spPr>
           <a:xfrm>
-            <a:off x="950976" y="3337560"/>
-            <a:ext cx="2194560" cy="365760"/>
+            <a:off x="6510528" y="3474720"/>
+            <a:ext cx="1578864" cy="365760"/>
           </a:xfrm>
           <a:prstGeom prst="rect">
             <a:avLst/>
@@ -32408,26 +32747,76 @@
             <a:r>
               <a:rPr lang="en-US" sz="2000" b="0" dirty="0">
                 <a:solidFill>
-                  <a:schemeClr val="accent3"/>
+                  <a:schemeClr val="dk1"/>
                 </a:solidFill>
                 <a:latin typeface="Times New Roman" panose="02020603050405020304" pitchFamily="18" charset="0"/>
                 <a:cs typeface="Times New Roman" panose="02020603050405020304" pitchFamily="18" charset="0"/>
               </a:rPr>
-              <a:t>2018</a:t>
+              <a:t>KOSPI</a:t>
             </a:r>
           </a:p>
         </p:txBody>
       </p:sp>
       <p:sp>
         <p:nvSpPr>
-          <p:cNvPr id="3108" name="Year 2024"/>
+          <p:cNvPr id="3114" name="Selloff 2 value"/>
           <p:cNvSpPr txBox="1"/>
           <p:nvPr/>
         </p:nvSpPr>
         <p:spPr>
           <a:xfrm>
-            <a:off x="3968496" y="3337560"/>
-            <a:ext cx="2194560" cy="365760"/>
+            <a:off x="8089392" y="2788920"/>
+            <a:ext cx="1578864" cy="685800"/>
+          </a:xfrm>
+          <a:prstGeom prst="rect">
+            <a:avLst/>
+          </a:prstGeom>
+          <a:noFill/>
+          <a:ln>
+            <a:noFill/>
+          </a:ln>
+        </p:spPr>
+        <p:txBody>
+          <a:bodyPr wrap="square" lIns="0" tIns="0" rIns="0" bIns="0" rtlCol="0" anchor="ctr">
+            <a:noAutofit/>
+          </a:bodyPr>
+          <a:lstStyle/>
+          <a:p>
+            <a:pPr marL="0" indent="0" algn="l">
+              <a:lnSpc>
+                <a:spcPct val="100000"/>
+              </a:lnSpc>
+              <a:spcBef>
+                <a:spcPts val="0"/>
+              </a:spcBef>
+              <a:spcAft>
+                <a:spcPts val="0"/>
+              </a:spcAft>
+              <a:buNone/>
+            </a:pPr>
+            <a:r>
+              <a:rPr lang="en-US" sz="4000" b="1" dirty="0">
+                <a:solidFill>
+                  <a:schemeClr val="dk2"/>
+                </a:solidFill>
+                <a:latin typeface="Times New Roman" panose="02020603050405020304" pitchFamily="18" charset="0"/>
+                <a:cs typeface="Times New Roman" panose="02020603050405020304" pitchFamily="18" charset="0"/>
+              </a:rPr>
+              <a:t>−7%</a:t>
+            </a:r>
+          </a:p>
+        </p:txBody>
+      </p:sp>
+      <p:sp>
+        <p:nvSpPr>
+          <p:cNvPr id="3115" name="Selloff 2 name"/>
+          <p:cNvSpPr txBox="1"/>
+          <p:nvPr/>
+        </p:nvSpPr>
+        <p:spPr>
+          <a:xfrm>
+            <a:off x="8089392" y="3474720"/>
+            <a:ext cx="1578864" cy="365760"/>
           </a:xfrm>
           <a:prstGeom prst="rect">
             <a:avLst/>
@@ -32458,78 +32847,76 @@
             <a:r>
               <a:rPr lang="en-US" sz="2000" b="0" dirty="0">
                 <a:solidFill>
-                  <a:schemeClr val="accent3"/>
+                  <a:schemeClr val="dk1"/>
                 </a:solidFill>
                 <a:latin typeface="Times New Roman" panose="02020603050405020304" pitchFamily="18" charset="0"/>
                 <a:cs typeface="Times New Roman" panose="02020603050405020304" pitchFamily="18" charset="0"/>
               </a:rPr>
-              <a:t>2024</a:t>
+              <a:t>Samsung</a:t>
             </a:r>
           </a:p>
         </p:txBody>
       </p:sp>
-      <p:cxnSp>
-        <p:nvCxnSpPr>
-          <p:cNvPr id="3109" name="Divider"/>
-          <p:cNvCxnSpPr/>
-          <p:nvPr/>
-        </p:nvCxnSpPr>
-        <p:spPr>
-          <a:xfrm>
-            <a:off x="950976" y="4160520"/>
-            <a:ext cx="5120640" cy="0"/>
-          </a:xfrm>
-          <a:prstGeom prst="straightConnector1">
-            <a:avLst/>
-          </a:prstGeom>
-          <a:ln w="9525">
-            <a:solidFill>
-              <a:schemeClr val="accent4"/>
-            </a:solidFill>
-          </a:ln>
-        </p:spPr>
-      </p:cxnSp>
       <p:sp>
         <p:nvSpPr>
-          <p:cNvPr id="3110" name="Rebound marker"/>
-          <p:cNvSpPr/>
+          <p:cNvPr id="3116" name="Selloff 3 value"/>
+          <p:cNvSpPr txBox="1"/>
           <p:nvPr/>
         </p:nvSpPr>
         <p:spPr>
           <a:xfrm>
-            <a:off x="950976" y="4498848"/>
-            <a:ext cx="219456" cy="219456"/>
+            <a:off x="9668256" y="2788920"/>
+            <a:ext cx="1578864" cy="685800"/>
           </a:xfrm>
           <a:prstGeom prst="rect">
             <a:avLst/>
           </a:prstGeom>
-          <a:solidFill>
-            <a:schemeClr val="accent5"/>
-          </a:solidFill>
+          <a:noFill/>
           <a:ln>
             <a:noFill/>
           </a:ln>
         </p:spPr>
         <p:txBody>
-          <a:bodyPr wrap="square" lIns="0" tIns="0" rIns="0" bIns="0" rtlCol="0" anchor="t">
+          <a:bodyPr wrap="square" lIns="0" tIns="0" rIns="0" bIns="0" rtlCol="0" anchor="ctr">
             <a:noAutofit/>
           </a:bodyPr>
           <a:lstStyle/>
           <a:p>
-            <a:endParaRPr lang="en-US"/>
+            <a:pPr marL="0" indent="0" algn="l">
+              <a:lnSpc>
+                <a:spcPct val="100000"/>
+              </a:lnSpc>
+              <a:spcBef>
+                <a:spcPts val="0"/>
+              </a:spcBef>
+              <a:spcAft>
+                <a:spcPts val="0"/>
+              </a:spcAft>
+              <a:buNone/>
+            </a:pPr>
+            <a:r>
+              <a:rPr lang="en-US" sz="4000" b="1" dirty="0">
+                <a:solidFill>
+                  <a:schemeClr val="dk2"/>
+                </a:solidFill>
+                <a:latin typeface="Times New Roman" panose="02020603050405020304" pitchFamily="18" charset="0"/>
+                <a:cs typeface="Times New Roman" panose="02020603050405020304" pitchFamily="18" charset="0"/>
+              </a:rPr>
+              <a:t>−10%</a:t>
+            </a:r>
           </a:p>
         </p:txBody>
       </p:sp>
       <p:sp>
         <p:nvSpPr>
-          <p:cNvPr id="3111" name="Rebound"/>
+          <p:cNvPr id="3117" name="Selloff 3 name"/>
           <p:cNvSpPr txBox="1"/>
           <p:nvPr/>
         </p:nvSpPr>
         <p:spPr>
           <a:xfrm>
-            <a:off x="1362456" y="4370832"/>
-            <a:ext cx="4709160" cy="1097280"/>
+            <a:off x="9668256" y="3474720"/>
+            <a:ext cx="1578864" cy="365760"/>
           </a:xfrm>
           <a:prstGeom prst="rect">
             <a:avLst/>
@@ -32553,30 +32940,6 @@
                 <a:spcPts val="0"/>
               </a:spcBef>
               <a:spcAft>
-                <a:spcPts val="400"/>
-              </a:spcAft>
-              <a:buNone/>
-            </a:pPr>
-            <a:r>
-              <a:rPr lang="en-US" sz="2200" b="1" dirty="0">
-                <a:solidFill>
-                  <a:schemeClr val="accent5"/>
-                </a:solidFill>
-                <a:latin typeface="Times New Roman" panose="02020603050405020304" pitchFamily="18" charset="0"/>
-                <a:cs typeface="Times New Roman" panose="02020603050405020304" pitchFamily="18" charset="0"/>
-              </a:rPr>
-              <a:t>2026: exports to China rebound strongly</a:t>
-            </a:r>
-          </a:p>
-          <a:p>
-            <a:pPr marL="0" indent="0" algn="l">
-              <a:lnSpc>
-                <a:spcPct val="100000"/>
-              </a:lnSpc>
-              <a:spcBef>
-                <a:spcPts val="0"/>
-              </a:spcBef>
-              <a:spcAft>
                 <a:spcPts val="0"/>
               </a:spcAft>
               <a:buNone/>
@@ -32589,7 +32952,203 @@
                 <a:latin typeface="Times New Roman" panose="02020603050405020304" pitchFamily="18" charset="0"/>
                 <a:cs typeface="Times New Roman" panose="02020603050405020304" pitchFamily="18" charset="0"/>
               </a:rPr>
-              <a:t>driven by AI chip demand</a:t>
+              <a:t>SK Hynix</a:t>
+            </a:r>
+          </a:p>
+        </p:txBody>
+      </p:sp>
+      <p:cxnSp>
+        <p:nvCxnSpPr>
+          <p:cNvPr id="3118" name="Selloff rule"/>
+          <p:cNvCxnSpPr/>
+          <p:nvPr/>
+        </p:nvCxnSpPr>
+        <p:spPr>
+          <a:xfrm>
+            <a:off x="6510528" y="3959352"/>
+            <a:ext cx="4736592" cy="0"/>
+          </a:xfrm>
+          <a:prstGeom prst="straightConnector1">
+            <a:avLst/>
+          </a:prstGeom>
+          <a:ln w="9525">
+            <a:solidFill>
+              <a:schemeClr val="accent4"/>
+            </a:solidFill>
+          </a:ln>
+        </p:spPr>
+      </p:cxnSp>
+      <p:sp>
+        <p:nvSpPr>
+          <p:cNvPr id="3119" name="July selloff"/>
+          <p:cNvSpPr txBox="1"/>
+          <p:nvPr/>
+        </p:nvSpPr>
+        <p:spPr>
+          <a:xfrm>
+            <a:off x="6510528" y="4041648"/>
+            <a:ext cx="4736592" cy="384048"/>
+          </a:xfrm>
+          <a:prstGeom prst="rect">
+            <a:avLst/>
+          </a:prstGeom>
+          <a:noFill/>
+          <a:ln>
+            <a:noFill/>
+          </a:ln>
+        </p:spPr>
+        <p:txBody>
+          <a:bodyPr wrap="square" lIns="0" tIns="0" rIns="0" bIns="0" rtlCol="0" anchor="t">
+            <a:noAutofit/>
+          </a:bodyPr>
+          <a:lstStyle/>
+          <a:p>
+            <a:pPr marL="0" indent="0" algn="l">
+              <a:lnSpc>
+                <a:spcPct val="100000"/>
+              </a:lnSpc>
+              <a:spcBef>
+                <a:spcPts val="0"/>
+              </a:spcBef>
+              <a:spcAft>
+                <a:spcPts val="0"/>
+              </a:spcAft>
+              <a:buNone/>
+            </a:pPr>
+            <a:r>
+              <a:rPr lang="en-US" sz="2000" b="1" dirty="0">
+                <a:solidFill>
+                  <a:schemeClr val="dk1"/>
+                </a:solidFill>
+                <a:latin typeface="Times New Roman" panose="02020603050405020304" pitchFamily="18" charset="0"/>
+                <a:cs typeface="Times New Roman" panose="02020603050405020304" pitchFamily="18" charset="0"/>
+              </a:rPr>
+              <a:t>July selloff: </a:t>
+            </a:r>
+            <a:r>
+              <a:rPr lang="en-US" sz="2000" b="1" dirty="0">
+                <a:solidFill>
+                  <a:schemeClr val="dk2"/>
+                </a:solidFill>
+                <a:latin typeface="Times New Roman" panose="02020603050405020304" pitchFamily="18" charset="0"/>
+                <a:cs typeface="Times New Roman" panose="02020603050405020304" pitchFamily="18" charset="0"/>
+              </a:rPr>
+              <a:t>KOSPI fell nearly 11%</a:t>
+            </a:r>
+          </a:p>
+        </p:txBody>
+      </p:sp>
+      <p:sp>
+        <p:nvSpPr>
+          <p:cNvPr id="3120" name="Selloff note"/>
+          <p:cNvSpPr txBox="1"/>
+          <p:nvPr/>
+        </p:nvSpPr>
+        <p:spPr>
+          <a:xfrm>
+            <a:off x="6510528" y="4498848"/>
+            <a:ext cx="4736592" cy="777240"/>
+          </a:xfrm>
+          <a:prstGeom prst="rect">
+            <a:avLst/>
+          </a:prstGeom>
+          <a:noFill/>
+          <a:ln>
+            <a:noFill/>
+          </a:ln>
+        </p:spPr>
+        <p:txBody>
+          <a:bodyPr wrap="square" lIns="0" tIns="0" rIns="0" bIns="0" rtlCol="0" anchor="t">
+            <a:noAutofit/>
+          </a:bodyPr>
+          <a:lstStyle/>
+          <a:p>
+            <a:pPr marL="0" indent="0" algn="l">
+              <a:lnSpc>
+                <a:spcPct val="100000"/>
+              </a:lnSpc>
+              <a:spcBef>
+                <a:spcPts val="0"/>
+              </a:spcBef>
+              <a:spcAft>
+                <a:spcPts val="0"/>
+              </a:spcAft>
+              <a:buNone/>
+            </a:pPr>
+            <a:r>
+              <a:rPr lang="en-US" sz="1600" b="0" i="1" dirty="0">
+                <a:solidFill>
+                  <a:schemeClr val="accent3"/>
+                </a:solidFill>
+                <a:latin typeface="Times New Roman" panose="02020603050405020304" pitchFamily="18" charset="0"/>
+                <a:cs typeface="Times New Roman" panose="02020603050405020304" pitchFamily="18" charset="0"/>
+              </a:rPr>
+              <a:t>AI-investment worries played a part, but CXMT's progress raised fears that more chip supply will squeeze Korean prices and profits</a:t>
+            </a:r>
+          </a:p>
+        </p:txBody>
+      </p:sp>
+      <p:sp>
+        <p:nvSpPr>
+          <p:cNvPr id="3121" name="Takeaway banner"/>
+          <p:cNvSpPr/>
+          <p:nvPr/>
+        </p:nvSpPr>
+        <p:spPr>
+          <a:xfrm>
+            <a:off x="950976" y="5440680"/>
+            <a:ext cx="10296144" cy="868680"/>
+          </a:xfrm>
+          <a:prstGeom prst="rect">
+            <a:avLst/>
+          </a:prstGeom>
+          <a:solidFill>
+            <a:schemeClr val="tx1">
+              <a:lumMod val="50000"/>
+              <a:lumOff val="50000"/>
+            </a:schemeClr>
+          </a:solidFill>
+          <a:ln>
+            <a:noFill/>
+          </a:ln>
+        </p:spPr>
+        <p:txBody>
+          <a:bodyPr wrap="square" lIns="91440" tIns="91440" rIns="91440" bIns="91440" rtlCol="0" anchor="ctr">
+            <a:noAutofit/>
+          </a:bodyPr>
+          <a:lstStyle/>
+          <a:p>
+            <a:pPr marL="0" indent="0" algn="ctr">
+              <a:lnSpc>
+                <a:spcPct val="100000"/>
+              </a:lnSpc>
+              <a:spcBef>
+                <a:spcPts val="0"/>
+              </a:spcBef>
+              <a:spcAft>
+                <a:spcPts val="0"/>
+              </a:spcAft>
+              <a:buNone/>
+            </a:pPr>
+            <a:r>
+              <a:rPr lang="en-US" sz="1800" b="1" dirty="0">
+                <a:solidFill>
+                  <a:schemeClr val="bg1"/>
+                </a:solidFill>
+                <a:latin typeface="Times New Roman" panose="02020603050405020304" pitchFamily="18" charset="0"/>
+                <a:cs typeface="Times New Roman" panose="02020603050405020304" pitchFamily="18" charset="0"/>
+              </a:rPr>
+              <a:t>Chinese demand supports Korean exports today, but competition could extend into higher-value chips. </a:t>
+            </a:r>
+            <a:r>
+              <a:rPr lang="en-US" sz="1800" b="1" i="1" dirty="0">
+                <a:solidFill>
+                  <a:schemeClr val="bg1"/>
+                </a:solidFill>
+                <a:latin typeface="Times New Roman" panose="02020603050405020304" pitchFamily="18" charset="0"/>
+                <a:cs typeface="Times New Roman" panose="02020603050405020304" pitchFamily="18" charset="0"/>
+              </a:rPr>
+              <a:t>Can Korea sustain its export strength as China shifts from customer to competitor?</a:t>
             </a:r>
           </a:p>
         </p:txBody>
@@ -32621,728 +33180,7 @@
       </p:grpSpPr>
       <p:sp>
         <p:nvSpPr>
-          <p:cNvPr id="3112" name="Title band"/>
-          <p:cNvSpPr/>
-          <p:nvPr/>
-        </p:nvSpPr>
-        <p:spPr>
-          <a:xfrm>
-            <a:off x="0" y="274320"/>
-            <a:ext cx="12191695" cy="960120"/>
-          </a:xfrm>
-          <a:prstGeom prst="rect">
-            <a:avLst/>
-          </a:prstGeom>
-          <a:solidFill>
-            <a:schemeClr val="accent2"/>
-          </a:solidFill>
-          <a:ln>
-            <a:noFill/>
-          </a:ln>
-        </p:spPr>
-        <p:txBody>
-          <a:bodyPr wrap="square" lIns="0" tIns="0" rIns="0" bIns="0" rtlCol="0" anchor="t">
-            <a:noAutofit/>
-          </a:bodyPr>
-          <a:lstStyle/>
-          <a:p>
-            <a:endParaRPr lang="en-US">
-              <a:latin typeface="Times New Roman" panose="02020603050405020304" pitchFamily="18" charset="0"/>
-              <a:cs typeface="Times New Roman" panose="02020603050405020304" pitchFamily="18" charset="0"/>
-            </a:endParaRPr>
-          </a:p>
-        </p:txBody>
-      </p:sp>
-      <p:sp>
-        <p:nvSpPr>
-          <p:cNvPr id="3113" name="Title"/>
-          <p:cNvSpPr txBox="1">
-            <a:spLocks noGrp="1"/>
-          </p:cNvSpPr>
-          <p:nvPr>
-            <p:ph type="title"/>
-          </p:nvPr>
-        </p:nvSpPr>
-        <p:spPr>
-          <a:xfrm>
-            <a:off x="950976" y="274320"/>
-            <a:ext cx="11149279" cy="960120"/>
-          </a:xfrm>
-        </p:spPr>
-        <p:txBody>
-          <a:bodyPr spcFirstLastPara="1" wrap="square" lIns="121900" tIns="121900" rIns="121900" bIns="121900" anchor="ctr" anchorCtr="0">
-            <a:noAutofit/>
-          </a:bodyPr>
-          <a:lstStyle/>
-          <a:p>
-            <a:pPr algn="l"/>
-            <a:r>
-              <a:rPr lang="en-US" sz="3600" b="1" dirty="0">
-                <a:solidFill>
-                  <a:schemeClr val="lt1"/>
-                </a:solidFill>
-                <a:latin typeface="Times New Roman" panose="02020603050405020304" pitchFamily="18" charset="0"/>
-                <a:cs typeface="Times New Roman" panose="02020603050405020304" pitchFamily="18" charset="0"/>
-              </a:rPr>
-              <a:t>Long-Term: Markets Fear China's Rise</a:t>
-            </a:r>
-          </a:p>
-        </p:txBody>
-      </p:sp>
-      <p:sp>
-        <p:nvSpPr>
-          <p:cNvPr id="3114" name="Most recent selloff (approx.) label"/>
-          <p:cNvSpPr txBox="1"/>
-          <p:nvPr/>
-        </p:nvSpPr>
-        <p:spPr>
-          <a:xfrm>
-            <a:off x="5943600" y="1600200"/>
-            <a:ext cx="5303520" cy="384048"/>
-          </a:xfrm>
-          <a:prstGeom prst="rect">
-            <a:avLst/>
-          </a:prstGeom>
-          <a:noFill/>
-          <a:ln>
-            <a:noFill/>
-          </a:ln>
-        </p:spPr>
-        <p:txBody>
-          <a:bodyPr wrap="square" lIns="0" tIns="0" rIns="0" bIns="0" rtlCol="0" anchor="t">
-            <a:noAutofit/>
-          </a:bodyPr>
-          <a:lstStyle/>
-          <a:p>
-            <a:pPr marL="0" indent="0" algn="l">
-              <a:lnSpc>
-                <a:spcPct val="100000"/>
-              </a:lnSpc>
-              <a:spcBef>
-                <a:spcPts val="0"/>
-              </a:spcBef>
-              <a:spcAft>
-                <a:spcPts val="0"/>
-              </a:spcAft>
-              <a:buNone/>
-            </a:pPr>
-            <a:r>
-              <a:rPr lang="en-US" sz="2000" b="1" dirty="0">
-                <a:solidFill>
-                  <a:schemeClr val="accent2"/>
-                </a:solidFill>
-                <a:latin typeface="Times New Roman" panose="02020603050405020304" pitchFamily="18" charset="0"/>
-                <a:cs typeface="Times New Roman" panose="02020603050405020304" pitchFamily="18" charset="0"/>
-              </a:rPr>
-              <a:t>Most recent selloff (approx.)</a:t>
-            </a:r>
-          </a:p>
-        </p:txBody>
-      </p:sp>
-      <p:sp>
-        <p:nvSpPr>
-          <p:cNvPr id="3115" name="Most recent selloff (approx.) 1 value"/>
-          <p:cNvSpPr txBox="1"/>
-          <p:nvPr/>
-        </p:nvSpPr>
-        <p:spPr>
-          <a:xfrm>
-            <a:off x="5943600" y="2011680"/>
-            <a:ext cx="1767840" cy="777240"/>
-          </a:xfrm>
-          <a:prstGeom prst="rect">
-            <a:avLst/>
-          </a:prstGeom>
-          <a:noFill/>
-          <a:ln>
-            <a:noFill/>
-          </a:ln>
-        </p:spPr>
-        <p:txBody>
-          <a:bodyPr wrap="square" lIns="0" tIns="0" rIns="0" bIns="0" rtlCol="0" anchor="ctr">
-            <a:noAutofit/>
-          </a:bodyPr>
-          <a:lstStyle/>
-          <a:p>
-            <a:pPr marL="0" indent="0" algn="l">
-              <a:lnSpc>
-                <a:spcPct val="100000"/>
-              </a:lnSpc>
-              <a:spcBef>
-                <a:spcPts val="0"/>
-              </a:spcBef>
-              <a:spcAft>
-                <a:spcPts val="0"/>
-              </a:spcAft>
-              <a:buNone/>
-            </a:pPr>
-            <a:r>
-              <a:rPr lang="en-US" sz="4400" b="1" dirty="0">
-                <a:solidFill>
-                  <a:schemeClr val="dk2"/>
-                </a:solidFill>
-                <a:latin typeface="Times New Roman" panose="02020603050405020304" pitchFamily="18" charset="0"/>
-                <a:cs typeface="Times New Roman" panose="02020603050405020304" pitchFamily="18" charset="0"/>
-              </a:rPr>
-              <a:t>−5.5%</a:t>
-            </a:r>
-          </a:p>
-        </p:txBody>
-      </p:sp>
-      <p:sp>
-        <p:nvSpPr>
-          <p:cNvPr id="3116" name="Most recent selloff (approx.) 1 name"/>
-          <p:cNvSpPr txBox="1"/>
-          <p:nvPr/>
-        </p:nvSpPr>
-        <p:spPr>
-          <a:xfrm>
-            <a:off x="5943600" y="2788920"/>
-            <a:ext cx="1767840" cy="365760"/>
-          </a:xfrm>
-          <a:prstGeom prst="rect">
-            <a:avLst/>
-          </a:prstGeom>
-          <a:noFill/>
-          <a:ln>
-            <a:noFill/>
-          </a:ln>
-        </p:spPr>
-        <p:txBody>
-          <a:bodyPr wrap="square" lIns="0" tIns="0" rIns="0" bIns="0" rtlCol="0" anchor="t">
-            <a:noAutofit/>
-          </a:bodyPr>
-          <a:lstStyle/>
-          <a:p>
-            <a:pPr marL="0" indent="0" algn="l">
-              <a:lnSpc>
-                <a:spcPct val="100000"/>
-              </a:lnSpc>
-              <a:spcBef>
-                <a:spcPts val="0"/>
-              </a:spcBef>
-              <a:spcAft>
-                <a:spcPts val="0"/>
-              </a:spcAft>
-              <a:buNone/>
-            </a:pPr>
-            <a:r>
-              <a:rPr lang="en-US" sz="2000" b="0" dirty="0">
-                <a:solidFill>
-                  <a:schemeClr val="dk1"/>
-                </a:solidFill>
-                <a:latin typeface="Times New Roman" panose="02020603050405020304" pitchFamily="18" charset="0"/>
-                <a:cs typeface="Times New Roman" panose="02020603050405020304" pitchFamily="18" charset="0"/>
-              </a:rPr>
-              <a:t>KOSPI</a:t>
-            </a:r>
-          </a:p>
-        </p:txBody>
-      </p:sp>
-      <p:sp>
-        <p:nvSpPr>
-          <p:cNvPr id="3117" name="Most recent selloff (approx.) 2 value"/>
-          <p:cNvSpPr txBox="1"/>
-          <p:nvPr/>
-        </p:nvSpPr>
-        <p:spPr>
-          <a:xfrm>
-            <a:off x="7711440" y="2011680"/>
-            <a:ext cx="1767840" cy="777240"/>
-          </a:xfrm>
-          <a:prstGeom prst="rect">
-            <a:avLst/>
-          </a:prstGeom>
-          <a:noFill/>
-          <a:ln>
-            <a:noFill/>
-          </a:ln>
-        </p:spPr>
-        <p:txBody>
-          <a:bodyPr wrap="square" lIns="0" tIns="0" rIns="0" bIns="0" rtlCol="0" anchor="ctr">
-            <a:noAutofit/>
-          </a:bodyPr>
-          <a:lstStyle/>
-          <a:p>
-            <a:pPr marL="0" indent="0" algn="l">
-              <a:lnSpc>
-                <a:spcPct val="100000"/>
-              </a:lnSpc>
-              <a:spcBef>
-                <a:spcPts val="0"/>
-              </a:spcBef>
-              <a:spcAft>
-                <a:spcPts val="0"/>
-              </a:spcAft>
-              <a:buNone/>
-            </a:pPr>
-            <a:r>
-              <a:rPr lang="en-US" sz="4400" b="1" dirty="0">
-                <a:solidFill>
-                  <a:schemeClr val="dk2"/>
-                </a:solidFill>
-                <a:latin typeface="Times New Roman" panose="02020603050405020304" pitchFamily="18" charset="0"/>
-                <a:cs typeface="Times New Roman" panose="02020603050405020304" pitchFamily="18" charset="0"/>
-              </a:rPr>
-              <a:t>−7%</a:t>
-            </a:r>
-          </a:p>
-        </p:txBody>
-      </p:sp>
-      <p:sp>
-        <p:nvSpPr>
-          <p:cNvPr id="3118" name="Most recent selloff (approx.) 2 name"/>
-          <p:cNvSpPr txBox="1"/>
-          <p:nvPr/>
-        </p:nvSpPr>
-        <p:spPr>
-          <a:xfrm>
-            <a:off x="7711440" y="2788920"/>
-            <a:ext cx="1767840" cy="365760"/>
-          </a:xfrm>
-          <a:prstGeom prst="rect">
-            <a:avLst/>
-          </a:prstGeom>
-          <a:noFill/>
-          <a:ln>
-            <a:noFill/>
-          </a:ln>
-        </p:spPr>
-        <p:txBody>
-          <a:bodyPr wrap="square" lIns="0" tIns="0" rIns="0" bIns="0" rtlCol="0" anchor="t">
-            <a:noAutofit/>
-          </a:bodyPr>
-          <a:lstStyle/>
-          <a:p>
-            <a:pPr marL="0" indent="0" algn="l">
-              <a:lnSpc>
-                <a:spcPct val="100000"/>
-              </a:lnSpc>
-              <a:spcBef>
-                <a:spcPts val="0"/>
-              </a:spcBef>
-              <a:spcAft>
-                <a:spcPts val="0"/>
-              </a:spcAft>
-              <a:buNone/>
-            </a:pPr>
-            <a:r>
-              <a:rPr lang="en-US" sz="2000" b="0" dirty="0">
-                <a:solidFill>
-                  <a:schemeClr val="dk1"/>
-                </a:solidFill>
-                <a:latin typeface="Times New Roman" panose="02020603050405020304" pitchFamily="18" charset="0"/>
-                <a:cs typeface="Times New Roman" panose="02020603050405020304" pitchFamily="18" charset="0"/>
-              </a:rPr>
-              <a:t>Samsung</a:t>
-            </a:r>
-          </a:p>
-        </p:txBody>
-      </p:sp>
-      <p:sp>
-        <p:nvSpPr>
-          <p:cNvPr id="3119" name="Most recent selloff (approx.) 3 value"/>
-          <p:cNvSpPr txBox="1"/>
-          <p:nvPr/>
-        </p:nvSpPr>
-        <p:spPr>
-          <a:xfrm>
-            <a:off x="9479280" y="2011680"/>
-            <a:ext cx="1767840" cy="777240"/>
-          </a:xfrm>
-          <a:prstGeom prst="rect">
-            <a:avLst/>
-          </a:prstGeom>
-          <a:noFill/>
-          <a:ln>
-            <a:noFill/>
-          </a:ln>
-        </p:spPr>
-        <p:txBody>
-          <a:bodyPr wrap="square" lIns="0" tIns="0" rIns="0" bIns="0" rtlCol="0" anchor="ctr">
-            <a:noAutofit/>
-          </a:bodyPr>
-          <a:lstStyle/>
-          <a:p>
-            <a:pPr marL="0" indent="0" algn="l">
-              <a:lnSpc>
-                <a:spcPct val="100000"/>
-              </a:lnSpc>
-              <a:spcBef>
-                <a:spcPts val="0"/>
-              </a:spcBef>
-              <a:spcAft>
-                <a:spcPts val="0"/>
-              </a:spcAft>
-              <a:buNone/>
-            </a:pPr>
-            <a:r>
-              <a:rPr lang="en-US" sz="4400" b="1" dirty="0">
-                <a:solidFill>
-                  <a:schemeClr val="dk2"/>
-                </a:solidFill>
-                <a:latin typeface="Times New Roman" panose="02020603050405020304" pitchFamily="18" charset="0"/>
-                <a:cs typeface="Times New Roman" panose="02020603050405020304" pitchFamily="18" charset="0"/>
-              </a:rPr>
-              <a:t>−10%</a:t>
-            </a:r>
-          </a:p>
-        </p:txBody>
-      </p:sp>
-      <p:sp>
-        <p:nvSpPr>
-          <p:cNvPr id="3120" name="Most recent selloff (approx.) 3 name"/>
-          <p:cNvSpPr txBox="1"/>
-          <p:nvPr/>
-        </p:nvSpPr>
-        <p:spPr>
-          <a:xfrm>
-            <a:off x="9479280" y="2788920"/>
-            <a:ext cx="1767840" cy="365760"/>
-          </a:xfrm>
-          <a:prstGeom prst="rect">
-            <a:avLst/>
-          </a:prstGeom>
-          <a:noFill/>
-          <a:ln>
-            <a:noFill/>
-          </a:ln>
-        </p:spPr>
-        <p:txBody>
-          <a:bodyPr wrap="square" lIns="0" tIns="0" rIns="0" bIns="0" rtlCol="0" anchor="t">
-            <a:noAutofit/>
-          </a:bodyPr>
-          <a:lstStyle/>
-          <a:p>
-            <a:pPr marL="0" indent="0" algn="l">
-              <a:lnSpc>
-                <a:spcPct val="100000"/>
-              </a:lnSpc>
-              <a:spcBef>
-                <a:spcPts val="0"/>
-              </a:spcBef>
-              <a:spcAft>
-                <a:spcPts val="0"/>
-              </a:spcAft>
-              <a:buNone/>
-            </a:pPr>
-            <a:r>
-              <a:rPr lang="en-US" sz="2000" b="0" dirty="0">
-                <a:solidFill>
-                  <a:schemeClr val="dk1"/>
-                </a:solidFill>
-                <a:latin typeface="Times New Roman" panose="02020603050405020304" pitchFamily="18" charset="0"/>
-                <a:cs typeface="Times New Roman" panose="02020603050405020304" pitchFamily="18" charset="0"/>
-              </a:rPr>
-              <a:t>SK Hynix</a:t>
-            </a:r>
-          </a:p>
-        </p:txBody>
-      </p:sp>
-      <p:cxnSp>
-        <p:nvCxnSpPr>
-          <p:cNvPr id="3121" name="Selloff rule"/>
-          <p:cNvCxnSpPr/>
-          <p:nvPr/>
-        </p:nvCxnSpPr>
-        <p:spPr>
-          <a:xfrm>
-            <a:off x="5943600" y="3310128"/>
-            <a:ext cx="5303520" cy="0"/>
-          </a:xfrm>
-          <a:prstGeom prst="straightConnector1">
-            <a:avLst/>
-          </a:prstGeom>
-          <a:ln w="9525">
-            <a:solidFill>
-              <a:schemeClr val="accent4"/>
-            </a:solidFill>
-          </a:ln>
-        </p:spPr>
-      </p:cxnSp>
-      <p:sp>
-        <p:nvSpPr>
-          <p:cNvPr id="3122" name="July selloff label"/>
-          <p:cNvSpPr txBox="1"/>
-          <p:nvPr/>
-        </p:nvSpPr>
-        <p:spPr>
-          <a:xfrm>
-            <a:off x="5943600" y="3429000"/>
-            <a:ext cx="5303520" cy="384048"/>
-          </a:xfrm>
-          <a:prstGeom prst="rect">
-            <a:avLst/>
-          </a:prstGeom>
-          <a:noFill/>
-          <a:ln>
-            <a:noFill/>
-          </a:ln>
-        </p:spPr>
-        <p:txBody>
-          <a:bodyPr wrap="square" lIns="0" tIns="0" rIns="0" bIns="0" rtlCol="0" anchor="t">
-            <a:noAutofit/>
-          </a:bodyPr>
-          <a:lstStyle/>
-          <a:p>
-            <a:pPr marL="0" indent="0" algn="l">
-              <a:lnSpc>
-                <a:spcPct val="100000"/>
-              </a:lnSpc>
-              <a:spcBef>
-                <a:spcPts val="0"/>
-              </a:spcBef>
-              <a:spcAft>
-                <a:spcPts val="0"/>
-              </a:spcAft>
-              <a:buNone/>
-            </a:pPr>
-            <a:r>
-              <a:rPr lang="en-US" sz="2000" b="1" dirty="0">
-                <a:solidFill>
-                  <a:schemeClr val="accent2"/>
-                </a:solidFill>
-                <a:latin typeface="Times New Roman" panose="02020603050405020304" pitchFamily="18" charset="0"/>
-                <a:cs typeface="Times New Roman" panose="02020603050405020304" pitchFamily="18" charset="0"/>
-              </a:rPr>
-              <a:t>July selloff</a:t>
-            </a:r>
-          </a:p>
-        </p:txBody>
-      </p:sp>
-      <p:sp>
-        <p:nvSpPr>
-          <p:cNvPr id="3123" name="July selloff 1 value"/>
-          <p:cNvSpPr txBox="1"/>
-          <p:nvPr/>
-        </p:nvSpPr>
-        <p:spPr>
-          <a:xfrm>
-            <a:off x="5943600" y="3840480"/>
-            <a:ext cx="1767840" cy="777240"/>
-          </a:xfrm>
-          <a:prstGeom prst="rect">
-            <a:avLst/>
-          </a:prstGeom>
-          <a:noFill/>
-          <a:ln>
-            <a:noFill/>
-          </a:ln>
-        </p:spPr>
-        <p:txBody>
-          <a:bodyPr wrap="square" lIns="0" tIns="0" rIns="0" bIns="0" rtlCol="0" anchor="ctr">
-            <a:noAutofit/>
-          </a:bodyPr>
-          <a:lstStyle/>
-          <a:p>
-            <a:pPr marL="0" indent="0" algn="l">
-              <a:lnSpc>
-                <a:spcPct val="100000"/>
-              </a:lnSpc>
-              <a:spcBef>
-                <a:spcPts val="0"/>
-              </a:spcBef>
-              <a:spcAft>
-                <a:spcPts val="0"/>
-              </a:spcAft>
-              <a:buNone/>
-            </a:pPr>
-            <a:r>
-              <a:rPr lang="en-US" sz="4400" b="1" dirty="0">
-                <a:solidFill>
-                  <a:schemeClr val="dk2"/>
-                </a:solidFill>
-                <a:latin typeface="Times New Roman" panose="02020603050405020304" pitchFamily="18" charset="0"/>
-                <a:cs typeface="Times New Roman" panose="02020603050405020304" pitchFamily="18" charset="0"/>
-              </a:rPr>
-              <a:t>−11%</a:t>
-            </a:r>
-          </a:p>
-        </p:txBody>
-      </p:sp>
-      <p:sp>
-        <p:nvSpPr>
-          <p:cNvPr id="3124" name="July selloff 1 name"/>
-          <p:cNvSpPr txBox="1"/>
-          <p:nvPr/>
-        </p:nvSpPr>
-        <p:spPr>
-          <a:xfrm>
-            <a:off x="5943600" y="4617720"/>
-            <a:ext cx="1767840" cy="365760"/>
-          </a:xfrm>
-          <a:prstGeom prst="rect">
-            <a:avLst/>
-          </a:prstGeom>
-          <a:noFill/>
-          <a:ln>
-            <a:noFill/>
-          </a:ln>
-        </p:spPr>
-        <p:txBody>
-          <a:bodyPr wrap="square" lIns="0" tIns="0" rIns="0" bIns="0" rtlCol="0" anchor="t">
-            <a:noAutofit/>
-          </a:bodyPr>
-          <a:lstStyle/>
-          <a:p>
-            <a:pPr marL="0" indent="0" algn="l">
-              <a:lnSpc>
-                <a:spcPct val="100000"/>
-              </a:lnSpc>
-              <a:spcBef>
-                <a:spcPts val="0"/>
-              </a:spcBef>
-              <a:spcAft>
-                <a:spcPts val="0"/>
-              </a:spcAft>
-              <a:buNone/>
-            </a:pPr>
-            <a:r>
-              <a:rPr lang="en-US" sz="2000" b="0" dirty="0">
-                <a:solidFill>
-                  <a:schemeClr val="dk1"/>
-                </a:solidFill>
-                <a:latin typeface="Times New Roman" panose="02020603050405020304" pitchFamily="18" charset="0"/>
-                <a:cs typeface="Times New Roman" panose="02020603050405020304" pitchFamily="18" charset="0"/>
-              </a:rPr>
-              <a:t>KOSPI (nearly)</a:t>
-            </a:r>
-          </a:p>
-        </p:txBody>
-      </p:sp>
-      <p:sp>
-        <p:nvSpPr>
-          <p:cNvPr id="3125" name="Selloff note"/>
-          <p:cNvSpPr txBox="1"/>
-          <p:nvPr/>
-        </p:nvSpPr>
-        <p:spPr>
-          <a:xfrm>
-            <a:off x="7802880" y="3931920"/>
-            <a:ext cx="3444240" cy="1097280"/>
-          </a:xfrm>
-          <a:prstGeom prst="rect">
-            <a:avLst/>
-          </a:prstGeom>
-          <a:noFill/>
-          <a:ln>
-            <a:noFill/>
-          </a:ln>
-        </p:spPr>
-        <p:txBody>
-          <a:bodyPr wrap="square" lIns="0" tIns="0" rIns="0" bIns="0" rtlCol="0" anchor="ctr">
-            <a:noAutofit/>
-          </a:bodyPr>
-          <a:lstStyle/>
-          <a:p>
-            <a:pPr marL="0" indent="0" algn="l">
-              <a:lnSpc>
-                <a:spcPct val="100000"/>
-              </a:lnSpc>
-              <a:spcBef>
-                <a:spcPts val="0"/>
-              </a:spcBef>
-              <a:spcAft>
-                <a:spcPts val="0"/>
-              </a:spcAft>
-              <a:buNone/>
-            </a:pPr>
-            <a:r>
-              <a:rPr lang="en-US" sz="1800" b="0" i="1" dirty="0">
-                <a:solidFill>
-                  <a:schemeClr val="accent3"/>
-                </a:solidFill>
-                <a:latin typeface="Times New Roman" panose="02020603050405020304" pitchFamily="18" charset="0"/>
-                <a:cs typeface="Times New Roman" panose="02020603050405020304" pitchFamily="18" charset="0"/>
-              </a:rPr>
-              <a:t>CXMT's progress fuels fears that more chip supply will squeeze Korean prices and profits</a:t>
-            </a:r>
-          </a:p>
-        </p:txBody>
-      </p:sp>
-      <p:sp>
-        <p:nvSpPr>
-          <p:cNvPr id="3126" name="Takeaway banner"/>
-          <p:cNvSpPr/>
-          <p:nvPr/>
-        </p:nvSpPr>
-        <p:spPr>
-          <a:xfrm>
-            <a:off x="950976" y="5486400"/>
-            <a:ext cx="9473184" cy="685800"/>
-          </a:xfrm>
-          <a:prstGeom prst="rect">
-            <a:avLst/>
-          </a:prstGeom>
-          <a:solidFill>
-            <a:schemeClr val="tx1">
-              <a:lumMod val="50000"/>
-              <a:lumOff val="50000"/>
-            </a:schemeClr>
-          </a:solidFill>
-          <a:ln>
-            <a:noFill/>
-          </a:ln>
-        </p:spPr>
-        <p:txBody>
-          <a:bodyPr wrap="square" lIns="91440" tIns="91440" rIns="91440" bIns="91440" rtlCol="0" anchor="ctr">
-            <a:noAutofit/>
-          </a:bodyPr>
-          <a:lstStyle/>
-          <a:p>
-            <a:pPr marL="0" indent="0" algn="ctr">
-              <a:lnSpc>
-                <a:spcPct val="100000"/>
-              </a:lnSpc>
-              <a:spcBef>
-                <a:spcPts val="0"/>
-              </a:spcBef>
-              <a:spcAft>
-                <a:spcPts val="0"/>
-              </a:spcAft>
-              <a:buNone/>
-            </a:pPr>
-            <a:r>
-              <a:rPr lang="en-US" sz="2000" b="1" i="1" dirty="0">
-                <a:solidFill>
-                  <a:schemeClr val="bg1"/>
-                </a:solidFill>
-                <a:latin typeface="Times New Roman" panose="02020603050405020304" pitchFamily="18" charset="0"/>
-                <a:cs typeface="Times New Roman" panose="02020603050405020304" pitchFamily="18" charset="0"/>
-              </a:rPr>
-              <a:t>Can Korea sustain its export strength as China shifts from customer to competitor?</a:t>
-            </a:r>
-          </a:p>
-        </p:txBody>
-      </p:sp>
-    </p:spTree>
-  </p:cSld>
-  <p:clrMapOvr>
-    <a:masterClrMapping/>
-  </p:clrMapOvr>
-</p:sld>
-</file>
-
-<file path=ppt/slides/slide8.xml><?xml version="1.0" encoding="utf-8"?>
-<p:sld xmlns:a="http://schemas.openxmlformats.org/drawingml/2006/main" xmlns:r="http://schemas.openxmlformats.org/officeDocument/2006/relationships" xmlns:p="http://schemas.openxmlformats.org/presentationml/2006/main">
-  <p:cSld>
-    <p:spTree>
-      <p:nvGrpSpPr>
-        <p:cNvPr id="1" name=""/>
-        <p:cNvGrpSpPr/>
-        <p:nvPr/>
-      </p:nvGrpSpPr>
-      <p:grpSpPr>
-        <a:xfrm>
-          <a:off x="0" y="0"/>
-          <a:ext cx="0" cy="0"/>
-          <a:chOff x="0" y="0"/>
-          <a:chExt cx="0" cy="0"/>
-        </a:xfrm>
-      </p:grpSpPr>
-      <p:sp>
-        <p:nvSpPr>
-          <p:cNvPr id="3127" name="Title band"/>
+          <p:cNvPr id="3122" name="Title band"/>
           <p:cNvSpPr/>
           <p:nvPr/>
         </p:nvSpPr>
@@ -33376,7 +33214,7 @@
       </p:sp>
       <p:sp>
         <p:nvSpPr>
-          <p:cNvPr id="3128" name="Title"/>
+          <p:cNvPr id="3123" name="Title"/>
           <p:cNvSpPr txBox="1">
             <a:spLocks noGrp="1"/>
           </p:cNvSpPr>
@@ -33412,7 +33250,7 @@
       </p:sp>
       <p:sp>
         <p:nvSpPr>
-          <p:cNvPr id="3129" name="Column 1 header"/>
+          <p:cNvPr id="3124" name="Column 1 header"/>
           <p:cNvSpPr/>
           <p:nvPr/>
         </p:nvSpPr>
@@ -33488,7 +33326,7 @@
       </p:sp>
       <p:sp>
         <p:nvSpPr>
-          <p:cNvPr id="3130" name="Column 1 marker 1"/>
+          <p:cNvPr id="3125" name="Column 1 marker 1"/>
           <p:cNvSpPr/>
           <p:nvPr/>
         </p:nvSpPr>
@@ -33519,7 +33357,7 @@
       </p:sp>
       <p:sp>
         <p:nvSpPr>
-          <p:cNvPr id="3131" name="Column 1 point 1"/>
+          <p:cNvPr id="3126" name="Column 1 point 1"/>
           <p:cNvSpPr txBox="1"/>
           <p:nvPr/>
         </p:nvSpPr>
@@ -33579,7 +33417,7 @@
       </p:sp>
       <p:sp>
         <p:nvSpPr>
-          <p:cNvPr id="3132" name="Column 1 marker 2"/>
+          <p:cNvPr id="3127" name="Column 1 marker 2"/>
           <p:cNvSpPr/>
           <p:nvPr/>
         </p:nvSpPr>
@@ -33610,7 +33448,7 @@
       </p:sp>
       <p:sp>
         <p:nvSpPr>
-          <p:cNvPr id="3133" name="Column 1 point 2"/>
+          <p:cNvPr id="3128" name="Column 1 point 2"/>
           <p:cNvSpPr txBox="1"/>
           <p:nvPr/>
         </p:nvSpPr>
@@ -33660,7 +33498,7 @@
       </p:sp>
       <p:sp>
         <p:nvSpPr>
-          <p:cNvPr id="3134" name="Column 1 marker 3"/>
+          <p:cNvPr id="3129" name="Column 1 marker 3"/>
           <p:cNvSpPr/>
           <p:nvPr/>
         </p:nvSpPr>
@@ -33691,7 +33529,7 @@
       </p:sp>
       <p:sp>
         <p:nvSpPr>
-          <p:cNvPr id="3135" name="Column 1 point 3"/>
+          <p:cNvPr id="3130" name="Column 1 point 3"/>
           <p:cNvSpPr txBox="1"/>
           <p:nvPr/>
         </p:nvSpPr>
@@ -33751,7 +33589,7 @@
       </p:sp>
       <p:sp>
         <p:nvSpPr>
-          <p:cNvPr id="3136" name="Column 2 header"/>
+          <p:cNvPr id="3131" name="Column 2 header"/>
           <p:cNvSpPr/>
           <p:nvPr/>
         </p:nvSpPr>
@@ -33827,7 +33665,7 @@
       </p:sp>
       <p:sp>
         <p:nvSpPr>
-          <p:cNvPr id="3137" name="Column 2 marker 1"/>
+          <p:cNvPr id="3132" name="Column 2 marker 1"/>
           <p:cNvSpPr/>
           <p:nvPr/>
         </p:nvSpPr>
@@ -33858,7 +33696,7 @@
       </p:sp>
       <p:sp>
         <p:nvSpPr>
-          <p:cNvPr id="3138" name="Column 2 point 1"/>
+          <p:cNvPr id="3133" name="Column 2 point 1"/>
           <p:cNvSpPr txBox="1"/>
           <p:nvPr/>
         </p:nvSpPr>
@@ -33908,7 +33746,7 @@
       </p:sp>
       <p:sp>
         <p:nvSpPr>
-          <p:cNvPr id="3139" name="Column 2 marker 2"/>
+          <p:cNvPr id="3134" name="Column 2 marker 2"/>
           <p:cNvSpPr/>
           <p:nvPr/>
         </p:nvSpPr>
@@ -33939,7 +33777,7 @@
       </p:sp>
       <p:sp>
         <p:nvSpPr>
-          <p:cNvPr id="3140" name="Column 2 point 2"/>
+          <p:cNvPr id="3135" name="Column 2 point 2"/>
           <p:cNvSpPr txBox="1"/>
           <p:nvPr/>
         </p:nvSpPr>
@@ -33989,7 +33827,7 @@
       </p:sp>
       <p:sp>
         <p:nvSpPr>
-          <p:cNvPr id="3141" name="Column 2 marker 3"/>
+          <p:cNvPr id="3136" name="Column 2 marker 3"/>
           <p:cNvSpPr/>
           <p:nvPr/>
         </p:nvSpPr>
@@ -34020,7 +33858,7 @@
       </p:sp>
       <p:sp>
         <p:nvSpPr>
-          <p:cNvPr id="3142" name="Column 2 point 3"/>
+          <p:cNvPr id="3137" name="Column 2 point 3"/>
           <p:cNvSpPr txBox="1"/>
           <p:nvPr/>
         </p:nvSpPr>
@@ -34080,7 +33918,7 @@
       </p:sp>
       <p:sp>
         <p:nvSpPr>
-          <p:cNvPr id="3143" name="Takeaway banner"/>
+          <p:cNvPr id="3138" name="Takeaway banner"/>
           <p:cNvSpPr/>
           <p:nvPr/>
         </p:nvSpPr>

</xml_diff>

<commit_message>
Add final slide 8: Future Outlooks
Co-Authored-By: Claude Opus 5.5 <noreply@anthropic.com>
Claude-Session: https://claude.ai/code/session_01EAqNWxuCBt8vBHk7fm7zMv
</commit_message>
<xml_diff>
--- a/korea-china-trade.pptx
+++ b/korea-china-trade.pptx
@@ -16,6 +16,7 @@
     <p:sldId id="286" r:id="rId7"/>
     <p:sldId id="287" r:id="rId29"/>
     <p:sldId id="288" r:id="rId30"/>
+    <p:sldId id="289" r:id="rId31"/>
   </p:sldIdLst>
   <p:sldSz cx="12192000" cy="6858000"/>
   <p:notesSz cx="6858000" cy="9144000"/>
@@ -33979,6 +33980,559 @@
 </p:sld>
 </file>
 
+<file path=ppt/slides/slide8.xml><?xml version="1.0" encoding="utf-8"?>
+<p:sld xmlns:a="http://schemas.openxmlformats.org/drawingml/2006/main" xmlns:r="http://schemas.openxmlformats.org/officeDocument/2006/relationships" xmlns:p="http://schemas.openxmlformats.org/presentationml/2006/main">
+  <p:cSld>
+    <p:spTree>
+      <p:nvGrpSpPr>
+        <p:cNvPr id="1" name=""/>
+        <p:cNvGrpSpPr/>
+        <p:nvPr/>
+      </p:nvGrpSpPr>
+      <p:grpSpPr>
+        <a:xfrm>
+          <a:off x="0" y="0"/>
+          <a:ext cx="0" cy="0"/>
+          <a:chOff x="0" y="0"/>
+          <a:chExt cx="0" cy="0"/>
+        </a:xfrm>
+      </p:grpSpPr>
+      <p:sp>
+        <p:nvSpPr>
+          <p:cNvPr id="3101" name="Title band"/>
+          <p:cNvSpPr/>
+          <p:nvPr/>
+        </p:nvSpPr>
+        <p:spPr>
+          <a:xfrm>
+            <a:off x="0" y="274320"/>
+            <a:ext cx="11338560" cy="960120"/>
+          </a:xfrm>
+          <a:prstGeom prst="rect">
+            <a:avLst/>
+          </a:prstGeom>
+          <a:solidFill>
+            <a:schemeClr val="accent2"/>
+          </a:solidFill>
+          <a:ln>
+            <a:noFill/>
+          </a:ln>
+        </p:spPr>
+        <p:txBody>
+          <a:bodyPr wrap="square" lIns="0" tIns="0" rIns="0" bIns="0" rtlCol="0" anchor="t">
+            <a:noAutofit/>
+          </a:bodyPr>
+          <a:lstStyle/>
+          <a:p>
+            <a:endParaRPr lang="en-US">
+              <a:latin typeface="Times New Roman" panose="02020603050405020304" pitchFamily="18" charset="0"/>
+              <a:cs typeface="Times New Roman" panose="02020603050405020304" pitchFamily="18" charset="0"/>
+            </a:endParaRPr>
+          </a:p>
+        </p:txBody>
+      </p:sp>
+      <p:sp>
+        <p:nvSpPr>
+          <p:cNvPr id="3102" name="Title"/>
+          <p:cNvSpPr txBox="1">
+            <a:spLocks noGrp="1"/>
+          </p:cNvSpPr>
+          <p:nvPr>
+            <p:ph type="title"/>
+          </p:nvPr>
+        </p:nvSpPr>
+        <p:spPr>
+          <a:xfrm>
+            <a:off x="950976" y="274320"/>
+            <a:ext cx="10296144" cy="960120"/>
+          </a:xfrm>
+        </p:spPr>
+        <p:txBody>
+          <a:bodyPr spcFirstLastPara="1" wrap="square" lIns="121900" tIns="121900" rIns="121900" bIns="121900" anchor="ctr" anchorCtr="0">
+            <a:noAutofit/>
+          </a:bodyPr>
+          <a:lstStyle/>
+          <a:p>
+            <a:pPr algn="l"/>
+            <a:r>
+              <a:rPr lang="en-US" sz="3600" b="1" dirty="0">
+                <a:solidFill>
+                  <a:schemeClr val="lt1"/>
+                </a:solidFill>
+                <a:latin typeface="Times New Roman" panose="02020603050405020304" pitchFamily="18" charset="0"/>
+                <a:cs typeface="Times New Roman" panose="02020603050405020304" pitchFamily="18" charset="0"/>
+              </a:rPr>
+              <a:t>Future Outlooks</a:t>
+            </a:r>
+          </a:p>
+        </p:txBody>
+      </p:sp>
+      <p:sp>
+        <p:nvSpPr>
+          <p:cNvPr id="3103" name="Question 1 number"/>
+          <p:cNvSpPr/>
+          <p:nvPr/>
+        </p:nvSpPr>
+        <p:spPr>
+          <a:xfrm>
+            <a:off x="950976" y="1536192"/>
+            <a:ext cx="1188720" cy="1188720"/>
+          </a:xfrm>
+          <a:prstGeom prst="rect">
+            <a:avLst/>
+          </a:prstGeom>
+          <a:solidFill>
+            <a:schemeClr val="dk2"/>
+          </a:solidFill>
+          <a:ln>
+            <a:noFill/>
+          </a:ln>
+        </p:spPr>
+        <p:txBody>
+          <a:bodyPr wrap="square" lIns="0" tIns="0" rIns="0" bIns="0" rtlCol="0" anchor="ctr">
+            <a:noAutofit/>
+          </a:bodyPr>
+          <a:lstStyle/>
+          <a:p>
+            <a:pPr marL="0" indent="0" algn="ctr">
+              <a:lnSpc>
+                <a:spcPct val="100000"/>
+              </a:lnSpc>
+              <a:spcBef>
+                <a:spcPts val="0"/>
+              </a:spcBef>
+              <a:spcAft>
+                <a:spcPts val="0"/>
+              </a:spcAft>
+              <a:buNone/>
+            </a:pPr>
+            <a:r>
+              <a:rPr lang="en-US" sz="3600" b="1" dirty="0">
+                <a:solidFill>
+                  <a:schemeClr val="bg1"/>
+                </a:solidFill>
+                <a:latin typeface="Times New Roman" panose="02020603050405020304" pitchFamily="18" charset="0"/>
+                <a:cs typeface="Times New Roman" panose="02020603050405020304" pitchFamily="18" charset="0"/>
+              </a:rPr>
+              <a:t>01</a:t>
+            </a:r>
+          </a:p>
+        </p:txBody>
+      </p:sp>
+      <p:sp>
+        <p:nvSpPr>
+          <p:cNvPr id="3104" name="Question 1 card"/>
+          <p:cNvSpPr/>
+          <p:nvPr/>
+        </p:nvSpPr>
+        <p:spPr>
+          <a:xfrm>
+            <a:off x="2322576" y="1536192"/>
+            <a:ext cx="8924544" cy="1188720"/>
+          </a:xfrm>
+          <a:prstGeom prst="rect">
+            <a:avLst/>
+          </a:prstGeom>
+          <a:solidFill>
+            <a:schemeClr val="accent4">
+              <a:lumMod val="20000"/>
+              <a:lumOff val="80000"/>
+            </a:schemeClr>
+          </a:solidFill>
+          <a:ln>
+            <a:noFill/>
+          </a:ln>
+        </p:spPr>
+        <p:txBody>
+          <a:bodyPr wrap="square" lIns="164592" tIns="164592" rIns="164592" bIns="164592" rtlCol="0" anchor="ctr">
+            <a:noAutofit/>
+          </a:bodyPr>
+          <a:lstStyle/>
+          <a:p>
+            <a:pPr marL="0" indent="0" algn="l">
+              <a:lnSpc>
+                <a:spcPct val="100000"/>
+              </a:lnSpc>
+              <a:spcBef>
+                <a:spcPts val="0"/>
+              </a:spcBef>
+              <a:spcAft>
+                <a:spcPts val="200"/>
+              </a:spcAft>
+              <a:buNone/>
+            </a:pPr>
+            <a:r>
+              <a:rPr lang="en-US" sz="2200" b="1" dirty="0">
+                <a:solidFill>
+                  <a:schemeClr val="accent2"/>
+                </a:solidFill>
+                <a:latin typeface="Times New Roman" panose="02020603050405020304" pitchFamily="18" charset="0"/>
+                <a:cs typeface="Times New Roman" panose="02020603050405020304" pitchFamily="18" charset="0"/>
+              </a:rPr>
+              <a:t>Could China overtake Korea?</a:t>
+            </a:r>
+          </a:p>
+          <a:p>
+            <a:pPr marL="0" indent="0" algn="l">
+              <a:lnSpc>
+                <a:spcPct val="100000"/>
+              </a:lnSpc>
+              <a:spcBef>
+                <a:spcPts val="0"/>
+              </a:spcBef>
+              <a:spcAft>
+                <a:spcPts val="0"/>
+              </a:spcAft>
+              <a:buNone/>
+            </a:pPr>
+            <a:r>
+              <a:rPr lang="en-US" sz="2000" b="0" dirty="0">
+                <a:solidFill>
+                  <a:schemeClr val="dk1"/>
+                </a:solidFill>
+                <a:latin typeface="Times New Roman" panose="02020603050405020304" pitchFamily="18" charset="0"/>
+                <a:cs typeface="Times New Roman" panose="02020603050405020304" pitchFamily="18" charset="0"/>
+              </a:rPr>
+              <a:t>China is advancing fast. Samsung and SK Hynix lead in advanced memory chips, but that lead cannot be taken for granted.</a:t>
+            </a:r>
+          </a:p>
+        </p:txBody>
+      </p:sp>
+      <p:sp>
+        <p:nvSpPr>
+          <p:cNvPr id="3105" name="Question 2 number"/>
+          <p:cNvSpPr/>
+          <p:nvPr/>
+        </p:nvSpPr>
+        <p:spPr>
+          <a:xfrm>
+            <a:off x="950976" y="2834640"/>
+            <a:ext cx="1188720" cy="1188720"/>
+          </a:xfrm>
+          <a:prstGeom prst="rect">
+            <a:avLst/>
+          </a:prstGeom>
+          <a:solidFill>
+            <a:schemeClr val="dk2"/>
+          </a:solidFill>
+          <a:ln>
+            <a:noFill/>
+          </a:ln>
+        </p:spPr>
+        <p:txBody>
+          <a:bodyPr wrap="square" lIns="0" tIns="0" rIns="0" bIns="0" rtlCol="0" anchor="ctr">
+            <a:noAutofit/>
+          </a:bodyPr>
+          <a:lstStyle/>
+          <a:p>
+            <a:pPr marL="0" indent="0" algn="ctr">
+              <a:lnSpc>
+                <a:spcPct val="100000"/>
+              </a:lnSpc>
+              <a:spcBef>
+                <a:spcPts val="0"/>
+              </a:spcBef>
+              <a:spcAft>
+                <a:spcPts val="0"/>
+              </a:spcAft>
+              <a:buNone/>
+            </a:pPr>
+            <a:r>
+              <a:rPr lang="en-US" sz="3600" b="1" dirty="0">
+                <a:solidFill>
+                  <a:schemeClr val="bg1"/>
+                </a:solidFill>
+                <a:latin typeface="Times New Roman" panose="02020603050405020304" pitchFamily="18" charset="0"/>
+                <a:cs typeface="Times New Roman" panose="02020603050405020304" pitchFamily="18" charset="0"/>
+              </a:rPr>
+              <a:t>02</a:t>
+            </a:r>
+          </a:p>
+        </p:txBody>
+      </p:sp>
+      <p:sp>
+        <p:nvSpPr>
+          <p:cNvPr id="3106" name="Question 2 card"/>
+          <p:cNvSpPr/>
+          <p:nvPr/>
+        </p:nvSpPr>
+        <p:spPr>
+          <a:xfrm>
+            <a:off x="2322576" y="2834640"/>
+            <a:ext cx="8924544" cy="1188720"/>
+          </a:xfrm>
+          <a:prstGeom prst="rect">
+            <a:avLst/>
+          </a:prstGeom>
+          <a:solidFill>
+            <a:schemeClr val="accent4">
+              <a:lumMod val="20000"/>
+              <a:lumOff val="80000"/>
+            </a:schemeClr>
+          </a:solidFill>
+          <a:ln>
+            <a:noFill/>
+          </a:ln>
+        </p:spPr>
+        <p:txBody>
+          <a:bodyPr wrap="square" lIns="164592" tIns="164592" rIns="164592" bIns="164592" rtlCol="0" anchor="ctr">
+            <a:noAutofit/>
+          </a:bodyPr>
+          <a:lstStyle/>
+          <a:p>
+            <a:pPr marL="0" indent="0" algn="l">
+              <a:lnSpc>
+                <a:spcPct val="100000"/>
+              </a:lnSpc>
+              <a:spcBef>
+                <a:spcPts val="0"/>
+              </a:spcBef>
+              <a:spcAft>
+                <a:spcPts val="200"/>
+              </a:spcAft>
+              <a:buNone/>
+            </a:pPr>
+            <a:r>
+              <a:rPr lang="en-US" sz="2200" b="1" dirty="0">
+                <a:solidFill>
+                  <a:schemeClr val="accent2"/>
+                </a:solidFill>
+                <a:latin typeface="Times New Roman" panose="02020603050405020304" pitchFamily="18" charset="0"/>
+                <a:cs typeface="Times New Roman" panose="02020603050405020304" pitchFamily="18" charset="0"/>
+              </a:rPr>
+              <a:t>Specialize or diversify?</a:t>
+            </a:r>
+          </a:p>
+          <a:p>
+            <a:pPr marL="0" indent="0" algn="l">
+              <a:lnSpc>
+                <a:spcPct val="100000"/>
+              </a:lnSpc>
+              <a:spcBef>
+                <a:spcPts val="0"/>
+              </a:spcBef>
+              <a:spcAft>
+                <a:spcPts val="0"/>
+              </a:spcAft>
+              <a:buNone/>
+            </a:pPr>
+            <a:r>
+              <a:rPr lang="en-US" sz="2000" b="0" dirty="0">
+                <a:solidFill>
+                  <a:schemeClr val="dk1"/>
+                </a:solidFill>
+                <a:latin typeface="Times New Roman" panose="02020603050405020304" pitchFamily="18" charset="0"/>
+                <a:cs typeface="Times New Roman" panose="02020603050405020304" pitchFamily="18" charset="0"/>
+              </a:rPr>
+              <a:t>Stay focused on memory leadership, or branch into AI chip design, advanced packaging and processing-in-memory? The payoff is uncertain.</a:t>
+            </a:r>
+          </a:p>
+        </p:txBody>
+      </p:sp>
+      <p:sp>
+        <p:nvSpPr>
+          <p:cNvPr id="3107" name="Question 3 number"/>
+          <p:cNvSpPr/>
+          <p:nvPr/>
+        </p:nvSpPr>
+        <p:spPr>
+          <a:xfrm>
+            <a:off x="950976" y="4133088"/>
+            <a:ext cx="1188720" cy="1188720"/>
+          </a:xfrm>
+          <a:prstGeom prst="rect">
+            <a:avLst/>
+          </a:prstGeom>
+          <a:solidFill>
+            <a:schemeClr val="dk2"/>
+          </a:solidFill>
+          <a:ln>
+            <a:noFill/>
+          </a:ln>
+        </p:spPr>
+        <p:txBody>
+          <a:bodyPr wrap="square" lIns="0" tIns="0" rIns="0" bIns="0" rtlCol="0" anchor="ctr">
+            <a:noAutofit/>
+          </a:bodyPr>
+          <a:lstStyle/>
+          <a:p>
+            <a:pPr marL="0" indent="0" algn="ctr">
+              <a:lnSpc>
+                <a:spcPct val="100000"/>
+              </a:lnSpc>
+              <a:spcBef>
+                <a:spcPts val="0"/>
+              </a:spcBef>
+              <a:spcAft>
+                <a:spcPts val="0"/>
+              </a:spcAft>
+              <a:buNone/>
+            </a:pPr>
+            <a:r>
+              <a:rPr lang="en-US" sz="3600" b="1" dirty="0">
+                <a:solidFill>
+                  <a:schemeClr val="bg1"/>
+                </a:solidFill>
+                <a:latin typeface="Times New Roman" panose="02020603050405020304" pitchFamily="18" charset="0"/>
+                <a:cs typeface="Times New Roman" panose="02020603050405020304" pitchFamily="18" charset="0"/>
+              </a:rPr>
+              <a:t>03</a:t>
+            </a:r>
+          </a:p>
+        </p:txBody>
+      </p:sp>
+      <p:sp>
+        <p:nvSpPr>
+          <p:cNvPr id="3108" name="Question 3 card"/>
+          <p:cNvSpPr/>
+          <p:nvPr/>
+        </p:nvSpPr>
+        <p:spPr>
+          <a:xfrm>
+            <a:off x="2322576" y="4133088"/>
+            <a:ext cx="8924544" cy="1188720"/>
+          </a:xfrm>
+          <a:prstGeom prst="rect">
+            <a:avLst/>
+          </a:prstGeom>
+          <a:solidFill>
+            <a:schemeClr val="accent4">
+              <a:lumMod val="20000"/>
+              <a:lumOff val="80000"/>
+            </a:schemeClr>
+          </a:solidFill>
+          <a:ln>
+            <a:noFill/>
+          </a:ln>
+        </p:spPr>
+        <p:txBody>
+          <a:bodyPr wrap="square" lIns="164592" tIns="164592" rIns="164592" bIns="164592" rtlCol="0" anchor="ctr">
+            <a:noAutofit/>
+          </a:bodyPr>
+          <a:lstStyle/>
+          <a:p>
+            <a:pPr marL="0" indent="0" algn="l">
+              <a:lnSpc>
+                <a:spcPct val="100000"/>
+              </a:lnSpc>
+              <a:spcBef>
+                <a:spcPts val="0"/>
+              </a:spcBef>
+              <a:spcAft>
+                <a:spcPts val="200"/>
+              </a:spcAft>
+              <a:buNone/>
+            </a:pPr>
+            <a:r>
+              <a:rPr lang="en-US" sz="2200" b="1" dirty="0">
+                <a:solidFill>
+                  <a:schemeClr val="accent2"/>
+                </a:solidFill>
+                <a:latin typeface="Times New Roman" panose="02020603050405020304" pitchFamily="18" charset="0"/>
+                <a:cs typeface="Times New Roman" panose="02020603050405020304" pitchFamily="18" charset="0"/>
+              </a:rPr>
+              <a:t>What happens to bilateral trade?</a:t>
+            </a:r>
+          </a:p>
+          <a:p>
+            <a:pPr marL="0" indent="0" algn="l">
+              <a:lnSpc>
+                <a:spcPct val="100000"/>
+              </a:lnSpc>
+              <a:spcBef>
+                <a:spcPts val="0"/>
+              </a:spcBef>
+              <a:spcAft>
+                <a:spcPts val="0"/>
+              </a:spcAft>
+              <a:buNone/>
+            </a:pPr>
+            <a:r>
+              <a:rPr lang="en-US" sz="2000" b="0" dirty="0">
+                <a:solidFill>
+                  <a:schemeClr val="dk1"/>
+                </a:solidFill>
+                <a:latin typeface="Times New Roman" panose="02020603050405020304" pitchFamily="18" charset="0"/>
+                <a:cs typeface="Times New Roman" panose="02020603050405020304" pitchFamily="18" charset="0"/>
+              </a:rPr>
+              <a:t>Will China keep relying on Korean memory chips for its AI industry, or will self-sufficiency cut demand and reshape decades of interdependence?</a:t>
+            </a:r>
+          </a:p>
+        </p:txBody>
+      </p:sp>
+      <p:sp>
+        <p:nvSpPr>
+          <p:cNvPr id="3109" name="Next step banner"/>
+          <p:cNvSpPr/>
+          <p:nvPr/>
+        </p:nvSpPr>
+        <p:spPr>
+          <a:xfrm>
+            <a:off x="950976" y="5486400"/>
+            <a:ext cx="10296144" cy="685800"/>
+          </a:xfrm>
+          <a:prstGeom prst="rect">
+            <a:avLst/>
+          </a:prstGeom>
+          <a:solidFill>
+            <a:schemeClr val="tx1">
+              <a:lumMod val="50000"/>
+              <a:lumOff val="50000"/>
+            </a:schemeClr>
+          </a:solidFill>
+          <a:ln>
+            <a:noFill/>
+          </a:ln>
+        </p:spPr>
+        <p:txBody>
+          <a:bodyPr wrap="square" lIns="91440" tIns="91440" rIns="91440" bIns="91440" rtlCol="0" anchor="ctr">
+            <a:noAutofit/>
+          </a:bodyPr>
+          <a:lstStyle/>
+          <a:p>
+            <a:pPr marL="0" indent="0" algn="ctr">
+              <a:lnSpc>
+                <a:spcPct val="100000"/>
+              </a:lnSpc>
+              <a:spcBef>
+                <a:spcPts val="0"/>
+              </a:spcBef>
+              <a:spcAft>
+                <a:spcPts val="0"/>
+              </a:spcAft>
+              <a:buNone/>
+            </a:pPr>
+            <a:r>
+              <a:rPr lang="en-US" sz="2000" b="1" dirty="0">
+                <a:solidFill>
+                  <a:schemeClr val="bg1"/>
+                </a:solidFill>
+                <a:latin typeface="Times New Roman" panose="02020603050405020304" pitchFamily="18" charset="0"/>
+                <a:cs typeface="Times New Roman" panose="02020603050405020304" pitchFamily="18" charset="0"/>
+              </a:rPr>
+              <a:t>Next step: </a:t>
+            </a:r>
+            <a:r>
+              <a:rPr lang="en-US" sz="2000" b="0" dirty="0">
+                <a:solidFill>
+                  <a:schemeClr val="bg1"/>
+                </a:solidFill>
+                <a:latin typeface="Times New Roman" panose="02020603050405020304" pitchFamily="18" charset="0"/>
+                <a:cs typeface="Times New Roman" panose="02020603050405020304" pitchFamily="18" charset="0"/>
+              </a:rPr>
+              <a:t>my final research paper will explore these questions in greater depth</a:t>
+            </a:r>
+          </a:p>
+        </p:txBody>
+      </p:sp>
+    </p:spTree>
+  </p:cSld>
+  <p:clrMapOvr>
+    <a:masterClrMapping/>
+  </p:clrMapOvr>
+</p:sld>
+</file>
+
 <file path=ppt/theme/theme1.xml><?xml version="1.0" encoding="utf-8"?>
 <a:theme xmlns:a="http://schemas.openxmlformats.org/drawingml/2006/main" name="The Four Asian Tigers: Singapore, Hong Kong, Taiwan and South Korea by Slidesgo">
   <a:themeElements>

</xml_diff>